<commit_message>
Fix lesson 02 agent component diagram
</commit_message>
<xml_diff>
--- a/slides/lesson-02-ai-agents-vibe-coding-desktop-utilities.pptx
+++ b/slides/lesson-02-ai-agents-vibe-coding-desktop-utilities.pptx
@@ -2,32 +2,32 @@
 <file path=ppt/presentation.xml><?xml version="1.0" encoding="utf-8"?>
 <p:presentation xmlns:p="http://schemas.openxmlformats.org/presentationml/2006/main">
   <p:sldMasterIdLst>
-    <p:sldMasterId xmlns:r="http://schemas.openxmlformats.org/officeDocument/2006/relationships" id="2147483648" r:id="R715cda7419904910"/>
+    <p:sldMasterId xmlns:r="http://schemas.openxmlformats.org/officeDocument/2006/relationships" id="2147483648" r:id="R6171306a05594227"/>
   </p:sldMasterIdLst>
   <p:notesMasterIdLst>
-    <p:notesMasterId xmlns:r="http://schemas.openxmlformats.org/officeDocument/2006/relationships" r:id="Rebdd5cc502714850"/>
+    <p:notesMasterId xmlns:r="http://schemas.openxmlformats.org/officeDocument/2006/relationships" r:id="Rd1914a8e75de4e10"/>
   </p:notesMasterIdLst>
   <p:sldIdLst>
-    <p:sldId xmlns:r="http://schemas.openxmlformats.org/officeDocument/2006/relationships" id="256" r:id="R20b24303e0e9431d"/>
-    <p:sldId xmlns:r="http://schemas.openxmlformats.org/officeDocument/2006/relationships" id="257" r:id="R0e5c48f17a6740dc"/>
-    <p:sldId xmlns:r="http://schemas.openxmlformats.org/officeDocument/2006/relationships" id="258" r:id="R0cefdaf83927453b"/>
-    <p:sldId xmlns:r="http://schemas.openxmlformats.org/officeDocument/2006/relationships" id="259" r:id="R45016fcb1d974611"/>
-    <p:sldId xmlns:r="http://schemas.openxmlformats.org/officeDocument/2006/relationships" id="260" r:id="Rf223dd2b8d6f4b33"/>
-    <p:sldId xmlns:r="http://schemas.openxmlformats.org/officeDocument/2006/relationships" id="261" r:id="R905eae84cf5a40cb"/>
-    <p:sldId xmlns:r="http://schemas.openxmlformats.org/officeDocument/2006/relationships" id="262" r:id="R56f8d5e402c941c9"/>
-    <p:sldId xmlns:r="http://schemas.openxmlformats.org/officeDocument/2006/relationships" id="263" r:id="R974b31d91a384a41"/>
-    <p:sldId xmlns:r="http://schemas.openxmlformats.org/officeDocument/2006/relationships" id="264" r:id="Rb830c720326e4884"/>
-    <p:sldId xmlns:r="http://schemas.openxmlformats.org/officeDocument/2006/relationships" id="265" r:id="Rbce89f3045fd4d12"/>
-    <p:sldId xmlns:r="http://schemas.openxmlformats.org/officeDocument/2006/relationships" id="266" r:id="R2c9fc6af014348ce"/>
-    <p:sldId xmlns:r="http://schemas.openxmlformats.org/officeDocument/2006/relationships" id="267" r:id="R56eda17a9ec747e7"/>
-    <p:sldId xmlns:r="http://schemas.openxmlformats.org/officeDocument/2006/relationships" id="268" r:id="Rfbdb59ffbf0e4821"/>
-    <p:sldId xmlns:r="http://schemas.openxmlformats.org/officeDocument/2006/relationships" id="269" r:id="R5dfb1f1abeff4c5e"/>
-    <p:sldId xmlns:r="http://schemas.openxmlformats.org/officeDocument/2006/relationships" id="270" r:id="Rf43deafb4d954a0c"/>
-    <p:sldId xmlns:r="http://schemas.openxmlformats.org/officeDocument/2006/relationships" id="271" r:id="R6520a8084f1f4217"/>
-    <p:sldId xmlns:r="http://schemas.openxmlformats.org/officeDocument/2006/relationships" id="272" r:id="R2a0bc8bad6a2465c"/>
-    <p:sldId xmlns:r="http://schemas.openxmlformats.org/officeDocument/2006/relationships" id="273" r:id="R09770670ae9345e9"/>
-    <p:sldId xmlns:r="http://schemas.openxmlformats.org/officeDocument/2006/relationships" id="274" r:id="Rdf40dbe282b848a4"/>
-    <p:sldId xmlns:r="http://schemas.openxmlformats.org/officeDocument/2006/relationships" id="275" r:id="R2f426561d3374f9d"/>
+    <p:sldId xmlns:r="http://schemas.openxmlformats.org/officeDocument/2006/relationships" id="256" r:id="Rf414fa4eb0e74f57"/>
+    <p:sldId xmlns:r="http://schemas.openxmlformats.org/officeDocument/2006/relationships" id="257" r:id="R60d7018a5ab7478c"/>
+    <p:sldId xmlns:r="http://schemas.openxmlformats.org/officeDocument/2006/relationships" id="258" r:id="R6aac74a2af464990"/>
+    <p:sldId xmlns:r="http://schemas.openxmlformats.org/officeDocument/2006/relationships" id="259" r:id="R390413cec34f4d33"/>
+    <p:sldId xmlns:r="http://schemas.openxmlformats.org/officeDocument/2006/relationships" id="260" r:id="R1f9f721604e24577"/>
+    <p:sldId xmlns:r="http://schemas.openxmlformats.org/officeDocument/2006/relationships" id="261" r:id="R288b739bdddf4526"/>
+    <p:sldId xmlns:r="http://schemas.openxmlformats.org/officeDocument/2006/relationships" id="262" r:id="R1053127786774ef2"/>
+    <p:sldId xmlns:r="http://schemas.openxmlformats.org/officeDocument/2006/relationships" id="263" r:id="R0236d8de5b164f4a"/>
+    <p:sldId xmlns:r="http://schemas.openxmlformats.org/officeDocument/2006/relationships" id="264" r:id="R327f23a4cb5f409a"/>
+    <p:sldId xmlns:r="http://schemas.openxmlformats.org/officeDocument/2006/relationships" id="265" r:id="R1ddcd1b32e6941d8"/>
+    <p:sldId xmlns:r="http://schemas.openxmlformats.org/officeDocument/2006/relationships" id="266" r:id="Rfd0b00059c2a48be"/>
+    <p:sldId xmlns:r="http://schemas.openxmlformats.org/officeDocument/2006/relationships" id="267" r:id="Raa4047ee1e474b00"/>
+    <p:sldId xmlns:r="http://schemas.openxmlformats.org/officeDocument/2006/relationships" id="268" r:id="R71f0b5b710f341ce"/>
+    <p:sldId xmlns:r="http://schemas.openxmlformats.org/officeDocument/2006/relationships" id="269" r:id="Rf8f2f1832e3047c2"/>
+    <p:sldId xmlns:r="http://schemas.openxmlformats.org/officeDocument/2006/relationships" id="270" r:id="R56cf715b7019454c"/>
+    <p:sldId xmlns:r="http://schemas.openxmlformats.org/officeDocument/2006/relationships" id="271" r:id="R619250268bcf437c"/>
+    <p:sldId xmlns:r="http://schemas.openxmlformats.org/officeDocument/2006/relationships" id="272" r:id="R131248629ddc40e4"/>
+    <p:sldId xmlns:r="http://schemas.openxmlformats.org/officeDocument/2006/relationships" id="273" r:id="R5aef5e2727cf4c51"/>
+    <p:sldId xmlns:r="http://schemas.openxmlformats.org/officeDocument/2006/relationships" id="274" r:id="Rf16463795a6d48e3"/>
+    <p:sldId xmlns:r="http://schemas.openxmlformats.org/officeDocument/2006/relationships" id="275" r:id="R5b71f17591f14cb9"/>
   </p:sldIdLst>
   <p:sldSz cx="12192000" cy="6858000"/>
   <p:notesSz cx="6858000" cy="9144000"/>
@@ -1954,7 +1954,7 @@
   </p:cSld>
   <p:clrMap bg1="lt1" tx1="dk1" bg2="lt2" tx2="dk2" accent1="accent1" accent2="accent2" accent3="accent3" accent4="accent4" accent5="accent5" accent6="accent6" hlink="hlink" folHlink="folHlink"/>
   <p:sldLayoutIdLst>
-    <p:sldLayoutId xmlns:r="http://schemas.openxmlformats.org/officeDocument/2006/relationships" id="2147483649" r:id="R83ac7999813b4a6f"/>
+    <p:sldLayoutId xmlns:r="http://schemas.openxmlformats.org/officeDocument/2006/relationships" id="2147483649" r:id="Re02fc1f50e394af6"/>
   </p:sldLayoutIdLst>
   <p:txStyles>
     <p:titleStyle>
@@ -2505,7 +2505,7 @@
           <p:cNvPr id="1" name="eyebrow">
             <a:extLst xmlns:a="http://schemas.openxmlformats.org/drawingml/2006/main">
               <a:ext uri="{FF2B5EF4-FFF2-40B4-BE49-F238E27FC236}">
-                <a16:creationId xmlns:a16="http://schemas.microsoft.com/office/drawing/2014/main" id="{0AB0F601-0420-4B53-AD5A-EA5E0298C9CF}"/>
+                <a16:creationId xmlns:a16="http://schemas.microsoft.com/office/drawing/2014/main" id="{89E35109-3FA3-4A68-84BD-6CA8A02ED6B9}"/>
               </a:ext>
             </a:extLst>
           </p:cNvPr>
@@ -2565,7 +2565,7 @@
           <p:cNvPr id="2" name="lesson-title">
             <a:extLst xmlns:a="http://schemas.openxmlformats.org/drawingml/2006/main">
               <a:ext uri="{FF2B5EF4-FFF2-40B4-BE49-F238E27FC236}">
-                <a16:creationId xmlns:a16="http://schemas.microsoft.com/office/drawing/2014/main" id="{588AA979-2A4D-4C12-AF4A-341172BF26DD}"/>
+                <a16:creationId xmlns:a16="http://schemas.microsoft.com/office/drawing/2014/main" id="{3F4C892B-4DD8-429F-95F7-9A91604DEFC5}"/>
               </a:ext>
             </a:extLst>
           </p:cNvPr>
@@ -2625,7 +2625,7 @@
           <p:cNvPr id="3" name="subtitle">
             <a:extLst xmlns:a="http://schemas.openxmlformats.org/drawingml/2006/main">
               <a:ext uri="{FF2B5EF4-FFF2-40B4-BE49-F238E27FC236}">
-                <a16:creationId xmlns:a16="http://schemas.microsoft.com/office/drawing/2014/main" id="{78A07C98-66C7-46D6-937A-7AE0A0A99E02}"/>
+                <a16:creationId xmlns:a16="http://schemas.microsoft.com/office/drawing/2014/main" id="{30EE9088-4691-4455-AED6-76A12DBED5EB}"/>
               </a:ext>
             </a:extLst>
           </p:cNvPr>
@@ -2685,7 +2685,7 @@
           <p:cNvPr id="4" name="questions">
             <a:extLst xmlns:a="http://schemas.openxmlformats.org/drawingml/2006/main">
               <a:ext uri="{FF2B5EF4-FFF2-40B4-BE49-F238E27FC236}">
-                <a16:creationId xmlns:a16="http://schemas.microsoft.com/office/drawing/2014/main" id="{B943E010-1A33-4B9E-8400-E020718AEB44}"/>
+                <a16:creationId xmlns:a16="http://schemas.microsoft.com/office/drawing/2014/main" id="{76AE9DC6-1E8D-4C50-8171-3CF6943B2CE1}"/>
               </a:ext>
             </a:extLst>
           </p:cNvPr>
@@ -2808,7 +2808,7 @@
           <p:cNvPr id="5" name="flow-line-1">
             <a:extLst xmlns:a="http://schemas.openxmlformats.org/drawingml/2006/main">
               <a:ext uri="{FF2B5EF4-FFF2-40B4-BE49-F238E27FC236}">
-                <a16:creationId xmlns:a16="http://schemas.microsoft.com/office/drawing/2014/main" id="{0D3412B5-B902-4C67-A342-7432A1C3520A}"/>
+                <a16:creationId xmlns:a16="http://schemas.microsoft.com/office/drawing/2014/main" id="{1A78E723-E7A4-4493-9B8F-578C1274053A}"/>
               </a:ext>
             </a:extLst>
           </p:cNvPr>
@@ -2839,7 +2839,7 @@
           <p:cNvPr id="6" name="flow-line-2">
             <a:extLst xmlns:a="http://schemas.openxmlformats.org/drawingml/2006/main">
               <a:ext uri="{FF2B5EF4-FFF2-40B4-BE49-F238E27FC236}">
-                <a16:creationId xmlns:a16="http://schemas.microsoft.com/office/drawing/2014/main" id="{D789F13D-9C67-4F5D-A3E1-F621BC659A78}"/>
+                <a16:creationId xmlns:a16="http://schemas.microsoft.com/office/drawing/2014/main" id="{2EDB3419-79A0-4AC3-A500-801B0DA6C9A7}"/>
               </a:ext>
             </a:extLst>
           </p:cNvPr>
@@ -2870,7 +2870,7 @@
           <p:cNvPr id="7" name="flow-line-3">
             <a:extLst xmlns:a="http://schemas.openxmlformats.org/drawingml/2006/main">
               <a:ext uri="{FF2B5EF4-FFF2-40B4-BE49-F238E27FC236}">
-                <a16:creationId xmlns:a16="http://schemas.microsoft.com/office/drawing/2014/main" id="{46BB83F0-217F-48DA-9EF0-72595AEF832A}"/>
+                <a16:creationId xmlns:a16="http://schemas.microsoft.com/office/drawing/2014/main" id="{EA68ECFB-DF78-4549-B228-B6A55536F2D4}"/>
               </a:ext>
             </a:extLst>
           </p:cNvPr>
@@ -2901,7 +2901,7 @@
           <p:cNvPr id="8" name="ask">
             <a:extLst xmlns:a="http://schemas.openxmlformats.org/drawingml/2006/main">
               <a:ext uri="{FF2B5EF4-FFF2-40B4-BE49-F238E27FC236}">
-                <a16:creationId xmlns:a16="http://schemas.microsoft.com/office/drawing/2014/main" id="{679BA4E4-393C-486E-95DA-5FFEC24DDEB3}"/>
+                <a16:creationId xmlns:a16="http://schemas.microsoft.com/office/drawing/2014/main" id="{E1E27A7B-699E-45F4-BB70-4501335DA599}"/>
               </a:ext>
             </a:extLst>
           </p:cNvPr>
@@ -2967,7 +2967,7 @@
           <p:cNvPr id="9" name="plan">
             <a:extLst xmlns:a="http://schemas.openxmlformats.org/drawingml/2006/main">
               <a:ext uri="{FF2B5EF4-FFF2-40B4-BE49-F238E27FC236}">
-                <a16:creationId xmlns:a16="http://schemas.microsoft.com/office/drawing/2014/main" id="{98066F79-4536-4874-A628-A6E325F70541}"/>
+                <a16:creationId xmlns:a16="http://schemas.microsoft.com/office/drawing/2014/main" id="{F6C5F352-E72A-413A-99DE-40D2F7ECEE65}"/>
               </a:ext>
             </a:extLst>
           </p:cNvPr>
@@ -3033,7 +3033,7 @@
           <p:cNvPr id="10" name="tools">
             <a:extLst xmlns:a="http://schemas.openxmlformats.org/drawingml/2006/main">
               <a:ext uri="{FF2B5EF4-FFF2-40B4-BE49-F238E27FC236}">
-                <a16:creationId xmlns:a16="http://schemas.microsoft.com/office/drawing/2014/main" id="{81C6DD70-CF7D-47A2-8C5E-0FA7ADF20D48}"/>
+                <a16:creationId xmlns:a16="http://schemas.microsoft.com/office/drawing/2014/main" id="{51E99080-97B2-464B-9E0D-50E1CA36CC7E}"/>
               </a:ext>
             </a:extLst>
           </p:cNvPr>
@@ -3099,7 +3099,7 @@
           <p:cNvPr id="11" name="verify">
             <a:extLst xmlns:a="http://schemas.openxmlformats.org/drawingml/2006/main">
               <a:ext uri="{FF2B5EF4-FFF2-40B4-BE49-F238E27FC236}">
-                <a16:creationId xmlns:a16="http://schemas.microsoft.com/office/drawing/2014/main" id="{FD07F369-03C8-4596-BF37-60FB3CE1B0D0}"/>
+                <a16:creationId xmlns:a16="http://schemas.microsoft.com/office/drawing/2014/main" id="{41D0C1E0-6B8E-44CD-AADD-95D970ACD60C}"/>
               </a:ext>
             </a:extLst>
           </p:cNvPr>
@@ -3165,7 +3165,7 @@
           <p:cNvPr id="12" name="deliver">
             <a:extLst xmlns:a="http://schemas.openxmlformats.org/drawingml/2006/main">
               <a:ext uri="{FF2B5EF4-FFF2-40B4-BE49-F238E27FC236}">
-                <a16:creationId xmlns:a16="http://schemas.microsoft.com/office/drawing/2014/main" id="{78690B49-6F35-4801-8205-98A81EBCA1CF}"/>
+                <a16:creationId xmlns:a16="http://schemas.microsoft.com/office/drawing/2014/main" id="{669C9CD5-9DBF-41CC-933F-AFAED75C1789}"/>
               </a:ext>
             </a:extLst>
           </p:cNvPr>
@@ -3231,7 +3231,7 @@
           <p:cNvPr id="13" name="right-note">
             <a:extLst xmlns:a="http://schemas.openxmlformats.org/drawingml/2006/main">
               <a:ext uri="{FF2B5EF4-FFF2-40B4-BE49-F238E27FC236}">
-                <a16:creationId xmlns:a16="http://schemas.microsoft.com/office/drawing/2014/main" id="{5AA1DF91-79D6-4A5D-9EEF-C5B8990D10C9}"/>
+                <a16:creationId xmlns:a16="http://schemas.microsoft.com/office/drawing/2014/main" id="{C9D37ADE-518F-45CB-8A31-C91E20D04CDA}"/>
               </a:ext>
             </a:extLst>
           </p:cNvPr>
@@ -3291,7 +3291,7 @@
           <p:cNvPr id="14" name="footer">
             <a:extLst xmlns:a="http://schemas.openxmlformats.org/drawingml/2006/main">
               <a:ext uri="{FF2B5EF4-FFF2-40B4-BE49-F238E27FC236}">
-                <a16:creationId xmlns:a16="http://schemas.microsoft.com/office/drawing/2014/main" id="{B93FFFAA-1B32-4DEB-B0DC-F3D4C9B18642}"/>
+                <a16:creationId xmlns:a16="http://schemas.microsoft.com/office/drawing/2014/main" id="{9168B718-A13C-47F0-844B-FB6FED548E96}"/>
               </a:ext>
             </a:extLst>
           </p:cNvPr>
@@ -3349,7 +3349,7 @@
     </p:spTree>
     <p:extLst>
       <p:ext uri="{BB962C8B-B14F-4D97-AF65-F5344CB8AC3E}">
-        <p14:creationId xmlns:p14="http://schemas.microsoft.com/office/powerpoint/2010/main" val="881884273"/>
+        <p14:creationId xmlns:p14="http://schemas.microsoft.com/office/powerpoint/2010/main" val="446266599"/>
       </p:ext>
     </p:extLst>
   </p:cSld>
@@ -3380,7 +3380,7 @@
           <p:cNvPr id="1" name="eyebrow">
             <a:extLst xmlns:a="http://schemas.openxmlformats.org/drawingml/2006/main">
               <a:ext uri="{FF2B5EF4-FFF2-40B4-BE49-F238E27FC236}">
-                <a16:creationId xmlns:a16="http://schemas.microsoft.com/office/drawing/2014/main" id="{F0A352DE-AF17-408C-86BB-148C71EE874A}"/>
+                <a16:creationId xmlns:a16="http://schemas.microsoft.com/office/drawing/2014/main" id="{0FD09173-3F93-4BB0-8C3E-10C9E5C025B4}"/>
               </a:ext>
             </a:extLst>
           </p:cNvPr>
@@ -3440,7 +3440,7 @@
           <p:cNvPr id="2" name="title">
             <a:extLst xmlns:a="http://schemas.openxmlformats.org/drawingml/2006/main">
               <a:ext uri="{FF2B5EF4-FFF2-40B4-BE49-F238E27FC236}">
-                <a16:creationId xmlns:a16="http://schemas.microsoft.com/office/drawing/2014/main" id="{19FCD9F3-DFCF-4001-AFAA-15D38C8DBEBD}"/>
+                <a16:creationId xmlns:a16="http://schemas.microsoft.com/office/drawing/2014/main" id="{FFF64B04-BCB2-4067-AF00-889BE497CF8F}"/>
               </a:ext>
             </a:extLst>
           </p:cNvPr>
@@ -3500,7 +3500,7 @@
           <p:cNvPr id="3" name="footer">
             <a:extLst xmlns:a="http://schemas.openxmlformats.org/drawingml/2006/main">
               <a:ext uri="{FF2B5EF4-FFF2-40B4-BE49-F238E27FC236}">
-                <a16:creationId xmlns:a16="http://schemas.microsoft.com/office/drawing/2014/main" id="{B4D51C61-2EE8-4091-98F5-F384C5FCD4BC}"/>
+                <a16:creationId xmlns:a16="http://schemas.microsoft.com/office/drawing/2014/main" id="{48167524-248A-4BF2-81AA-8A8EE00C234B}"/>
               </a:ext>
             </a:extLst>
           </p:cNvPr>
@@ -3560,7 +3560,7 @@
           <p:cNvPr id="4" name="good">
             <a:extLst xmlns:a="http://schemas.openxmlformats.org/drawingml/2006/main">
               <a:ext uri="{FF2B5EF4-FFF2-40B4-BE49-F238E27FC236}">
-                <a16:creationId xmlns:a16="http://schemas.microsoft.com/office/drawing/2014/main" id="{D048E220-BCAF-4301-A47F-79A683FBA2C4}"/>
+                <a16:creationId xmlns:a16="http://schemas.microsoft.com/office/drawing/2014/main" id="{F95EB47B-E87D-4F04-8114-84DE67ADB2BA}"/>
               </a:ext>
             </a:extLst>
           </p:cNvPr>
@@ -3595,7 +3595,7 @@
           <p:cNvPr id="5" name="bad">
             <a:extLst xmlns:a="http://schemas.openxmlformats.org/drawingml/2006/main">
               <a:ext uri="{FF2B5EF4-FFF2-40B4-BE49-F238E27FC236}">
-                <a16:creationId xmlns:a16="http://schemas.microsoft.com/office/drawing/2014/main" id="{44B19DA9-8C00-4A63-8125-5F41E1565644}"/>
+                <a16:creationId xmlns:a16="http://schemas.microsoft.com/office/drawing/2014/main" id="{5A12C317-C46F-421F-94DC-29D8E4057CC5}"/>
               </a:ext>
             </a:extLst>
           </p:cNvPr>
@@ -3630,7 +3630,7 @@
           <p:cNvPr id="6" name="good-title">
             <a:extLst xmlns:a="http://schemas.openxmlformats.org/drawingml/2006/main">
               <a:ext uri="{FF2B5EF4-FFF2-40B4-BE49-F238E27FC236}">
-                <a16:creationId xmlns:a16="http://schemas.microsoft.com/office/drawing/2014/main" id="{71A5C46A-8405-4998-A6FE-3D0F5B591D63}"/>
+                <a16:creationId xmlns:a16="http://schemas.microsoft.com/office/drawing/2014/main" id="{2E2AD5E1-A0BC-4412-9007-03D1E9385F67}"/>
               </a:ext>
             </a:extLst>
           </p:cNvPr>
@@ -3690,7 +3690,7 @@
           <p:cNvPr id="7" name="bad-title">
             <a:extLst xmlns:a="http://schemas.openxmlformats.org/drawingml/2006/main">
               <a:ext uri="{FF2B5EF4-FFF2-40B4-BE49-F238E27FC236}">
-                <a16:creationId xmlns:a16="http://schemas.microsoft.com/office/drawing/2014/main" id="{F11D7C34-AD4F-48BB-9207-0F65C9E02349}"/>
+                <a16:creationId xmlns:a16="http://schemas.microsoft.com/office/drawing/2014/main" id="{B41252E1-B299-4D14-A540-B8B5D78ABBA9}"/>
               </a:ext>
             </a:extLst>
           </p:cNvPr>
@@ -3750,7 +3750,7 @@
           <p:cNvPr id="8" name="good-list">
             <a:extLst xmlns:a="http://schemas.openxmlformats.org/drawingml/2006/main">
               <a:ext uri="{FF2B5EF4-FFF2-40B4-BE49-F238E27FC236}">
-                <a16:creationId xmlns:a16="http://schemas.microsoft.com/office/drawing/2014/main" id="{C0A14E8E-DDB6-426F-A647-091F1EE40348}"/>
+                <a16:creationId xmlns:a16="http://schemas.microsoft.com/office/drawing/2014/main" id="{77C14359-64EA-44DC-BD3A-4E43A2AD2048}"/>
               </a:ext>
             </a:extLst>
           </p:cNvPr>
@@ -3933,7 +3933,7 @@
           <p:cNvPr id="9" name="bad-list">
             <a:extLst xmlns:a="http://schemas.openxmlformats.org/drawingml/2006/main">
               <a:ext uri="{FF2B5EF4-FFF2-40B4-BE49-F238E27FC236}">
-                <a16:creationId xmlns:a16="http://schemas.microsoft.com/office/drawing/2014/main" id="{2FC9BB3F-A43D-495E-BCB0-3FC5C014D5B3}"/>
+                <a16:creationId xmlns:a16="http://schemas.microsoft.com/office/drawing/2014/main" id="{FAFE76D3-FFA3-479A-ACAA-485C0910CC57}"/>
               </a:ext>
             </a:extLst>
           </p:cNvPr>
@@ -4116,7 +4116,7 @@
           <p:cNvPr id="10" name="bottom">
             <a:extLst xmlns:a="http://schemas.openxmlformats.org/drawingml/2006/main">
               <a:ext uri="{FF2B5EF4-FFF2-40B4-BE49-F238E27FC236}">
-                <a16:creationId xmlns:a16="http://schemas.microsoft.com/office/drawing/2014/main" id="{CC8C9388-5E44-43BF-B8E1-11C9ED82B860}"/>
+                <a16:creationId xmlns:a16="http://schemas.microsoft.com/office/drawing/2014/main" id="{18E1E24C-F441-4F56-801A-753410301CCC}"/>
               </a:ext>
             </a:extLst>
           </p:cNvPr>
@@ -4174,7 +4174,7 @@
     </p:spTree>
     <p:extLst>
       <p:ext uri="{BB962C8B-B14F-4D97-AF65-F5344CB8AC3E}">
-        <p14:creationId xmlns:p14="http://schemas.microsoft.com/office/powerpoint/2010/main" val="283094009"/>
+        <p14:creationId xmlns:p14="http://schemas.microsoft.com/office/powerpoint/2010/main" val="1414027697"/>
       </p:ext>
     </p:extLst>
   </p:cSld>
@@ -4205,7 +4205,7 @@
           <p:cNvPr id="1" name="eyebrow">
             <a:extLst xmlns:a="http://schemas.openxmlformats.org/drawingml/2006/main">
               <a:ext uri="{FF2B5EF4-FFF2-40B4-BE49-F238E27FC236}">
-                <a16:creationId xmlns:a16="http://schemas.microsoft.com/office/drawing/2014/main" id="{8E491CA4-6CD8-4C3F-BFD9-97E540D9AC74}"/>
+                <a16:creationId xmlns:a16="http://schemas.microsoft.com/office/drawing/2014/main" id="{91A4D2A8-B765-42F7-8067-6E5528CFA31F}"/>
               </a:ext>
             </a:extLst>
           </p:cNvPr>
@@ -4265,7 +4265,7 @@
           <p:cNvPr id="2" name="title">
             <a:extLst xmlns:a="http://schemas.openxmlformats.org/drawingml/2006/main">
               <a:ext uri="{FF2B5EF4-FFF2-40B4-BE49-F238E27FC236}">
-                <a16:creationId xmlns:a16="http://schemas.microsoft.com/office/drawing/2014/main" id="{AE5E0E08-BDEC-4D78-AD1A-EAA2FB3E3EDE}"/>
+                <a16:creationId xmlns:a16="http://schemas.microsoft.com/office/drawing/2014/main" id="{AC4BB5EC-EBC4-4029-8628-B5836194B9F9}"/>
               </a:ext>
             </a:extLst>
           </p:cNvPr>
@@ -4325,7 +4325,7 @@
           <p:cNvPr id="3" name="footer">
             <a:extLst xmlns:a="http://schemas.openxmlformats.org/drawingml/2006/main">
               <a:ext uri="{FF2B5EF4-FFF2-40B4-BE49-F238E27FC236}">
-                <a16:creationId xmlns:a16="http://schemas.microsoft.com/office/drawing/2014/main" id="{D872543D-78C4-4783-8779-07F8021C75CB}"/>
+                <a16:creationId xmlns:a16="http://schemas.microsoft.com/office/drawing/2014/main" id="{ABEB1CAD-27F2-4BF5-AB36-03ADA5F8868C}"/>
               </a:ext>
             </a:extLst>
           </p:cNvPr>
@@ -4385,7 +4385,7 @@
           <p:cNvPr id="4" name="risk-0">
             <a:extLst xmlns:a="http://schemas.openxmlformats.org/drawingml/2006/main">
               <a:ext uri="{FF2B5EF4-FFF2-40B4-BE49-F238E27FC236}">
-                <a16:creationId xmlns:a16="http://schemas.microsoft.com/office/drawing/2014/main" id="{0AC49704-EDBB-4EF0-968D-A4F22C31235F}"/>
+                <a16:creationId xmlns:a16="http://schemas.microsoft.com/office/drawing/2014/main" id="{097248D5-6E12-408D-A28B-7948973F3447}"/>
               </a:ext>
             </a:extLst>
           </p:cNvPr>
@@ -4420,7 +4420,7 @@
           <p:cNvPr id="5" name="risk-title-0">
             <a:extLst xmlns:a="http://schemas.openxmlformats.org/drawingml/2006/main">
               <a:ext uri="{FF2B5EF4-FFF2-40B4-BE49-F238E27FC236}">
-                <a16:creationId xmlns:a16="http://schemas.microsoft.com/office/drawing/2014/main" id="{FB33FB3D-59B8-49F7-879D-113739A56C26}"/>
+                <a16:creationId xmlns:a16="http://schemas.microsoft.com/office/drawing/2014/main" id="{DBABCD75-93BA-44AC-B1D5-7C41F1085A05}"/>
               </a:ext>
             </a:extLst>
           </p:cNvPr>
@@ -4480,7 +4480,7 @@
           <p:cNvPr id="6" name="risk-copy-0">
             <a:extLst xmlns:a="http://schemas.openxmlformats.org/drawingml/2006/main">
               <a:ext uri="{FF2B5EF4-FFF2-40B4-BE49-F238E27FC236}">
-                <a16:creationId xmlns:a16="http://schemas.microsoft.com/office/drawing/2014/main" id="{AA2C439E-BBA4-4AEB-A6BB-07315CCF0023}"/>
+                <a16:creationId xmlns:a16="http://schemas.microsoft.com/office/drawing/2014/main" id="{D6EE036F-7C0B-4087-9C8A-86C61A72778C}"/>
               </a:ext>
             </a:extLst>
           </p:cNvPr>
@@ -4540,7 +4540,7 @@
           <p:cNvPr id="7" name="risk-1">
             <a:extLst xmlns:a="http://schemas.openxmlformats.org/drawingml/2006/main">
               <a:ext uri="{FF2B5EF4-FFF2-40B4-BE49-F238E27FC236}">
-                <a16:creationId xmlns:a16="http://schemas.microsoft.com/office/drawing/2014/main" id="{B3387A14-289C-4F64-A162-12E90A7AB6C9}"/>
+                <a16:creationId xmlns:a16="http://schemas.microsoft.com/office/drawing/2014/main" id="{4A36EB92-3433-4876-B03C-02CC1EF14DA4}"/>
               </a:ext>
             </a:extLst>
           </p:cNvPr>
@@ -4575,7 +4575,7 @@
           <p:cNvPr id="8" name="risk-title-1">
             <a:extLst xmlns:a="http://schemas.openxmlformats.org/drawingml/2006/main">
               <a:ext uri="{FF2B5EF4-FFF2-40B4-BE49-F238E27FC236}">
-                <a16:creationId xmlns:a16="http://schemas.microsoft.com/office/drawing/2014/main" id="{311770FE-1C62-40A7-99C6-515FCDB6078C}"/>
+                <a16:creationId xmlns:a16="http://schemas.microsoft.com/office/drawing/2014/main" id="{97144970-FD52-4015-9BBA-FCC7504624EC}"/>
               </a:ext>
             </a:extLst>
           </p:cNvPr>
@@ -4635,7 +4635,7 @@
           <p:cNvPr id="9" name="risk-copy-1">
             <a:extLst xmlns:a="http://schemas.openxmlformats.org/drawingml/2006/main">
               <a:ext uri="{FF2B5EF4-FFF2-40B4-BE49-F238E27FC236}">
-                <a16:creationId xmlns:a16="http://schemas.microsoft.com/office/drawing/2014/main" id="{04C56160-2F1D-40CB-A2FE-2878DD733B21}"/>
+                <a16:creationId xmlns:a16="http://schemas.microsoft.com/office/drawing/2014/main" id="{DCC05974-F690-4569-BE68-79249F16CA5E}"/>
               </a:ext>
             </a:extLst>
           </p:cNvPr>
@@ -4695,7 +4695,7 @@
           <p:cNvPr id="10" name="risk-2">
             <a:extLst xmlns:a="http://schemas.openxmlformats.org/drawingml/2006/main">
               <a:ext uri="{FF2B5EF4-FFF2-40B4-BE49-F238E27FC236}">
-                <a16:creationId xmlns:a16="http://schemas.microsoft.com/office/drawing/2014/main" id="{2016368B-5B42-4B4A-8A7A-448547BB70C5}"/>
+                <a16:creationId xmlns:a16="http://schemas.microsoft.com/office/drawing/2014/main" id="{28088A0E-177F-47EF-9F11-644E853E8455}"/>
               </a:ext>
             </a:extLst>
           </p:cNvPr>
@@ -4730,7 +4730,7 @@
           <p:cNvPr id="11" name="risk-title-2">
             <a:extLst xmlns:a="http://schemas.openxmlformats.org/drawingml/2006/main">
               <a:ext uri="{FF2B5EF4-FFF2-40B4-BE49-F238E27FC236}">
-                <a16:creationId xmlns:a16="http://schemas.microsoft.com/office/drawing/2014/main" id="{9B910248-3B91-4FB1-9233-05A423C8648C}"/>
+                <a16:creationId xmlns:a16="http://schemas.microsoft.com/office/drawing/2014/main" id="{0016A91E-FCA6-408F-964C-BE6781786843}"/>
               </a:ext>
             </a:extLst>
           </p:cNvPr>
@@ -4790,7 +4790,7 @@
           <p:cNvPr id="12" name="risk-copy-2">
             <a:extLst xmlns:a="http://schemas.openxmlformats.org/drawingml/2006/main">
               <a:ext uri="{FF2B5EF4-FFF2-40B4-BE49-F238E27FC236}">
-                <a16:creationId xmlns:a16="http://schemas.microsoft.com/office/drawing/2014/main" id="{4F3641CD-2457-49AB-A3BF-EEFA8AC92C80}"/>
+                <a16:creationId xmlns:a16="http://schemas.microsoft.com/office/drawing/2014/main" id="{ABD2CFEF-4C1C-4E20-9AE5-76025F70372F}"/>
               </a:ext>
             </a:extLst>
           </p:cNvPr>
@@ -4850,7 +4850,7 @@
           <p:cNvPr id="13" name="risk-3">
             <a:extLst xmlns:a="http://schemas.openxmlformats.org/drawingml/2006/main">
               <a:ext uri="{FF2B5EF4-FFF2-40B4-BE49-F238E27FC236}">
-                <a16:creationId xmlns:a16="http://schemas.microsoft.com/office/drawing/2014/main" id="{41389BB1-F483-4807-B4C9-204CD8625D01}"/>
+                <a16:creationId xmlns:a16="http://schemas.microsoft.com/office/drawing/2014/main" id="{5903DEEE-2EA4-4FCB-8570-70212750C3D0}"/>
               </a:ext>
             </a:extLst>
           </p:cNvPr>
@@ -4885,7 +4885,7 @@
           <p:cNvPr id="14" name="risk-title-3">
             <a:extLst xmlns:a="http://schemas.openxmlformats.org/drawingml/2006/main">
               <a:ext uri="{FF2B5EF4-FFF2-40B4-BE49-F238E27FC236}">
-                <a16:creationId xmlns:a16="http://schemas.microsoft.com/office/drawing/2014/main" id="{84FA1754-23E8-4914-AD57-4053C76831D4}"/>
+                <a16:creationId xmlns:a16="http://schemas.microsoft.com/office/drawing/2014/main" id="{69EB5B27-079F-4E7E-9875-914388C37C57}"/>
               </a:ext>
             </a:extLst>
           </p:cNvPr>
@@ -4945,7 +4945,7 @@
           <p:cNvPr id="15" name="risk-copy-3">
             <a:extLst xmlns:a="http://schemas.openxmlformats.org/drawingml/2006/main">
               <a:ext uri="{FF2B5EF4-FFF2-40B4-BE49-F238E27FC236}">
-                <a16:creationId xmlns:a16="http://schemas.microsoft.com/office/drawing/2014/main" id="{FE1A229C-2FDA-4529-A43D-B1E45C93D2B9}"/>
+                <a16:creationId xmlns:a16="http://schemas.microsoft.com/office/drawing/2014/main" id="{0BB52576-489D-4514-A4E1-10AAEF1E37ED}"/>
               </a:ext>
             </a:extLst>
           </p:cNvPr>
@@ -5005,7 +5005,7 @@
           <p:cNvPr id="16" name="gate">
             <a:extLst xmlns:a="http://schemas.openxmlformats.org/drawingml/2006/main">
               <a:ext uri="{FF2B5EF4-FFF2-40B4-BE49-F238E27FC236}">
-                <a16:creationId xmlns:a16="http://schemas.microsoft.com/office/drawing/2014/main" id="{8CC1B024-3A24-40B0-86B4-08026223C42D}"/>
+                <a16:creationId xmlns:a16="http://schemas.microsoft.com/office/drawing/2014/main" id="{EF8CEAB8-D6A4-4DA8-9B7D-4D07195A21BE}"/>
               </a:ext>
             </a:extLst>
           </p:cNvPr>
@@ -5069,7 +5069,7 @@
     </p:spTree>
     <p:extLst>
       <p:ext uri="{BB962C8B-B14F-4D97-AF65-F5344CB8AC3E}">
-        <p14:creationId xmlns:p14="http://schemas.microsoft.com/office/powerpoint/2010/main" val="111191541"/>
+        <p14:creationId xmlns:p14="http://schemas.microsoft.com/office/powerpoint/2010/main" val="1602031200"/>
       </p:ext>
     </p:extLst>
   </p:cSld>
@@ -5100,7 +5100,7 @@
           <p:cNvPr id="1" name="eyebrow">
             <a:extLst xmlns:a="http://schemas.openxmlformats.org/drawingml/2006/main">
               <a:ext uri="{FF2B5EF4-FFF2-40B4-BE49-F238E27FC236}">
-                <a16:creationId xmlns:a16="http://schemas.microsoft.com/office/drawing/2014/main" id="{A26B2192-00BC-473A-9EAB-6C7D2B399C5E}"/>
+                <a16:creationId xmlns:a16="http://schemas.microsoft.com/office/drawing/2014/main" id="{5BC456E5-12B9-4ACD-8977-345EA8F03D4E}"/>
               </a:ext>
             </a:extLst>
           </p:cNvPr>
@@ -5160,7 +5160,7 @@
           <p:cNvPr id="2" name="title">
             <a:extLst xmlns:a="http://schemas.openxmlformats.org/drawingml/2006/main">
               <a:ext uri="{FF2B5EF4-FFF2-40B4-BE49-F238E27FC236}">
-                <a16:creationId xmlns:a16="http://schemas.microsoft.com/office/drawing/2014/main" id="{53F49546-0294-4F3A-93D4-22500A33AA23}"/>
+                <a16:creationId xmlns:a16="http://schemas.microsoft.com/office/drawing/2014/main" id="{63C717DA-2F4A-474E-9CDA-2B33704C26F3}"/>
               </a:ext>
             </a:extLst>
           </p:cNvPr>
@@ -5220,7 +5220,7 @@
           <p:cNvPr id="3" name="footer">
             <a:extLst xmlns:a="http://schemas.openxmlformats.org/drawingml/2006/main">
               <a:ext uri="{FF2B5EF4-FFF2-40B4-BE49-F238E27FC236}">
-                <a16:creationId xmlns:a16="http://schemas.microsoft.com/office/drawing/2014/main" id="{B6E7C731-E411-40C7-8C31-455AD2669AA6}"/>
+                <a16:creationId xmlns:a16="http://schemas.microsoft.com/office/drawing/2014/main" id="{39BC58AF-0227-4900-8FE1-EB5FDC65678A}"/>
               </a:ext>
             </a:extLst>
           </p:cNvPr>
@@ -5280,7 +5280,7 @@
           <p:cNvPr id="4" name="stage-line">
             <a:extLst xmlns:a="http://schemas.openxmlformats.org/drawingml/2006/main">
               <a:ext uri="{FF2B5EF4-FFF2-40B4-BE49-F238E27FC236}">
-                <a16:creationId xmlns:a16="http://schemas.microsoft.com/office/drawing/2014/main" id="{C9611CDE-7485-4864-BFAC-75F03948ED5C}"/>
+                <a16:creationId xmlns:a16="http://schemas.microsoft.com/office/drawing/2014/main" id="{D7042F83-D65B-48D0-8434-C7BFCC9DADF8}"/>
               </a:ext>
             </a:extLst>
           </p:cNvPr>
@@ -5311,7 +5311,7 @@
           <p:cNvPr id="5" name="stage-0">
             <a:extLst xmlns:a="http://schemas.openxmlformats.org/drawingml/2006/main">
               <a:ext uri="{FF2B5EF4-FFF2-40B4-BE49-F238E27FC236}">
-                <a16:creationId xmlns:a16="http://schemas.microsoft.com/office/drawing/2014/main" id="{9166B7B0-3B9E-457D-AA71-00C0AC3EA965}"/>
+                <a16:creationId xmlns:a16="http://schemas.microsoft.com/office/drawing/2014/main" id="{82C652DC-9A73-445E-8A69-0B139F8377A9}"/>
               </a:ext>
             </a:extLst>
           </p:cNvPr>
@@ -5377,7 +5377,7 @@
           <p:cNvPr id="6" name="stage-copy-0">
             <a:extLst xmlns:a="http://schemas.openxmlformats.org/drawingml/2006/main">
               <a:ext uri="{FF2B5EF4-FFF2-40B4-BE49-F238E27FC236}">
-                <a16:creationId xmlns:a16="http://schemas.microsoft.com/office/drawing/2014/main" id="{852060BF-CF99-4659-AA86-2D3F6BA352D5}"/>
+                <a16:creationId xmlns:a16="http://schemas.microsoft.com/office/drawing/2014/main" id="{819ACE5F-ED1F-44BC-9374-749CFBB30A2D}"/>
               </a:ext>
             </a:extLst>
           </p:cNvPr>
@@ -5437,7 +5437,7 @@
           <p:cNvPr id="7" name="stage-1">
             <a:extLst xmlns:a="http://schemas.openxmlformats.org/drawingml/2006/main">
               <a:ext uri="{FF2B5EF4-FFF2-40B4-BE49-F238E27FC236}">
-                <a16:creationId xmlns:a16="http://schemas.microsoft.com/office/drawing/2014/main" id="{8E971ECC-AA04-4CE8-A5C5-9E14D319584E}"/>
+                <a16:creationId xmlns:a16="http://schemas.microsoft.com/office/drawing/2014/main" id="{3789790A-97FC-4B03-A5C5-23C73F9950B3}"/>
               </a:ext>
             </a:extLst>
           </p:cNvPr>
@@ -5503,7 +5503,7 @@
           <p:cNvPr id="8" name="stage-copy-1">
             <a:extLst xmlns:a="http://schemas.openxmlformats.org/drawingml/2006/main">
               <a:ext uri="{FF2B5EF4-FFF2-40B4-BE49-F238E27FC236}">
-                <a16:creationId xmlns:a16="http://schemas.microsoft.com/office/drawing/2014/main" id="{B28E9019-FB79-4A00-91CB-81EC3C10B84D}"/>
+                <a16:creationId xmlns:a16="http://schemas.microsoft.com/office/drawing/2014/main" id="{9C86D73D-4E1D-447C-9205-F606B1719B8A}"/>
               </a:ext>
             </a:extLst>
           </p:cNvPr>
@@ -5563,7 +5563,7 @@
           <p:cNvPr id="9" name="stage-2">
             <a:extLst xmlns:a="http://schemas.openxmlformats.org/drawingml/2006/main">
               <a:ext uri="{FF2B5EF4-FFF2-40B4-BE49-F238E27FC236}">
-                <a16:creationId xmlns:a16="http://schemas.microsoft.com/office/drawing/2014/main" id="{519D7666-4C3E-4862-86CC-BA2E00A38420}"/>
+                <a16:creationId xmlns:a16="http://schemas.microsoft.com/office/drawing/2014/main" id="{7B57A912-E959-4287-A74C-340A66084057}"/>
               </a:ext>
             </a:extLst>
           </p:cNvPr>
@@ -5629,7 +5629,7 @@
           <p:cNvPr id="10" name="stage-copy-2">
             <a:extLst xmlns:a="http://schemas.openxmlformats.org/drawingml/2006/main">
               <a:ext uri="{FF2B5EF4-FFF2-40B4-BE49-F238E27FC236}">
-                <a16:creationId xmlns:a16="http://schemas.microsoft.com/office/drawing/2014/main" id="{10530289-1027-46FF-8A39-85AA5EF25E05}"/>
+                <a16:creationId xmlns:a16="http://schemas.microsoft.com/office/drawing/2014/main" id="{52CBEA84-3C9C-490E-B424-7D564401992F}"/>
               </a:ext>
             </a:extLst>
           </p:cNvPr>
@@ -5689,7 +5689,7 @@
           <p:cNvPr id="11" name="stage-3">
             <a:extLst xmlns:a="http://schemas.openxmlformats.org/drawingml/2006/main">
               <a:ext uri="{FF2B5EF4-FFF2-40B4-BE49-F238E27FC236}">
-                <a16:creationId xmlns:a16="http://schemas.microsoft.com/office/drawing/2014/main" id="{68CDF1C5-00E7-4811-BA78-FA243E26FA7C}"/>
+                <a16:creationId xmlns:a16="http://schemas.microsoft.com/office/drawing/2014/main" id="{9AFC72EF-E48D-4DE0-B62B-CDD7EA7508F5}"/>
               </a:ext>
             </a:extLst>
           </p:cNvPr>
@@ -5755,7 +5755,7 @@
           <p:cNvPr id="12" name="stage-copy-3">
             <a:extLst xmlns:a="http://schemas.openxmlformats.org/drawingml/2006/main">
               <a:ext uri="{FF2B5EF4-FFF2-40B4-BE49-F238E27FC236}">
-                <a16:creationId xmlns:a16="http://schemas.microsoft.com/office/drawing/2014/main" id="{E004CEA2-9842-40DD-89FC-B94795554964}"/>
+                <a16:creationId xmlns:a16="http://schemas.microsoft.com/office/drawing/2014/main" id="{AD5D175C-0A66-4614-91F4-14AFFA292C5D}"/>
               </a:ext>
             </a:extLst>
           </p:cNvPr>
@@ -5815,7 +5815,7 @@
           <p:cNvPr id="13" name="stage-4">
             <a:extLst xmlns:a="http://schemas.openxmlformats.org/drawingml/2006/main">
               <a:ext uri="{FF2B5EF4-FFF2-40B4-BE49-F238E27FC236}">
-                <a16:creationId xmlns:a16="http://schemas.microsoft.com/office/drawing/2014/main" id="{EFB34A3F-6B96-4436-B80B-6A836A4B70C6}"/>
+                <a16:creationId xmlns:a16="http://schemas.microsoft.com/office/drawing/2014/main" id="{D3EC1FD8-FC9C-4B22-A7FE-CBB07B707145}"/>
               </a:ext>
             </a:extLst>
           </p:cNvPr>
@@ -5881,7 +5881,7 @@
           <p:cNvPr id="14" name="stage-copy-4">
             <a:extLst xmlns:a="http://schemas.openxmlformats.org/drawingml/2006/main">
               <a:ext uri="{FF2B5EF4-FFF2-40B4-BE49-F238E27FC236}">
-                <a16:creationId xmlns:a16="http://schemas.microsoft.com/office/drawing/2014/main" id="{BE69C28E-9A40-4C9F-B7CF-DDC2CD41C092}"/>
+                <a16:creationId xmlns:a16="http://schemas.microsoft.com/office/drawing/2014/main" id="{C5624939-DC0B-4E65-B8F8-A052B7F3C724}"/>
               </a:ext>
             </a:extLst>
           </p:cNvPr>
@@ -5941,7 +5941,7 @@
           <p:cNvPr id="15" name="bottom">
             <a:extLst xmlns:a="http://schemas.openxmlformats.org/drawingml/2006/main">
               <a:ext uri="{FF2B5EF4-FFF2-40B4-BE49-F238E27FC236}">
-                <a16:creationId xmlns:a16="http://schemas.microsoft.com/office/drawing/2014/main" id="{B10EC172-6E45-41EF-8832-34F2E3200B81}"/>
+                <a16:creationId xmlns:a16="http://schemas.microsoft.com/office/drawing/2014/main" id="{AE5B018F-FE96-42B6-B251-CB200931C379}"/>
               </a:ext>
             </a:extLst>
           </p:cNvPr>
@@ -5999,7 +5999,7 @@
     </p:spTree>
     <p:extLst>
       <p:ext uri="{BB962C8B-B14F-4D97-AF65-F5344CB8AC3E}">
-        <p14:creationId xmlns:p14="http://schemas.microsoft.com/office/powerpoint/2010/main" val="1829455350"/>
+        <p14:creationId xmlns:p14="http://schemas.microsoft.com/office/powerpoint/2010/main" val="1613217493"/>
       </p:ext>
     </p:extLst>
   </p:cSld>
@@ -6030,7 +6030,7 @@
           <p:cNvPr id="1" name="eyebrow">
             <a:extLst xmlns:a="http://schemas.openxmlformats.org/drawingml/2006/main">
               <a:ext uri="{FF2B5EF4-FFF2-40B4-BE49-F238E27FC236}">
-                <a16:creationId xmlns:a16="http://schemas.microsoft.com/office/drawing/2014/main" id="{830E5021-DDD6-48E0-B1E1-EF9F60CAA028}"/>
+                <a16:creationId xmlns:a16="http://schemas.microsoft.com/office/drawing/2014/main" id="{3873F65D-0D75-4276-B68B-E5D66828D590}"/>
               </a:ext>
             </a:extLst>
           </p:cNvPr>
@@ -6090,7 +6090,7 @@
           <p:cNvPr id="2" name="title">
             <a:extLst xmlns:a="http://schemas.openxmlformats.org/drawingml/2006/main">
               <a:ext uri="{FF2B5EF4-FFF2-40B4-BE49-F238E27FC236}">
-                <a16:creationId xmlns:a16="http://schemas.microsoft.com/office/drawing/2014/main" id="{4212699F-F066-485D-9EA6-57351005F2E2}"/>
+                <a16:creationId xmlns:a16="http://schemas.microsoft.com/office/drawing/2014/main" id="{8A7B20CA-7731-4199-BED5-D8882055E40D}"/>
               </a:ext>
             </a:extLst>
           </p:cNvPr>
@@ -6150,7 +6150,7 @@
           <p:cNvPr id="3" name="footer">
             <a:extLst xmlns:a="http://schemas.openxmlformats.org/drawingml/2006/main">
               <a:ext uri="{FF2B5EF4-FFF2-40B4-BE49-F238E27FC236}">
-                <a16:creationId xmlns:a16="http://schemas.microsoft.com/office/drawing/2014/main" id="{80131DB6-57C9-414A-851A-A8467870F14E}"/>
+                <a16:creationId xmlns:a16="http://schemas.microsoft.com/office/drawing/2014/main" id="{AD5B80B1-BE17-4E52-A0FD-C57461D080B9}"/>
               </a:ext>
             </a:extLst>
           </p:cNvPr>
@@ -6210,7 +6210,7 @@
           <p:cNvPr id="4" name="line-0">
             <a:extLst xmlns:a="http://schemas.openxmlformats.org/drawingml/2006/main">
               <a:ext uri="{FF2B5EF4-FFF2-40B4-BE49-F238E27FC236}">
-                <a16:creationId xmlns:a16="http://schemas.microsoft.com/office/drawing/2014/main" id="{8D7659C7-B4D5-4401-8900-B38063B062FA}"/>
+                <a16:creationId xmlns:a16="http://schemas.microsoft.com/office/drawing/2014/main" id="{A625FB0A-829E-42FD-A201-DB6417627399}"/>
               </a:ext>
             </a:extLst>
           </p:cNvPr>
@@ -6241,7 +6241,7 @@
           <p:cNvPr id="5" name="line-1">
             <a:extLst xmlns:a="http://schemas.openxmlformats.org/drawingml/2006/main">
               <a:ext uri="{FF2B5EF4-FFF2-40B4-BE49-F238E27FC236}">
-                <a16:creationId xmlns:a16="http://schemas.microsoft.com/office/drawing/2014/main" id="{03292967-C8DF-4A6A-A2C0-5ABA7C306961}"/>
+                <a16:creationId xmlns:a16="http://schemas.microsoft.com/office/drawing/2014/main" id="{F5F7F8D5-A70A-4F1C-AB65-2F9D0302E3D1}"/>
               </a:ext>
             </a:extLst>
           </p:cNvPr>
@@ -6272,7 +6272,7 @@
           <p:cNvPr id="6" name="line-2">
             <a:extLst xmlns:a="http://schemas.openxmlformats.org/drawingml/2006/main">
               <a:ext uri="{FF2B5EF4-FFF2-40B4-BE49-F238E27FC236}">
-                <a16:creationId xmlns:a16="http://schemas.microsoft.com/office/drawing/2014/main" id="{C150FBAF-C4A9-4A78-B2A1-1BB27AEFE2E8}"/>
+                <a16:creationId xmlns:a16="http://schemas.microsoft.com/office/drawing/2014/main" id="{A60062EF-D09C-4824-8223-842699C9543A}"/>
               </a:ext>
             </a:extLst>
           </p:cNvPr>
@@ -6303,7 +6303,7 @@
           <p:cNvPr id="7" name="line-3">
             <a:extLst xmlns:a="http://schemas.openxmlformats.org/drawingml/2006/main">
               <a:ext uri="{FF2B5EF4-FFF2-40B4-BE49-F238E27FC236}">
-                <a16:creationId xmlns:a16="http://schemas.microsoft.com/office/drawing/2014/main" id="{85AE9446-0580-4FFA-A72E-2BAF25AEE910}"/>
+                <a16:creationId xmlns:a16="http://schemas.microsoft.com/office/drawing/2014/main" id="{C18C21A3-D212-449D-877E-59D86420E0C9}"/>
               </a:ext>
             </a:extLst>
           </p:cNvPr>
@@ -6334,7 +6334,7 @@
           <p:cNvPr id="8" name="line-4">
             <a:extLst xmlns:a="http://schemas.openxmlformats.org/drawingml/2006/main">
               <a:ext uri="{FF2B5EF4-FFF2-40B4-BE49-F238E27FC236}">
-                <a16:creationId xmlns:a16="http://schemas.microsoft.com/office/drawing/2014/main" id="{10F0CB5C-44A0-429A-82F6-8569EE87D50E}"/>
+                <a16:creationId xmlns:a16="http://schemas.microsoft.com/office/drawing/2014/main" id="{CC36A04C-627C-4788-83BC-C6FFACEDD793}"/>
               </a:ext>
             </a:extLst>
           </p:cNvPr>
@@ -6365,7 +6365,7 @@
           <p:cNvPr id="9" name="num-0">
             <a:extLst xmlns:a="http://schemas.openxmlformats.org/drawingml/2006/main">
               <a:ext uri="{FF2B5EF4-FFF2-40B4-BE49-F238E27FC236}">
-                <a16:creationId xmlns:a16="http://schemas.microsoft.com/office/drawing/2014/main" id="{0A0AC036-F6CB-4070-A75C-6C2AC6546777}"/>
+                <a16:creationId xmlns:a16="http://schemas.microsoft.com/office/drawing/2014/main" id="{6C0C35F8-BCAD-45DD-9AF9-809753670A9F}"/>
               </a:ext>
             </a:extLst>
           </p:cNvPr>
@@ -6431,7 +6431,7 @@
           <p:cNvPr id="10" name="step-0">
             <a:extLst xmlns:a="http://schemas.openxmlformats.org/drawingml/2006/main">
               <a:ext uri="{FF2B5EF4-FFF2-40B4-BE49-F238E27FC236}">
-                <a16:creationId xmlns:a16="http://schemas.microsoft.com/office/drawing/2014/main" id="{773B96D3-FDCA-4A5A-A5FB-4290FA705030}"/>
+                <a16:creationId xmlns:a16="http://schemas.microsoft.com/office/drawing/2014/main" id="{514D3379-D62E-4569-A955-7301161EFC79}"/>
               </a:ext>
             </a:extLst>
           </p:cNvPr>
@@ -6524,7 +6524,7 @@
           <p:cNvPr id="11" name="num-1">
             <a:extLst xmlns:a="http://schemas.openxmlformats.org/drawingml/2006/main">
               <a:ext uri="{FF2B5EF4-FFF2-40B4-BE49-F238E27FC236}">
-                <a16:creationId xmlns:a16="http://schemas.microsoft.com/office/drawing/2014/main" id="{5C6B9B70-D72D-4602-A833-4BB09B720AE6}"/>
+                <a16:creationId xmlns:a16="http://schemas.microsoft.com/office/drawing/2014/main" id="{0E451595-AA6E-47C0-80EB-F3AE4CC6E5FC}"/>
               </a:ext>
             </a:extLst>
           </p:cNvPr>
@@ -6590,7 +6590,7 @@
           <p:cNvPr id="12" name="step-1">
             <a:extLst xmlns:a="http://schemas.openxmlformats.org/drawingml/2006/main">
               <a:ext uri="{FF2B5EF4-FFF2-40B4-BE49-F238E27FC236}">
-                <a16:creationId xmlns:a16="http://schemas.microsoft.com/office/drawing/2014/main" id="{B5F7D58F-350F-4B6B-915C-04E14F60505C}"/>
+                <a16:creationId xmlns:a16="http://schemas.microsoft.com/office/drawing/2014/main" id="{57FA7106-4187-47EA-881E-9B89ADD78353}"/>
               </a:ext>
             </a:extLst>
           </p:cNvPr>
@@ -6683,7 +6683,7 @@
           <p:cNvPr id="13" name="num-2">
             <a:extLst xmlns:a="http://schemas.openxmlformats.org/drawingml/2006/main">
               <a:ext uri="{FF2B5EF4-FFF2-40B4-BE49-F238E27FC236}">
-                <a16:creationId xmlns:a16="http://schemas.microsoft.com/office/drawing/2014/main" id="{2256B3FA-A4C6-462A-8745-AE1393562FC3}"/>
+                <a16:creationId xmlns:a16="http://schemas.microsoft.com/office/drawing/2014/main" id="{87E81E2A-3BCF-4D3F-937D-7772D7CFE669}"/>
               </a:ext>
             </a:extLst>
           </p:cNvPr>
@@ -6749,7 +6749,7 @@
           <p:cNvPr id="14" name="step-2">
             <a:extLst xmlns:a="http://schemas.openxmlformats.org/drawingml/2006/main">
               <a:ext uri="{FF2B5EF4-FFF2-40B4-BE49-F238E27FC236}">
-                <a16:creationId xmlns:a16="http://schemas.microsoft.com/office/drawing/2014/main" id="{45D63865-9329-4AE6-A2C9-30464B47DEED}"/>
+                <a16:creationId xmlns:a16="http://schemas.microsoft.com/office/drawing/2014/main" id="{90C2DEF7-1291-4C4E-B44B-484B27AEB094}"/>
               </a:ext>
             </a:extLst>
           </p:cNvPr>
@@ -6842,7 +6842,7 @@
           <p:cNvPr id="15" name="num-3">
             <a:extLst xmlns:a="http://schemas.openxmlformats.org/drawingml/2006/main">
               <a:ext uri="{FF2B5EF4-FFF2-40B4-BE49-F238E27FC236}">
-                <a16:creationId xmlns:a16="http://schemas.microsoft.com/office/drawing/2014/main" id="{FF75A194-3F6F-49B5-B6E8-0A3F122D80CD}"/>
+                <a16:creationId xmlns:a16="http://schemas.microsoft.com/office/drawing/2014/main" id="{C12820C7-9ADF-4653-BA61-592234E7A7E5}"/>
               </a:ext>
             </a:extLst>
           </p:cNvPr>
@@ -6908,7 +6908,7 @@
           <p:cNvPr id="16" name="step-3">
             <a:extLst xmlns:a="http://schemas.openxmlformats.org/drawingml/2006/main">
               <a:ext uri="{FF2B5EF4-FFF2-40B4-BE49-F238E27FC236}">
-                <a16:creationId xmlns:a16="http://schemas.microsoft.com/office/drawing/2014/main" id="{45821D8B-3950-4653-AC05-F6F07F954607}"/>
+                <a16:creationId xmlns:a16="http://schemas.microsoft.com/office/drawing/2014/main" id="{06D3A420-7B53-4044-AAE2-E2B0E1B9EA90}"/>
               </a:ext>
             </a:extLst>
           </p:cNvPr>
@@ -7001,7 +7001,7 @@
           <p:cNvPr id="17" name="num-4">
             <a:extLst xmlns:a="http://schemas.openxmlformats.org/drawingml/2006/main">
               <a:ext uri="{FF2B5EF4-FFF2-40B4-BE49-F238E27FC236}">
-                <a16:creationId xmlns:a16="http://schemas.microsoft.com/office/drawing/2014/main" id="{73B538C9-A620-4E83-894B-81B7D6E6E3E9}"/>
+                <a16:creationId xmlns:a16="http://schemas.microsoft.com/office/drawing/2014/main" id="{C45485B8-F24F-473D-AF0F-25B21D660121}"/>
               </a:ext>
             </a:extLst>
           </p:cNvPr>
@@ -7067,7 +7067,7 @@
           <p:cNvPr id="18" name="step-4">
             <a:extLst xmlns:a="http://schemas.openxmlformats.org/drawingml/2006/main">
               <a:ext uri="{FF2B5EF4-FFF2-40B4-BE49-F238E27FC236}">
-                <a16:creationId xmlns:a16="http://schemas.microsoft.com/office/drawing/2014/main" id="{12208B21-2F73-44DD-A309-57D3B5A154BA}"/>
+                <a16:creationId xmlns:a16="http://schemas.microsoft.com/office/drawing/2014/main" id="{0EA171E2-8B59-4FCC-BF3D-45473CFE3366}"/>
               </a:ext>
             </a:extLst>
           </p:cNvPr>
@@ -7160,7 +7160,7 @@
           <p:cNvPr id="19" name="num-5">
             <a:extLst xmlns:a="http://schemas.openxmlformats.org/drawingml/2006/main">
               <a:ext uri="{FF2B5EF4-FFF2-40B4-BE49-F238E27FC236}">
-                <a16:creationId xmlns:a16="http://schemas.microsoft.com/office/drawing/2014/main" id="{616627E2-E02F-4BDD-BBC7-C8CFD3E7BE29}"/>
+                <a16:creationId xmlns:a16="http://schemas.microsoft.com/office/drawing/2014/main" id="{683BA996-C4A3-484B-8B7F-84CF007A9EAD}"/>
               </a:ext>
             </a:extLst>
           </p:cNvPr>
@@ -7226,7 +7226,7 @@
           <p:cNvPr id="20" name="step-5">
             <a:extLst xmlns:a="http://schemas.openxmlformats.org/drawingml/2006/main">
               <a:ext uri="{FF2B5EF4-FFF2-40B4-BE49-F238E27FC236}">
-                <a16:creationId xmlns:a16="http://schemas.microsoft.com/office/drawing/2014/main" id="{A67E393C-7A71-4AC6-B118-0ACCD2F47681}"/>
+                <a16:creationId xmlns:a16="http://schemas.microsoft.com/office/drawing/2014/main" id="{DE269D3D-5EE1-4699-907F-FA25C0D28489}"/>
               </a:ext>
             </a:extLst>
           </p:cNvPr>
@@ -7319,7 +7319,7 @@
           <p:cNvPr id="21" name="rule">
             <a:extLst xmlns:a="http://schemas.openxmlformats.org/drawingml/2006/main">
               <a:ext uri="{FF2B5EF4-FFF2-40B4-BE49-F238E27FC236}">
-                <a16:creationId xmlns:a16="http://schemas.microsoft.com/office/drawing/2014/main" id="{E8B7DBC4-7810-4EA7-9356-DF687F12914C}"/>
+                <a16:creationId xmlns:a16="http://schemas.microsoft.com/office/drawing/2014/main" id="{CB7D4006-7E77-44BA-A059-610E0080A042}"/>
               </a:ext>
             </a:extLst>
           </p:cNvPr>
@@ -7354,7 +7354,7 @@
           <p:cNvPr id="22" name="rule-text">
             <a:extLst xmlns:a="http://schemas.openxmlformats.org/drawingml/2006/main">
               <a:ext uri="{FF2B5EF4-FFF2-40B4-BE49-F238E27FC236}">
-                <a16:creationId xmlns:a16="http://schemas.microsoft.com/office/drawing/2014/main" id="{768FD8C5-BE63-41B4-BC17-1AAA4275ACF7}"/>
+                <a16:creationId xmlns:a16="http://schemas.microsoft.com/office/drawing/2014/main" id="{3C6A499A-B955-4F2B-AC57-D8C9F7D62614}"/>
               </a:ext>
             </a:extLst>
           </p:cNvPr>
@@ -7412,7 +7412,7 @@
     </p:spTree>
     <p:extLst>
       <p:ext uri="{BB962C8B-B14F-4D97-AF65-F5344CB8AC3E}">
-        <p14:creationId xmlns:p14="http://schemas.microsoft.com/office/powerpoint/2010/main" val="1876063752"/>
+        <p14:creationId xmlns:p14="http://schemas.microsoft.com/office/powerpoint/2010/main" val="231093349"/>
       </p:ext>
     </p:extLst>
   </p:cSld>
@@ -7443,7 +7443,7 @@
           <p:cNvPr id="1" name="eyebrow">
             <a:extLst xmlns:a="http://schemas.openxmlformats.org/drawingml/2006/main">
               <a:ext uri="{FF2B5EF4-FFF2-40B4-BE49-F238E27FC236}">
-                <a16:creationId xmlns:a16="http://schemas.microsoft.com/office/drawing/2014/main" id="{F52B172E-609B-4FC5-832B-BBCB56131604}"/>
+                <a16:creationId xmlns:a16="http://schemas.microsoft.com/office/drawing/2014/main" id="{4BCEADA6-5B25-4959-A766-B891B49F7798}"/>
               </a:ext>
             </a:extLst>
           </p:cNvPr>
@@ -7503,7 +7503,7 @@
           <p:cNvPr id="2" name="title">
             <a:extLst xmlns:a="http://schemas.openxmlformats.org/drawingml/2006/main">
               <a:ext uri="{FF2B5EF4-FFF2-40B4-BE49-F238E27FC236}">
-                <a16:creationId xmlns:a16="http://schemas.microsoft.com/office/drawing/2014/main" id="{3DD72FB6-8C75-4B70-93E8-D9C146498C58}"/>
+                <a16:creationId xmlns:a16="http://schemas.microsoft.com/office/drawing/2014/main" id="{758E14B5-E994-490D-8B5E-6B6BF771AD06}"/>
               </a:ext>
             </a:extLst>
           </p:cNvPr>
@@ -7563,7 +7563,7 @@
           <p:cNvPr id="3" name="footer">
             <a:extLst xmlns:a="http://schemas.openxmlformats.org/drawingml/2006/main">
               <a:ext uri="{FF2B5EF4-FFF2-40B4-BE49-F238E27FC236}">
-                <a16:creationId xmlns:a16="http://schemas.microsoft.com/office/drawing/2014/main" id="{6D4692DA-A00E-4BB8-80BE-E158544E5437}"/>
+                <a16:creationId xmlns:a16="http://schemas.microsoft.com/office/drawing/2014/main" id="{159A4D74-6E27-4A2E-8687-DB457017137C}"/>
               </a:ext>
             </a:extLst>
           </p:cNvPr>
@@ -7623,7 +7623,7 @@
           <p:cNvPr id="4" name="matrix">
             <a:extLst xmlns:a="http://schemas.openxmlformats.org/drawingml/2006/main">
               <a:ext uri="{FF2B5EF4-FFF2-40B4-BE49-F238E27FC236}">
-                <a16:creationId xmlns:a16="http://schemas.microsoft.com/office/drawing/2014/main" id="{ABCC3D18-9E92-439C-84CA-41DC34CEFD2E}"/>
+                <a16:creationId xmlns:a16="http://schemas.microsoft.com/office/drawing/2014/main" id="{4072E74B-5417-401B-AD31-013978FA5C47}"/>
               </a:ext>
             </a:extLst>
           </p:cNvPr>
@@ -7658,7 +7658,7 @@
           <p:cNvPr id="5" name="vline">
             <a:extLst xmlns:a="http://schemas.openxmlformats.org/drawingml/2006/main">
               <a:ext uri="{FF2B5EF4-FFF2-40B4-BE49-F238E27FC236}">
-                <a16:creationId xmlns:a16="http://schemas.microsoft.com/office/drawing/2014/main" id="{A7C7AB9B-8603-4C71-998B-B38953627686}"/>
+                <a16:creationId xmlns:a16="http://schemas.microsoft.com/office/drawing/2014/main" id="{2C27E62B-1A6D-4BC6-8EFD-D3CC526D5B1C}"/>
               </a:ext>
             </a:extLst>
           </p:cNvPr>
@@ -7689,7 +7689,7 @@
           <p:cNvPr id="6" name="hline">
             <a:extLst xmlns:a="http://schemas.openxmlformats.org/drawingml/2006/main">
               <a:ext uri="{FF2B5EF4-FFF2-40B4-BE49-F238E27FC236}">
-                <a16:creationId xmlns:a16="http://schemas.microsoft.com/office/drawing/2014/main" id="{224EA204-4209-4F09-9E0B-D942FBE4ACD3}"/>
+                <a16:creationId xmlns:a16="http://schemas.microsoft.com/office/drawing/2014/main" id="{0AA4EBFB-932C-4E3A-A06B-D0F809F1A82F}"/>
               </a:ext>
             </a:extLst>
           </p:cNvPr>
@@ -7720,7 +7720,7 @@
           <p:cNvPr id="7" name="axis-x">
             <a:extLst xmlns:a="http://schemas.openxmlformats.org/drawingml/2006/main">
               <a:ext uri="{FF2B5EF4-FFF2-40B4-BE49-F238E27FC236}">
-                <a16:creationId xmlns:a16="http://schemas.microsoft.com/office/drawing/2014/main" id="{27EC3681-8EB1-4809-99F9-E6E9CAA68D5C}"/>
+                <a16:creationId xmlns:a16="http://schemas.microsoft.com/office/drawing/2014/main" id="{FB508457-1009-4724-967C-17D56FCAABEC}"/>
               </a:ext>
             </a:extLst>
           </p:cNvPr>
@@ -7780,7 +7780,7 @@
           <p:cNvPr id="8" name="axis-y">
             <a:extLst xmlns:a="http://schemas.openxmlformats.org/drawingml/2006/main">
               <a:ext uri="{FF2B5EF4-FFF2-40B4-BE49-F238E27FC236}">
-                <a16:creationId xmlns:a16="http://schemas.microsoft.com/office/drawing/2014/main" id="{DAC3022A-2149-417D-B614-63FC09B8D8A9}"/>
+                <a16:creationId xmlns:a16="http://schemas.microsoft.com/office/drawing/2014/main" id="{8DBDC652-CB59-44F4-9CC8-58B732E1C229}"/>
               </a:ext>
             </a:extLst>
           </p:cNvPr>
@@ -7840,7 +7840,7 @@
           <p:cNvPr id="9" name="q1">
             <a:extLst xmlns:a="http://schemas.openxmlformats.org/drawingml/2006/main">
               <a:ext uri="{FF2B5EF4-FFF2-40B4-BE49-F238E27FC236}">
-                <a16:creationId xmlns:a16="http://schemas.microsoft.com/office/drawing/2014/main" id="{9B2D6D5E-328A-4AF3-96C0-77D41130385A}"/>
+                <a16:creationId xmlns:a16="http://schemas.microsoft.com/office/drawing/2014/main" id="{91FE5033-DC80-45E1-9C92-A777A3FC1719}"/>
               </a:ext>
             </a:extLst>
           </p:cNvPr>
@@ -7927,7 +7927,7 @@
           <p:cNvPr id="10" name="q2">
             <a:extLst xmlns:a="http://schemas.openxmlformats.org/drawingml/2006/main">
               <a:ext uri="{FF2B5EF4-FFF2-40B4-BE49-F238E27FC236}">
-                <a16:creationId xmlns:a16="http://schemas.microsoft.com/office/drawing/2014/main" id="{35FC1E99-5D49-47DA-9417-6E1BC15504EC}"/>
+                <a16:creationId xmlns:a16="http://schemas.microsoft.com/office/drawing/2014/main" id="{4C8D0BE3-36E3-4DE9-800A-C22B6F76444D}"/>
               </a:ext>
             </a:extLst>
           </p:cNvPr>
@@ -8014,7 +8014,7 @@
           <p:cNvPr id="11" name="q3">
             <a:extLst xmlns:a="http://schemas.openxmlformats.org/drawingml/2006/main">
               <a:ext uri="{FF2B5EF4-FFF2-40B4-BE49-F238E27FC236}">
-                <a16:creationId xmlns:a16="http://schemas.microsoft.com/office/drawing/2014/main" id="{EF9D95CD-4560-473C-8010-8BF49C6DB225}"/>
+                <a16:creationId xmlns:a16="http://schemas.microsoft.com/office/drawing/2014/main" id="{69E1B25D-7DF5-4DB6-9C8A-F4AA2DB7CFF3}"/>
               </a:ext>
             </a:extLst>
           </p:cNvPr>
@@ -8101,7 +8101,7 @@
           <p:cNvPr id="12" name="q4">
             <a:extLst xmlns:a="http://schemas.openxmlformats.org/drawingml/2006/main">
               <a:ext uri="{FF2B5EF4-FFF2-40B4-BE49-F238E27FC236}">
-                <a16:creationId xmlns:a16="http://schemas.microsoft.com/office/drawing/2014/main" id="{E711DA10-6FD7-4020-9829-237407B14451}"/>
+                <a16:creationId xmlns:a16="http://schemas.microsoft.com/office/drawing/2014/main" id="{E85A52A5-496B-4BBF-9783-FDF97FD21A15}"/>
               </a:ext>
             </a:extLst>
           </p:cNvPr>
@@ -8215,7 +8215,7 @@
           <p:cNvPr id="13" name="matrix-note">
             <a:extLst xmlns:a="http://schemas.openxmlformats.org/drawingml/2006/main">
               <a:ext uri="{FF2B5EF4-FFF2-40B4-BE49-F238E27FC236}">
-                <a16:creationId xmlns:a16="http://schemas.microsoft.com/office/drawing/2014/main" id="{85778698-5AD6-4814-AB61-C1ADF11357C3}"/>
+                <a16:creationId xmlns:a16="http://schemas.microsoft.com/office/drawing/2014/main" id="{228D6B37-03E6-4525-A54A-491FEA3106E1}"/>
               </a:ext>
             </a:extLst>
           </p:cNvPr>
@@ -8273,7 +8273,7 @@
     </p:spTree>
     <p:extLst>
       <p:ext uri="{BB962C8B-B14F-4D97-AF65-F5344CB8AC3E}">
-        <p14:creationId xmlns:p14="http://schemas.microsoft.com/office/powerpoint/2010/main" val="150224148"/>
+        <p14:creationId xmlns:p14="http://schemas.microsoft.com/office/powerpoint/2010/main" val="1809874187"/>
       </p:ext>
     </p:extLst>
   </p:cSld>
@@ -8304,7 +8304,7 @@
           <p:cNvPr id="1" name="eyebrow">
             <a:extLst xmlns:a="http://schemas.openxmlformats.org/drawingml/2006/main">
               <a:ext uri="{FF2B5EF4-FFF2-40B4-BE49-F238E27FC236}">
-                <a16:creationId xmlns:a16="http://schemas.microsoft.com/office/drawing/2014/main" id="{26A7ADB0-9407-408A-A920-351B58D11E88}"/>
+                <a16:creationId xmlns:a16="http://schemas.microsoft.com/office/drawing/2014/main" id="{8F645678-2424-4024-AF2B-4D1B098B883F}"/>
               </a:ext>
             </a:extLst>
           </p:cNvPr>
@@ -8364,7 +8364,7 @@
           <p:cNvPr id="2" name="title">
             <a:extLst xmlns:a="http://schemas.openxmlformats.org/drawingml/2006/main">
               <a:ext uri="{FF2B5EF4-FFF2-40B4-BE49-F238E27FC236}">
-                <a16:creationId xmlns:a16="http://schemas.microsoft.com/office/drawing/2014/main" id="{791F5ABE-68E5-4B9A-A320-52CE3D9427CC}"/>
+                <a16:creationId xmlns:a16="http://schemas.microsoft.com/office/drawing/2014/main" id="{D083FD36-02CC-487A-8BB1-1FE377C2C062}"/>
               </a:ext>
             </a:extLst>
           </p:cNvPr>
@@ -8424,7 +8424,7 @@
           <p:cNvPr id="3" name="footer">
             <a:extLst xmlns:a="http://schemas.openxmlformats.org/drawingml/2006/main">
               <a:ext uri="{FF2B5EF4-FFF2-40B4-BE49-F238E27FC236}">
-                <a16:creationId xmlns:a16="http://schemas.microsoft.com/office/drawing/2014/main" id="{610D2E11-6D01-4641-B73A-AB0C8B1DFF90}"/>
+                <a16:creationId xmlns:a16="http://schemas.microsoft.com/office/drawing/2014/main" id="{18C49F8E-9A71-4254-BD3D-8A312B268BC4}"/>
               </a:ext>
             </a:extLst>
           </p:cNvPr>
@@ -8484,7 +8484,7 @@
           <p:cNvPr id="4" name="tool-0">
             <a:extLst xmlns:a="http://schemas.openxmlformats.org/drawingml/2006/main">
               <a:ext uri="{FF2B5EF4-FFF2-40B4-BE49-F238E27FC236}">
-                <a16:creationId xmlns:a16="http://schemas.microsoft.com/office/drawing/2014/main" id="{48B4ABA1-5B7B-49E3-9FBB-D09E5D21A89C}"/>
+                <a16:creationId xmlns:a16="http://schemas.microsoft.com/office/drawing/2014/main" id="{8CBFEB67-84AC-420D-A04A-E4FD4FA53C5F}"/>
               </a:ext>
             </a:extLst>
           </p:cNvPr>
@@ -8550,7 +8550,7 @@
           <p:cNvPr id="5" name="use-0">
             <a:extLst xmlns:a="http://schemas.openxmlformats.org/drawingml/2006/main">
               <a:ext uri="{FF2B5EF4-FFF2-40B4-BE49-F238E27FC236}">
-                <a16:creationId xmlns:a16="http://schemas.microsoft.com/office/drawing/2014/main" id="{160CC4D9-B776-4345-83F2-43630C1C7ED5}"/>
+                <a16:creationId xmlns:a16="http://schemas.microsoft.com/office/drawing/2014/main" id="{2F99D07B-6060-4082-8C70-6F9594117E5B}"/>
               </a:ext>
             </a:extLst>
           </p:cNvPr>
@@ -8610,7 +8610,7 @@
           <p:cNvPr id="6" name="link-0">
             <a:extLst xmlns:a="http://schemas.openxmlformats.org/drawingml/2006/main">
               <a:ext uri="{FF2B5EF4-FFF2-40B4-BE49-F238E27FC236}">
-                <a16:creationId xmlns:a16="http://schemas.microsoft.com/office/drawing/2014/main" id="{436DF510-1340-4C6A-BFBC-97C0B296E1A4}"/>
+                <a16:creationId xmlns:a16="http://schemas.microsoft.com/office/drawing/2014/main" id="{02387425-2FD9-46A1-9616-29DB4B7627A0}"/>
               </a:ext>
             </a:extLst>
           </p:cNvPr>
@@ -8641,7 +8641,7 @@
           <p:cNvPr id="7" name="tool-1">
             <a:extLst xmlns:a="http://schemas.openxmlformats.org/drawingml/2006/main">
               <a:ext uri="{FF2B5EF4-FFF2-40B4-BE49-F238E27FC236}">
-                <a16:creationId xmlns:a16="http://schemas.microsoft.com/office/drawing/2014/main" id="{94217751-02A7-4CF9-AB8D-17434E8AC879}"/>
+                <a16:creationId xmlns:a16="http://schemas.microsoft.com/office/drawing/2014/main" id="{971045DF-5B83-4273-9F96-0A88A4BC4B58}"/>
               </a:ext>
             </a:extLst>
           </p:cNvPr>
@@ -8707,7 +8707,7 @@
           <p:cNvPr id="8" name="use-1">
             <a:extLst xmlns:a="http://schemas.openxmlformats.org/drawingml/2006/main">
               <a:ext uri="{FF2B5EF4-FFF2-40B4-BE49-F238E27FC236}">
-                <a16:creationId xmlns:a16="http://schemas.microsoft.com/office/drawing/2014/main" id="{40DF01EF-D90C-4AEC-BEA4-8785A49F0156}"/>
+                <a16:creationId xmlns:a16="http://schemas.microsoft.com/office/drawing/2014/main" id="{14F17394-A2F7-4BF2-8497-00254404A101}"/>
               </a:ext>
             </a:extLst>
           </p:cNvPr>
@@ -8767,7 +8767,7 @@
           <p:cNvPr id="9" name="link-1">
             <a:extLst xmlns:a="http://schemas.openxmlformats.org/drawingml/2006/main">
               <a:ext uri="{FF2B5EF4-FFF2-40B4-BE49-F238E27FC236}">
-                <a16:creationId xmlns:a16="http://schemas.microsoft.com/office/drawing/2014/main" id="{7C2C8E0E-00C7-412D-8C98-3A80AA97A5B1}"/>
+                <a16:creationId xmlns:a16="http://schemas.microsoft.com/office/drawing/2014/main" id="{D243AD1D-7510-47DF-B578-F5164E71C12D}"/>
               </a:ext>
             </a:extLst>
           </p:cNvPr>
@@ -8798,7 +8798,7 @@
           <p:cNvPr id="10" name="tool-2">
             <a:extLst xmlns:a="http://schemas.openxmlformats.org/drawingml/2006/main">
               <a:ext uri="{FF2B5EF4-FFF2-40B4-BE49-F238E27FC236}">
-                <a16:creationId xmlns:a16="http://schemas.microsoft.com/office/drawing/2014/main" id="{34BC0A23-45B1-45D9-B73F-A1675453B557}"/>
+                <a16:creationId xmlns:a16="http://schemas.microsoft.com/office/drawing/2014/main" id="{A66BC897-1025-4943-A77A-5DDDC5A66236}"/>
               </a:ext>
             </a:extLst>
           </p:cNvPr>
@@ -8864,7 +8864,7 @@
           <p:cNvPr id="11" name="use-2">
             <a:extLst xmlns:a="http://schemas.openxmlformats.org/drawingml/2006/main">
               <a:ext uri="{FF2B5EF4-FFF2-40B4-BE49-F238E27FC236}">
-                <a16:creationId xmlns:a16="http://schemas.microsoft.com/office/drawing/2014/main" id="{75CA1D01-14CC-431E-8A31-97DE097AFE31}"/>
+                <a16:creationId xmlns:a16="http://schemas.microsoft.com/office/drawing/2014/main" id="{EB348030-5F15-419E-8CFB-5A7895D1F6F5}"/>
               </a:ext>
             </a:extLst>
           </p:cNvPr>
@@ -8924,7 +8924,7 @@
           <p:cNvPr id="12" name="link-2">
             <a:extLst xmlns:a="http://schemas.openxmlformats.org/drawingml/2006/main">
               <a:ext uri="{FF2B5EF4-FFF2-40B4-BE49-F238E27FC236}">
-                <a16:creationId xmlns:a16="http://schemas.microsoft.com/office/drawing/2014/main" id="{20AE8DC0-9BAA-4632-AF91-D0D3EE37E38C}"/>
+                <a16:creationId xmlns:a16="http://schemas.microsoft.com/office/drawing/2014/main" id="{49714164-64AA-4BF2-93B5-9891330E158F}"/>
               </a:ext>
             </a:extLst>
           </p:cNvPr>
@@ -8955,7 +8955,7 @@
           <p:cNvPr id="13" name="tool-3">
             <a:extLst xmlns:a="http://schemas.openxmlformats.org/drawingml/2006/main">
               <a:ext uri="{FF2B5EF4-FFF2-40B4-BE49-F238E27FC236}">
-                <a16:creationId xmlns:a16="http://schemas.microsoft.com/office/drawing/2014/main" id="{F7F97BE2-224F-4AE0-8B84-8033BB890528}"/>
+                <a16:creationId xmlns:a16="http://schemas.microsoft.com/office/drawing/2014/main" id="{22A90528-6AAD-4D50-8BAA-C208ACB6B292}"/>
               </a:ext>
             </a:extLst>
           </p:cNvPr>
@@ -9021,7 +9021,7 @@
           <p:cNvPr id="14" name="use-3">
             <a:extLst xmlns:a="http://schemas.openxmlformats.org/drawingml/2006/main">
               <a:ext uri="{FF2B5EF4-FFF2-40B4-BE49-F238E27FC236}">
-                <a16:creationId xmlns:a16="http://schemas.microsoft.com/office/drawing/2014/main" id="{A59B5A73-8F87-44D9-B656-6D7B2DE06285}"/>
+                <a16:creationId xmlns:a16="http://schemas.microsoft.com/office/drawing/2014/main" id="{01CCB798-265E-41C6-858C-83B398B5CBFD}"/>
               </a:ext>
             </a:extLst>
           </p:cNvPr>
@@ -9081,7 +9081,7 @@
           <p:cNvPr id="15" name="link-3">
             <a:extLst xmlns:a="http://schemas.openxmlformats.org/drawingml/2006/main">
               <a:ext uri="{FF2B5EF4-FFF2-40B4-BE49-F238E27FC236}">
-                <a16:creationId xmlns:a16="http://schemas.microsoft.com/office/drawing/2014/main" id="{D8AEBEA2-439F-4BC8-B27A-1D6456D63336}"/>
+                <a16:creationId xmlns:a16="http://schemas.microsoft.com/office/drawing/2014/main" id="{058DC07F-97F7-43B4-992B-272CF2128469}"/>
               </a:ext>
             </a:extLst>
           </p:cNvPr>
@@ -9112,7 +9112,7 @@
           <p:cNvPr id="16" name="tool-4">
             <a:extLst xmlns:a="http://schemas.openxmlformats.org/drawingml/2006/main">
               <a:ext uri="{FF2B5EF4-FFF2-40B4-BE49-F238E27FC236}">
-                <a16:creationId xmlns:a16="http://schemas.microsoft.com/office/drawing/2014/main" id="{91DD2682-F6D2-486F-8D87-1B169F520DBC}"/>
+                <a16:creationId xmlns:a16="http://schemas.microsoft.com/office/drawing/2014/main" id="{9692B239-8202-4D81-976E-957B3F4A2C6B}"/>
               </a:ext>
             </a:extLst>
           </p:cNvPr>
@@ -9178,7 +9178,7 @@
           <p:cNvPr id="17" name="use-4">
             <a:extLst xmlns:a="http://schemas.openxmlformats.org/drawingml/2006/main">
               <a:ext uri="{FF2B5EF4-FFF2-40B4-BE49-F238E27FC236}">
-                <a16:creationId xmlns:a16="http://schemas.microsoft.com/office/drawing/2014/main" id="{5A726309-9260-4357-A87A-F55D0D043FF6}"/>
+                <a16:creationId xmlns:a16="http://schemas.microsoft.com/office/drawing/2014/main" id="{473F88D1-C91A-48B0-9D5F-3B0FE1831362}"/>
               </a:ext>
             </a:extLst>
           </p:cNvPr>
@@ -9238,7 +9238,7 @@
           <p:cNvPr id="18" name="link-4">
             <a:extLst xmlns:a="http://schemas.openxmlformats.org/drawingml/2006/main">
               <a:ext uri="{FF2B5EF4-FFF2-40B4-BE49-F238E27FC236}">
-                <a16:creationId xmlns:a16="http://schemas.microsoft.com/office/drawing/2014/main" id="{BC75A1EB-9D6E-4174-87F5-CD13C251EA69}"/>
+                <a16:creationId xmlns:a16="http://schemas.microsoft.com/office/drawing/2014/main" id="{B2934B44-9503-4874-8F59-86802C07CFB4}"/>
               </a:ext>
             </a:extLst>
           </p:cNvPr>
@@ -9269,7 +9269,7 @@
           <p:cNvPr id="19" name="bottom">
             <a:extLst xmlns:a="http://schemas.openxmlformats.org/drawingml/2006/main">
               <a:ext uri="{FF2B5EF4-FFF2-40B4-BE49-F238E27FC236}">
-                <a16:creationId xmlns:a16="http://schemas.microsoft.com/office/drawing/2014/main" id="{2F92256B-CD69-4EBF-8CBB-51CCCB39E784}"/>
+                <a16:creationId xmlns:a16="http://schemas.microsoft.com/office/drawing/2014/main" id="{5B14CE68-0087-4EE5-95DC-A95F1D7D8FF9}"/>
               </a:ext>
             </a:extLst>
           </p:cNvPr>
@@ -9327,7 +9327,7 @@
     </p:spTree>
     <p:extLst>
       <p:ext uri="{BB962C8B-B14F-4D97-AF65-F5344CB8AC3E}">
-        <p14:creationId xmlns:p14="http://schemas.microsoft.com/office/powerpoint/2010/main" val="1776431132"/>
+        <p14:creationId xmlns:p14="http://schemas.microsoft.com/office/powerpoint/2010/main" val="209524692"/>
       </p:ext>
     </p:extLst>
   </p:cSld>
@@ -9358,7 +9358,7 @@
           <p:cNvPr id="1" name="eyebrow">
             <a:extLst xmlns:a="http://schemas.openxmlformats.org/drawingml/2006/main">
               <a:ext uri="{FF2B5EF4-FFF2-40B4-BE49-F238E27FC236}">
-                <a16:creationId xmlns:a16="http://schemas.microsoft.com/office/drawing/2014/main" id="{64B097F6-3488-448A-B50A-B50E79C8495F}"/>
+                <a16:creationId xmlns:a16="http://schemas.microsoft.com/office/drawing/2014/main" id="{822ADEAE-47F2-4EE2-9DFB-28AD91E8C137}"/>
               </a:ext>
             </a:extLst>
           </p:cNvPr>
@@ -9418,7 +9418,7 @@
           <p:cNvPr id="2" name="title">
             <a:extLst xmlns:a="http://schemas.openxmlformats.org/drawingml/2006/main">
               <a:ext uri="{FF2B5EF4-FFF2-40B4-BE49-F238E27FC236}">
-                <a16:creationId xmlns:a16="http://schemas.microsoft.com/office/drawing/2014/main" id="{D7AB5201-0936-487D-AE4F-474D6E0CE6C7}"/>
+                <a16:creationId xmlns:a16="http://schemas.microsoft.com/office/drawing/2014/main" id="{D268F20F-BF3B-4B4A-ACB8-FB4E4751D292}"/>
               </a:ext>
             </a:extLst>
           </p:cNvPr>
@@ -9478,7 +9478,7 @@
           <p:cNvPr id="3" name="footer">
             <a:extLst xmlns:a="http://schemas.openxmlformats.org/drawingml/2006/main">
               <a:ext uri="{FF2B5EF4-FFF2-40B4-BE49-F238E27FC236}">
-                <a16:creationId xmlns:a16="http://schemas.microsoft.com/office/drawing/2014/main" id="{8C2DFA41-2F2B-4C51-9114-99E2E6C2B82C}"/>
+                <a16:creationId xmlns:a16="http://schemas.microsoft.com/office/drawing/2014/main" id="{14BF2834-6073-4979-A78D-5CF5FB1FC522}"/>
               </a:ext>
             </a:extLst>
           </p:cNvPr>
@@ -9538,7 +9538,7 @@
           <p:cNvPr id="4" name="flow">
             <a:extLst xmlns:a="http://schemas.openxmlformats.org/drawingml/2006/main">
               <a:ext uri="{FF2B5EF4-FFF2-40B4-BE49-F238E27FC236}">
-                <a16:creationId xmlns:a16="http://schemas.microsoft.com/office/drawing/2014/main" id="{DD726F2B-A135-49D2-9C59-7A5A3B2EECCA}"/>
+                <a16:creationId xmlns:a16="http://schemas.microsoft.com/office/drawing/2014/main" id="{34E912AF-B457-4F6E-A1B3-28BCD2ECD535}"/>
               </a:ext>
             </a:extLst>
           </p:cNvPr>
@@ -9569,7 +9569,7 @@
           <p:cNvPr id="5" name="step-0">
             <a:extLst xmlns:a="http://schemas.openxmlformats.org/drawingml/2006/main">
               <a:ext uri="{FF2B5EF4-FFF2-40B4-BE49-F238E27FC236}">
-                <a16:creationId xmlns:a16="http://schemas.microsoft.com/office/drawing/2014/main" id="{3C60CD24-E9B5-42D9-9B3F-E616E7A96F37}"/>
+                <a16:creationId xmlns:a16="http://schemas.microsoft.com/office/drawing/2014/main" id="{DCC69FA5-C3DF-43F8-98F5-63A44A67102C}"/>
               </a:ext>
             </a:extLst>
           </p:cNvPr>
@@ -9635,7 +9635,7 @@
           <p:cNvPr id="6" name="copy-0">
             <a:extLst xmlns:a="http://schemas.openxmlformats.org/drawingml/2006/main">
               <a:ext uri="{FF2B5EF4-FFF2-40B4-BE49-F238E27FC236}">
-                <a16:creationId xmlns:a16="http://schemas.microsoft.com/office/drawing/2014/main" id="{5D446AC8-4E14-415A-8035-F9A2EAA5A5AF}"/>
+                <a16:creationId xmlns:a16="http://schemas.microsoft.com/office/drawing/2014/main" id="{01EC1A83-8195-4F22-BB97-BF695A56DE7F}"/>
               </a:ext>
             </a:extLst>
           </p:cNvPr>
@@ -9695,7 +9695,7 @@
           <p:cNvPr id="7" name="step-1">
             <a:extLst xmlns:a="http://schemas.openxmlformats.org/drawingml/2006/main">
               <a:ext uri="{FF2B5EF4-FFF2-40B4-BE49-F238E27FC236}">
-                <a16:creationId xmlns:a16="http://schemas.microsoft.com/office/drawing/2014/main" id="{83F0B283-D681-4435-9012-19F34225056C}"/>
+                <a16:creationId xmlns:a16="http://schemas.microsoft.com/office/drawing/2014/main" id="{B23C51CC-FA48-4DEA-840C-44A2C09E38D9}"/>
               </a:ext>
             </a:extLst>
           </p:cNvPr>
@@ -9761,7 +9761,7 @@
           <p:cNvPr id="8" name="copy-1">
             <a:extLst xmlns:a="http://schemas.openxmlformats.org/drawingml/2006/main">
               <a:ext uri="{FF2B5EF4-FFF2-40B4-BE49-F238E27FC236}">
-                <a16:creationId xmlns:a16="http://schemas.microsoft.com/office/drawing/2014/main" id="{B217CCD6-7DA8-4034-9709-E716FDBC1C1F}"/>
+                <a16:creationId xmlns:a16="http://schemas.microsoft.com/office/drawing/2014/main" id="{384CB38C-C146-49D9-B63A-8A56DADBECA4}"/>
               </a:ext>
             </a:extLst>
           </p:cNvPr>
@@ -9821,7 +9821,7 @@
           <p:cNvPr id="9" name="step-2">
             <a:extLst xmlns:a="http://schemas.openxmlformats.org/drawingml/2006/main">
               <a:ext uri="{FF2B5EF4-FFF2-40B4-BE49-F238E27FC236}">
-                <a16:creationId xmlns:a16="http://schemas.microsoft.com/office/drawing/2014/main" id="{5C8220EF-DFF0-47B3-851A-D11A04A19EAC}"/>
+                <a16:creationId xmlns:a16="http://schemas.microsoft.com/office/drawing/2014/main" id="{26E84632-307E-46AA-A2EA-82EED3BF22C3}"/>
               </a:ext>
             </a:extLst>
           </p:cNvPr>
@@ -9887,7 +9887,7 @@
           <p:cNvPr id="10" name="copy-2">
             <a:extLst xmlns:a="http://schemas.openxmlformats.org/drawingml/2006/main">
               <a:ext uri="{FF2B5EF4-FFF2-40B4-BE49-F238E27FC236}">
-                <a16:creationId xmlns:a16="http://schemas.microsoft.com/office/drawing/2014/main" id="{8FA2FCC0-72FF-4A26-834B-314E6FA4D4BA}"/>
+                <a16:creationId xmlns:a16="http://schemas.microsoft.com/office/drawing/2014/main" id="{5D112CC5-0D7C-43EE-8815-F9E9253215BF}"/>
               </a:ext>
             </a:extLst>
           </p:cNvPr>
@@ -9947,7 +9947,7 @@
           <p:cNvPr id="11" name="step-3">
             <a:extLst xmlns:a="http://schemas.openxmlformats.org/drawingml/2006/main">
               <a:ext uri="{FF2B5EF4-FFF2-40B4-BE49-F238E27FC236}">
-                <a16:creationId xmlns:a16="http://schemas.microsoft.com/office/drawing/2014/main" id="{0F78C87D-D3D1-429A-B0CB-BCF1430AC718}"/>
+                <a16:creationId xmlns:a16="http://schemas.microsoft.com/office/drawing/2014/main" id="{48DA65FB-4EFF-4990-B97F-F7E34D89F650}"/>
               </a:ext>
             </a:extLst>
           </p:cNvPr>
@@ -10013,7 +10013,7 @@
           <p:cNvPr id="12" name="copy-3">
             <a:extLst xmlns:a="http://schemas.openxmlformats.org/drawingml/2006/main">
               <a:ext uri="{FF2B5EF4-FFF2-40B4-BE49-F238E27FC236}">
-                <a16:creationId xmlns:a16="http://schemas.microsoft.com/office/drawing/2014/main" id="{FAD70134-D107-406C-AD8A-C9D7BE9DC578}"/>
+                <a16:creationId xmlns:a16="http://schemas.microsoft.com/office/drawing/2014/main" id="{3A73D708-68A1-4A48-BA0D-C372690CBEF1}"/>
               </a:ext>
             </a:extLst>
           </p:cNvPr>
@@ -10073,7 +10073,7 @@
           <p:cNvPr id="13" name="example">
             <a:extLst xmlns:a="http://schemas.openxmlformats.org/drawingml/2006/main">
               <a:ext uri="{FF2B5EF4-FFF2-40B4-BE49-F238E27FC236}">
-                <a16:creationId xmlns:a16="http://schemas.microsoft.com/office/drawing/2014/main" id="{1C6831EC-199C-4C9E-B6C7-8A3A3F225DD8}"/>
+                <a16:creationId xmlns:a16="http://schemas.microsoft.com/office/drawing/2014/main" id="{C7737CDA-1C7B-4C3C-A6B7-F4F10AF62693}"/>
               </a:ext>
             </a:extLst>
           </p:cNvPr>
@@ -10108,7 +10108,7 @@
           <p:cNvPr id="14" name="example-text">
             <a:extLst xmlns:a="http://schemas.openxmlformats.org/drawingml/2006/main">
               <a:ext uri="{FF2B5EF4-FFF2-40B4-BE49-F238E27FC236}">
-                <a16:creationId xmlns:a16="http://schemas.microsoft.com/office/drawing/2014/main" id="{BFD4C80F-8D6B-48BA-82F6-D9F3B0B6ECC1}"/>
+                <a16:creationId xmlns:a16="http://schemas.microsoft.com/office/drawing/2014/main" id="{9C079020-2EAD-4DBE-AED7-AFE290D3C9BF}"/>
               </a:ext>
             </a:extLst>
           </p:cNvPr>
@@ -10166,7 +10166,7 @@
     </p:spTree>
     <p:extLst>
       <p:ext uri="{BB962C8B-B14F-4D97-AF65-F5344CB8AC3E}">
-        <p14:creationId xmlns:p14="http://schemas.microsoft.com/office/powerpoint/2010/main" val="488740667"/>
+        <p14:creationId xmlns:p14="http://schemas.microsoft.com/office/powerpoint/2010/main" val="1511108053"/>
       </p:ext>
     </p:extLst>
   </p:cSld>
@@ -10197,7 +10197,7 @@
           <p:cNvPr id="1" name="eyebrow">
             <a:extLst xmlns:a="http://schemas.openxmlformats.org/drawingml/2006/main">
               <a:ext uri="{FF2B5EF4-FFF2-40B4-BE49-F238E27FC236}">
-                <a16:creationId xmlns:a16="http://schemas.microsoft.com/office/drawing/2014/main" id="{A1DE215A-5E62-4F2F-93B4-16D24E54CF20}"/>
+                <a16:creationId xmlns:a16="http://schemas.microsoft.com/office/drawing/2014/main" id="{011F40B2-FD83-45F2-A142-2ED75C08172D}"/>
               </a:ext>
             </a:extLst>
           </p:cNvPr>
@@ -10257,7 +10257,7 @@
           <p:cNvPr id="2" name="title">
             <a:extLst xmlns:a="http://schemas.openxmlformats.org/drawingml/2006/main">
               <a:ext uri="{FF2B5EF4-FFF2-40B4-BE49-F238E27FC236}">
-                <a16:creationId xmlns:a16="http://schemas.microsoft.com/office/drawing/2014/main" id="{E38A6142-2DAE-4BC1-86E7-ACD3195BB066}"/>
+                <a16:creationId xmlns:a16="http://schemas.microsoft.com/office/drawing/2014/main" id="{60B52FB3-C47C-4ADB-99BD-A78A99380AB0}"/>
               </a:ext>
             </a:extLst>
           </p:cNvPr>
@@ -10317,7 +10317,7 @@
           <p:cNvPr id="3" name="footer">
             <a:extLst xmlns:a="http://schemas.openxmlformats.org/drawingml/2006/main">
               <a:ext uri="{FF2B5EF4-FFF2-40B4-BE49-F238E27FC236}">
-                <a16:creationId xmlns:a16="http://schemas.microsoft.com/office/drawing/2014/main" id="{BD398FFB-7B17-42BF-8164-9D85803F17F9}"/>
+                <a16:creationId xmlns:a16="http://schemas.microsoft.com/office/drawing/2014/main" id="{89595C82-C8C0-4766-88EA-8EA381088A6A}"/>
               </a:ext>
             </a:extLst>
           </p:cNvPr>
@@ -10377,7 +10377,7 @@
           <p:cNvPr id="4" name="f-0">
             <a:extLst xmlns:a="http://schemas.openxmlformats.org/drawingml/2006/main">
               <a:ext uri="{FF2B5EF4-FFF2-40B4-BE49-F238E27FC236}">
-                <a16:creationId xmlns:a16="http://schemas.microsoft.com/office/drawing/2014/main" id="{3433FA19-8217-4E5B-BCAE-97FECA092176}"/>
+                <a16:creationId xmlns:a16="http://schemas.microsoft.com/office/drawing/2014/main" id="{5AD11596-7EDE-4A43-8986-523EE173A3DA}"/>
               </a:ext>
             </a:extLst>
           </p:cNvPr>
@@ -10412,7 +10412,7 @@
           <p:cNvPr id="5" name="f-title-0">
             <a:extLst xmlns:a="http://schemas.openxmlformats.org/drawingml/2006/main">
               <a:ext uri="{FF2B5EF4-FFF2-40B4-BE49-F238E27FC236}">
-                <a16:creationId xmlns:a16="http://schemas.microsoft.com/office/drawing/2014/main" id="{43DAAB9A-B26A-4CFF-9949-C5920A53901A}"/>
+                <a16:creationId xmlns:a16="http://schemas.microsoft.com/office/drawing/2014/main" id="{EFE274DD-1388-42AB-96A5-198A0BBE7979}"/>
               </a:ext>
             </a:extLst>
           </p:cNvPr>
@@ -10472,7 +10472,7 @@
           <p:cNvPr id="6" name="f-copy-0">
             <a:extLst xmlns:a="http://schemas.openxmlformats.org/drawingml/2006/main">
               <a:ext uri="{FF2B5EF4-FFF2-40B4-BE49-F238E27FC236}">
-                <a16:creationId xmlns:a16="http://schemas.microsoft.com/office/drawing/2014/main" id="{07422BE7-D56F-4827-82E4-F99DFBCF1E91}"/>
+                <a16:creationId xmlns:a16="http://schemas.microsoft.com/office/drawing/2014/main" id="{B4E1B553-B778-4FBE-BEAE-FC99F6010847}"/>
               </a:ext>
             </a:extLst>
           </p:cNvPr>
@@ -10532,7 +10532,7 @@
           <p:cNvPr id="7" name="f-1">
             <a:extLst xmlns:a="http://schemas.openxmlformats.org/drawingml/2006/main">
               <a:ext uri="{FF2B5EF4-FFF2-40B4-BE49-F238E27FC236}">
-                <a16:creationId xmlns:a16="http://schemas.microsoft.com/office/drawing/2014/main" id="{C3C67241-3125-4BD2-B9E7-796BF1E5DCF9}"/>
+                <a16:creationId xmlns:a16="http://schemas.microsoft.com/office/drawing/2014/main" id="{9B79DF80-A207-4650-BD40-4A3FB9801FB2}"/>
               </a:ext>
             </a:extLst>
           </p:cNvPr>
@@ -10567,7 +10567,7 @@
           <p:cNvPr id="8" name="f-title-1">
             <a:extLst xmlns:a="http://schemas.openxmlformats.org/drawingml/2006/main">
               <a:ext uri="{FF2B5EF4-FFF2-40B4-BE49-F238E27FC236}">
-                <a16:creationId xmlns:a16="http://schemas.microsoft.com/office/drawing/2014/main" id="{D2C234ED-FA30-4AD9-B02B-1D3B55613927}"/>
+                <a16:creationId xmlns:a16="http://schemas.microsoft.com/office/drawing/2014/main" id="{00CFEF2A-1BC6-4D75-8948-752BEAFF6B99}"/>
               </a:ext>
             </a:extLst>
           </p:cNvPr>
@@ -10627,7 +10627,7 @@
           <p:cNvPr id="9" name="f-copy-1">
             <a:extLst xmlns:a="http://schemas.openxmlformats.org/drawingml/2006/main">
               <a:ext uri="{FF2B5EF4-FFF2-40B4-BE49-F238E27FC236}">
-                <a16:creationId xmlns:a16="http://schemas.microsoft.com/office/drawing/2014/main" id="{B19BD888-EAD2-4D34-B4FB-157E8C380F67}"/>
+                <a16:creationId xmlns:a16="http://schemas.microsoft.com/office/drawing/2014/main" id="{6775B91F-3F42-4E92-BE18-3BBCDEA8EAB3}"/>
               </a:ext>
             </a:extLst>
           </p:cNvPr>
@@ -10687,7 +10687,7 @@
           <p:cNvPr id="10" name="f-2">
             <a:extLst xmlns:a="http://schemas.openxmlformats.org/drawingml/2006/main">
               <a:ext uri="{FF2B5EF4-FFF2-40B4-BE49-F238E27FC236}">
-                <a16:creationId xmlns:a16="http://schemas.microsoft.com/office/drawing/2014/main" id="{2E0379CD-5FD9-44CB-81A7-7A4CBA49A2A3}"/>
+                <a16:creationId xmlns:a16="http://schemas.microsoft.com/office/drawing/2014/main" id="{70770B7C-01D7-4A27-B4B2-D33A834D56BA}"/>
               </a:ext>
             </a:extLst>
           </p:cNvPr>
@@ -10722,7 +10722,7 @@
           <p:cNvPr id="11" name="f-title-2">
             <a:extLst xmlns:a="http://schemas.openxmlformats.org/drawingml/2006/main">
               <a:ext uri="{FF2B5EF4-FFF2-40B4-BE49-F238E27FC236}">
-                <a16:creationId xmlns:a16="http://schemas.microsoft.com/office/drawing/2014/main" id="{77E34591-D5E1-4CDA-B297-EBE932FEC734}"/>
+                <a16:creationId xmlns:a16="http://schemas.microsoft.com/office/drawing/2014/main" id="{57C83A6D-4182-4DA7-9955-13A466CBE067}"/>
               </a:ext>
             </a:extLst>
           </p:cNvPr>
@@ -10782,7 +10782,7 @@
           <p:cNvPr id="12" name="f-copy-2">
             <a:extLst xmlns:a="http://schemas.openxmlformats.org/drawingml/2006/main">
               <a:ext uri="{FF2B5EF4-FFF2-40B4-BE49-F238E27FC236}">
-                <a16:creationId xmlns:a16="http://schemas.microsoft.com/office/drawing/2014/main" id="{B0AB2DFF-08DE-4575-AE54-FBB40A7B89DC}"/>
+                <a16:creationId xmlns:a16="http://schemas.microsoft.com/office/drawing/2014/main" id="{11FD6499-F717-441E-88D8-49480868271A}"/>
               </a:ext>
             </a:extLst>
           </p:cNvPr>
@@ -10842,7 +10842,7 @@
           <p:cNvPr id="13" name="f-3">
             <a:extLst xmlns:a="http://schemas.openxmlformats.org/drawingml/2006/main">
               <a:ext uri="{FF2B5EF4-FFF2-40B4-BE49-F238E27FC236}">
-                <a16:creationId xmlns:a16="http://schemas.microsoft.com/office/drawing/2014/main" id="{57B2F3EC-37EF-416B-8EEE-A086ACBD3EC8}"/>
+                <a16:creationId xmlns:a16="http://schemas.microsoft.com/office/drawing/2014/main" id="{0F764F84-AAE4-497F-9D1D-0EC4A7533B1B}"/>
               </a:ext>
             </a:extLst>
           </p:cNvPr>
@@ -10877,7 +10877,7 @@
           <p:cNvPr id="14" name="f-title-3">
             <a:extLst xmlns:a="http://schemas.openxmlformats.org/drawingml/2006/main">
               <a:ext uri="{FF2B5EF4-FFF2-40B4-BE49-F238E27FC236}">
-                <a16:creationId xmlns:a16="http://schemas.microsoft.com/office/drawing/2014/main" id="{E3BE2517-53B4-46FC-A05D-3F4D48320257}"/>
+                <a16:creationId xmlns:a16="http://schemas.microsoft.com/office/drawing/2014/main" id="{A7B9DAD9-3F88-4BBB-96D3-41320412FCB2}"/>
               </a:ext>
             </a:extLst>
           </p:cNvPr>
@@ -10937,7 +10937,7 @@
           <p:cNvPr id="15" name="f-copy-3">
             <a:extLst xmlns:a="http://schemas.openxmlformats.org/drawingml/2006/main">
               <a:ext uri="{FF2B5EF4-FFF2-40B4-BE49-F238E27FC236}">
-                <a16:creationId xmlns:a16="http://schemas.microsoft.com/office/drawing/2014/main" id="{8849FEBF-F210-4305-A302-A69AC4695FCA}"/>
+                <a16:creationId xmlns:a16="http://schemas.microsoft.com/office/drawing/2014/main" id="{8F2E1B02-AA10-471A-8319-E3B8089ED500}"/>
               </a:ext>
             </a:extLst>
           </p:cNvPr>
@@ -10997,7 +10997,7 @@
           <p:cNvPr id="16" name="f-4">
             <a:extLst xmlns:a="http://schemas.openxmlformats.org/drawingml/2006/main">
               <a:ext uri="{FF2B5EF4-FFF2-40B4-BE49-F238E27FC236}">
-                <a16:creationId xmlns:a16="http://schemas.microsoft.com/office/drawing/2014/main" id="{8FB12BB8-63C1-4FB7-A56B-D982FD7AB7E5}"/>
+                <a16:creationId xmlns:a16="http://schemas.microsoft.com/office/drawing/2014/main" id="{1EC5DEF9-7322-482D-8EA1-8A5C28584843}"/>
               </a:ext>
             </a:extLst>
           </p:cNvPr>
@@ -11032,7 +11032,7 @@
           <p:cNvPr id="17" name="f-title-4">
             <a:extLst xmlns:a="http://schemas.openxmlformats.org/drawingml/2006/main">
               <a:ext uri="{FF2B5EF4-FFF2-40B4-BE49-F238E27FC236}">
-                <a16:creationId xmlns:a16="http://schemas.microsoft.com/office/drawing/2014/main" id="{6FE8F4BB-79FD-487F-BF24-BE63ED17B56D}"/>
+                <a16:creationId xmlns:a16="http://schemas.microsoft.com/office/drawing/2014/main" id="{D2C39157-59E7-4A49-928E-A3059CEB1D7A}"/>
               </a:ext>
             </a:extLst>
           </p:cNvPr>
@@ -11092,7 +11092,7 @@
           <p:cNvPr id="18" name="f-copy-4">
             <a:extLst xmlns:a="http://schemas.openxmlformats.org/drawingml/2006/main">
               <a:ext uri="{FF2B5EF4-FFF2-40B4-BE49-F238E27FC236}">
-                <a16:creationId xmlns:a16="http://schemas.microsoft.com/office/drawing/2014/main" id="{4C91EFF8-0941-4F12-B87D-F77ED772F2AF}"/>
+                <a16:creationId xmlns:a16="http://schemas.microsoft.com/office/drawing/2014/main" id="{72546F8D-68C7-4E0A-B03A-8BD6B4A12483}"/>
               </a:ext>
             </a:extLst>
           </p:cNvPr>
@@ -11152,7 +11152,7 @@
           <p:cNvPr id="19" name="f-5">
             <a:extLst xmlns:a="http://schemas.openxmlformats.org/drawingml/2006/main">
               <a:ext uri="{FF2B5EF4-FFF2-40B4-BE49-F238E27FC236}">
-                <a16:creationId xmlns:a16="http://schemas.microsoft.com/office/drawing/2014/main" id="{DC31355E-F4DA-4D65-92CF-A02C5DEE3BBE}"/>
+                <a16:creationId xmlns:a16="http://schemas.microsoft.com/office/drawing/2014/main" id="{A4E592DB-1EAE-4498-91BF-62E873D48A46}"/>
               </a:ext>
             </a:extLst>
           </p:cNvPr>
@@ -11187,7 +11187,7 @@
           <p:cNvPr id="20" name="f-title-5">
             <a:extLst xmlns:a="http://schemas.openxmlformats.org/drawingml/2006/main">
               <a:ext uri="{FF2B5EF4-FFF2-40B4-BE49-F238E27FC236}">
-                <a16:creationId xmlns:a16="http://schemas.microsoft.com/office/drawing/2014/main" id="{A72D5D6D-51C5-42C7-93E3-5E09A9ACAC68}"/>
+                <a16:creationId xmlns:a16="http://schemas.microsoft.com/office/drawing/2014/main" id="{01080342-FA9F-49FF-9423-F398C6D2CD7B}"/>
               </a:ext>
             </a:extLst>
           </p:cNvPr>
@@ -11247,7 +11247,7 @@
           <p:cNvPr id="21" name="f-copy-5">
             <a:extLst xmlns:a="http://schemas.openxmlformats.org/drawingml/2006/main">
               <a:ext uri="{FF2B5EF4-FFF2-40B4-BE49-F238E27FC236}">
-                <a16:creationId xmlns:a16="http://schemas.microsoft.com/office/drawing/2014/main" id="{B8C881B8-BE4D-4175-B9E5-B3FC66E2F62D}"/>
+                <a16:creationId xmlns:a16="http://schemas.microsoft.com/office/drawing/2014/main" id="{AF59B019-0EB0-46E0-8FC5-1610A36FDC95}"/>
               </a:ext>
             </a:extLst>
           </p:cNvPr>
@@ -11307,7 +11307,7 @@
           <p:cNvPr id="22" name="bottom">
             <a:extLst xmlns:a="http://schemas.openxmlformats.org/drawingml/2006/main">
               <a:ext uri="{FF2B5EF4-FFF2-40B4-BE49-F238E27FC236}">
-                <a16:creationId xmlns:a16="http://schemas.microsoft.com/office/drawing/2014/main" id="{BD32EFED-8E1D-41D0-85E9-08F23552936D}"/>
+                <a16:creationId xmlns:a16="http://schemas.microsoft.com/office/drawing/2014/main" id="{A196DBBE-1403-4FE9-B45C-2781620219EA}"/>
               </a:ext>
             </a:extLst>
           </p:cNvPr>
@@ -11365,7 +11365,7 @@
     </p:spTree>
     <p:extLst>
       <p:ext uri="{BB962C8B-B14F-4D97-AF65-F5344CB8AC3E}">
-        <p14:creationId xmlns:p14="http://schemas.microsoft.com/office/powerpoint/2010/main" val="688711880"/>
+        <p14:creationId xmlns:p14="http://schemas.microsoft.com/office/powerpoint/2010/main" val="1042448050"/>
       </p:ext>
     </p:extLst>
   </p:cSld>
@@ -11396,7 +11396,7 @@
           <p:cNvPr id="1" name="eyebrow">
             <a:extLst xmlns:a="http://schemas.openxmlformats.org/drawingml/2006/main">
               <a:ext uri="{FF2B5EF4-FFF2-40B4-BE49-F238E27FC236}">
-                <a16:creationId xmlns:a16="http://schemas.microsoft.com/office/drawing/2014/main" id="{B398B4FF-7E05-4A53-A803-0D0D74B9B300}"/>
+                <a16:creationId xmlns:a16="http://schemas.microsoft.com/office/drawing/2014/main" id="{E7923A9B-805C-454A-A4E2-CFA7CEBF64D0}"/>
               </a:ext>
             </a:extLst>
           </p:cNvPr>
@@ -11456,7 +11456,7 @@
           <p:cNvPr id="2" name="title">
             <a:extLst xmlns:a="http://schemas.openxmlformats.org/drawingml/2006/main">
               <a:ext uri="{FF2B5EF4-FFF2-40B4-BE49-F238E27FC236}">
-                <a16:creationId xmlns:a16="http://schemas.microsoft.com/office/drawing/2014/main" id="{E3B4BFBD-2928-45D1-AB94-8C1965AF2F84}"/>
+                <a16:creationId xmlns:a16="http://schemas.microsoft.com/office/drawing/2014/main" id="{F4E5D1EB-BE37-4050-9952-CA931A2DDD8B}"/>
               </a:ext>
             </a:extLst>
           </p:cNvPr>
@@ -11516,7 +11516,7 @@
           <p:cNvPr id="3" name="footer">
             <a:extLst xmlns:a="http://schemas.openxmlformats.org/drawingml/2006/main">
               <a:ext uri="{FF2B5EF4-FFF2-40B4-BE49-F238E27FC236}">
-                <a16:creationId xmlns:a16="http://schemas.microsoft.com/office/drawing/2014/main" id="{742CB52F-26BD-483F-816D-331BD20451FE}"/>
+                <a16:creationId xmlns:a16="http://schemas.microsoft.com/office/drawing/2014/main" id="{9988B158-2500-4846-AD00-A81D2CF11D7C}"/>
               </a:ext>
             </a:extLst>
           </p:cNvPr>
@@ -11576,7 +11576,7 @@
           <p:cNvPr id="4" name="case-0">
             <a:extLst xmlns:a="http://schemas.openxmlformats.org/drawingml/2006/main">
               <a:ext uri="{FF2B5EF4-FFF2-40B4-BE49-F238E27FC236}">
-                <a16:creationId xmlns:a16="http://schemas.microsoft.com/office/drawing/2014/main" id="{8DB0E0E0-3172-4F80-BA35-A5428B20095D}"/>
+                <a16:creationId xmlns:a16="http://schemas.microsoft.com/office/drawing/2014/main" id="{D683A511-956C-4C9F-BA73-536E95481E35}"/>
               </a:ext>
             </a:extLst>
           </p:cNvPr>
@@ -11611,7 +11611,7 @@
           <p:cNvPr id="5" name="case-label-0">
             <a:extLst xmlns:a="http://schemas.openxmlformats.org/drawingml/2006/main">
               <a:ext uri="{FF2B5EF4-FFF2-40B4-BE49-F238E27FC236}">
-                <a16:creationId xmlns:a16="http://schemas.microsoft.com/office/drawing/2014/main" id="{C57A1B1A-3997-4428-BFAE-8FA5051FB62E}"/>
+                <a16:creationId xmlns:a16="http://schemas.microsoft.com/office/drawing/2014/main" id="{185DCEA9-4AEA-48A3-B5A8-C61558846E2D}"/>
               </a:ext>
             </a:extLst>
           </p:cNvPr>
@@ -11677,7 +11677,7 @@
           <p:cNvPr id="6" name="case-copy-0">
             <a:extLst xmlns:a="http://schemas.openxmlformats.org/drawingml/2006/main">
               <a:ext uri="{FF2B5EF4-FFF2-40B4-BE49-F238E27FC236}">
-                <a16:creationId xmlns:a16="http://schemas.microsoft.com/office/drawing/2014/main" id="{F1F52A8A-3AF7-4C41-AF53-95913B7E68CF}"/>
+                <a16:creationId xmlns:a16="http://schemas.microsoft.com/office/drawing/2014/main" id="{8B08970D-54BF-4D19-90F3-BBCC1C2EB7DA}"/>
               </a:ext>
             </a:extLst>
           </p:cNvPr>
@@ -11764,7 +11764,7 @@
           <p:cNvPr id="7" name="case-1">
             <a:extLst xmlns:a="http://schemas.openxmlformats.org/drawingml/2006/main">
               <a:ext uri="{FF2B5EF4-FFF2-40B4-BE49-F238E27FC236}">
-                <a16:creationId xmlns:a16="http://schemas.microsoft.com/office/drawing/2014/main" id="{7F592D00-30C0-43CC-9FF1-5E5125DE479E}"/>
+                <a16:creationId xmlns:a16="http://schemas.microsoft.com/office/drawing/2014/main" id="{B154F3ED-CA26-4BD5-9E6C-EF840BDBB0B0}"/>
               </a:ext>
             </a:extLst>
           </p:cNvPr>
@@ -11799,7 +11799,7 @@
           <p:cNvPr id="8" name="case-label-1">
             <a:extLst xmlns:a="http://schemas.openxmlformats.org/drawingml/2006/main">
               <a:ext uri="{FF2B5EF4-FFF2-40B4-BE49-F238E27FC236}">
-                <a16:creationId xmlns:a16="http://schemas.microsoft.com/office/drawing/2014/main" id="{BB86CC0F-8EA9-43E3-B546-E139FC5E7999}"/>
+                <a16:creationId xmlns:a16="http://schemas.microsoft.com/office/drawing/2014/main" id="{62832CC6-69FB-460A-94AF-ECCFFB584AA9}"/>
               </a:ext>
             </a:extLst>
           </p:cNvPr>
@@ -11865,7 +11865,7 @@
           <p:cNvPr id="9" name="case-copy-1">
             <a:extLst xmlns:a="http://schemas.openxmlformats.org/drawingml/2006/main">
               <a:ext uri="{FF2B5EF4-FFF2-40B4-BE49-F238E27FC236}">
-                <a16:creationId xmlns:a16="http://schemas.microsoft.com/office/drawing/2014/main" id="{461B12F9-514B-46EA-910E-D2E1C2D6011F}"/>
+                <a16:creationId xmlns:a16="http://schemas.microsoft.com/office/drawing/2014/main" id="{3537E46E-A347-40EF-87AB-34342336AF43}"/>
               </a:ext>
             </a:extLst>
           </p:cNvPr>
@@ -11952,7 +11952,7 @@
           <p:cNvPr id="10" name="case-2">
             <a:extLst xmlns:a="http://schemas.openxmlformats.org/drawingml/2006/main">
               <a:ext uri="{FF2B5EF4-FFF2-40B4-BE49-F238E27FC236}">
-                <a16:creationId xmlns:a16="http://schemas.microsoft.com/office/drawing/2014/main" id="{55B03F1F-1BE3-4D98-9272-0BBA92F5F944}"/>
+                <a16:creationId xmlns:a16="http://schemas.microsoft.com/office/drawing/2014/main" id="{B9B00392-1AD8-4EF9-A24F-5FE7E9A476B2}"/>
               </a:ext>
             </a:extLst>
           </p:cNvPr>
@@ -11987,7 +11987,7 @@
           <p:cNvPr id="11" name="case-label-2">
             <a:extLst xmlns:a="http://schemas.openxmlformats.org/drawingml/2006/main">
               <a:ext uri="{FF2B5EF4-FFF2-40B4-BE49-F238E27FC236}">
-                <a16:creationId xmlns:a16="http://schemas.microsoft.com/office/drawing/2014/main" id="{1F29BBF7-FC86-4C37-BCAA-D76BC90BE96B}"/>
+                <a16:creationId xmlns:a16="http://schemas.microsoft.com/office/drawing/2014/main" id="{E6124741-B211-4072-B030-7AB178A88577}"/>
               </a:ext>
             </a:extLst>
           </p:cNvPr>
@@ -12053,7 +12053,7 @@
           <p:cNvPr id="12" name="case-copy-2">
             <a:extLst xmlns:a="http://schemas.openxmlformats.org/drawingml/2006/main">
               <a:ext uri="{FF2B5EF4-FFF2-40B4-BE49-F238E27FC236}">
-                <a16:creationId xmlns:a16="http://schemas.microsoft.com/office/drawing/2014/main" id="{3C46FF65-9731-4C21-85F7-07D8ECC1A4F1}"/>
+                <a16:creationId xmlns:a16="http://schemas.microsoft.com/office/drawing/2014/main" id="{7A126AE2-BD61-477F-9DBF-366A31E0AAA6}"/>
               </a:ext>
             </a:extLst>
           </p:cNvPr>
@@ -12140,7 +12140,7 @@
           <p:cNvPr id="13" name="prompt">
             <a:extLst xmlns:a="http://schemas.openxmlformats.org/drawingml/2006/main">
               <a:ext uri="{FF2B5EF4-FFF2-40B4-BE49-F238E27FC236}">
-                <a16:creationId xmlns:a16="http://schemas.microsoft.com/office/drawing/2014/main" id="{5B86624B-2FF6-415A-82AA-1608C059C53B}"/>
+                <a16:creationId xmlns:a16="http://schemas.microsoft.com/office/drawing/2014/main" id="{B4B76E03-5E4A-4CDC-A549-322AA19E9E80}"/>
               </a:ext>
             </a:extLst>
           </p:cNvPr>
@@ -12198,7 +12198,7 @@
     </p:spTree>
     <p:extLst>
       <p:ext uri="{BB962C8B-B14F-4D97-AF65-F5344CB8AC3E}">
-        <p14:creationId xmlns:p14="http://schemas.microsoft.com/office/powerpoint/2010/main" val="295125835"/>
+        <p14:creationId xmlns:p14="http://schemas.microsoft.com/office/powerpoint/2010/main" val="948220856"/>
       </p:ext>
     </p:extLst>
   </p:cSld>
@@ -12229,7 +12229,7 @@
           <p:cNvPr id="1" name="eyebrow">
             <a:extLst xmlns:a="http://schemas.openxmlformats.org/drawingml/2006/main">
               <a:ext uri="{FF2B5EF4-FFF2-40B4-BE49-F238E27FC236}">
-                <a16:creationId xmlns:a16="http://schemas.microsoft.com/office/drawing/2014/main" id="{62A81EB8-7AD7-4075-8309-CA7FEEA58C14}"/>
+                <a16:creationId xmlns:a16="http://schemas.microsoft.com/office/drawing/2014/main" id="{0DCF0180-2975-4250-8C98-C105A6C60DBD}"/>
               </a:ext>
             </a:extLst>
           </p:cNvPr>
@@ -12289,7 +12289,7 @@
           <p:cNvPr id="2" name="title">
             <a:extLst xmlns:a="http://schemas.openxmlformats.org/drawingml/2006/main">
               <a:ext uri="{FF2B5EF4-FFF2-40B4-BE49-F238E27FC236}">
-                <a16:creationId xmlns:a16="http://schemas.microsoft.com/office/drawing/2014/main" id="{6BD5F4FA-47E0-4471-AE61-B311FFA24DC3}"/>
+                <a16:creationId xmlns:a16="http://schemas.microsoft.com/office/drawing/2014/main" id="{9E7C42A8-96AD-4B36-93CE-55E80D67DB22}"/>
               </a:ext>
             </a:extLst>
           </p:cNvPr>
@@ -12349,7 +12349,7 @@
           <p:cNvPr id="3" name="footer">
             <a:extLst xmlns:a="http://schemas.openxmlformats.org/drawingml/2006/main">
               <a:ext uri="{FF2B5EF4-FFF2-40B4-BE49-F238E27FC236}">
-                <a16:creationId xmlns:a16="http://schemas.microsoft.com/office/drawing/2014/main" id="{24E90F84-B2E0-4AD8-88EE-AE46AB43E94C}"/>
+                <a16:creationId xmlns:a16="http://schemas.microsoft.com/office/drawing/2014/main" id="{9E20C69E-1174-470C-83E1-978AC2CFB225}"/>
               </a:ext>
             </a:extLst>
           </p:cNvPr>
@@ -12409,7 +12409,7 @@
           <p:cNvPr id="4" name="worksheet-0">
             <a:extLst xmlns:a="http://schemas.openxmlformats.org/drawingml/2006/main">
               <a:ext uri="{FF2B5EF4-FFF2-40B4-BE49-F238E27FC236}">
-                <a16:creationId xmlns:a16="http://schemas.microsoft.com/office/drawing/2014/main" id="{1C26BA3F-DB90-4F5B-806D-4B2BF3EDC67B}"/>
+                <a16:creationId xmlns:a16="http://schemas.microsoft.com/office/drawing/2014/main" id="{4E95646A-79AE-4E63-AABE-C79E7E88320B}"/>
               </a:ext>
             </a:extLst>
           </p:cNvPr>
@@ -12444,7 +12444,7 @@
           <p:cNvPr id="5" name="worksheet-head-0">
             <a:extLst xmlns:a="http://schemas.openxmlformats.org/drawingml/2006/main">
               <a:ext uri="{FF2B5EF4-FFF2-40B4-BE49-F238E27FC236}">
-                <a16:creationId xmlns:a16="http://schemas.microsoft.com/office/drawing/2014/main" id="{CC4498DD-1F83-4EF7-B05E-041938F5A2DB}"/>
+                <a16:creationId xmlns:a16="http://schemas.microsoft.com/office/drawing/2014/main" id="{A3A655E4-68BE-4BD6-A395-19C375BFD267}"/>
               </a:ext>
             </a:extLst>
           </p:cNvPr>
@@ -12504,7 +12504,7 @@
           <p:cNvPr id="6" name="worksheet-sub-0">
             <a:extLst xmlns:a="http://schemas.openxmlformats.org/drawingml/2006/main">
               <a:ext uri="{FF2B5EF4-FFF2-40B4-BE49-F238E27FC236}">
-                <a16:creationId xmlns:a16="http://schemas.microsoft.com/office/drawing/2014/main" id="{6FF4661E-7FCA-4F2C-8576-97781711E318}"/>
+                <a16:creationId xmlns:a16="http://schemas.microsoft.com/office/drawing/2014/main" id="{B0584DDB-28D8-409E-A4EF-B46E5FF90C19}"/>
               </a:ext>
             </a:extLst>
           </p:cNvPr>
@@ -12564,7 +12564,7 @@
           <p:cNvPr id="7" name="worksheet-1">
             <a:extLst xmlns:a="http://schemas.openxmlformats.org/drawingml/2006/main">
               <a:ext uri="{FF2B5EF4-FFF2-40B4-BE49-F238E27FC236}">
-                <a16:creationId xmlns:a16="http://schemas.microsoft.com/office/drawing/2014/main" id="{7B9EFFD9-AABF-46D6-A43D-8A1AA5C4D830}"/>
+                <a16:creationId xmlns:a16="http://schemas.microsoft.com/office/drawing/2014/main" id="{FEEB2BBD-EC76-4000-9D2B-EDE291549A42}"/>
               </a:ext>
             </a:extLst>
           </p:cNvPr>
@@ -12599,7 +12599,7 @@
           <p:cNvPr id="8" name="worksheet-head-1">
             <a:extLst xmlns:a="http://schemas.openxmlformats.org/drawingml/2006/main">
               <a:ext uri="{FF2B5EF4-FFF2-40B4-BE49-F238E27FC236}">
-                <a16:creationId xmlns:a16="http://schemas.microsoft.com/office/drawing/2014/main" id="{25FE8D92-E16E-4273-A1A3-FBC75337BC8B}"/>
+                <a16:creationId xmlns:a16="http://schemas.microsoft.com/office/drawing/2014/main" id="{7215E3E1-320A-47D0-A8F7-7D64866C5124}"/>
               </a:ext>
             </a:extLst>
           </p:cNvPr>
@@ -12659,7 +12659,7 @@
           <p:cNvPr id="9" name="worksheet-sub-1">
             <a:extLst xmlns:a="http://schemas.openxmlformats.org/drawingml/2006/main">
               <a:ext uri="{FF2B5EF4-FFF2-40B4-BE49-F238E27FC236}">
-                <a16:creationId xmlns:a16="http://schemas.microsoft.com/office/drawing/2014/main" id="{D30DC206-B84F-4C98-910A-A382479D9FE9}"/>
+                <a16:creationId xmlns:a16="http://schemas.microsoft.com/office/drawing/2014/main" id="{F9D78A48-F4F8-4249-A8FA-49ACD428825C}"/>
               </a:ext>
             </a:extLst>
           </p:cNvPr>
@@ -12719,7 +12719,7 @@
           <p:cNvPr id="10" name="worksheet-2">
             <a:extLst xmlns:a="http://schemas.openxmlformats.org/drawingml/2006/main">
               <a:ext uri="{FF2B5EF4-FFF2-40B4-BE49-F238E27FC236}">
-                <a16:creationId xmlns:a16="http://schemas.microsoft.com/office/drawing/2014/main" id="{DAD25225-818B-4E75-A984-9DB55421D249}"/>
+                <a16:creationId xmlns:a16="http://schemas.microsoft.com/office/drawing/2014/main" id="{598DD9BD-7D2D-4BB1-9562-754C5E72C9D9}"/>
               </a:ext>
             </a:extLst>
           </p:cNvPr>
@@ -12754,7 +12754,7 @@
           <p:cNvPr id="11" name="worksheet-head-2">
             <a:extLst xmlns:a="http://schemas.openxmlformats.org/drawingml/2006/main">
               <a:ext uri="{FF2B5EF4-FFF2-40B4-BE49-F238E27FC236}">
-                <a16:creationId xmlns:a16="http://schemas.microsoft.com/office/drawing/2014/main" id="{67855489-1EC2-451E-8230-F80E2F7997AB}"/>
+                <a16:creationId xmlns:a16="http://schemas.microsoft.com/office/drawing/2014/main" id="{77087FB9-7ED2-486D-980E-A70E02A4DDA3}"/>
               </a:ext>
             </a:extLst>
           </p:cNvPr>
@@ -12814,7 +12814,7 @@
           <p:cNvPr id="12" name="worksheet-sub-2">
             <a:extLst xmlns:a="http://schemas.openxmlformats.org/drawingml/2006/main">
               <a:ext uri="{FF2B5EF4-FFF2-40B4-BE49-F238E27FC236}">
-                <a16:creationId xmlns:a16="http://schemas.microsoft.com/office/drawing/2014/main" id="{8ECC5C90-23D8-490C-BEEB-56279FB2DCE1}"/>
+                <a16:creationId xmlns:a16="http://schemas.microsoft.com/office/drawing/2014/main" id="{A5EDFB53-8575-4FB1-A724-88F73D70249E}"/>
               </a:ext>
             </a:extLst>
           </p:cNvPr>
@@ -12874,7 +12874,7 @@
           <p:cNvPr id="13" name="worksheet-3">
             <a:extLst xmlns:a="http://schemas.openxmlformats.org/drawingml/2006/main">
               <a:ext uri="{FF2B5EF4-FFF2-40B4-BE49-F238E27FC236}">
-                <a16:creationId xmlns:a16="http://schemas.microsoft.com/office/drawing/2014/main" id="{3B413556-C0B8-4E1D-80A1-845043CE8EA1}"/>
+                <a16:creationId xmlns:a16="http://schemas.microsoft.com/office/drawing/2014/main" id="{C369C0C2-3E22-494E-98DA-1172E38222D1}"/>
               </a:ext>
             </a:extLst>
           </p:cNvPr>
@@ -12909,7 +12909,7 @@
           <p:cNvPr id="14" name="worksheet-head-3">
             <a:extLst xmlns:a="http://schemas.openxmlformats.org/drawingml/2006/main">
               <a:ext uri="{FF2B5EF4-FFF2-40B4-BE49-F238E27FC236}">
-                <a16:creationId xmlns:a16="http://schemas.microsoft.com/office/drawing/2014/main" id="{4244EC9C-D3FF-4A9D-83AF-966772D04356}"/>
+                <a16:creationId xmlns:a16="http://schemas.microsoft.com/office/drawing/2014/main" id="{8212868A-2E8B-4E5D-B412-EE68E5122B6C}"/>
               </a:ext>
             </a:extLst>
           </p:cNvPr>
@@ -12969,7 +12969,7 @@
           <p:cNvPr id="15" name="worksheet-sub-3">
             <a:extLst xmlns:a="http://schemas.openxmlformats.org/drawingml/2006/main">
               <a:ext uri="{FF2B5EF4-FFF2-40B4-BE49-F238E27FC236}">
-                <a16:creationId xmlns:a16="http://schemas.microsoft.com/office/drawing/2014/main" id="{EB9E859D-982F-4342-BFA9-A63904C10778}"/>
+                <a16:creationId xmlns:a16="http://schemas.microsoft.com/office/drawing/2014/main" id="{4BA42ED5-0ACC-4751-88E6-5E354E11A18D}"/>
               </a:ext>
             </a:extLst>
           </p:cNvPr>
@@ -13029,7 +13029,7 @@
           <p:cNvPr id="16" name="worksheet-4">
             <a:extLst xmlns:a="http://schemas.openxmlformats.org/drawingml/2006/main">
               <a:ext uri="{FF2B5EF4-FFF2-40B4-BE49-F238E27FC236}">
-                <a16:creationId xmlns:a16="http://schemas.microsoft.com/office/drawing/2014/main" id="{134386C0-5A51-49A5-971E-97DCD12CBCDC}"/>
+                <a16:creationId xmlns:a16="http://schemas.microsoft.com/office/drawing/2014/main" id="{01287AE4-7B15-44CF-AA4B-983C4E51678C}"/>
               </a:ext>
             </a:extLst>
           </p:cNvPr>
@@ -13064,7 +13064,7 @@
           <p:cNvPr id="17" name="worksheet-head-4">
             <a:extLst xmlns:a="http://schemas.openxmlformats.org/drawingml/2006/main">
               <a:ext uri="{FF2B5EF4-FFF2-40B4-BE49-F238E27FC236}">
-                <a16:creationId xmlns:a16="http://schemas.microsoft.com/office/drawing/2014/main" id="{0BF6F67D-D5F8-4034-91C4-DB49B70595F3}"/>
+                <a16:creationId xmlns:a16="http://schemas.microsoft.com/office/drawing/2014/main" id="{6F656761-FBA0-4478-894B-1F499670BB6A}"/>
               </a:ext>
             </a:extLst>
           </p:cNvPr>
@@ -13124,7 +13124,7 @@
           <p:cNvPr id="18" name="worksheet-sub-4">
             <a:extLst xmlns:a="http://schemas.openxmlformats.org/drawingml/2006/main">
               <a:ext uri="{FF2B5EF4-FFF2-40B4-BE49-F238E27FC236}">
-                <a16:creationId xmlns:a16="http://schemas.microsoft.com/office/drawing/2014/main" id="{1A2D959B-EA93-4D50-965C-80A9A6B50D22}"/>
+                <a16:creationId xmlns:a16="http://schemas.microsoft.com/office/drawing/2014/main" id="{583B5093-2A53-4519-8A82-03D0B78B4DBF}"/>
               </a:ext>
             </a:extLst>
           </p:cNvPr>
@@ -13184,7 +13184,7 @@
           <p:cNvPr id="19" name="deliverable">
             <a:extLst xmlns:a="http://schemas.openxmlformats.org/drawingml/2006/main">
               <a:ext uri="{FF2B5EF4-FFF2-40B4-BE49-F238E27FC236}">
-                <a16:creationId xmlns:a16="http://schemas.microsoft.com/office/drawing/2014/main" id="{FF9EE5EB-1638-4C8D-B1A6-13DA912E52D2}"/>
+                <a16:creationId xmlns:a16="http://schemas.microsoft.com/office/drawing/2014/main" id="{DB56A8CC-1D63-42FE-95E9-70E9A6BD6F75}"/>
               </a:ext>
             </a:extLst>
           </p:cNvPr>
@@ -13219,7 +13219,7 @@
           <p:cNvPr id="20" name="deliverable-text">
             <a:extLst xmlns:a="http://schemas.openxmlformats.org/drawingml/2006/main">
               <a:ext uri="{FF2B5EF4-FFF2-40B4-BE49-F238E27FC236}">
-                <a16:creationId xmlns:a16="http://schemas.microsoft.com/office/drawing/2014/main" id="{6B50644E-34A1-4531-A690-18F048FF203B}"/>
+                <a16:creationId xmlns:a16="http://schemas.microsoft.com/office/drawing/2014/main" id="{4D113B16-C037-4A7F-98F8-FA7D7FD42716}"/>
               </a:ext>
             </a:extLst>
           </p:cNvPr>
@@ -13277,7 +13277,7 @@
     </p:spTree>
     <p:extLst>
       <p:ext uri="{BB962C8B-B14F-4D97-AF65-F5344CB8AC3E}">
-        <p14:creationId xmlns:p14="http://schemas.microsoft.com/office/powerpoint/2010/main" val="79624312"/>
+        <p14:creationId xmlns:p14="http://schemas.microsoft.com/office/powerpoint/2010/main" val="1893638892"/>
       </p:ext>
     </p:extLst>
   </p:cSld>
@@ -13308,7 +13308,7 @@
           <p:cNvPr id="1" name="eyebrow">
             <a:extLst xmlns:a="http://schemas.openxmlformats.org/drawingml/2006/main">
               <a:ext uri="{FF2B5EF4-FFF2-40B4-BE49-F238E27FC236}">
-                <a16:creationId xmlns:a16="http://schemas.microsoft.com/office/drawing/2014/main" id="{369E3BCE-5EB1-4C4C-86CA-F33650C23532}"/>
+                <a16:creationId xmlns:a16="http://schemas.microsoft.com/office/drawing/2014/main" id="{961470BB-D74A-4D1E-BF63-FE1DEDD80025}"/>
               </a:ext>
             </a:extLst>
           </p:cNvPr>
@@ -13368,7 +13368,7 @@
           <p:cNvPr id="2" name="title">
             <a:extLst xmlns:a="http://schemas.openxmlformats.org/drawingml/2006/main">
               <a:ext uri="{FF2B5EF4-FFF2-40B4-BE49-F238E27FC236}">
-                <a16:creationId xmlns:a16="http://schemas.microsoft.com/office/drawing/2014/main" id="{09C2FFE6-EABE-4801-8848-0B60F9D60041}"/>
+                <a16:creationId xmlns:a16="http://schemas.microsoft.com/office/drawing/2014/main" id="{779C624A-2121-4B15-8788-C219CE64015E}"/>
               </a:ext>
             </a:extLst>
           </p:cNvPr>
@@ -13428,7 +13428,7 @@
           <p:cNvPr id="3" name="footer">
             <a:extLst xmlns:a="http://schemas.openxmlformats.org/drawingml/2006/main">
               <a:ext uri="{FF2B5EF4-FFF2-40B4-BE49-F238E27FC236}">
-                <a16:creationId xmlns:a16="http://schemas.microsoft.com/office/drawing/2014/main" id="{8354B9CA-DE3F-4231-82E7-FF7C3AD96D23}"/>
+                <a16:creationId xmlns:a16="http://schemas.microsoft.com/office/drawing/2014/main" id="{43EBE611-1BFC-47C6-B96D-CF9295E8987D}"/>
               </a:ext>
             </a:extLst>
           </p:cNvPr>
@@ -13488,7 +13488,7 @@
           <p:cNvPr id="4" name="lead">
             <a:extLst xmlns:a="http://schemas.openxmlformats.org/drawingml/2006/main">
               <a:ext uri="{FF2B5EF4-FFF2-40B4-BE49-F238E27FC236}">
-                <a16:creationId xmlns:a16="http://schemas.microsoft.com/office/drawing/2014/main" id="{3640DF6E-AAC6-4AA5-A150-EE6E97AF8ED4}"/>
+                <a16:creationId xmlns:a16="http://schemas.microsoft.com/office/drawing/2014/main" id="{9308997B-FBFC-4ECB-9008-13E17DF088B6}"/>
               </a:ext>
             </a:extLst>
           </p:cNvPr>
@@ -13548,7 +13548,7 @@
           <p:cNvPr id="5" name="surface-0">
             <a:extLst xmlns:a="http://schemas.openxmlformats.org/drawingml/2006/main">
               <a:ext uri="{FF2B5EF4-FFF2-40B4-BE49-F238E27FC236}">
-                <a16:creationId xmlns:a16="http://schemas.microsoft.com/office/drawing/2014/main" id="{9B0FA46B-A1F0-4663-AA9D-56F56FF88EEE}"/>
+                <a16:creationId xmlns:a16="http://schemas.microsoft.com/office/drawing/2014/main" id="{164878A0-465D-4CBC-92E4-AB98880A8BB6}"/>
               </a:ext>
             </a:extLst>
           </p:cNvPr>
@@ -13583,7 +13583,7 @@
           <p:cNvPr id="6" name="head-0">
             <a:extLst xmlns:a="http://schemas.openxmlformats.org/drawingml/2006/main">
               <a:ext uri="{FF2B5EF4-FFF2-40B4-BE49-F238E27FC236}">
-                <a16:creationId xmlns:a16="http://schemas.microsoft.com/office/drawing/2014/main" id="{66777CE3-8537-4B41-A4E0-1FFB30E9CCB1}"/>
+                <a16:creationId xmlns:a16="http://schemas.microsoft.com/office/drawing/2014/main" id="{C7AB1ACD-F228-415D-A8D0-BB6EBE0EAD6F}"/>
               </a:ext>
             </a:extLst>
           </p:cNvPr>
@@ -13643,7 +13643,7 @@
           <p:cNvPr id="7" name="list-0">
             <a:extLst xmlns:a="http://schemas.openxmlformats.org/drawingml/2006/main">
               <a:ext uri="{FF2B5EF4-FFF2-40B4-BE49-F238E27FC236}">
-                <a16:creationId xmlns:a16="http://schemas.microsoft.com/office/drawing/2014/main" id="{71857F45-02CC-442A-A4CA-A1E0DE09BF2F}"/>
+                <a16:creationId xmlns:a16="http://schemas.microsoft.com/office/drawing/2014/main" id="{4798DC0D-D355-47CE-9B02-5CCA7A129F43}"/>
               </a:ext>
             </a:extLst>
           </p:cNvPr>
@@ -13766,7 +13766,7 @@
           <p:cNvPr id="8" name="surface-1">
             <a:extLst xmlns:a="http://schemas.openxmlformats.org/drawingml/2006/main">
               <a:ext uri="{FF2B5EF4-FFF2-40B4-BE49-F238E27FC236}">
-                <a16:creationId xmlns:a16="http://schemas.microsoft.com/office/drawing/2014/main" id="{250DF1C0-DB09-4F4D-B13E-36ED849B68F1}"/>
+                <a16:creationId xmlns:a16="http://schemas.microsoft.com/office/drawing/2014/main" id="{F67ABC6E-4A33-42B6-AA8A-1A246406C295}"/>
               </a:ext>
             </a:extLst>
           </p:cNvPr>
@@ -13801,7 +13801,7 @@
           <p:cNvPr id="9" name="head-1">
             <a:extLst xmlns:a="http://schemas.openxmlformats.org/drawingml/2006/main">
               <a:ext uri="{FF2B5EF4-FFF2-40B4-BE49-F238E27FC236}">
-                <a16:creationId xmlns:a16="http://schemas.microsoft.com/office/drawing/2014/main" id="{C4420652-9DCD-49C6-A1B3-1B2E82C9318B}"/>
+                <a16:creationId xmlns:a16="http://schemas.microsoft.com/office/drawing/2014/main" id="{238E5DBC-9EB1-43AC-AFF0-7F8C8B548BC8}"/>
               </a:ext>
             </a:extLst>
           </p:cNvPr>
@@ -13861,7 +13861,7 @@
           <p:cNvPr id="10" name="list-1">
             <a:extLst xmlns:a="http://schemas.openxmlformats.org/drawingml/2006/main">
               <a:ext uri="{FF2B5EF4-FFF2-40B4-BE49-F238E27FC236}">
-                <a16:creationId xmlns:a16="http://schemas.microsoft.com/office/drawing/2014/main" id="{FE3F8FDF-BA77-4C4E-8DB0-B8677C1684B8}"/>
+                <a16:creationId xmlns:a16="http://schemas.microsoft.com/office/drawing/2014/main" id="{8F1ED5DA-4639-44CE-8071-B32B5F9DAF43}"/>
               </a:ext>
             </a:extLst>
           </p:cNvPr>
@@ -13984,7 +13984,7 @@
           <p:cNvPr id="11" name="bottom">
             <a:extLst xmlns:a="http://schemas.openxmlformats.org/drawingml/2006/main">
               <a:ext uri="{FF2B5EF4-FFF2-40B4-BE49-F238E27FC236}">
-                <a16:creationId xmlns:a16="http://schemas.microsoft.com/office/drawing/2014/main" id="{B6DED8CB-A802-432B-A59E-D3706166FFCE}"/>
+                <a16:creationId xmlns:a16="http://schemas.microsoft.com/office/drawing/2014/main" id="{D0EFAEC0-FEE1-4EBE-B0DA-DC849ACCB434}"/>
               </a:ext>
             </a:extLst>
           </p:cNvPr>
@@ -14042,7 +14042,7 @@
     </p:spTree>
     <p:extLst>
       <p:ext uri="{BB962C8B-B14F-4D97-AF65-F5344CB8AC3E}">
-        <p14:creationId xmlns:p14="http://schemas.microsoft.com/office/powerpoint/2010/main" val="1918959247"/>
+        <p14:creationId xmlns:p14="http://schemas.microsoft.com/office/powerpoint/2010/main" val="881549769"/>
       </p:ext>
     </p:extLst>
   </p:cSld>
@@ -14073,7 +14073,7 @@
           <p:cNvPr id="1" name="transition-title">
             <a:extLst xmlns:a="http://schemas.openxmlformats.org/drawingml/2006/main">
               <a:ext uri="{FF2B5EF4-FFF2-40B4-BE49-F238E27FC236}">
-                <a16:creationId xmlns:a16="http://schemas.microsoft.com/office/drawing/2014/main" id="{8DAF6668-A2B7-4032-B4F9-F38645A47D12}"/>
+                <a16:creationId xmlns:a16="http://schemas.microsoft.com/office/drawing/2014/main" id="{47CE911E-0F34-4403-A5FA-196FA6DA548A}"/>
               </a:ext>
             </a:extLst>
           </p:cNvPr>
@@ -14133,7 +14133,7 @@
           <p:cNvPr id="2" name="transition-subtitle">
             <a:extLst xmlns:a="http://schemas.openxmlformats.org/drawingml/2006/main">
               <a:ext uri="{FF2B5EF4-FFF2-40B4-BE49-F238E27FC236}">
-                <a16:creationId xmlns:a16="http://schemas.microsoft.com/office/drawing/2014/main" id="{59DC76A4-9361-43E6-A50D-6B727B717737}"/>
+                <a16:creationId xmlns:a16="http://schemas.microsoft.com/office/drawing/2014/main" id="{57C915D0-C500-4DEE-9E47-5D2F747A30BA}"/>
               </a:ext>
             </a:extLst>
           </p:cNvPr>
@@ -14193,7 +14193,7 @@
           <p:cNvPr id="3" name="model">
             <a:extLst xmlns:a="http://schemas.openxmlformats.org/drawingml/2006/main">
               <a:ext uri="{FF2B5EF4-FFF2-40B4-BE49-F238E27FC236}">
-                <a16:creationId xmlns:a16="http://schemas.microsoft.com/office/drawing/2014/main" id="{3CD46884-F65D-48D6-B2BC-24501B842257}"/>
+                <a16:creationId xmlns:a16="http://schemas.microsoft.com/office/drawing/2014/main" id="{DCCD56BE-7AAF-44CB-9671-B932DE8EDD19}"/>
               </a:ext>
             </a:extLst>
           </p:cNvPr>
@@ -14259,7 +14259,7 @@
           <p:cNvPr id="4" name="context">
             <a:extLst xmlns:a="http://schemas.openxmlformats.org/drawingml/2006/main">
               <a:ext uri="{FF2B5EF4-FFF2-40B4-BE49-F238E27FC236}">
-                <a16:creationId xmlns:a16="http://schemas.microsoft.com/office/drawing/2014/main" id="{78A19E55-452B-4C97-8FD8-0AA60B918DBC}"/>
+                <a16:creationId xmlns:a16="http://schemas.microsoft.com/office/drawing/2014/main" id="{9003D614-62C1-449E-B26B-91BFB08F0749}"/>
               </a:ext>
             </a:extLst>
           </p:cNvPr>
@@ -14325,7 +14325,7 @@
           <p:cNvPr id="5" name="tools">
             <a:extLst xmlns:a="http://schemas.openxmlformats.org/drawingml/2006/main">
               <a:ext uri="{FF2B5EF4-FFF2-40B4-BE49-F238E27FC236}">
-                <a16:creationId xmlns:a16="http://schemas.microsoft.com/office/drawing/2014/main" id="{52B56EA3-9FE4-43C1-9316-E93E79EB48BF}"/>
+                <a16:creationId xmlns:a16="http://schemas.microsoft.com/office/drawing/2014/main" id="{E7A7112B-BDF0-484D-8013-6568E80675B9}"/>
               </a:ext>
             </a:extLst>
           </p:cNvPr>
@@ -14391,7 +14391,7 @@
           <p:cNvPr id="6" name="verify">
             <a:extLst xmlns:a="http://schemas.openxmlformats.org/drawingml/2006/main">
               <a:ext uri="{FF2B5EF4-FFF2-40B4-BE49-F238E27FC236}">
-                <a16:creationId xmlns:a16="http://schemas.microsoft.com/office/drawing/2014/main" id="{18E380AD-09C6-4369-8E26-4DB62B27826F}"/>
+                <a16:creationId xmlns:a16="http://schemas.microsoft.com/office/drawing/2014/main" id="{E8263EEE-51EE-42CD-BBD9-68037EAE611A}"/>
               </a:ext>
             </a:extLst>
           </p:cNvPr>
@@ -14457,7 +14457,7 @@
           <p:cNvPr id="7" name="l1">
             <a:extLst xmlns:a="http://schemas.openxmlformats.org/drawingml/2006/main">
               <a:ext uri="{FF2B5EF4-FFF2-40B4-BE49-F238E27FC236}">
-                <a16:creationId xmlns:a16="http://schemas.microsoft.com/office/drawing/2014/main" id="{C98B2DEC-1DF7-4338-ADE7-4034B4F1E847}"/>
+                <a16:creationId xmlns:a16="http://schemas.microsoft.com/office/drawing/2014/main" id="{B6401517-F268-4F4A-B970-E91E0DA0B603}"/>
               </a:ext>
             </a:extLst>
           </p:cNvPr>
@@ -14488,7 +14488,7 @@
           <p:cNvPr id="8" name="l2">
             <a:extLst xmlns:a="http://schemas.openxmlformats.org/drawingml/2006/main">
               <a:ext uri="{FF2B5EF4-FFF2-40B4-BE49-F238E27FC236}">
-                <a16:creationId xmlns:a16="http://schemas.microsoft.com/office/drawing/2014/main" id="{FD2C0C03-CCE8-46D4-AC94-ECE52C1B2580}"/>
+                <a16:creationId xmlns:a16="http://schemas.microsoft.com/office/drawing/2014/main" id="{F9BBED5E-5D59-4272-B0A9-B64CBD21FAC1}"/>
               </a:ext>
             </a:extLst>
           </p:cNvPr>
@@ -14519,7 +14519,7 @@
           <p:cNvPr id="9" name="l3">
             <a:extLst xmlns:a="http://schemas.openxmlformats.org/drawingml/2006/main">
               <a:ext uri="{FF2B5EF4-FFF2-40B4-BE49-F238E27FC236}">
-                <a16:creationId xmlns:a16="http://schemas.microsoft.com/office/drawing/2014/main" id="{1D24FF7B-811A-4ECA-9D6F-C10102455E66}"/>
+                <a16:creationId xmlns:a16="http://schemas.microsoft.com/office/drawing/2014/main" id="{D88ED907-0E93-4134-96E9-F3F982636650}"/>
               </a:ext>
             </a:extLst>
           </p:cNvPr>
@@ -14550,7 +14550,7 @@
           <p:cNvPr id="10" name="wrap">
             <a:extLst xmlns:a="http://schemas.openxmlformats.org/drawingml/2006/main">
               <a:ext uri="{FF2B5EF4-FFF2-40B4-BE49-F238E27FC236}">
-                <a16:creationId xmlns:a16="http://schemas.microsoft.com/office/drawing/2014/main" id="{8D332270-8446-4AC6-9E11-74EABB4F2B58}"/>
+                <a16:creationId xmlns:a16="http://schemas.microsoft.com/office/drawing/2014/main" id="{C03D7171-699E-4300-B5C7-6A54BC85CE66}"/>
               </a:ext>
             </a:extLst>
           </p:cNvPr>
@@ -14610,7 +14610,7 @@
           <p:cNvPr id="11" name="footer-dark">
             <a:extLst xmlns:a="http://schemas.openxmlformats.org/drawingml/2006/main">
               <a:ext uri="{FF2B5EF4-FFF2-40B4-BE49-F238E27FC236}">
-                <a16:creationId xmlns:a16="http://schemas.microsoft.com/office/drawing/2014/main" id="{B46E7C1C-1DAC-497A-A616-D8DCBFE145B2}"/>
+                <a16:creationId xmlns:a16="http://schemas.microsoft.com/office/drawing/2014/main" id="{2278AB89-A568-4289-ADA0-698D4D93BB9F}"/>
               </a:ext>
             </a:extLst>
           </p:cNvPr>
@@ -14668,7 +14668,7 @@
     </p:spTree>
     <p:extLst>
       <p:ext uri="{BB962C8B-B14F-4D97-AF65-F5344CB8AC3E}">
-        <p14:creationId xmlns:p14="http://schemas.microsoft.com/office/powerpoint/2010/main" val="329002509"/>
+        <p14:creationId xmlns:p14="http://schemas.microsoft.com/office/powerpoint/2010/main" val="2047788643"/>
       </p:ext>
     </p:extLst>
   </p:cSld>
@@ -14699,7 +14699,7 @@
           <p:cNvPr id="1" name="eyebrow">
             <a:extLst xmlns:a="http://schemas.openxmlformats.org/drawingml/2006/main">
               <a:ext uri="{FF2B5EF4-FFF2-40B4-BE49-F238E27FC236}">
-                <a16:creationId xmlns:a16="http://schemas.microsoft.com/office/drawing/2014/main" id="{F966A855-B589-4165-8133-EA9DD2A96020}"/>
+                <a16:creationId xmlns:a16="http://schemas.microsoft.com/office/drawing/2014/main" id="{F7FB7E10-3F72-49E7-909F-34B06E103005}"/>
               </a:ext>
             </a:extLst>
           </p:cNvPr>
@@ -14759,7 +14759,7 @@
           <p:cNvPr id="2" name="title">
             <a:extLst xmlns:a="http://schemas.openxmlformats.org/drawingml/2006/main">
               <a:ext uri="{FF2B5EF4-FFF2-40B4-BE49-F238E27FC236}">
-                <a16:creationId xmlns:a16="http://schemas.microsoft.com/office/drawing/2014/main" id="{69869F3F-D076-45ED-BD3F-403C8C1564DB}"/>
+                <a16:creationId xmlns:a16="http://schemas.microsoft.com/office/drawing/2014/main" id="{25783733-8456-40DF-A831-BF948E66B18E}"/>
               </a:ext>
             </a:extLst>
           </p:cNvPr>
@@ -14819,7 +14819,7 @@
           <p:cNvPr id="3" name="footer">
             <a:extLst xmlns:a="http://schemas.openxmlformats.org/drawingml/2006/main">
               <a:ext uri="{FF2B5EF4-FFF2-40B4-BE49-F238E27FC236}">
-                <a16:creationId xmlns:a16="http://schemas.microsoft.com/office/drawing/2014/main" id="{21A40C54-3C50-4D5D-BD25-4B3262504192}"/>
+                <a16:creationId xmlns:a16="http://schemas.microsoft.com/office/drawing/2014/main" id="{B5AE2443-E8F3-4A10-9EDC-6A4F556CBBDD}"/>
               </a:ext>
             </a:extLst>
           </p:cNvPr>
@@ -14879,7 +14879,7 @@
           <p:cNvPr id="4" name="stack-0">
             <a:extLst xmlns:a="http://schemas.openxmlformats.org/drawingml/2006/main">
               <a:ext uri="{FF2B5EF4-FFF2-40B4-BE49-F238E27FC236}">
-                <a16:creationId xmlns:a16="http://schemas.microsoft.com/office/drawing/2014/main" id="{BF0E949E-26E1-4C4A-AB76-10AC7D7094B6}"/>
+                <a16:creationId xmlns:a16="http://schemas.microsoft.com/office/drawing/2014/main" id="{2B68EC39-26DB-4D2A-9F86-DC1B52063005}"/>
               </a:ext>
             </a:extLst>
           </p:cNvPr>
@@ -14914,7 +14914,7 @@
           <p:cNvPr id="5" name="stack-name-0">
             <a:extLst xmlns:a="http://schemas.openxmlformats.org/drawingml/2006/main">
               <a:ext uri="{FF2B5EF4-FFF2-40B4-BE49-F238E27FC236}">
-                <a16:creationId xmlns:a16="http://schemas.microsoft.com/office/drawing/2014/main" id="{06846408-2239-47FE-9DEB-47C69E51F7A2}"/>
+                <a16:creationId xmlns:a16="http://schemas.microsoft.com/office/drawing/2014/main" id="{564D68ED-6484-4D26-A001-A3FF0A7CC6D9}"/>
               </a:ext>
             </a:extLst>
           </p:cNvPr>
@@ -14974,7 +14974,7 @@
           <p:cNvPr id="6" name="stack-copy-0">
             <a:extLst xmlns:a="http://schemas.openxmlformats.org/drawingml/2006/main">
               <a:ext uri="{FF2B5EF4-FFF2-40B4-BE49-F238E27FC236}">
-                <a16:creationId xmlns:a16="http://schemas.microsoft.com/office/drawing/2014/main" id="{83D30021-3976-4A00-A744-9D995FFCE8C7}"/>
+                <a16:creationId xmlns:a16="http://schemas.microsoft.com/office/drawing/2014/main" id="{A2A93F5A-E805-47E2-AF5B-559F64576BA3}"/>
               </a:ext>
             </a:extLst>
           </p:cNvPr>
@@ -15034,7 +15034,7 @@
           <p:cNvPr id="7" name="stack-line-0">
             <a:extLst xmlns:a="http://schemas.openxmlformats.org/drawingml/2006/main">
               <a:ext uri="{FF2B5EF4-FFF2-40B4-BE49-F238E27FC236}">
-                <a16:creationId xmlns:a16="http://schemas.microsoft.com/office/drawing/2014/main" id="{848420EF-CAA0-44A2-AD9B-F96493FE443B}"/>
+                <a16:creationId xmlns:a16="http://schemas.microsoft.com/office/drawing/2014/main" id="{37087F17-0EFB-4BA6-9894-D49C66DE3E83}"/>
               </a:ext>
             </a:extLst>
           </p:cNvPr>
@@ -15065,7 +15065,7 @@
           <p:cNvPr id="8" name="stack-1">
             <a:extLst xmlns:a="http://schemas.openxmlformats.org/drawingml/2006/main">
               <a:ext uri="{FF2B5EF4-FFF2-40B4-BE49-F238E27FC236}">
-                <a16:creationId xmlns:a16="http://schemas.microsoft.com/office/drawing/2014/main" id="{9FAB150F-B537-45D1-88AC-769103BC1D99}"/>
+                <a16:creationId xmlns:a16="http://schemas.microsoft.com/office/drawing/2014/main" id="{72677F5D-9105-4D8F-A320-AD767CD385A2}"/>
               </a:ext>
             </a:extLst>
           </p:cNvPr>
@@ -15100,7 +15100,7 @@
           <p:cNvPr id="9" name="stack-name-1">
             <a:extLst xmlns:a="http://schemas.openxmlformats.org/drawingml/2006/main">
               <a:ext uri="{FF2B5EF4-FFF2-40B4-BE49-F238E27FC236}">
-                <a16:creationId xmlns:a16="http://schemas.microsoft.com/office/drawing/2014/main" id="{C3EC4BA3-FFD6-4ADA-8791-493029835FEE}"/>
+                <a16:creationId xmlns:a16="http://schemas.microsoft.com/office/drawing/2014/main" id="{CB2FE843-90B1-489C-911E-9EF40844B345}"/>
               </a:ext>
             </a:extLst>
           </p:cNvPr>
@@ -15160,7 +15160,7 @@
           <p:cNvPr id="10" name="stack-copy-1">
             <a:extLst xmlns:a="http://schemas.openxmlformats.org/drawingml/2006/main">
               <a:ext uri="{FF2B5EF4-FFF2-40B4-BE49-F238E27FC236}">
-                <a16:creationId xmlns:a16="http://schemas.microsoft.com/office/drawing/2014/main" id="{2D223C4A-82D0-4D0B-9BEF-230E3C5908D1}"/>
+                <a16:creationId xmlns:a16="http://schemas.microsoft.com/office/drawing/2014/main" id="{4B56D0D4-1E31-41F8-B23A-F03483069DAF}"/>
               </a:ext>
             </a:extLst>
           </p:cNvPr>
@@ -15220,7 +15220,7 @@
           <p:cNvPr id="11" name="stack-line-1">
             <a:extLst xmlns:a="http://schemas.openxmlformats.org/drawingml/2006/main">
               <a:ext uri="{FF2B5EF4-FFF2-40B4-BE49-F238E27FC236}">
-                <a16:creationId xmlns:a16="http://schemas.microsoft.com/office/drawing/2014/main" id="{7901D1F3-6997-4195-91D6-BB271E413972}"/>
+                <a16:creationId xmlns:a16="http://schemas.microsoft.com/office/drawing/2014/main" id="{47D74292-2192-4799-89E7-37481393D658}"/>
               </a:ext>
             </a:extLst>
           </p:cNvPr>
@@ -15251,7 +15251,7 @@
           <p:cNvPr id="12" name="stack-2">
             <a:extLst xmlns:a="http://schemas.openxmlformats.org/drawingml/2006/main">
               <a:ext uri="{FF2B5EF4-FFF2-40B4-BE49-F238E27FC236}">
-                <a16:creationId xmlns:a16="http://schemas.microsoft.com/office/drawing/2014/main" id="{583208CC-43E1-4501-8881-E990D6BB88AF}"/>
+                <a16:creationId xmlns:a16="http://schemas.microsoft.com/office/drawing/2014/main" id="{A37A9165-9FB1-4D88-8A4E-32C36337107E}"/>
               </a:ext>
             </a:extLst>
           </p:cNvPr>
@@ -15286,7 +15286,7 @@
           <p:cNvPr id="13" name="stack-name-2">
             <a:extLst xmlns:a="http://schemas.openxmlformats.org/drawingml/2006/main">
               <a:ext uri="{FF2B5EF4-FFF2-40B4-BE49-F238E27FC236}">
-                <a16:creationId xmlns:a16="http://schemas.microsoft.com/office/drawing/2014/main" id="{2BDD8889-CD73-4B50-AA1C-EB8F9933A1E5}"/>
+                <a16:creationId xmlns:a16="http://schemas.microsoft.com/office/drawing/2014/main" id="{E950E63D-6C19-43F2-A3CD-458A6CBCDFC7}"/>
               </a:ext>
             </a:extLst>
           </p:cNvPr>
@@ -15346,7 +15346,7 @@
           <p:cNvPr id="14" name="stack-copy-2">
             <a:extLst xmlns:a="http://schemas.openxmlformats.org/drawingml/2006/main">
               <a:ext uri="{FF2B5EF4-FFF2-40B4-BE49-F238E27FC236}">
-                <a16:creationId xmlns:a16="http://schemas.microsoft.com/office/drawing/2014/main" id="{F302738B-2220-4F3A-9E50-79D818371DF5}"/>
+                <a16:creationId xmlns:a16="http://schemas.microsoft.com/office/drawing/2014/main" id="{DBD3DD9E-691E-461D-A320-4A59A06CF394}"/>
               </a:ext>
             </a:extLst>
           </p:cNvPr>
@@ -15406,7 +15406,7 @@
           <p:cNvPr id="15" name="stack-line-2">
             <a:extLst xmlns:a="http://schemas.openxmlformats.org/drawingml/2006/main">
               <a:ext uri="{FF2B5EF4-FFF2-40B4-BE49-F238E27FC236}">
-                <a16:creationId xmlns:a16="http://schemas.microsoft.com/office/drawing/2014/main" id="{5CC84BDD-49DA-471E-A207-4AB8D7292F1D}"/>
+                <a16:creationId xmlns:a16="http://schemas.microsoft.com/office/drawing/2014/main" id="{5AED4FA1-E5E0-460B-BEB5-2435BA0DD53E}"/>
               </a:ext>
             </a:extLst>
           </p:cNvPr>
@@ -15437,7 +15437,7 @@
           <p:cNvPr id="16" name="stack-3">
             <a:extLst xmlns:a="http://schemas.openxmlformats.org/drawingml/2006/main">
               <a:ext uri="{FF2B5EF4-FFF2-40B4-BE49-F238E27FC236}">
-                <a16:creationId xmlns:a16="http://schemas.microsoft.com/office/drawing/2014/main" id="{E30B34A5-9B28-48A5-BD59-E5360D79BECA}"/>
+                <a16:creationId xmlns:a16="http://schemas.microsoft.com/office/drawing/2014/main" id="{93B36330-C0FB-4EC3-B505-7D9F71C1B735}"/>
               </a:ext>
             </a:extLst>
           </p:cNvPr>
@@ -15472,7 +15472,7 @@
           <p:cNvPr id="17" name="stack-name-3">
             <a:extLst xmlns:a="http://schemas.openxmlformats.org/drawingml/2006/main">
               <a:ext uri="{FF2B5EF4-FFF2-40B4-BE49-F238E27FC236}">
-                <a16:creationId xmlns:a16="http://schemas.microsoft.com/office/drawing/2014/main" id="{3374EDA8-46FF-4FC0-8AB8-E9C0D53042CA}"/>
+                <a16:creationId xmlns:a16="http://schemas.microsoft.com/office/drawing/2014/main" id="{E25C6451-84E5-4B84-B2E1-A3E5B98E7070}"/>
               </a:ext>
             </a:extLst>
           </p:cNvPr>
@@ -15532,7 +15532,7 @@
           <p:cNvPr id="18" name="stack-copy-3">
             <a:extLst xmlns:a="http://schemas.openxmlformats.org/drawingml/2006/main">
               <a:ext uri="{FF2B5EF4-FFF2-40B4-BE49-F238E27FC236}">
-                <a16:creationId xmlns:a16="http://schemas.microsoft.com/office/drawing/2014/main" id="{778FC70F-4F95-4FFA-926D-E1211B530892}"/>
+                <a16:creationId xmlns:a16="http://schemas.microsoft.com/office/drawing/2014/main" id="{23CD4935-5A23-43D0-9827-9DE1F028B196}"/>
               </a:ext>
             </a:extLst>
           </p:cNvPr>
@@ -15592,7 +15592,7 @@
           <p:cNvPr id="19" name="stack-line-3">
             <a:extLst xmlns:a="http://schemas.openxmlformats.org/drawingml/2006/main">
               <a:ext uri="{FF2B5EF4-FFF2-40B4-BE49-F238E27FC236}">
-                <a16:creationId xmlns:a16="http://schemas.microsoft.com/office/drawing/2014/main" id="{B3B595F2-4B5C-47C2-81FC-71056DB32ED9}"/>
+                <a16:creationId xmlns:a16="http://schemas.microsoft.com/office/drawing/2014/main" id="{1617835A-A276-4187-BB91-FE3AE0B710B3}"/>
               </a:ext>
             </a:extLst>
           </p:cNvPr>
@@ -15623,7 +15623,7 @@
           <p:cNvPr id="20" name="stack-4">
             <a:extLst xmlns:a="http://schemas.openxmlformats.org/drawingml/2006/main">
               <a:ext uri="{FF2B5EF4-FFF2-40B4-BE49-F238E27FC236}">
-                <a16:creationId xmlns:a16="http://schemas.microsoft.com/office/drawing/2014/main" id="{5C9C956C-0628-441F-B5A8-088A1F92E249}"/>
+                <a16:creationId xmlns:a16="http://schemas.microsoft.com/office/drawing/2014/main" id="{1A553FD9-BFF3-424F-BCFF-83FC7071123D}"/>
               </a:ext>
             </a:extLst>
           </p:cNvPr>
@@ -15658,7 +15658,7 @@
           <p:cNvPr id="21" name="stack-name-4">
             <a:extLst xmlns:a="http://schemas.openxmlformats.org/drawingml/2006/main">
               <a:ext uri="{FF2B5EF4-FFF2-40B4-BE49-F238E27FC236}">
-                <a16:creationId xmlns:a16="http://schemas.microsoft.com/office/drawing/2014/main" id="{DE5BCC6E-AD77-4A3E-9916-8F164D0C300C}"/>
+                <a16:creationId xmlns:a16="http://schemas.microsoft.com/office/drawing/2014/main" id="{DB0EBEED-E404-450E-8263-AEFEB3E58CAD}"/>
               </a:ext>
             </a:extLst>
           </p:cNvPr>
@@ -15718,7 +15718,7 @@
           <p:cNvPr id="22" name="stack-copy-4">
             <a:extLst xmlns:a="http://schemas.openxmlformats.org/drawingml/2006/main">
               <a:ext uri="{FF2B5EF4-FFF2-40B4-BE49-F238E27FC236}">
-                <a16:creationId xmlns:a16="http://schemas.microsoft.com/office/drawing/2014/main" id="{737B3103-33B0-4FD2-B3B4-AA5175C58EA1}"/>
+                <a16:creationId xmlns:a16="http://schemas.microsoft.com/office/drawing/2014/main" id="{11A07700-45CD-4923-9AC5-F6022FC869D3}"/>
               </a:ext>
             </a:extLst>
           </p:cNvPr>
@@ -15778,7 +15778,7 @@
           <p:cNvPr id="23" name="stack-line-4">
             <a:extLst xmlns:a="http://schemas.openxmlformats.org/drawingml/2006/main">
               <a:ext uri="{FF2B5EF4-FFF2-40B4-BE49-F238E27FC236}">
-                <a16:creationId xmlns:a16="http://schemas.microsoft.com/office/drawing/2014/main" id="{9974C619-BBD0-4E3C-B9BA-D76CCDC829E3}"/>
+                <a16:creationId xmlns:a16="http://schemas.microsoft.com/office/drawing/2014/main" id="{D8028370-1CEC-4219-A210-93F225CE49A1}"/>
               </a:ext>
             </a:extLst>
           </p:cNvPr>
@@ -15809,7 +15809,7 @@
           <p:cNvPr id="24" name="goal-box">
             <a:extLst xmlns:a="http://schemas.openxmlformats.org/drawingml/2006/main">
               <a:ext uri="{FF2B5EF4-FFF2-40B4-BE49-F238E27FC236}">
-                <a16:creationId xmlns:a16="http://schemas.microsoft.com/office/drawing/2014/main" id="{06923C59-88A4-4CDA-A970-A876664AF830}"/>
+                <a16:creationId xmlns:a16="http://schemas.microsoft.com/office/drawing/2014/main" id="{401C2498-C1FF-4E13-883D-3FF1D2690F63}"/>
               </a:ext>
             </a:extLst>
           </p:cNvPr>
@@ -15844,7 +15844,7 @@
           <p:cNvPr id="25" name="goal-text">
             <a:extLst xmlns:a="http://schemas.openxmlformats.org/drawingml/2006/main">
               <a:ext uri="{FF2B5EF4-FFF2-40B4-BE49-F238E27FC236}">
-                <a16:creationId xmlns:a16="http://schemas.microsoft.com/office/drawing/2014/main" id="{C251665F-E7CB-42D9-872B-DF8DAE175646}"/>
+                <a16:creationId xmlns:a16="http://schemas.microsoft.com/office/drawing/2014/main" id="{5C35EAE2-E91A-4648-AA1C-4EDE1AE80173}"/>
               </a:ext>
             </a:extLst>
           </p:cNvPr>
@@ -15902,7 +15902,7 @@
     </p:spTree>
     <p:extLst>
       <p:ext uri="{BB962C8B-B14F-4D97-AF65-F5344CB8AC3E}">
-        <p14:creationId xmlns:p14="http://schemas.microsoft.com/office/powerpoint/2010/main" val="386316451"/>
+        <p14:creationId xmlns:p14="http://schemas.microsoft.com/office/powerpoint/2010/main" val="713548040"/>
       </p:ext>
     </p:extLst>
   </p:cSld>
@@ -15933,7 +15933,7 @@
           <p:cNvPr id="1" name="eyebrow">
             <a:extLst xmlns:a="http://schemas.openxmlformats.org/drawingml/2006/main">
               <a:ext uri="{FF2B5EF4-FFF2-40B4-BE49-F238E27FC236}">
-                <a16:creationId xmlns:a16="http://schemas.microsoft.com/office/drawing/2014/main" id="{0765B526-F9E8-482F-B180-AE3D3217125E}"/>
+                <a16:creationId xmlns:a16="http://schemas.microsoft.com/office/drawing/2014/main" id="{ACE4509C-1F17-4C42-8359-12EB72B04A4C}"/>
               </a:ext>
             </a:extLst>
           </p:cNvPr>
@@ -15993,7 +15993,7 @@
           <p:cNvPr id="2" name="title">
             <a:extLst xmlns:a="http://schemas.openxmlformats.org/drawingml/2006/main">
               <a:ext uri="{FF2B5EF4-FFF2-40B4-BE49-F238E27FC236}">
-                <a16:creationId xmlns:a16="http://schemas.microsoft.com/office/drawing/2014/main" id="{E3E532CC-CC9F-41B0-BD7A-1FC472BF6E9A}"/>
+                <a16:creationId xmlns:a16="http://schemas.microsoft.com/office/drawing/2014/main" id="{66CA6180-C25C-4752-BEDF-335034E55FC4}"/>
               </a:ext>
             </a:extLst>
           </p:cNvPr>
@@ -16053,7 +16053,7 @@
           <p:cNvPr id="3" name="footer">
             <a:extLst xmlns:a="http://schemas.openxmlformats.org/drawingml/2006/main">
               <a:ext uri="{FF2B5EF4-FFF2-40B4-BE49-F238E27FC236}">
-                <a16:creationId xmlns:a16="http://schemas.microsoft.com/office/drawing/2014/main" id="{55EA2AEE-DAD5-4E7A-88C8-F043B45F2ACF}"/>
+                <a16:creationId xmlns:a16="http://schemas.microsoft.com/office/drawing/2014/main" id="{3FC6591E-BCF7-45C8-A442-784F96928064}"/>
               </a:ext>
             </a:extLst>
           </p:cNvPr>
@@ -16113,7 +16113,7 @@
           <p:cNvPr id="4" name="scenario">
             <a:extLst xmlns:a="http://schemas.openxmlformats.org/drawingml/2006/main">
               <a:ext uri="{FF2B5EF4-FFF2-40B4-BE49-F238E27FC236}">
-                <a16:creationId xmlns:a16="http://schemas.microsoft.com/office/drawing/2014/main" id="{DC8F2F26-BD81-40F7-A30E-E6C8E637A7B0}"/>
+                <a16:creationId xmlns:a16="http://schemas.microsoft.com/office/drawing/2014/main" id="{D989045A-010F-4B13-8CC1-A6440A57B568}"/>
               </a:ext>
             </a:extLst>
           </p:cNvPr>
@@ -16173,7 +16173,7 @@
           <p:cNvPr id="5" name="row-head-0">
             <a:extLst xmlns:a="http://schemas.openxmlformats.org/drawingml/2006/main">
               <a:ext uri="{FF2B5EF4-FFF2-40B4-BE49-F238E27FC236}">
-                <a16:creationId xmlns:a16="http://schemas.microsoft.com/office/drawing/2014/main" id="{56A8BB56-1E78-4905-9FF0-BEC785E2517D}"/>
+                <a16:creationId xmlns:a16="http://schemas.microsoft.com/office/drawing/2014/main" id="{83B26797-2734-47B1-8BC7-64011E8DE6BC}"/>
               </a:ext>
             </a:extLst>
           </p:cNvPr>
@@ -16239,7 +16239,7 @@
           <p:cNvPr id="6" name="row-copy-0">
             <a:extLst xmlns:a="http://schemas.openxmlformats.org/drawingml/2006/main">
               <a:ext uri="{FF2B5EF4-FFF2-40B4-BE49-F238E27FC236}">
-                <a16:creationId xmlns:a16="http://schemas.microsoft.com/office/drawing/2014/main" id="{13B91C60-F71E-4EFB-8467-2D3FD81901D6}"/>
+                <a16:creationId xmlns:a16="http://schemas.microsoft.com/office/drawing/2014/main" id="{1BB84B6A-E7F8-4564-BA2D-BAE658F7654C}"/>
               </a:ext>
             </a:extLst>
           </p:cNvPr>
@@ -16299,7 +16299,7 @@
           <p:cNvPr id="7" name="row-line-0">
             <a:extLst xmlns:a="http://schemas.openxmlformats.org/drawingml/2006/main">
               <a:ext uri="{FF2B5EF4-FFF2-40B4-BE49-F238E27FC236}">
-                <a16:creationId xmlns:a16="http://schemas.microsoft.com/office/drawing/2014/main" id="{4E1E8AE4-B6E4-4E6E-AF38-E97E5B71FEFB}"/>
+                <a16:creationId xmlns:a16="http://schemas.microsoft.com/office/drawing/2014/main" id="{1EF8283F-049E-4AE3-B617-0842ADB12979}"/>
               </a:ext>
             </a:extLst>
           </p:cNvPr>
@@ -16330,7 +16330,7 @@
           <p:cNvPr id="8" name="row-head-1">
             <a:extLst xmlns:a="http://schemas.openxmlformats.org/drawingml/2006/main">
               <a:ext uri="{FF2B5EF4-FFF2-40B4-BE49-F238E27FC236}">
-                <a16:creationId xmlns:a16="http://schemas.microsoft.com/office/drawing/2014/main" id="{B886C311-61A3-48B9-8608-69FB1737B98C}"/>
+                <a16:creationId xmlns:a16="http://schemas.microsoft.com/office/drawing/2014/main" id="{4633D9FD-5EBC-42D4-91C9-EA93998CCD86}"/>
               </a:ext>
             </a:extLst>
           </p:cNvPr>
@@ -16396,7 +16396,7 @@
           <p:cNvPr id="9" name="row-copy-1">
             <a:extLst xmlns:a="http://schemas.openxmlformats.org/drawingml/2006/main">
               <a:ext uri="{FF2B5EF4-FFF2-40B4-BE49-F238E27FC236}">
-                <a16:creationId xmlns:a16="http://schemas.microsoft.com/office/drawing/2014/main" id="{B4C06BCA-DE68-477A-ABC9-B0361DDB02BF}"/>
+                <a16:creationId xmlns:a16="http://schemas.microsoft.com/office/drawing/2014/main" id="{02E1FDFE-AC6E-4203-8E49-B666CE7DD941}"/>
               </a:ext>
             </a:extLst>
           </p:cNvPr>
@@ -16456,7 +16456,7 @@
           <p:cNvPr id="10" name="row-line-1">
             <a:extLst xmlns:a="http://schemas.openxmlformats.org/drawingml/2006/main">
               <a:ext uri="{FF2B5EF4-FFF2-40B4-BE49-F238E27FC236}">
-                <a16:creationId xmlns:a16="http://schemas.microsoft.com/office/drawing/2014/main" id="{4907C81C-6427-42B6-AB5F-2519D851490B}"/>
+                <a16:creationId xmlns:a16="http://schemas.microsoft.com/office/drawing/2014/main" id="{F495CC6C-388D-48FE-9597-8A83009BC0D7}"/>
               </a:ext>
             </a:extLst>
           </p:cNvPr>
@@ -16487,7 +16487,7 @@
           <p:cNvPr id="11" name="row-head-2">
             <a:extLst xmlns:a="http://schemas.openxmlformats.org/drawingml/2006/main">
               <a:ext uri="{FF2B5EF4-FFF2-40B4-BE49-F238E27FC236}">
-                <a16:creationId xmlns:a16="http://schemas.microsoft.com/office/drawing/2014/main" id="{AAEBA343-35CF-41BE-AE74-5BC8E770B010}"/>
+                <a16:creationId xmlns:a16="http://schemas.microsoft.com/office/drawing/2014/main" id="{4EBBFE36-E588-4446-A6B2-25FD3F580A94}"/>
               </a:ext>
             </a:extLst>
           </p:cNvPr>
@@ -16553,7 +16553,7 @@
           <p:cNvPr id="12" name="row-copy-2">
             <a:extLst xmlns:a="http://schemas.openxmlformats.org/drawingml/2006/main">
               <a:ext uri="{FF2B5EF4-FFF2-40B4-BE49-F238E27FC236}">
-                <a16:creationId xmlns:a16="http://schemas.microsoft.com/office/drawing/2014/main" id="{E7FF49E5-0A95-4BE3-91E0-B8CFC0673E39}"/>
+                <a16:creationId xmlns:a16="http://schemas.microsoft.com/office/drawing/2014/main" id="{8EAB7A44-C760-4AB0-BA68-D6E0A1D5FCCE}"/>
               </a:ext>
             </a:extLst>
           </p:cNvPr>
@@ -16613,7 +16613,7 @@
           <p:cNvPr id="13" name="row-line-2">
             <a:extLst xmlns:a="http://schemas.openxmlformats.org/drawingml/2006/main">
               <a:ext uri="{FF2B5EF4-FFF2-40B4-BE49-F238E27FC236}">
-                <a16:creationId xmlns:a16="http://schemas.microsoft.com/office/drawing/2014/main" id="{431B0D28-D4F2-4BEB-A4DA-588C4D274D02}"/>
+                <a16:creationId xmlns:a16="http://schemas.microsoft.com/office/drawing/2014/main" id="{EBD286EE-930B-4934-B080-644BB2F4666C}"/>
               </a:ext>
             </a:extLst>
           </p:cNvPr>
@@ -16644,7 +16644,7 @@
           <p:cNvPr id="14" name="row-head-3">
             <a:extLst xmlns:a="http://schemas.openxmlformats.org/drawingml/2006/main">
               <a:ext uri="{FF2B5EF4-FFF2-40B4-BE49-F238E27FC236}">
-                <a16:creationId xmlns:a16="http://schemas.microsoft.com/office/drawing/2014/main" id="{615468F2-7676-4937-B9AC-4FB9F74AEF9F}"/>
+                <a16:creationId xmlns:a16="http://schemas.microsoft.com/office/drawing/2014/main" id="{4C08DFE2-5357-4E43-9B30-8DD7EDE2AF07}"/>
               </a:ext>
             </a:extLst>
           </p:cNvPr>
@@ -16710,7 +16710,7 @@
           <p:cNvPr id="15" name="row-copy-3">
             <a:extLst xmlns:a="http://schemas.openxmlformats.org/drawingml/2006/main">
               <a:ext uri="{FF2B5EF4-FFF2-40B4-BE49-F238E27FC236}">
-                <a16:creationId xmlns:a16="http://schemas.microsoft.com/office/drawing/2014/main" id="{D930F78A-8CF1-4169-A667-5494E17C6FEF}"/>
+                <a16:creationId xmlns:a16="http://schemas.microsoft.com/office/drawing/2014/main" id="{F50C4B9B-2B62-4453-BD23-9BA0FFF294F9}"/>
               </a:ext>
             </a:extLst>
           </p:cNvPr>
@@ -16770,7 +16770,7 @@
           <p:cNvPr id="16" name="row-line-3">
             <a:extLst xmlns:a="http://schemas.openxmlformats.org/drawingml/2006/main">
               <a:ext uri="{FF2B5EF4-FFF2-40B4-BE49-F238E27FC236}">
-                <a16:creationId xmlns:a16="http://schemas.microsoft.com/office/drawing/2014/main" id="{6D0AD622-6445-47E8-AB3D-D33B31F654E0}"/>
+                <a16:creationId xmlns:a16="http://schemas.microsoft.com/office/drawing/2014/main" id="{CAFF81DF-A608-4755-9E47-BD0CBFB5754D}"/>
               </a:ext>
             </a:extLst>
           </p:cNvPr>
@@ -16801,7 +16801,7 @@
           <p:cNvPr id="17" name="note">
             <a:extLst xmlns:a="http://schemas.openxmlformats.org/drawingml/2006/main">
               <a:ext uri="{FF2B5EF4-FFF2-40B4-BE49-F238E27FC236}">
-                <a16:creationId xmlns:a16="http://schemas.microsoft.com/office/drawing/2014/main" id="{26711E85-02F8-41D2-B5C8-B6EA59164DD4}"/>
+                <a16:creationId xmlns:a16="http://schemas.microsoft.com/office/drawing/2014/main" id="{C6DC7D16-E318-42B1-A8BB-83E7C3C505A0}"/>
               </a:ext>
             </a:extLst>
           </p:cNvPr>
@@ -16859,7 +16859,7 @@
     </p:spTree>
     <p:extLst>
       <p:ext uri="{BB962C8B-B14F-4D97-AF65-F5344CB8AC3E}">
-        <p14:creationId xmlns:p14="http://schemas.microsoft.com/office/powerpoint/2010/main" val="2016296505"/>
+        <p14:creationId xmlns:p14="http://schemas.microsoft.com/office/powerpoint/2010/main" val="2069406665"/>
       </p:ext>
     </p:extLst>
   </p:cSld>
@@ -16890,7 +16890,7 @@
           <p:cNvPr id="1" name="eyebrow">
             <a:extLst xmlns:a="http://schemas.openxmlformats.org/drawingml/2006/main">
               <a:ext uri="{FF2B5EF4-FFF2-40B4-BE49-F238E27FC236}">
-                <a16:creationId xmlns:a16="http://schemas.microsoft.com/office/drawing/2014/main" id="{D2411D66-4313-459B-9FE3-DC9BDAB67FC7}"/>
+                <a16:creationId xmlns:a16="http://schemas.microsoft.com/office/drawing/2014/main" id="{8FED15C3-94A2-4279-8DF4-831CD2F33C26}"/>
               </a:ext>
             </a:extLst>
           </p:cNvPr>
@@ -16950,7 +16950,7 @@
           <p:cNvPr id="2" name="title">
             <a:extLst xmlns:a="http://schemas.openxmlformats.org/drawingml/2006/main">
               <a:ext uri="{FF2B5EF4-FFF2-40B4-BE49-F238E27FC236}">
-                <a16:creationId xmlns:a16="http://schemas.microsoft.com/office/drawing/2014/main" id="{AB0AA2ED-2603-4615-BE65-39678DC0BB76}"/>
+                <a16:creationId xmlns:a16="http://schemas.microsoft.com/office/drawing/2014/main" id="{336209F4-9DC3-4FBE-B410-41DD76AE2118}"/>
               </a:ext>
             </a:extLst>
           </p:cNvPr>
@@ -17010,7 +17010,7 @@
           <p:cNvPr id="3" name="footer">
             <a:extLst xmlns:a="http://schemas.openxmlformats.org/drawingml/2006/main">
               <a:ext uri="{FF2B5EF4-FFF2-40B4-BE49-F238E27FC236}">
-                <a16:creationId xmlns:a16="http://schemas.microsoft.com/office/drawing/2014/main" id="{43A86ACD-E24E-471C-BDEE-41494DB048EC}"/>
+                <a16:creationId xmlns:a16="http://schemas.microsoft.com/office/drawing/2014/main" id="{90A35F33-538E-4252-AF37-A83D1A024DDB}"/>
               </a:ext>
             </a:extLst>
           </p:cNvPr>
@@ -17070,7 +17070,7 @@
           <p:cNvPr id="4" name="ladder-line">
             <a:extLst xmlns:a="http://schemas.openxmlformats.org/drawingml/2006/main">
               <a:ext uri="{FF2B5EF4-FFF2-40B4-BE49-F238E27FC236}">
-                <a16:creationId xmlns:a16="http://schemas.microsoft.com/office/drawing/2014/main" id="{197F3C28-A7A3-45F9-8EAC-4ADDD8393A75}"/>
+                <a16:creationId xmlns:a16="http://schemas.microsoft.com/office/drawing/2014/main" id="{E1AECFA0-3887-45BA-BC79-6942F6D6A0DA}"/>
               </a:ext>
             </a:extLst>
           </p:cNvPr>
@@ -17101,7 +17101,7 @@
           <p:cNvPr id="5" name="level-0">
             <a:extLst xmlns:a="http://schemas.openxmlformats.org/drawingml/2006/main">
               <a:ext uri="{FF2B5EF4-FFF2-40B4-BE49-F238E27FC236}">
-                <a16:creationId xmlns:a16="http://schemas.microsoft.com/office/drawing/2014/main" id="{2D1962D4-596C-4524-B36E-CC1D6B761F77}"/>
+                <a16:creationId xmlns:a16="http://schemas.microsoft.com/office/drawing/2014/main" id="{DA275454-77C7-415C-BE90-134CCDE78448}"/>
               </a:ext>
             </a:extLst>
           </p:cNvPr>
@@ -17167,7 +17167,7 @@
           <p:cNvPr id="6" name="level-copy-0">
             <a:extLst xmlns:a="http://schemas.openxmlformats.org/drawingml/2006/main">
               <a:ext uri="{FF2B5EF4-FFF2-40B4-BE49-F238E27FC236}">
-                <a16:creationId xmlns:a16="http://schemas.microsoft.com/office/drawing/2014/main" id="{B57475C3-3316-4EA6-9B54-D23096440513}"/>
+                <a16:creationId xmlns:a16="http://schemas.microsoft.com/office/drawing/2014/main" id="{FB1F40D8-D643-4005-AFBD-AF11276A7F42}"/>
               </a:ext>
             </a:extLst>
           </p:cNvPr>
@@ -17227,7 +17227,7 @@
           <p:cNvPr id="7" name="level-1">
             <a:extLst xmlns:a="http://schemas.openxmlformats.org/drawingml/2006/main">
               <a:ext uri="{FF2B5EF4-FFF2-40B4-BE49-F238E27FC236}">
-                <a16:creationId xmlns:a16="http://schemas.microsoft.com/office/drawing/2014/main" id="{CB753938-B545-4C2E-8554-3EA243FA06E6}"/>
+                <a16:creationId xmlns:a16="http://schemas.microsoft.com/office/drawing/2014/main" id="{33CAD480-5B03-4A86-B4F8-7F2B79FB58D1}"/>
               </a:ext>
             </a:extLst>
           </p:cNvPr>
@@ -17293,7 +17293,7 @@
           <p:cNvPr id="8" name="level-copy-1">
             <a:extLst xmlns:a="http://schemas.openxmlformats.org/drawingml/2006/main">
               <a:ext uri="{FF2B5EF4-FFF2-40B4-BE49-F238E27FC236}">
-                <a16:creationId xmlns:a16="http://schemas.microsoft.com/office/drawing/2014/main" id="{BB76AA2F-7117-4EB3-988D-84C8F3DD812C}"/>
+                <a16:creationId xmlns:a16="http://schemas.microsoft.com/office/drawing/2014/main" id="{0C7A2802-3A3D-4008-AF9A-4E614A3FE4F9}"/>
               </a:ext>
             </a:extLst>
           </p:cNvPr>
@@ -17353,7 +17353,7 @@
           <p:cNvPr id="9" name="level-2">
             <a:extLst xmlns:a="http://schemas.openxmlformats.org/drawingml/2006/main">
               <a:ext uri="{FF2B5EF4-FFF2-40B4-BE49-F238E27FC236}">
-                <a16:creationId xmlns:a16="http://schemas.microsoft.com/office/drawing/2014/main" id="{3D277703-5F29-4FA8-BEE6-983D6E191C00}"/>
+                <a16:creationId xmlns:a16="http://schemas.microsoft.com/office/drawing/2014/main" id="{825DC013-9732-4B66-9C34-96E8F4808DA2}"/>
               </a:ext>
             </a:extLst>
           </p:cNvPr>
@@ -17419,7 +17419,7 @@
           <p:cNvPr id="10" name="level-copy-2">
             <a:extLst xmlns:a="http://schemas.openxmlformats.org/drawingml/2006/main">
               <a:ext uri="{FF2B5EF4-FFF2-40B4-BE49-F238E27FC236}">
-                <a16:creationId xmlns:a16="http://schemas.microsoft.com/office/drawing/2014/main" id="{E03F977D-8AD7-46E2-9377-1081F622AC5A}"/>
+                <a16:creationId xmlns:a16="http://schemas.microsoft.com/office/drawing/2014/main" id="{CAC81A54-740B-449B-BB74-45EF706F0A69}"/>
               </a:ext>
             </a:extLst>
           </p:cNvPr>
@@ -17479,7 +17479,7 @@
           <p:cNvPr id="11" name="level-3">
             <a:extLst xmlns:a="http://schemas.openxmlformats.org/drawingml/2006/main">
               <a:ext uri="{FF2B5EF4-FFF2-40B4-BE49-F238E27FC236}">
-                <a16:creationId xmlns:a16="http://schemas.microsoft.com/office/drawing/2014/main" id="{C872C212-3FAD-4839-9E42-66058FCACA8E}"/>
+                <a16:creationId xmlns:a16="http://schemas.microsoft.com/office/drawing/2014/main" id="{FDDCE750-198E-4B6D-BE63-7D81C0A2EC27}"/>
               </a:ext>
             </a:extLst>
           </p:cNvPr>
@@ -17545,7 +17545,7 @@
           <p:cNvPr id="12" name="level-copy-3">
             <a:extLst xmlns:a="http://schemas.openxmlformats.org/drawingml/2006/main">
               <a:ext uri="{FF2B5EF4-FFF2-40B4-BE49-F238E27FC236}">
-                <a16:creationId xmlns:a16="http://schemas.microsoft.com/office/drawing/2014/main" id="{F95E616D-EF8C-4DED-8946-7551CCB90BFC}"/>
+                <a16:creationId xmlns:a16="http://schemas.microsoft.com/office/drawing/2014/main" id="{FF5F94D7-7BCA-43B9-904B-293465EE5BD2}"/>
               </a:ext>
             </a:extLst>
           </p:cNvPr>
@@ -17605,7 +17605,7 @@
           <p:cNvPr id="13" name="level-4">
             <a:extLst xmlns:a="http://schemas.openxmlformats.org/drawingml/2006/main">
               <a:ext uri="{FF2B5EF4-FFF2-40B4-BE49-F238E27FC236}">
-                <a16:creationId xmlns:a16="http://schemas.microsoft.com/office/drawing/2014/main" id="{354AEE65-FD55-4C08-BAE1-79506E258617}"/>
+                <a16:creationId xmlns:a16="http://schemas.microsoft.com/office/drawing/2014/main" id="{6CC6E507-DB09-4AE6-913F-228BC54039FE}"/>
               </a:ext>
             </a:extLst>
           </p:cNvPr>
@@ -17671,7 +17671,7 @@
           <p:cNvPr id="14" name="level-copy-4">
             <a:extLst xmlns:a="http://schemas.openxmlformats.org/drawingml/2006/main">
               <a:ext uri="{FF2B5EF4-FFF2-40B4-BE49-F238E27FC236}">
-                <a16:creationId xmlns:a16="http://schemas.microsoft.com/office/drawing/2014/main" id="{7624251F-139A-4D8C-88CA-CBEF3F740BD3}"/>
+                <a16:creationId xmlns:a16="http://schemas.microsoft.com/office/drawing/2014/main" id="{2A5FE297-7E6B-4D5F-BE06-F06F885B2184}"/>
               </a:ext>
             </a:extLst>
           </p:cNvPr>
@@ -17731,7 +17731,7 @@
           <p:cNvPr id="15" name="takeaway">
             <a:extLst xmlns:a="http://schemas.openxmlformats.org/drawingml/2006/main">
               <a:ext uri="{FF2B5EF4-FFF2-40B4-BE49-F238E27FC236}">
-                <a16:creationId xmlns:a16="http://schemas.microsoft.com/office/drawing/2014/main" id="{C7EFC272-F1A1-4D5C-9139-29A023C9B4E9}"/>
+                <a16:creationId xmlns:a16="http://schemas.microsoft.com/office/drawing/2014/main" id="{1019E615-86F9-4752-8B18-E041BA937289}"/>
               </a:ext>
             </a:extLst>
           </p:cNvPr>
@@ -17789,7 +17789,7 @@
     </p:spTree>
     <p:extLst>
       <p:ext uri="{BB962C8B-B14F-4D97-AF65-F5344CB8AC3E}">
-        <p14:creationId xmlns:p14="http://schemas.microsoft.com/office/powerpoint/2010/main" val="743014790"/>
+        <p14:creationId xmlns:p14="http://schemas.microsoft.com/office/powerpoint/2010/main" val="1027577305"/>
       </p:ext>
     </p:extLst>
   </p:cSld>
@@ -17820,7 +17820,7 @@
           <p:cNvPr id="1" name="eyebrow">
             <a:extLst xmlns:a="http://schemas.openxmlformats.org/drawingml/2006/main">
               <a:ext uri="{FF2B5EF4-FFF2-40B4-BE49-F238E27FC236}">
-                <a16:creationId xmlns:a16="http://schemas.microsoft.com/office/drawing/2014/main" id="{E23E37CF-DA03-48C9-9DC5-EE00B360B709}"/>
+                <a16:creationId xmlns:a16="http://schemas.microsoft.com/office/drawing/2014/main" id="{323012BD-CB5B-4E12-9E39-93983D104F18}"/>
               </a:ext>
             </a:extLst>
           </p:cNvPr>
@@ -17880,7 +17880,7 @@
           <p:cNvPr id="2" name="title">
             <a:extLst xmlns:a="http://schemas.openxmlformats.org/drawingml/2006/main">
               <a:ext uri="{FF2B5EF4-FFF2-40B4-BE49-F238E27FC236}">
-                <a16:creationId xmlns:a16="http://schemas.microsoft.com/office/drawing/2014/main" id="{E3082D19-66AE-4626-ACDA-253955BF8249}"/>
+                <a16:creationId xmlns:a16="http://schemas.microsoft.com/office/drawing/2014/main" id="{F08B38B3-4B41-4689-81A4-F125514C2754}"/>
               </a:ext>
             </a:extLst>
           </p:cNvPr>
@@ -17940,7 +17940,7 @@
           <p:cNvPr id="3" name="footer">
             <a:extLst xmlns:a="http://schemas.openxmlformats.org/drawingml/2006/main">
               <a:ext uri="{FF2B5EF4-FFF2-40B4-BE49-F238E27FC236}">
-                <a16:creationId xmlns:a16="http://schemas.microsoft.com/office/drawing/2014/main" id="{B4EC378E-4C6D-4004-BB00-6791FE176E96}"/>
+                <a16:creationId xmlns:a16="http://schemas.microsoft.com/office/drawing/2014/main" id="{584DA221-9AF0-4096-AC2C-93285A76103B}"/>
               </a:ext>
             </a:extLst>
           </p:cNvPr>
@@ -18000,7 +18000,7 @@
           <p:cNvPr id="4" name="left">
             <a:extLst xmlns:a="http://schemas.openxmlformats.org/drawingml/2006/main">
               <a:ext uri="{FF2B5EF4-FFF2-40B4-BE49-F238E27FC236}">
-                <a16:creationId xmlns:a16="http://schemas.microsoft.com/office/drawing/2014/main" id="{776D6D00-536D-4DAD-8BF7-62299119F828}"/>
+                <a16:creationId xmlns:a16="http://schemas.microsoft.com/office/drawing/2014/main" id="{CA96E668-E043-4F24-8BF8-E2423331642E}"/>
               </a:ext>
             </a:extLst>
           </p:cNvPr>
@@ -18035,7 +18035,7 @@
           <p:cNvPr id="5" name="right">
             <a:extLst xmlns:a="http://schemas.openxmlformats.org/drawingml/2006/main">
               <a:ext uri="{FF2B5EF4-FFF2-40B4-BE49-F238E27FC236}">
-                <a16:creationId xmlns:a16="http://schemas.microsoft.com/office/drawing/2014/main" id="{FF5496C7-A24E-4C0A-B2CA-EE876AC3BEB4}"/>
+                <a16:creationId xmlns:a16="http://schemas.microsoft.com/office/drawing/2014/main" id="{CECE6A03-50A0-4C8D-8E2B-B9E28F0630A6}"/>
               </a:ext>
             </a:extLst>
           </p:cNvPr>
@@ -18070,7 +18070,7 @@
           <p:cNvPr id="6" name="left-title">
             <a:extLst xmlns:a="http://schemas.openxmlformats.org/drawingml/2006/main">
               <a:ext uri="{FF2B5EF4-FFF2-40B4-BE49-F238E27FC236}">
-                <a16:creationId xmlns:a16="http://schemas.microsoft.com/office/drawing/2014/main" id="{DECC829D-FEF1-4C8D-A912-6389A563EBB9}"/>
+                <a16:creationId xmlns:a16="http://schemas.microsoft.com/office/drawing/2014/main" id="{BBA4CE19-5DCA-4B3B-8F3A-A1D454C03755}"/>
               </a:ext>
             </a:extLst>
           </p:cNvPr>
@@ -18130,7 +18130,7 @@
           <p:cNvPr id="7" name="right-title">
             <a:extLst xmlns:a="http://schemas.openxmlformats.org/drawingml/2006/main">
               <a:ext uri="{FF2B5EF4-FFF2-40B4-BE49-F238E27FC236}">
-                <a16:creationId xmlns:a16="http://schemas.microsoft.com/office/drawing/2014/main" id="{6F214E74-5C68-4BF7-B434-7B066320F6BF}"/>
+                <a16:creationId xmlns:a16="http://schemas.microsoft.com/office/drawing/2014/main" id="{D30C97CA-31FE-4684-8734-F3F78F67FCA8}"/>
               </a:ext>
             </a:extLst>
           </p:cNvPr>
@@ -18190,7 +18190,7 @@
           <p:cNvPr id="8" name="prompt">
             <a:extLst xmlns:a="http://schemas.openxmlformats.org/drawingml/2006/main">
               <a:ext uri="{FF2B5EF4-FFF2-40B4-BE49-F238E27FC236}">
-                <a16:creationId xmlns:a16="http://schemas.microsoft.com/office/drawing/2014/main" id="{53842126-0889-48F7-A757-AACE20F776CC}"/>
+                <a16:creationId xmlns:a16="http://schemas.microsoft.com/office/drawing/2014/main" id="{B209F902-3BBC-4E83-89B1-63BD86E55BFF}"/>
               </a:ext>
             </a:extLst>
           </p:cNvPr>
@@ -18256,7 +18256,7 @@
           <p:cNvPr id="9" name="response">
             <a:extLst xmlns:a="http://schemas.openxmlformats.org/drawingml/2006/main">
               <a:ext uri="{FF2B5EF4-FFF2-40B4-BE49-F238E27FC236}">
-                <a16:creationId xmlns:a16="http://schemas.microsoft.com/office/drawing/2014/main" id="{5A0A18B2-1B22-4C62-98F2-7BC1C7425851}"/>
+                <a16:creationId xmlns:a16="http://schemas.microsoft.com/office/drawing/2014/main" id="{F2D6A54F-EBDF-4CF6-932E-C2DB02A574B8}"/>
               </a:ext>
             </a:extLst>
           </p:cNvPr>
@@ -18322,7 +18322,7 @@
           <p:cNvPr id="10" name="chat-line">
             <a:extLst xmlns:a="http://schemas.openxmlformats.org/drawingml/2006/main">
               <a:ext uri="{FF2B5EF4-FFF2-40B4-BE49-F238E27FC236}">
-                <a16:creationId xmlns:a16="http://schemas.microsoft.com/office/drawing/2014/main" id="{CE4659F2-B962-4A88-AED2-708A540FDAE3}"/>
+                <a16:creationId xmlns:a16="http://schemas.microsoft.com/office/drawing/2014/main" id="{E7035AE9-6D0C-4D7D-88FF-C464B83B06BC}"/>
               </a:ext>
             </a:extLst>
           </p:cNvPr>
@@ -18353,7 +18353,7 @@
           <p:cNvPr id="11" name="left-copy">
             <a:extLst xmlns:a="http://schemas.openxmlformats.org/drawingml/2006/main">
               <a:ext uri="{FF2B5EF4-FFF2-40B4-BE49-F238E27FC236}">
-                <a16:creationId xmlns:a16="http://schemas.microsoft.com/office/drawing/2014/main" id="{09258684-6158-4334-A153-43A26A378911}"/>
+                <a16:creationId xmlns:a16="http://schemas.microsoft.com/office/drawing/2014/main" id="{DDBA57C9-C689-48E7-B816-CF7E13484002}"/>
               </a:ext>
             </a:extLst>
           </p:cNvPr>
@@ -18413,7 +18413,7 @@
           <p:cNvPr id="12" name="a1">
             <a:extLst xmlns:a="http://schemas.openxmlformats.org/drawingml/2006/main">
               <a:ext uri="{FF2B5EF4-FFF2-40B4-BE49-F238E27FC236}">
-                <a16:creationId xmlns:a16="http://schemas.microsoft.com/office/drawing/2014/main" id="{3CB5ADF6-0955-4941-9AE0-A37CB0402ED4}"/>
+                <a16:creationId xmlns:a16="http://schemas.microsoft.com/office/drawing/2014/main" id="{5DC46E5E-C37A-4582-AF79-E8B7C96615A5}"/>
               </a:ext>
             </a:extLst>
           </p:cNvPr>
@@ -18444,7 +18444,7 @@
           <p:cNvPr id="13" name="a2">
             <a:extLst xmlns:a="http://schemas.openxmlformats.org/drawingml/2006/main">
               <a:ext uri="{FF2B5EF4-FFF2-40B4-BE49-F238E27FC236}">
-                <a16:creationId xmlns:a16="http://schemas.microsoft.com/office/drawing/2014/main" id="{028FCD97-7F34-4A0D-83E8-F115A4054BDC}"/>
+                <a16:creationId xmlns:a16="http://schemas.microsoft.com/office/drawing/2014/main" id="{EC6E222A-1534-4694-A0AD-77E7FF2FAB49}"/>
               </a:ext>
             </a:extLst>
           </p:cNvPr>
@@ -18475,7 +18475,7 @@
           <p:cNvPr id="14" name="a3">
             <a:extLst xmlns:a="http://schemas.openxmlformats.org/drawingml/2006/main">
               <a:ext uri="{FF2B5EF4-FFF2-40B4-BE49-F238E27FC236}">
-                <a16:creationId xmlns:a16="http://schemas.microsoft.com/office/drawing/2014/main" id="{DB175B14-5A58-4F34-B01A-5862A1F86D13}"/>
+                <a16:creationId xmlns:a16="http://schemas.microsoft.com/office/drawing/2014/main" id="{9703F0D9-9DF4-4A00-90F3-C6A60529BD5C}"/>
               </a:ext>
             </a:extLst>
           </p:cNvPr>
@@ -18506,7 +18506,7 @@
           <p:cNvPr id="15" name="a4">
             <a:extLst xmlns:a="http://schemas.openxmlformats.org/drawingml/2006/main">
               <a:ext uri="{FF2B5EF4-FFF2-40B4-BE49-F238E27FC236}">
-                <a16:creationId xmlns:a16="http://schemas.microsoft.com/office/drawing/2014/main" id="{65A7AE6E-1753-4D4B-99EF-36FC7C4934BF}"/>
+                <a16:creationId xmlns:a16="http://schemas.microsoft.com/office/drawing/2014/main" id="{F2271D6E-3EEA-4FE1-BC28-0278AC37BD88}"/>
               </a:ext>
             </a:extLst>
           </p:cNvPr>
@@ -18537,7 +18537,7 @@
           <p:cNvPr id="16" name="agent-Goal">
             <a:extLst xmlns:a="http://schemas.openxmlformats.org/drawingml/2006/main">
               <a:ext uri="{FF2B5EF4-FFF2-40B4-BE49-F238E27FC236}">
-                <a16:creationId xmlns:a16="http://schemas.microsoft.com/office/drawing/2014/main" id="{203D76E1-05FF-4EA7-9AE0-BF6E8916762B}"/>
+                <a16:creationId xmlns:a16="http://schemas.microsoft.com/office/drawing/2014/main" id="{FC8694F8-706F-4640-A7FF-7E3AD28E01ED}"/>
               </a:ext>
             </a:extLst>
           </p:cNvPr>
@@ -18603,7 +18603,7 @@
           <p:cNvPr id="17" name="agent-Tools">
             <a:extLst xmlns:a="http://schemas.openxmlformats.org/drawingml/2006/main">
               <a:ext uri="{FF2B5EF4-FFF2-40B4-BE49-F238E27FC236}">
-                <a16:creationId xmlns:a16="http://schemas.microsoft.com/office/drawing/2014/main" id="{E545DB12-1399-4C8D-8CA0-AF441B4F5F2C}"/>
+                <a16:creationId xmlns:a16="http://schemas.microsoft.com/office/drawing/2014/main" id="{887B650D-62A2-4D32-B0C1-295F7C28E39D}"/>
               </a:ext>
             </a:extLst>
           </p:cNvPr>
@@ -18669,7 +18669,7 @@
           <p:cNvPr id="18" name="agent-Evidence">
             <a:extLst xmlns:a="http://schemas.openxmlformats.org/drawingml/2006/main">
               <a:ext uri="{FF2B5EF4-FFF2-40B4-BE49-F238E27FC236}">
-                <a16:creationId xmlns:a16="http://schemas.microsoft.com/office/drawing/2014/main" id="{5BC7EFEB-5190-4815-9B2D-9531738AAA6F}"/>
+                <a16:creationId xmlns:a16="http://schemas.microsoft.com/office/drawing/2014/main" id="{63673480-EAAA-4A6C-BA80-DBA3B80416C3}"/>
               </a:ext>
             </a:extLst>
           </p:cNvPr>
@@ -18735,7 +18735,7 @@
           <p:cNvPr id="19" name="agent-Verify">
             <a:extLst xmlns:a="http://schemas.openxmlformats.org/drawingml/2006/main">
               <a:ext uri="{FF2B5EF4-FFF2-40B4-BE49-F238E27FC236}">
-                <a16:creationId xmlns:a16="http://schemas.microsoft.com/office/drawing/2014/main" id="{A2BBE2A4-45BF-414C-AB7E-0C71F9D22781}"/>
+                <a16:creationId xmlns:a16="http://schemas.microsoft.com/office/drawing/2014/main" id="{3EE0DB46-E113-470C-B5CE-9C5A8D52285A}"/>
               </a:ext>
             </a:extLst>
           </p:cNvPr>
@@ -18801,7 +18801,7 @@
           <p:cNvPr id="20" name="agent-Artifact">
             <a:extLst xmlns:a="http://schemas.openxmlformats.org/drawingml/2006/main">
               <a:ext uri="{FF2B5EF4-FFF2-40B4-BE49-F238E27FC236}">
-                <a16:creationId xmlns:a16="http://schemas.microsoft.com/office/drawing/2014/main" id="{C0FBC851-B18E-4401-B2C1-179F56B4EC27}"/>
+                <a16:creationId xmlns:a16="http://schemas.microsoft.com/office/drawing/2014/main" id="{3AF38B3E-5F8B-4993-847A-D9F69537AF8F}"/>
               </a:ext>
             </a:extLst>
           </p:cNvPr>
@@ -18867,7 +18867,7 @@
           <p:cNvPr id="21" name="right-copy">
             <a:extLst xmlns:a="http://schemas.openxmlformats.org/drawingml/2006/main">
               <a:ext uri="{FF2B5EF4-FFF2-40B4-BE49-F238E27FC236}">
-                <a16:creationId xmlns:a16="http://schemas.microsoft.com/office/drawing/2014/main" id="{D441B766-1B0E-4D51-8D8A-0FFFFF4E46FB}"/>
+                <a16:creationId xmlns:a16="http://schemas.microsoft.com/office/drawing/2014/main" id="{6988435D-D1C9-4307-858A-A6C2F48D23F0}"/>
               </a:ext>
             </a:extLst>
           </p:cNvPr>
@@ -18925,7 +18925,7 @@
     </p:spTree>
     <p:extLst>
       <p:ext uri="{BB962C8B-B14F-4D97-AF65-F5344CB8AC3E}">
-        <p14:creationId xmlns:p14="http://schemas.microsoft.com/office/powerpoint/2010/main" val="97500835"/>
+        <p14:creationId xmlns:p14="http://schemas.microsoft.com/office/powerpoint/2010/main" val="257351570"/>
       </p:ext>
     </p:extLst>
   </p:cSld>
@@ -18956,7 +18956,7 @@
           <p:cNvPr id="1" name="eyebrow">
             <a:extLst xmlns:a="http://schemas.openxmlformats.org/drawingml/2006/main">
               <a:ext uri="{FF2B5EF4-FFF2-40B4-BE49-F238E27FC236}">
-                <a16:creationId xmlns:a16="http://schemas.microsoft.com/office/drawing/2014/main" id="{CF7C1109-A127-4C6C-B36B-3F96588DCC96}"/>
+                <a16:creationId xmlns:a16="http://schemas.microsoft.com/office/drawing/2014/main" id="{C961A3EE-AD22-4439-80BB-155846DAB6CF}"/>
               </a:ext>
             </a:extLst>
           </p:cNvPr>
@@ -19016,7 +19016,7 @@
           <p:cNvPr id="2" name="title">
             <a:extLst xmlns:a="http://schemas.openxmlformats.org/drawingml/2006/main">
               <a:ext uri="{FF2B5EF4-FFF2-40B4-BE49-F238E27FC236}">
-                <a16:creationId xmlns:a16="http://schemas.microsoft.com/office/drawing/2014/main" id="{E2F04E87-F7AA-4661-98EE-209FB9DD5351}"/>
+                <a16:creationId xmlns:a16="http://schemas.microsoft.com/office/drawing/2014/main" id="{A030E2F2-EAD4-4DB5-9781-587DF6C07441}"/>
               </a:ext>
             </a:extLst>
           </p:cNvPr>
@@ -19076,7 +19076,7 @@
           <p:cNvPr id="3" name="footer">
             <a:extLst xmlns:a="http://schemas.openxmlformats.org/drawingml/2006/main">
               <a:ext uri="{FF2B5EF4-FFF2-40B4-BE49-F238E27FC236}">
-                <a16:creationId xmlns:a16="http://schemas.microsoft.com/office/drawing/2014/main" id="{ED5206F1-39BC-41B3-A762-7F3A315C3F38}"/>
+                <a16:creationId xmlns:a16="http://schemas.microsoft.com/office/drawing/2014/main" id="{8528BACE-9EA4-4450-8C74-BBF7A162316E}"/>
               </a:ext>
             </a:extLst>
           </p:cNvPr>
@@ -19133,26 +19133,460 @@
       </p:sp>
       <p:sp>
         <p:nvSpPr>
-          <p:cNvPr id="4" name="model">
-            <a:extLst xmlns:a="http://schemas.openxmlformats.org/drawingml/2006/main">
-              <a:ext uri="{FF2B5EF4-FFF2-40B4-BE49-F238E27FC236}">
-                <a16:creationId xmlns:a16="http://schemas.microsoft.com/office/drawing/2014/main" id="{46E6E3F3-0342-4891-9CAD-1D458B47CE58}"/>
-              </a:ext>
-            </a:extLst>
-          </p:cNvPr>
-          <p:cNvSpPr>
-            <a:spLocks xmlns:a="http://schemas.openxmlformats.org/drawingml/2006/main" noGrp="1"/>
-          </p:cNvSpPr>
-          <p:nvPr/>
-        </p:nvSpPr>
-        <p:spPr>
-          <a:xfrm xmlns:a="http://schemas.openxmlformats.org/drawingml/2006/main">
-            <a:off x="5219700" y="3009900"/>
-            <a:ext cx="1752600" cy="781050"/>
+          <p:cNvPr id="4" name="workflow-boundary">
+            <a:extLst xmlns:a="http://schemas.openxmlformats.org/drawingml/2006/main">
+              <a:ext uri="{FF2B5EF4-FFF2-40B4-BE49-F238E27FC236}">
+                <a16:creationId xmlns:a16="http://schemas.microsoft.com/office/drawing/2014/main" id="{2B087F76-B73A-4A59-B785-2C52B2ED1297}"/>
+              </a:ext>
+            </a:extLst>
+          </p:cNvPr>
+          <p:cNvSpPr>
+            <a:spLocks xmlns:a="http://schemas.openxmlformats.org/drawingml/2006/main" noGrp="1"/>
+          </p:cNvSpPr>
+          <p:nvPr/>
+        </p:nvSpPr>
+        <p:spPr>
+          <a:xfrm xmlns:a="http://schemas.openxmlformats.org/drawingml/2006/main">
+            <a:off x="1181100" y="1924050"/>
+            <a:ext cx="9829800" cy="4057650"/>
           </a:xfrm>
           <a:prstGeom xmlns:a="http://schemas.openxmlformats.org/drawingml/2006/main" prst="roundRect">
             <a:avLst>
-              <a:gd name="adj" fmla="val 9756"/>
+              <a:gd name="adj" fmla="val 1878"/>
+            </a:avLst>
+          </a:prstGeom>
+          <a:noFill xmlns:a="http://schemas.openxmlformats.org/drawingml/2006/main"/>
+          <a:ln xmlns:a="http://schemas.openxmlformats.org/drawingml/2006/main" w="11430">
+            <a:solidFill>
+              <a:srgbClr val="D4DADD"/>
+            </a:solidFill>
+            <a:prstDash val="dash"/>
+          </a:ln>
+        </p:spPr>
+      </p:sp>
+      <p:sp>
+        <p:nvSpPr>
+          <p:cNvPr id="5" name="boundary-label">
+            <a:extLst xmlns:a="http://schemas.openxmlformats.org/drawingml/2006/main">
+              <a:ext uri="{FF2B5EF4-FFF2-40B4-BE49-F238E27FC236}">
+                <a16:creationId xmlns:a16="http://schemas.microsoft.com/office/drawing/2014/main" id="{ED5C1869-FB57-4706-9128-582B9C07DC56}"/>
+              </a:ext>
+            </a:extLst>
+          </p:cNvPr>
+          <p:cNvSpPr>
+            <a:spLocks xmlns:a="http://schemas.openxmlformats.org/drawingml/2006/main" noGrp="1"/>
+          </p:cNvSpPr>
+          <p:nvPr/>
+        </p:nvSpPr>
+        <p:spPr>
+          <a:xfrm xmlns:a="http://schemas.openxmlformats.org/drawingml/2006/main">
+            <a:off x="1466850" y="2019300"/>
+            <a:ext cx="1714500" cy="228600"/>
+          </a:xfrm>
+          <a:prstGeom xmlns:a="http://schemas.openxmlformats.org/drawingml/2006/main" prst="rect">
+            <a:avLst/>
+          </a:prstGeom>
+          <a:noFill xmlns:a="http://schemas.openxmlformats.org/drawingml/2006/main"/>
+          <a:ln xmlns:a="http://schemas.openxmlformats.org/drawingml/2006/main" w="0">
+            <a:noFill/>
+            <a:prstDash val="solid"/>
+          </a:ln>
+        </p:spPr>
+        <p:txBody>
+          <a:bodyPr xmlns:a="http://schemas.openxmlformats.org/drawingml/2006/main" lIns="0" tIns="0" rIns="0" bIns="0" anchor="t"/>
+          <a:lstStyle xmlns:a="http://schemas.openxmlformats.org/drawingml/2006/main"/>
+          <a:p xmlns:a="http://schemas.openxmlformats.org/drawingml/2006/main">
+            <a:pPr algn="l">
+              <a:lnSpc>
+                <a:spcPct val="108000"/>
+              </a:lnSpc>
+              <a:buNone/>
+              <a:defRPr sz="1125" b="1">
+                <a:solidFill>
+                  <a:srgbClr val="8C98A1"/>
+                </a:solidFill>
+                <a:latin typeface="Aptos"/>
+                <a:ea typeface="Aptos"/>
+                <a:cs typeface="Aptos"/>
+              </a:defRPr>
+            </a:pPr>
+            <a:r>
+              <a:rPr sz="1125" b="1">
+                <a:solidFill>
+                  <a:srgbClr val="8C98A1"/>
+                </a:solidFill>
+                <a:latin typeface="Aptos"/>
+                <a:ea typeface="Aptos"/>
+                <a:cs typeface="Aptos"/>
+              </a:rPr>
+              <a:t>workflow boundary</a:t>
+            </a:r>
+          </a:p>
+        </p:txBody>
+      </p:sp>
+      <p:sp>
+        <p:nvSpPr>
+          <p:cNvPr id="6" name="goal-to-model">
+            <a:extLst xmlns:a="http://schemas.openxmlformats.org/drawingml/2006/main">
+              <a:ext uri="{FF2B5EF4-FFF2-40B4-BE49-F238E27FC236}">
+                <a16:creationId xmlns:a16="http://schemas.microsoft.com/office/drawing/2014/main" id="{3E512499-E3F4-4D7A-B8BF-95BA69F803BE}"/>
+              </a:ext>
+            </a:extLst>
+          </p:cNvPr>
+          <p:cNvSpPr>
+            <a:spLocks xmlns:a="http://schemas.openxmlformats.org/drawingml/2006/main" noGrp="1"/>
+          </p:cNvSpPr>
+          <p:nvPr/>
+        </p:nvSpPr>
+        <p:spPr>
+          <a:xfrm xmlns:a="http://schemas.openxmlformats.org/drawingml/2006/main">
+            <a:off x="6096000" y="2667000"/>
+            <a:ext cx="0" cy="361950"/>
+          </a:xfrm>
+          <a:prstGeom xmlns:a="http://schemas.openxmlformats.org/drawingml/2006/main" prst="line">
+            <a:avLst/>
+          </a:prstGeom>
+          <a:noFill xmlns:a="http://schemas.openxmlformats.org/drawingml/2006/main"/>
+          <a:ln xmlns:a="http://schemas.openxmlformats.org/drawingml/2006/main" w="14288">
+            <a:solidFill>
+              <a:srgbClr val="D4DADD"/>
+            </a:solidFill>
+            <a:prstDash val="solid"/>
+          </a:ln>
+        </p:spPr>
+      </p:sp>
+      <p:sp>
+        <p:nvSpPr>
+          <p:cNvPr id="7" name="context-to-model">
+            <a:extLst xmlns:a="http://schemas.openxmlformats.org/drawingml/2006/main">
+              <a:ext uri="{FF2B5EF4-FFF2-40B4-BE49-F238E27FC236}">
+                <a16:creationId xmlns:a16="http://schemas.microsoft.com/office/drawing/2014/main" id="{BD86C3EC-91C7-4291-BCA6-A47CD245A60A}"/>
+              </a:ext>
+            </a:extLst>
+          </p:cNvPr>
+          <p:cNvSpPr>
+            <a:spLocks xmlns:a="http://schemas.openxmlformats.org/drawingml/2006/main" noGrp="1"/>
+          </p:cNvSpPr>
+          <p:nvPr/>
+        </p:nvSpPr>
+        <p:spPr>
+          <a:xfrm xmlns:a="http://schemas.openxmlformats.org/drawingml/2006/main">
+            <a:off x="4000500" y="3390900"/>
+            <a:ext cx="1104900" cy="0"/>
+          </a:xfrm>
+          <a:prstGeom xmlns:a="http://schemas.openxmlformats.org/drawingml/2006/main" prst="line">
+            <a:avLst/>
+          </a:prstGeom>
+          <a:noFill xmlns:a="http://schemas.openxmlformats.org/drawingml/2006/main"/>
+          <a:ln xmlns:a="http://schemas.openxmlformats.org/drawingml/2006/main" w="14288">
+            <a:solidFill>
+              <a:srgbClr val="D4DADD"/>
+            </a:solidFill>
+            <a:prstDash val="solid"/>
+          </a:ln>
+        </p:spPr>
+      </p:sp>
+      <p:sp>
+        <p:nvSpPr>
+          <p:cNvPr id="8" name="model-to-tools">
+            <a:extLst xmlns:a="http://schemas.openxmlformats.org/drawingml/2006/main">
+              <a:ext uri="{FF2B5EF4-FFF2-40B4-BE49-F238E27FC236}">
+                <a16:creationId xmlns:a16="http://schemas.microsoft.com/office/drawing/2014/main" id="{9AD87420-F50B-4FC3-B1A9-037B8E1060CB}"/>
+              </a:ext>
+            </a:extLst>
+          </p:cNvPr>
+          <p:cNvSpPr>
+            <a:spLocks xmlns:a="http://schemas.openxmlformats.org/drawingml/2006/main" noGrp="1"/>
+          </p:cNvSpPr>
+          <p:nvPr/>
+        </p:nvSpPr>
+        <p:spPr>
+          <a:xfrm xmlns:a="http://schemas.openxmlformats.org/drawingml/2006/main">
+            <a:off x="7086600" y="3390900"/>
+            <a:ext cx="1104900" cy="0"/>
+          </a:xfrm>
+          <a:prstGeom xmlns:a="http://schemas.openxmlformats.org/drawingml/2006/main" prst="line">
+            <a:avLst/>
+          </a:prstGeom>
+          <a:noFill xmlns:a="http://schemas.openxmlformats.org/drawingml/2006/main"/>
+          <a:ln xmlns:a="http://schemas.openxmlformats.org/drawingml/2006/main" w="14288">
+            <a:solidFill>
+              <a:srgbClr val="D4DADD"/>
+            </a:solidFill>
+            <a:prstDash val="solid"/>
+          </a:ln>
+        </p:spPr>
+      </p:sp>
+      <p:sp>
+        <p:nvSpPr>
+          <p:cNvPr id="9" name="model-to-state">
+            <a:extLst xmlns:a="http://schemas.openxmlformats.org/drawingml/2006/main">
+              <a:ext uri="{FF2B5EF4-FFF2-40B4-BE49-F238E27FC236}">
+                <a16:creationId xmlns:a16="http://schemas.microsoft.com/office/drawing/2014/main" id="{DA81B0A9-DD64-4F21-A25A-79F076A91209}"/>
+              </a:ext>
+            </a:extLst>
+          </p:cNvPr>
+          <p:cNvSpPr>
+            <a:spLocks xmlns:a="http://schemas.openxmlformats.org/drawingml/2006/main" noGrp="1"/>
+          </p:cNvSpPr>
+          <p:nvPr/>
+        </p:nvSpPr>
+        <p:spPr>
+          <a:xfrm xmlns:a="http://schemas.openxmlformats.org/drawingml/2006/main">
+            <a:off x="6096000" y="3752850"/>
+            <a:ext cx="0" cy="457200"/>
+          </a:xfrm>
+          <a:prstGeom xmlns:a="http://schemas.openxmlformats.org/drawingml/2006/main" prst="line">
+            <a:avLst/>
+          </a:prstGeom>
+          <a:noFill xmlns:a="http://schemas.openxmlformats.org/drawingml/2006/main"/>
+          <a:ln xmlns:a="http://schemas.openxmlformats.org/drawingml/2006/main" w="14288">
+            <a:solidFill>
+              <a:srgbClr val="D4DADD"/>
+            </a:solidFill>
+            <a:prstDash val="solid"/>
+          </a:ln>
+        </p:spPr>
+      </p:sp>
+      <p:sp>
+        <p:nvSpPr>
+          <p:cNvPr id="10" name="state-to-verify">
+            <a:extLst xmlns:a="http://schemas.openxmlformats.org/drawingml/2006/main">
+              <a:ext uri="{FF2B5EF4-FFF2-40B4-BE49-F238E27FC236}">
+                <a16:creationId xmlns:a16="http://schemas.microsoft.com/office/drawing/2014/main" id="{F53FD580-65CC-415F-A34A-1AA1DFFC3564}"/>
+              </a:ext>
+            </a:extLst>
+          </p:cNvPr>
+          <p:cNvSpPr>
+            <a:spLocks xmlns:a="http://schemas.openxmlformats.org/drawingml/2006/main" noGrp="1"/>
+          </p:cNvSpPr>
+          <p:nvPr/>
+        </p:nvSpPr>
+        <p:spPr>
+          <a:xfrm xmlns:a="http://schemas.openxmlformats.org/drawingml/2006/main">
+            <a:off x="6096000" y="4800600"/>
+            <a:ext cx="0" cy="361950"/>
+          </a:xfrm>
+          <a:prstGeom xmlns:a="http://schemas.openxmlformats.org/drawingml/2006/main" prst="line">
+            <a:avLst/>
+          </a:prstGeom>
+          <a:noFill xmlns:a="http://schemas.openxmlformats.org/drawingml/2006/main"/>
+          <a:ln xmlns:a="http://schemas.openxmlformats.org/drawingml/2006/main" w="14288">
+            <a:solidFill>
+              <a:srgbClr val="D4DADD"/>
+            </a:solidFill>
+            <a:prstDash val="solid"/>
+          </a:ln>
+        </p:spPr>
+      </p:sp>
+      <p:sp>
+        <p:nvSpPr>
+          <p:cNvPr id="11" name="node-Goal">
+            <a:extLst xmlns:a="http://schemas.openxmlformats.org/drawingml/2006/main">
+              <a:ext uri="{FF2B5EF4-FFF2-40B4-BE49-F238E27FC236}">
+                <a16:creationId xmlns:a16="http://schemas.microsoft.com/office/drawing/2014/main" id="{2CD13619-F414-41D8-A3AE-94429725F274}"/>
+              </a:ext>
+            </a:extLst>
+          </p:cNvPr>
+          <p:cNvSpPr>
+            <a:spLocks xmlns:a="http://schemas.openxmlformats.org/drawingml/2006/main" noGrp="1"/>
+          </p:cNvSpPr>
+          <p:nvPr/>
+        </p:nvSpPr>
+        <p:spPr>
+          <a:xfrm xmlns:a="http://schemas.openxmlformats.org/drawingml/2006/main">
+            <a:off x="5105400" y="2076450"/>
+            <a:ext cx="1981200" cy="590550"/>
+          </a:xfrm>
+          <a:prstGeom xmlns:a="http://schemas.openxmlformats.org/drawingml/2006/main" prst="roundRect">
+            <a:avLst>
+              <a:gd name="adj" fmla="val 12903"/>
+            </a:avLst>
+          </a:prstGeom>
+          <a:solidFill xmlns:a="http://schemas.openxmlformats.org/drawingml/2006/main">
+            <a:srgbClr val="EAF8F6"/>
+          </a:solidFill>
+          <a:ln xmlns:a="http://schemas.openxmlformats.org/drawingml/2006/main" w="12859">
+            <a:solidFill>
+              <a:srgbClr val="0E8F88"/>
+            </a:solidFill>
+            <a:prstDash val="solid"/>
+          </a:ln>
+        </p:spPr>
+        <p:txBody>
+          <a:bodyPr xmlns:a="http://schemas.openxmlformats.org/drawingml/2006/main" lIns="76200" tIns="57150" rIns="76200" bIns="57150" anchor="ctr"/>
+          <a:lstStyle xmlns:a="http://schemas.openxmlformats.org/drawingml/2006/main"/>
+          <a:p xmlns:a="http://schemas.openxmlformats.org/drawingml/2006/main">
+            <a:pPr algn="ctr">
+              <a:lnSpc>
+                <a:spcPct val="102000"/>
+              </a:lnSpc>
+              <a:buNone/>
+              <a:defRPr sz="1200" b="1">
+                <a:solidFill>
+                  <a:srgbClr val="0E8F88"/>
+                </a:solidFill>
+                <a:latin typeface="Aptos"/>
+                <a:ea typeface="Aptos"/>
+                <a:cs typeface="Aptos"/>
+              </a:defRPr>
+            </a:pPr>
+            <a:r>
+              <a:rPr sz="1200" b="1">
+                <a:solidFill>
+                  <a:srgbClr val="0E8F88"/>
+                </a:solidFill>
+                <a:latin typeface="Aptos"/>
+                <a:ea typeface="Aptos"/>
+                <a:cs typeface="Aptos"/>
+              </a:rPr>
+              <a:t>Goal</a:t>
+            </a:r>
+          </a:p>
+          <a:p xmlns:a="http://schemas.openxmlformats.org/drawingml/2006/main">
+            <a:pPr algn="ctr">
+              <a:lnSpc>
+                <a:spcPct val="102000"/>
+              </a:lnSpc>
+              <a:buNone/>
+              <a:defRPr sz="1200" b="1">
+                <a:solidFill>
+                  <a:srgbClr val="0E8F88"/>
+                </a:solidFill>
+                <a:latin typeface="Aptos"/>
+                <a:ea typeface="Aptos"/>
+                <a:cs typeface="Aptos"/>
+              </a:defRPr>
+            </a:pPr>
+            <a:r>
+              <a:rPr sz="1200" b="1">
+                <a:solidFill>
+                  <a:srgbClr val="0E8F88"/>
+                </a:solidFill>
+                <a:latin typeface="Aptos"/>
+                <a:ea typeface="Aptos"/>
+                <a:cs typeface="Aptos"/>
+              </a:rPr>
+              <a:t>成功條件</a:t>
+            </a:r>
+          </a:p>
+        </p:txBody>
+      </p:sp>
+      <p:sp>
+        <p:nvSpPr>
+          <p:cNvPr id="12" name="node-Context">
+            <a:extLst xmlns:a="http://schemas.openxmlformats.org/drawingml/2006/main">
+              <a:ext uri="{FF2B5EF4-FFF2-40B4-BE49-F238E27FC236}">
+                <a16:creationId xmlns:a16="http://schemas.microsoft.com/office/drawing/2014/main" id="{35BDF329-46A0-47C5-97EE-D931760B93B4}"/>
+              </a:ext>
+            </a:extLst>
+          </p:cNvPr>
+          <p:cNvSpPr>
+            <a:spLocks xmlns:a="http://schemas.openxmlformats.org/drawingml/2006/main" noGrp="1"/>
+          </p:cNvSpPr>
+          <p:nvPr/>
+        </p:nvSpPr>
+        <p:spPr>
+          <a:xfrm xmlns:a="http://schemas.openxmlformats.org/drawingml/2006/main">
+            <a:off x="1790700" y="3086100"/>
+            <a:ext cx="2209800" cy="609600"/>
+          </a:xfrm>
+          <a:prstGeom xmlns:a="http://schemas.openxmlformats.org/drawingml/2006/main" prst="roundRect">
+            <a:avLst>
+              <a:gd name="adj" fmla="val 12500"/>
+            </a:avLst>
+          </a:prstGeom>
+          <a:solidFill xmlns:a="http://schemas.openxmlformats.org/drawingml/2006/main">
+            <a:srgbClr val="FFFFFF"/>
+          </a:solidFill>
+          <a:ln xmlns:a="http://schemas.openxmlformats.org/drawingml/2006/main" w="12859">
+            <a:solidFill>
+              <a:srgbClr val="5C6670"/>
+            </a:solidFill>
+            <a:prstDash val="solid"/>
+          </a:ln>
+        </p:spPr>
+        <p:txBody>
+          <a:bodyPr xmlns:a="http://schemas.openxmlformats.org/drawingml/2006/main" lIns="76200" tIns="57150" rIns="76200" bIns="57150" anchor="ctr"/>
+          <a:lstStyle xmlns:a="http://schemas.openxmlformats.org/drawingml/2006/main"/>
+          <a:p xmlns:a="http://schemas.openxmlformats.org/drawingml/2006/main">
+            <a:pPr algn="ctr">
+              <a:lnSpc>
+                <a:spcPct val="102000"/>
+              </a:lnSpc>
+              <a:buNone/>
+              <a:defRPr sz="1200" b="1">
+                <a:solidFill>
+                  <a:srgbClr val="5C6670"/>
+                </a:solidFill>
+                <a:latin typeface="Aptos"/>
+                <a:ea typeface="Aptos"/>
+                <a:cs typeface="Aptos"/>
+              </a:defRPr>
+            </a:pPr>
+            <a:r>
+              <a:rPr sz="1200" b="1">
+                <a:solidFill>
+                  <a:srgbClr val="5C6670"/>
+                </a:solidFill>
+                <a:latin typeface="Aptos"/>
+                <a:ea typeface="Aptos"/>
+                <a:cs typeface="Aptos"/>
+              </a:rPr>
+              <a:t>Context</a:t>
+            </a:r>
+          </a:p>
+          <a:p xmlns:a="http://schemas.openxmlformats.org/drawingml/2006/main">
+            <a:pPr algn="ctr">
+              <a:lnSpc>
+                <a:spcPct val="102000"/>
+              </a:lnSpc>
+              <a:buNone/>
+              <a:defRPr sz="1200" b="1">
+                <a:solidFill>
+                  <a:srgbClr val="5C6670"/>
+                </a:solidFill>
+                <a:latin typeface="Aptos"/>
+                <a:ea typeface="Aptos"/>
+                <a:cs typeface="Aptos"/>
+              </a:defRPr>
+            </a:pPr>
+            <a:r>
+              <a:rPr sz="1200" b="1">
+                <a:solidFill>
+                  <a:srgbClr val="5C6670"/>
+                </a:solidFill>
+                <a:latin typeface="Aptos"/>
+                <a:ea typeface="Aptos"/>
+                <a:cs typeface="Aptos"/>
+              </a:rPr>
+              <a:t>任務、資料、限制</a:t>
+            </a:r>
+          </a:p>
+        </p:txBody>
+      </p:sp>
+      <p:sp>
+        <p:nvSpPr>
+          <p:cNvPr id="13" name="model">
+            <a:extLst xmlns:a="http://schemas.openxmlformats.org/drawingml/2006/main">
+              <a:ext uri="{FF2B5EF4-FFF2-40B4-BE49-F238E27FC236}">
+                <a16:creationId xmlns:a16="http://schemas.microsoft.com/office/drawing/2014/main" id="{D601F90D-B53F-4456-8242-E7874FBF14DE}"/>
+              </a:ext>
+            </a:extLst>
+          </p:cNvPr>
+          <p:cNvSpPr>
+            <a:spLocks xmlns:a="http://schemas.openxmlformats.org/drawingml/2006/main" noGrp="1"/>
+          </p:cNvSpPr>
+          <p:nvPr/>
+        </p:nvSpPr>
+        <p:spPr>
+          <a:xfrm xmlns:a="http://schemas.openxmlformats.org/drawingml/2006/main">
+            <a:off x="5105400" y="3028950"/>
+            <a:ext cx="1981200" cy="723900"/>
+          </a:xfrm>
+          <a:prstGeom xmlns:a="http://schemas.openxmlformats.org/drawingml/2006/main" prst="roundRect">
+            <a:avLst>
+              <a:gd name="adj" fmla="val 10526"/>
             </a:avLst>
           </a:prstGeom>
           <a:solidFill xmlns:a="http://schemas.openxmlformats.org/drawingml/2006/main">
@@ -19226,61 +19660,30 @@
       </p:sp>
       <p:sp>
         <p:nvSpPr>
-          <p:cNvPr id="5" name="line-Goal">
-            <a:extLst xmlns:a="http://schemas.openxmlformats.org/drawingml/2006/main">
-              <a:ext uri="{FF2B5EF4-FFF2-40B4-BE49-F238E27FC236}">
-                <a16:creationId xmlns:a16="http://schemas.microsoft.com/office/drawing/2014/main" id="{098685FB-6C31-4111-9803-029E2459AF3D}"/>
-              </a:ext>
-            </a:extLst>
-          </p:cNvPr>
-          <p:cNvSpPr>
-            <a:spLocks xmlns:a="http://schemas.openxmlformats.org/drawingml/2006/main" noGrp="1"/>
-          </p:cNvSpPr>
-          <p:nvPr/>
-        </p:nvSpPr>
-        <p:spPr>
-          <a:xfrm xmlns:a="http://schemas.openxmlformats.org/drawingml/2006/main">
-            <a:off x="2867025" y="2295525"/>
-            <a:ext cx="3228975" cy="1114425"/>
-          </a:xfrm>
-          <a:prstGeom xmlns:a="http://schemas.openxmlformats.org/drawingml/2006/main" prst="line">
-            <a:avLst/>
-          </a:prstGeom>
-          <a:noFill xmlns:a="http://schemas.openxmlformats.org/drawingml/2006/main"/>
-          <a:ln xmlns:a="http://schemas.openxmlformats.org/drawingml/2006/main" w="10478">
-            <a:solidFill>
-              <a:srgbClr val="D4DADD"/>
-            </a:solidFill>
-            <a:prstDash val="solid"/>
-          </a:ln>
-        </p:spPr>
-      </p:sp>
-      <p:sp>
-        <p:nvSpPr>
-          <p:cNvPr id="6" name="node-Goal">
-            <a:extLst xmlns:a="http://schemas.openxmlformats.org/drawingml/2006/main">
-              <a:ext uri="{FF2B5EF4-FFF2-40B4-BE49-F238E27FC236}">
-                <a16:creationId xmlns:a16="http://schemas.microsoft.com/office/drawing/2014/main" id="{83896E14-4872-4DB6-99A2-A1A3242AC60B}"/>
-              </a:ext>
-            </a:extLst>
-          </p:cNvPr>
-          <p:cNvSpPr>
-            <a:spLocks xmlns:a="http://schemas.openxmlformats.org/drawingml/2006/main" noGrp="1"/>
-          </p:cNvSpPr>
-          <p:nvPr/>
-        </p:nvSpPr>
-        <p:spPr>
-          <a:xfrm xmlns:a="http://schemas.openxmlformats.org/drawingml/2006/main">
-            <a:off x="1962150" y="2000250"/>
-            <a:ext cx="1809750" cy="590550"/>
+          <p:cNvPr id="14" name="node-Tools">
+            <a:extLst xmlns:a="http://schemas.openxmlformats.org/drawingml/2006/main">
+              <a:ext uri="{FF2B5EF4-FFF2-40B4-BE49-F238E27FC236}">
+                <a16:creationId xmlns:a16="http://schemas.microsoft.com/office/drawing/2014/main" id="{3448CF3D-CCBD-4A00-B5CE-449DD5EC1B9A}"/>
+              </a:ext>
+            </a:extLst>
+          </p:cNvPr>
+          <p:cNvSpPr>
+            <a:spLocks xmlns:a="http://schemas.openxmlformats.org/drawingml/2006/main" noGrp="1"/>
+          </p:cNvSpPr>
+          <p:nvPr/>
+        </p:nvSpPr>
+        <p:spPr>
+          <a:xfrm xmlns:a="http://schemas.openxmlformats.org/drawingml/2006/main">
+            <a:off x="8191500" y="3086100"/>
+            <a:ext cx="2209800" cy="609600"/>
           </a:xfrm>
           <a:prstGeom xmlns:a="http://schemas.openxmlformats.org/drawingml/2006/main" prst="roundRect">
             <a:avLst>
-              <a:gd name="adj" fmla="val 12903"/>
+              <a:gd name="adj" fmla="val 12500"/>
             </a:avLst>
           </a:prstGeom>
           <a:solidFill xmlns:a="http://schemas.openxmlformats.org/drawingml/2006/main">
-            <a:srgbClr val="EAF8F6"/>
+            <a:srgbClr val="FFFFFF"/>
           </a:solidFill>
           <a:ln xmlns:a="http://schemas.openxmlformats.org/drawingml/2006/main" w="12859">
             <a:solidFill>
@@ -19302,9 +19705,9 @@
                 <a:solidFill>
                   <a:srgbClr val="0E8F88"/>
                 </a:solidFill>
-                <a:latin typeface="PingFang TC"/>
-                <a:ea typeface="PingFang TC"/>
-                <a:cs typeface="PingFang TC"/>
+                <a:latin typeface="Aptos"/>
+                <a:ea typeface="Aptos"/>
+                <a:cs typeface="Aptos"/>
               </a:defRPr>
             </a:pPr>
             <a:r>
@@ -19312,11 +19715,11 @@
                 <a:solidFill>
                   <a:srgbClr val="0E8F88"/>
                 </a:solidFill>
-                <a:latin typeface="PingFang TC"/>
-                <a:ea typeface="PingFang TC"/>
-                <a:cs typeface="PingFang TC"/>
-              </a:rPr>
-              <a:t>Goal</a:t>
+                <a:latin typeface="Aptos"/>
+                <a:ea typeface="Aptos"/>
+                <a:cs typeface="Aptos"/>
+              </a:rPr>
+              <a:t>Tools</a:t>
             </a:r>
           </a:p>
           <a:p xmlns:a="http://schemas.openxmlformats.org/drawingml/2006/main">
@@ -19329,9 +19732,9 @@
                 <a:solidFill>
                   <a:srgbClr val="0E8F88"/>
                 </a:solidFill>
-                <a:latin typeface="PingFang TC"/>
-                <a:ea typeface="PingFang TC"/>
-                <a:cs typeface="PingFang TC"/>
+                <a:latin typeface="Aptos"/>
+                <a:ea typeface="Aptos"/>
+                <a:cs typeface="Aptos"/>
               </a:defRPr>
             </a:pPr>
             <a:r>
@@ -19339,64 +19742,33 @@
                 <a:solidFill>
                   <a:srgbClr val="0E8F88"/>
                 </a:solidFill>
-                <a:latin typeface="PingFang TC"/>
-                <a:ea typeface="PingFang TC"/>
-                <a:cs typeface="PingFang TC"/>
-              </a:rPr>
-              <a:t>成功條件</a:t>
-            </a:r>
-          </a:p>
-        </p:txBody>
-      </p:sp>
-      <p:sp>
-        <p:nvSpPr>
-          <p:cNvPr id="7" name="line-Context">
-            <a:extLst xmlns:a="http://schemas.openxmlformats.org/drawingml/2006/main">
-              <a:ext uri="{FF2B5EF4-FFF2-40B4-BE49-F238E27FC236}">
-                <a16:creationId xmlns:a16="http://schemas.microsoft.com/office/drawing/2014/main" id="{5EBFB7D2-879B-443E-B003-FB7D720F6E87}"/>
-              </a:ext>
-            </a:extLst>
-          </p:cNvPr>
-          <p:cNvSpPr>
-            <a:spLocks xmlns:a="http://schemas.openxmlformats.org/drawingml/2006/main" noGrp="1"/>
-          </p:cNvSpPr>
-          <p:nvPr/>
-        </p:nvSpPr>
-        <p:spPr>
-          <a:xfrm xmlns:a="http://schemas.openxmlformats.org/drawingml/2006/main">
-            <a:off x="6096000" y="2295525"/>
-            <a:ext cx="2390775" cy="1114425"/>
-          </a:xfrm>
-          <a:prstGeom xmlns:a="http://schemas.openxmlformats.org/drawingml/2006/main" prst="line">
-            <a:avLst/>
-          </a:prstGeom>
-          <a:noFill xmlns:a="http://schemas.openxmlformats.org/drawingml/2006/main"/>
-          <a:ln xmlns:a="http://schemas.openxmlformats.org/drawingml/2006/main" w="10478">
-            <a:solidFill>
-              <a:srgbClr val="D4DADD"/>
-            </a:solidFill>
-            <a:prstDash val="solid"/>
-          </a:ln>
-        </p:spPr>
-      </p:sp>
-      <p:sp>
-        <p:nvSpPr>
-          <p:cNvPr id="8" name="node-Context">
-            <a:extLst xmlns:a="http://schemas.openxmlformats.org/drawingml/2006/main">
-              <a:ext uri="{FF2B5EF4-FFF2-40B4-BE49-F238E27FC236}">
-                <a16:creationId xmlns:a16="http://schemas.microsoft.com/office/drawing/2014/main" id="{C85787E5-7B8F-495D-9339-468E42313BF4}"/>
-              </a:ext>
-            </a:extLst>
-          </p:cNvPr>
-          <p:cNvSpPr>
-            <a:spLocks xmlns:a="http://schemas.openxmlformats.org/drawingml/2006/main" noGrp="1"/>
-          </p:cNvSpPr>
-          <p:nvPr/>
-        </p:nvSpPr>
-        <p:spPr>
-          <a:xfrm xmlns:a="http://schemas.openxmlformats.org/drawingml/2006/main">
-            <a:off x="7581900" y="2000250"/>
-            <a:ext cx="1809750" cy="590550"/>
+                <a:latin typeface="Aptos"/>
+                <a:ea typeface="Aptos"/>
+                <a:cs typeface="Aptos"/>
+              </a:rPr>
+              <a:t>搜尋、讀檔、查 DB</a:t>
+            </a:r>
+          </a:p>
+        </p:txBody>
+      </p:sp>
+      <p:sp>
+        <p:nvSpPr>
+          <p:cNvPr id="15" name="node-State">
+            <a:extLst xmlns:a="http://schemas.openxmlformats.org/drawingml/2006/main">
+              <a:ext uri="{FF2B5EF4-FFF2-40B4-BE49-F238E27FC236}">
+                <a16:creationId xmlns:a16="http://schemas.microsoft.com/office/drawing/2014/main" id="{9B570EDD-8838-43A8-BE6F-69EEDB72C4FC}"/>
+              </a:ext>
+            </a:extLst>
+          </p:cNvPr>
+          <p:cNvSpPr>
+            <a:spLocks xmlns:a="http://schemas.openxmlformats.org/drawingml/2006/main" noGrp="1"/>
+          </p:cNvSpPr>
+          <p:nvPr/>
+        </p:nvSpPr>
+        <p:spPr>
+          <a:xfrm xmlns:a="http://schemas.openxmlformats.org/drawingml/2006/main">
+            <a:off x="5105400" y="4210050"/>
+            <a:ext cx="1981200" cy="590550"/>
           </a:xfrm>
           <a:prstGeom xmlns:a="http://schemas.openxmlformats.org/drawingml/2006/main" prst="roundRect">
             <a:avLst>
@@ -19440,7 +19812,7 @@
                 <a:ea typeface="Aptos"/>
                 <a:cs typeface="Aptos"/>
               </a:rPr>
-              <a:t>Context</a:t>
+              <a:t>State</a:t>
             </a:r>
           </a:p>
           <a:p xmlns:a="http://schemas.openxmlformats.org/drawingml/2006/main">
@@ -19467,254 +19839,6 @@
                 <a:ea typeface="Aptos"/>
                 <a:cs typeface="Aptos"/>
               </a:rPr>
-              <a:t>任務、資料、限制</a:t>
-            </a:r>
-          </a:p>
-        </p:txBody>
-      </p:sp>
-      <p:sp>
-        <p:nvSpPr>
-          <p:cNvPr id="9" name="line-Tools">
-            <a:extLst xmlns:a="http://schemas.openxmlformats.org/drawingml/2006/main">
-              <a:ext uri="{FF2B5EF4-FFF2-40B4-BE49-F238E27FC236}">
-                <a16:creationId xmlns:a16="http://schemas.microsoft.com/office/drawing/2014/main" id="{36609266-98DA-4F57-85AC-7AC1F421E160}"/>
-              </a:ext>
-            </a:extLst>
-          </p:cNvPr>
-          <p:cNvSpPr>
-            <a:spLocks xmlns:a="http://schemas.openxmlformats.org/drawingml/2006/main" noGrp="1"/>
-          </p:cNvSpPr>
-          <p:nvPr/>
-        </p:nvSpPr>
-        <p:spPr>
-          <a:xfrm xmlns:a="http://schemas.openxmlformats.org/drawingml/2006/main">
-            <a:off x="2466975" y="3409950"/>
-            <a:ext cx="3629025" cy="1057275"/>
-          </a:xfrm>
-          <a:prstGeom xmlns:a="http://schemas.openxmlformats.org/drawingml/2006/main" prst="line">
-            <a:avLst/>
-          </a:prstGeom>
-          <a:noFill xmlns:a="http://schemas.openxmlformats.org/drawingml/2006/main"/>
-          <a:ln xmlns:a="http://schemas.openxmlformats.org/drawingml/2006/main" w="10478">
-            <a:solidFill>
-              <a:srgbClr val="D4DADD"/>
-            </a:solidFill>
-            <a:prstDash val="solid"/>
-          </a:ln>
-        </p:spPr>
-      </p:sp>
-      <p:sp>
-        <p:nvSpPr>
-          <p:cNvPr id="10" name="node-Tools">
-            <a:extLst xmlns:a="http://schemas.openxmlformats.org/drawingml/2006/main">
-              <a:ext uri="{FF2B5EF4-FFF2-40B4-BE49-F238E27FC236}">
-                <a16:creationId xmlns:a16="http://schemas.microsoft.com/office/drawing/2014/main" id="{220CAEC7-CE7D-47C8-9975-1B4EEF76750F}"/>
-              </a:ext>
-            </a:extLst>
-          </p:cNvPr>
-          <p:cNvSpPr>
-            <a:spLocks xmlns:a="http://schemas.openxmlformats.org/drawingml/2006/main" noGrp="1"/>
-          </p:cNvSpPr>
-          <p:nvPr/>
-        </p:nvSpPr>
-        <p:spPr>
-          <a:xfrm xmlns:a="http://schemas.openxmlformats.org/drawingml/2006/main">
-            <a:off x="1562100" y="4171950"/>
-            <a:ext cx="1809750" cy="590550"/>
-          </a:xfrm>
-          <a:prstGeom xmlns:a="http://schemas.openxmlformats.org/drawingml/2006/main" prst="roundRect">
-            <a:avLst>
-              <a:gd name="adj" fmla="val 12903"/>
-            </a:avLst>
-          </a:prstGeom>
-          <a:solidFill xmlns:a="http://schemas.openxmlformats.org/drawingml/2006/main">
-            <a:srgbClr val="FFFFFF"/>
-          </a:solidFill>
-          <a:ln xmlns:a="http://schemas.openxmlformats.org/drawingml/2006/main" w="12859">
-            <a:solidFill>
-              <a:srgbClr val="0E8F88"/>
-            </a:solidFill>
-            <a:prstDash val="solid"/>
-          </a:ln>
-        </p:spPr>
-        <p:txBody>
-          <a:bodyPr xmlns:a="http://schemas.openxmlformats.org/drawingml/2006/main" lIns="76200" tIns="57150" rIns="76200" bIns="57150" anchor="ctr"/>
-          <a:lstStyle xmlns:a="http://schemas.openxmlformats.org/drawingml/2006/main"/>
-          <a:p xmlns:a="http://schemas.openxmlformats.org/drawingml/2006/main">
-            <a:pPr algn="ctr">
-              <a:lnSpc>
-                <a:spcPct val="102000"/>
-              </a:lnSpc>
-              <a:buNone/>
-              <a:defRPr sz="1200" b="1">
-                <a:solidFill>
-                  <a:srgbClr val="0E8F88"/>
-                </a:solidFill>
-                <a:latin typeface="Aptos"/>
-                <a:ea typeface="Aptos"/>
-                <a:cs typeface="Aptos"/>
-              </a:defRPr>
-            </a:pPr>
-            <a:r>
-              <a:rPr sz="1200" b="1">
-                <a:solidFill>
-                  <a:srgbClr val="0E8F88"/>
-                </a:solidFill>
-                <a:latin typeface="Aptos"/>
-                <a:ea typeface="Aptos"/>
-                <a:cs typeface="Aptos"/>
-              </a:rPr>
-              <a:t>Tools</a:t>
-            </a:r>
-          </a:p>
-          <a:p xmlns:a="http://schemas.openxmlformats.org/drawingml/2006/main">
-            <a:pPr algn="ctr">
-              <a:lnSpc>
-                <a:spcPct val="102000"/>
-              </a:lnSpc>
-              <a:buNone/>
-              <a:defRPr sz="1200" b="1">
-                <a:solidFill>
-                  <a:srgbClr val="0E8F88"/>
-                </a:solidFill>
-                <a:latin typeface="Aptos"/>
-                <a:ea typeface="Aptos"/>
-                <a:cs typeface="Aptos"/>
-              </a:defRPr>
-            </a:pPr>
-            <a:r>
-              <a:rPr sz="1200" b="1">
-                <a:solidFill>
-                  <a:srgbClr val="0E8F88"/>
-                </a:solidFill>
-                <a:latin typeface="Aptos"/>
-                <a:ea typeface="Aptos"/>
-                <a:cs typeface="Aptos"/>
-              </a:rPr>
-              <a:t>搜尋、讀檔、查 DB</a:t>
-            </a:r>
-          </a:p>
-        </p:txBody>
-      </p:sp>
-      <p:sp>
-        <p:nvSpPr>
-          <p:cNvPr id="11" name="line-State">
-            <a:extLst xmlns:a="http://schemas.openxmlformats.org/drawingml/2006/main">
-              <a:ext uri="{FF2B5EF4-FFF2-40B4-BE49-F238E27FC236}">
-                <a16:creationId xmlns:a16="http://schemas.microsoft.com/office/drawing/2014/main" id="{04EB7130-1139-437B-9462-BA760AB74978}"/>
-              </a:ext>
-            </a:extLst>
-          </p:cNvPr>
-          <p:cNvSpPr>
-            <a:spLocks xmlns:a="http://schemas.openxmlformats.org/drawingml/2006/main" noGrp="1"/>
-          </p:cNvSpPr>
-          <p:nvPr/>
-        </p:nvSpPr>
-        <p:spPr>
-          <a:xfrm xmlns:a="http://schemas.openxmlformats.org/drawingml/2006/main">
-            <a:off x="6096000" y="3409950"/>
-            <a:ext cx="2771775" cy="1057275"/>
-          </a:xfrm>
-          <a:prstGeom xmlns:a="http://schemas.openxmlformats.org/drawingml/2006/main" prst="line">
-            <a:avLst/>
-          </a:prstGeom>
-          <a:noFill xmlns:a="http://schemas.openxmlformats.org/drawingml/2006/main"/>
-          <a:ln xmlns:a="http://schemas.openxmlformats.org/drawingml/2006/main" w="10478">
-            <a:solidFill>
-              <a:srgbClr val="D4DADD"/>
-            </a:solidFill>
-            <a:prstDash val="solid"/>
-          </a:ln>
-        </p:spPr>
-      </p:sp>
-      <p:sp>
-        <p:nvSpPr>
-          <p:cNvPr id="12" name="node-State">
-            <a:extLst xmlns:a="http://schemas.openxmlformats.org/drawingml/2006/main">
-              <a:ext uri="{FF2B5EF4-FFF2-40B4-BE49-F238E27FC236}">
-                <a16:creationId xmlns:a16="http://schemas.microsoft.com/office/drawing/2014/main" id="{18294EAE-41B3-436B-8EE5-34FD0EF4F0E4}"/>
-              </a:ext>
-            </a:extLst>
-          </p:cNvPr>
-          <p:cNvSpPr>
-            <a:spLocks xmlns:a="http://schemas.openxmlformats.org/drawingml/2006/main" noGrp="1"/>
-          </p:cNvSpPr>
-          <p:nvPr/>
-        </p:nvSpPr>
-        <p:spPr>
-          <a:xfrm xmlns:a="http://schemas.openxmlformats.org/drawingml/2006/main">
-            <a:off x="7962900" y="4171950"/>
-            <a:ext cx="1809750" cy="590550"/>
-          </a:xfrm>
-          <a:prstGeom xmlns:a="http://schemas.openxmlformats.org/drawingml/2006/main" prst="roundRect">
-            <a:avLst>
-              <a:gd name="adj" fmla="val 12903"/>
-            </a:avLst>
-          </a:prstGeom>
-          <a:solidFill xmlns:a="http://schemas.openxmlformats.org/drawingml/2006/main">
-            <a:srgbClr val="FFFFFF"/>
-          </a:solidFill>
-          <a:ln xmlns:a="http://schemas.openxmlformats.org/drawingml/2006/main" w="12859">
-            <a:solidFill>
-              <a:srgbClr val="5C6670"/>
-            </a:solidFill>
-            <a:prstDash val="solid"/>
-          </a:ln>
-        </p:spPr>
-        <p:txBody>
-          <a:bodyPr xmlns:a="http://schemas.openxmlformats.org/drawingml/2006/main" lIns="76200" tIns="57150" rIns="76200" bIns="57150" anchor="ctr"/>
-          <a:lstStyle xmlns:a="http://schemas.openxmlformats.org/drawingml/2006/main"/>
-          <a:p xmlns:a="http://schemas.openxmlformats.org/drawingml/2006/main">
-            <a:pPr algn="ctr">
-              <a:lnSpc>
-                <a:spcPct val="102000"/>
-              </a:lnSpc>
-              <a:buNone/>
-              <a:defRPr sz="1200" b="1">
-                <a:solidFill>
-                  <a:srgbClr val="5C6670"/>
-                </a:solidFill>
-                <a:latin typeface="PingFang TC"/>
-                <a:ea typeface="PingFang TC"/>
-                <a:cs typeface="PingFang TC"/>
-              </a:defRPr>
-            </a:pPr>
-            <a:r>
-              <a:rPr sz="1200" b="1">
-                <a:solidFill>
-                  <a:srgbClr val="5C6670"/>
-                </a:solidFill>
-                <a:latin typeface="PingFang TC"/>
-                <a:ea typeface="PingFang TC"/>
-                <a:cs typeface="PingFang TC"/>
-              </a:rPr>
-              <a:t>State</a:t>
-            </a:r>
-          </a:p>
-          <a:p xmlns:a="http://schemas.openxmlformats.org/drawingml/2006/main">
-            <a:pPr algn="ctr">
-              <a:lnSpc>
-                <a:spcPct val="102000"/>
-              </a:lnSpc>
-              <a:buNone/>
-              <a:defRPr sz="1200" b="1">
-                <a:solidFill>
-                  <a:srgbClr val="5C6670"/>
-                </a:solidFill>
-                <a:latin typeface="PingFang TC"/>
-                <a:ea typeface="PingFang TC"/>
-                <a:cs typeface="PingFang TC"/>
-              </a:defRPr>
-            </a:pPr>
-            <a:r>
-              <a:rPr sz="1200" b="1">
-                <a:solidFill>
-                  <a:srgbClr val="5C6670"/>
-                </a:solidFill>
-                <a:latin typeface="PingFang TC"/>
-                <a:ea typeface="PingFang TC"/>
-                <a:cs typeface="PingFang TC"/>
-              </a:rPr>
               <a:t>進度與中間結果</a:t>
             </a:r>
           </a:p>
@@ -19722,53 +19846,22 @@
       </p:sp>
       <p:sp>
         <p:nvSpPr>
-          <p:cNvPr id="13" name="line-Verification">
-            <a:extLst xmlns:a="http://schemas.openxmlformats.org/drawingml/2006/main">
-              <a:ext uri="{FF2B5EF4-FFF2-40B4-BE49-F238E27FC236}">
-                <a16:creationId xmlns:a16="http://schemas.microsoft.com/office/drawing/2014/main" id="{2EFFC43A-CA9C-4C46-BD71-1A5F4AF00460}"/>
-              </a:ext>
-            </a:extLst>
-          </p:cNvPr>
-          <p:cNvSpPr>
-            <a:spLocks xmlns:a="http://schemas.openxmlformats.org/drawingml/2006/main" noGrp="1"/>
-          </p:cNvSpPr>
-          <p:nvPr/>
-        </p:nvSpPr>
-        <p:spPr>
-          <a:xfrm xmlns:a="http://schemas.openxmlformats.org/drawingml/2006/main">
-            <a:off x="5534025" y="3409950"/>
-            <a:ext cx="561975" cy="1895475"/>
-          </a:xfrm>
-          <a:prstGeom xmlns:a="http://schemas.openxmlformats.org/drawingml/2006/main" prst="line">
-            <a:avLst/>
-          </a:prstGeom>
-          <a:noFill xmlns:a="http://schemas.openxmlformats.org/drawingml/2006/main"/>
-          <a:ln xmlns:a="http://schemas.openxmlformats.org/drawingml/2006/main" w="10478">
-            <a:solidFill>
-              <a:srgbClr val="D4DADD"/>
-            </a:solidFill>
-            <a:prstDash val="solid"/>
-          </a:ln>
-        </p:spPr>
-      </p:sp>
-      <p:sp>
-        <p:nvSpPr>
-          <p:cNvPr id="14" name="node-Verification">
-            <a:extLst xmlns:a="http://schemas.openxmlformats.org/drawingml/2006/main">
-              <a:ext uri="{FF2B5EF4-FFF2-40B4-BE49-F238E27FC236}">
-                <a16:creationId xmlns:a16="http://schemas.microsoft.com/office/drawing/2014/main" id="{93FEB733-9194-41D4-8DA3-5BC9E69DF004}"/>
-              </a:ext>
-            </a:extLst>
-          </p:cNvPr>
-          <p:cNvSpPr>
-            <a:spLocks xmlns:a="http://schemas.openxmlformats.org/drawingml/2006/main" noGrp="1"/>
-          </p:cNvSpPr>
-          <p:nvPr/>
-        </p:nvSpPr>
-        <p:spPr>
-          <a:xfrm xmlns:a="http://schemas.openxmlformats.org/drawingml/2006/main">
-            <a:off x="4629150" y="5010150"/>
-            <a:ext cx="1809750" cy="590550"/>
+          <p:cNvPr id="16" name="node-Verification">
+            <a:extLst xmlns:a="http://schemas.openxmlformats.org/drawingml/2006/main">
+              <a:ext uri="{FF2B5EF4-FFF2-40B4-BE49-F238E27FC236}">
+                <a16:creationId xmlns:a16="http://schemas.microsoft.com/office/drawing/2014/main" id="{154FBDBA-6752-4694-94B4-7A17C40249CC}"/>
+              </a:ext>
+            </a:extLst>
+          </p:cNvPr>
+          <p:cNvSpPr>
+            <a:spLocks xmlns:a="http://schemas.openxmlformats.org/drawingml/2006/main" noGrp="1"/>
+          </p:cNvSpPr>
+          <p:nvPr/>
+        </p:nvSpPr>
+        <p:spPr>
+          <a:xfrm xmlns:a="http://schemas.openxmlformats.org/drawingml/2006/main">
+            <a:off x="5105400" y="5162550"/>
+            <a:ext cx="1981200" cy="590550"/>
           </a:xfrm>
           <a:prstGeom xmlns:a="http://schemas.openxmlformats.org/drawingml/2006/main" prst="roundRect">
             <a:avLst>
@@ -19798,9 +19891,9 @@
                 <a:solidFill>
                   <a:srgbClr val="D89A16"/>
                 </a:solidFill>
-                <a:latin typeface="PingFang TC"/>
-                <a:ea typeface="PingFang TC"/>
-                <a:cs typeface="PingFang TC"/>
+                <a:latin typeface="Aptos"/>
+                <a:ea typeface="Aptos"/>
+                <a:cs typeface="Aptos"/>
               </a:defRPr>
             </a:pPr>
             <a:r>
@@ -19808,9 +19901,9 @@
                 <a:solidFill>
                   <a:srgbClr val="D89A16"/>
                 </a:solidFill>
-                <a:latin typeface="PingFang TC"/>
-                <a:ea typeface="PingFang TC"/>
-                <a:cs typeface="PingFang TC"/>
+                <a:latin typeface="Aptos"/>
+                <a:ea typeface="Aptos"/>
+                <a:cs typeface="Aptos"/>
               </a:rPr>
               <a:t>Verification</a:t>
             </a:r>
@@ -19825,9 +19918,9 @@
                 <a:solidFill>
                   <a:srgbClr val="D89A16"/>
                 </a:solidFill>
-                <a:latin typeface="PingFang TC"/>
-                <a:ea typeface="PingFang TC"/>
-                <a:cs typeface="PingFang TC"/>
+                <a:latin typeface="Aptos"/>
+                <a:ea typeface="Aptos"/>
+                <a:cs typeface="Aptos"/>
               </a:defRPr>
             </a:pPr>
             <a:r>
@@ -19835,9 +19928,9 @@
                 <a:solidFill>
                   <a:srgbClr val="D89A16"/>
                 </a:solidFill>
-                <a:latin typeface="PingFang TC"/>
-                <a:ea typeface="PingFang TC"/>
-                <a:cs typeface="PingFang TC"/>
+                <a:latin typeface="Aptos"/>
+                <a:ea typeface="Aptos"/>
+                <a:cs typeface="Aptos"/>
               </a:rPr>
               <a:t>檢查與停止條件</a:t>
             </a:r>
@@ -19847,7 +19940,7 @@
     </p:spTree>
     <p:extLst>
       <p:ext uri="{BB962C8B-B14F-4D97-AF65-F5344CB8AC3E}">
-        <p14:creationId xmlns:p14="http://schemas.microsoft.com/office/powerpoint/2010/main" val="400014972"/>
+        <p14:creationId xmlns:p14="http://schemas.microsoft.com/office/powerpoint/2010/main" val="1167794927"/>
       </p:ext>
     </p:extLst>
   </p:cSld>
@@ -19878,7 +19971,7 @@
           <p:cNvPr id="1" name="eyebrow">
             <a:extLst xmlns:a="http://schemas.openxmlformats.org/drawingml/2006/main">
               <a:ext uri="{FF2B5EF4-FFF2-40B4-BE49-F238E27FC236}">
-                <a16:creationId xmlns:a16="http://schemas.microsoft.com/office/drawing/2014/main" id="{D69A8FC5-C80E-4513-AF2D-F9796662DEA0}"/>
+                <a16:creationId xmlns:a16="http://schemas.microsoft.com/office/drawing/2014/main" id="{F2C167AB-5B46-41C6-BFD2-9F7B864EC8B9}"/>
               </a:ext>
             </a:extLst>
           </p:cNvPr>
@@ -19938,7 +20031,7 @@
           <p:cNvPr id="2" name="title">
             <a:extLst xmlns:a="http://schemas.openxmlformats.org/drawingml/2006/main">
               <a:ext uri="{FF2B5EF4-FFF2-40B4-BE49-F238E27FC236}">
-                <a16:creationId xmlns:a16="http://schemas.microsoft.com/office/drawing/2014/main" id="{1CCDC119-D659-4AED-B37F-4509C2D168C2}"/>
+                <a16:creationId xmlns:a16="http://schemas.microsoft.com/office/drawing/2014/main" id="{495AA858-4065-4A95-8F35-E31362213126}"/>
               </a:ext>
             </a:extLst>
           </p:cNvPr>
@@ -19998,7 +20091,7 @@
           <p:cNvPr id="3" name="footer">
             <a:extLst xmlns:a="http://schemas.openxmlformats.org/drawingml/2006/main">
               <a:ext uri="{FF2B5EF4-FFF2-40B4-BE49-F238E27FC236}">
-                <a16:creationId xmlns:a16="http://schemas.microsoft.com/office/drawing/2014/main" id="{6275477B-E4E1-41F1-B2EB-BF19E1833816}"/>
+                <a16:creationId xmlns:a16="http://schemas.microsoft.com/office/drawing/2014/main" id="{F26D913E-080A-42B6-B482-45E027DEC3CD}"/>
               </a:ext>
             </a:extLst>
           </p:cNvPr>
@@ -20058,7 +20151,7 @@
           <p:cNvPr id="4" name="goal-plan-a">
             <a:extLst xmlns:a="http://schemas.openxmlformats.org/drawingml/2006/main">
               <a:ext uri="{FF2B5EF4-FFF2-40B4-BE49-F238E27FC236}">
-                <a16:creationId xmlns:a16="http://schemas.microsoft.com/office/drawing/2014/main" id="{4CF884B7-0A20-4526-AF80-83C11583E51D}"/>
+                <a16:creationId xmlns:a16="http://schemas.microsoft.com/office/drawing/2014/main" id="{2E8D19A7-7838-487E-85E0-C3D1FADD3B2D}"/>
               </a:ext>
             </a:extLst>
           </p:cNvPr>
@@ -20089,7 +20182,7 @@
           <p:cNvPr id="5" name="goal-plan-b">
             <a:extLst xmlns:a="http://schemas.openxmlformats.org/drawingml/2006/main">
               <a:ext uri="{FF2B5EF4-FFF2-40B4-BE49-F238E27FC236}">
-                <a16:creationId xmlns:a16="http://schemas.microsoft.com/office/drawing/2014/main" id="{4495BF2B-F39A-4B28-B702-643A92565C22}"/>
+                <a16:creationId xmlns:a16="http://schemas.microsoft.com/office/drawing/2014/main" id="{8F92E811-E4E1-4873-8E96-95605682CC7B}"/>
               </a:ext>
             </a:extLst>
           </p:cNvPr>
@@ -20120,7 +20213,7 @@
           <p:cNvPr id="6" name="goal-plan-c">
             <a:extLst xmlns:a="http://schemas.openxmlformats.org/drawingml/2006/main">
               <a:ext uri="{FF2B5EF4-FFF2-40B4-BE49-F238E27FC236}">
-                <a16:creationId xmlns:a16="http://schemas.microsoft.com/office/drawing/2014/main" id="{DAF4E22B-6EE9-4746-8E27-FFB4BEAA6DE6}"/>
+                <a16:creationId xmlns:a16="http://schemas.microsoft.com/office/drawing/2014/main" id="{AD4EC71A-2085-43B2-A623-C1F35DE2B6DC}"/>
               </a:ext>
             </a:extLst>
           </p:cNvPr>
@@ -20151,7 +20244,7 @@
           <p:cNvPr id="7" name="plan-act">
             <a:extLst xmlns:a="http://schemas.openxmlformats.org/drawingml/2006/main">
               <a:ext uri="{FF2B5EF4-FFF2-40B4-BE49-F238E27FC236}">
-                <a16:creationId xmlns:a16="http://schemas.microsoft.com/office/drawing/2014/main" id="{069976A6-3108-41A3-A26F-7A596CB2DA53}"/>
+                <a16:creationId xmlns:a16="http://schemas.microsoft.com/office/drawing/2014/main" id="{A93CDF8D-ABA8-4C28-A197-E162CF134B5A}"/>
               </a:ext>
             </a:extLst>
           </p:cNvPr>
@@ -20182,7 +20275,7 @@
           <p:cNvPr id="8" name="act-observe-a">
             <a:extLst xmlns:a="http://schemas.openxmlformats.org/drawingml/2006/main">
               <a:ext uri="{FF2B5EF4-FFF2-40B4-BE49-F238E27FC236}">
-                <a16:creationId xmlns:a16="http://schemas.microsoft.com/office/drawing/2014/main" id="{6300CD02-2D0C-496B-B7D0-B131F412E756}"/>
+                <a16:creationId xmlns:a16="http://schemas.microsoft.com/office/drawing/2014/main" id="{90A31365-02C2-4527-B89F-92F180F4C355}"/>
               </a:ext>
             </a:extLst>
           </p:cNvPr>
@@ -20213,7 +20306,7 @@
           <p:cNvPr id="9" name="act-observe-b">
             <a:extLst xmlns:a="http://schemas.openxmlformats.org/drawingml/2006/main">
               <a:ext uri="{FF2B5EF4-FFF2-40B4-BE49-F238E27FC236}">
-                <a16:creationId xmlns:a16="http://schemas.microsoft.com/office/drawing/2014/main" id="{F72A6256-67E9-4A64-948C-E51D629839D1}"/>
+                <a16:creationId xmlns:a16="http://schemas.microsoft.com/office/drawing/2014/main" id="{A3E17ADB-9009-49C8-8FFB-1760B28A6267}"/>
               </a:ext>
             </a:extLst>
           </p:cNvPr>
@@ -20244,7 +20337,7 @@
           <p:cNvPr id="10" name="act-observe-c">
             <a:extLst xmlns:a="http://schemas.openxmlformats.org/drawingml/2006/main">
               <a:ext uri="{FF2B5EF4-FFF2-40B4-BE49-F238E27FC236}">
-                <a16:creationId xmlns:a16="http://schemas.microsoft.com/office/drawing/2014/main" id="{1967D6F6-127C-4E9F-9B81-C77BA414CB35}"/>
+                <a16:creationId xmlns:a16="http://schemas.microsoft.com/office/drawing/2014/main" id="{F3B199AE-DF31-4903-9FA8-53B6058A99A6}"/>
               </a:ext>
             </a:extLst>
           </p:cNvPr>
@@ -20275,7 +20368,7 @@
           <p:cNvPr id="11" name="observe-verify-a">
             <a:extLst xmlns:a="http://schemas.openxmlformats.org/drawingml/2006/main">
               <a:ext uri="{FF2B5EF4-FFF2-40B4-BE49-F238E27FC236}">
-                <a16:creationId xmlns:a16="http://schemas.microsoft.com/office/drawing/2014/main" id="{BA87021E-62FF-47FA-A8F2-795769778DB8}"/>
+                <a16:creationId xmlns:a16="http://schemas.microsoft.com/office/drawing/2014/main" id="{0F880716-D19A-4002-ABED-E32529ADE0F0}"/>
               </a:ext>
             </a:extLst>
           </p:cNvPr>
@@ -20306,7 +20399,7 @@
           <p:cNvPr id="12" name="observe-verify-b">
             <a:extLst xmlns:a="http://schemas.openxmlformats.org/drawingml/2006/main">
               <a:ext uri="{FF2B5EF4-FFF2-40B4-BE49-F238E27FC236}">
-                <a16:creationId xmlns:a16="http://schemas.microsoft.com/office/drawing/2014/main" id="{7C3EFD17-E748-47D3-9581-11D1E98872FC}"/>
+                <a16:creationId xmlns:a16="http://schemas.microsoft.com/office/drawing/2014/main" id="{A36D8C1A-4517-4DA7-99D7-CC731029874D}"/>
               </a:ext>
             </a:extLst>
           </p:cNvPr>
@@ -20337,7 +20430,7 @@
           <p:cNvPr id="13" name="observe-verify-c">
             <a:extLst xmlns:a="http://schemas.openxmlformats.org/drawingml/2006/main">
               <a:ext uri="{FF2B5EF4-FFF2-40B4-BE49-F238E27FC236}">
-                <a16:creationId xmlns:a16="http://schemas.microsoft.com/office/drawing/2014/main" id="{019F9BA5-4D17-44F3-B340-8C3A37BE5067}"/>
+                <a16:creationId xmlns:a16="http://schemas.microsoft.com/office/drawing/2014/main" id="{25A3A311-6BF3-461B-9A72-D6A2D6B3BBF3}"/>
               </a:ext>
             </a:extLst>
           </p:cNvPr>
@@ -20368,7 +20461,7 @@
           <p:cNvPr id="14" name="verify-state">
             <a:extLst xmlns:a="http://schemas.openxmlformats.org/drawingml/2006/main">
               <a:ext uri="{FF2B5EF4-FFF2-40B4-BE49-F238E27FC236}">
-                <a16:creationId xmlns:a16="http://schemas.microsoft.com/office/drawing/2014/main" id="{822C99EF-02EF-4C34-B0F4-27C77B47874D}"/>
+                <a16:creationId xmlns:a16="http://schemas.microsoft.com/office/drawing/2014/main" id="{C05CA8C2-A01F-4C9E-B155-A29BBA7CC1D1}"/>
               </a:ext>
             </a:extLst>
           </p:cNvPr>
@@ -20399,7 +20492,7 @@
           <p:cNvPr id="15" name="state-goal-a">
             <a:extLst xmlns:a="http://schemas.openxmlformats.org/drawingml/2006/main">
               <a:ext uri="{FF2B5EF4-FFF2-40B4-BE49-F238E27FC236}">
-                <a16:creationId xmlns:a16="http://schemas.microsoft.com/office/drawing/2014/main" id="{76576376-DEAF-478E-B1D5-D39B82DF8438}"/>
+                <a16:creationId xmlns:a16="http://schemas.microsoft.com/office/drawing/2014/main" id="{63E9CB6E-656E-4D55-ABCD-6DE924FF01C5}"/>
               </a:ext>
             </a:extLst>
           </p:cNvPr>
@@ -20430,7 +20523,7 @@
           <p:cNvPr id="16" name="state-goal-b">
             <a:extLst xmlns:a="http://schemas.openxmlformats.org/drawingml/2006/main">
               <a:ext uri="{FF2B5EF4-FFF2-40B4-BE49-F238E27FC236}">
-                <a16:creationId xmlns:a16="http://schemas.microsoft.com/office/drawing/2014/main" id="{204747A5-42A7-4D9D-A6AD-1F8E40CBF302}"/>
+                <a16:creationId xmlns:a16="http://schemas.microsoft.com/office/drawing/2014/main" id="{A010474D-C501-40E2-95B4-2572DCD516E6}"/>
               </a:ext>
             </a:extLst>
           </p:cNvPr>
@@ -20461,7 +20554,7 @@
           <p:cNvPr id="17" name="state-goal-c">
             <a:extLst xmlns:a="http://schemas.openxmlformats.org/drawingml/2006/main">
               <a:ext uri="{FF2B5EF4-FFF2-40B4-BE49-F238E27FC236}">
-                <a16:creationId xmlns:a16="http://schemas.microsoft.com/office/drawing/2014/main" id="{AD9D3102-7F5B-4CC7-B67F-70CF05BDE399}"/>
+                <a16:creationId xmlns:a16="http://schemas.microsoft.com/office/drawing/2014/main" id="{B0F92CF5-ABF4-4AC4-8869-237DE8FDB8EA}"/>
               </a:ext>
             </a:extLst>
           </p:cNvPr>
@@ -20492,7 +20585,7 @@
           <p:cNvPr id="18" name="goal">
             <a:extLst xmlns:a="http://schemas.openxmlformats.org/drawingml/2006/main">
               <a:ext uri="{FF2B5EF4-FFF2-40B4-BE49-F238E27FC236}">
-                <a16:creationId xmlns:a16="http://schemas.microsoft.com/office/drawing/2014/main" id="{29DA3A7C-F80D-402C-A09D-FA5DE664FB5D}"/>
+                <a16:creationId xmlns:a16="http://schemas.microsoft.com/office/drawing/2014/main" id="{7DA1A1C0-9109-4944-90B8-0CB2BC522C5C}"/>
               </a:ext>
             </a:extLst>
           </p:cNvPr>
@@ -20558,7 +20651,7 @@
           <p:cNvPr id="19" name="plan">
             <a:extLst xmlns:a="http://schemas.openxmlformats.org/drawingml/2006/main">
               <a:ext uri="{FF2B5EF4-FFF2-40B4-BE49-F238E27FC236}">
-                <a16:creationId xmlns:a16="http://schemas.microsoft.com/office/drawing/2014/main" id="{703B0474-66DA-4968-A64F-58591204092A}"/>
+                <a16:creationId xmlns:a16="http://schemas.microsoft.com/office/drawing/2014/main" id="{E1FBCC13-A371-42C5-8859-A673F5805665}"/>
               </a:ext>
             </a:extLst>
           </p:cNvPr>
@@ -20624,7 +20717,7 @@
           <p:cNvPr id="20" name="act">
             <a:extLst xmlns:a="http://schemas.openxmlformats.org/drawingml/2006/main">
               <a:ext uri="{FF2B5EF4-FFF2-40B4-BE49-F238E27FC236}">
-                <a16:creationId xmlns:a16="http://schemas.microsoft.com/office/drawing/2014/main" id="{AC9C4269-4CBB-424E-B3C6-5978D0F70108}"/>
+                <a16:creationId xmlns:a16="http://schemas.microsoft.com/office/drawing/2014/main" id="{0C248113-4B8D-4398-9C7F-CA71724E7E54}"/>
               </a:ext>
             </a:extLst>
           </p:cNvPr>
@@ -20717,7 +20810,7 @@
           <p:cNvPr id="21" name="observe">
             <a:extLst xmlns:a="http://schemas.openxmlformats.org/drawingml/2006/main">
               <a:ext uri="{FF2B5EF4-FFF2-40B4-BE49-F238E27FC236}">
-                <a16:creationId xmlns:a16="http://schemas.microsoft.com/office/drawing/2014/main" id="{D9DE4206-AD9D-43AF-99AA-262E20AB97E2}"/>
+                <a16:creationId xmlns:a16="http://schemas.microsoft.com/office/drawing/2014/main" id="{BCADF2EE-35C5-4444-8806-ECC95F9F3C42}"/>
               </a:ext>
             </a:extLst>
           </p:cNvPr>
@@ -20783,7 +20876,7 @@
           <p:cNvPr id="22" name="verify">
             <a:extLst xmlns:a="http://schemas.openxmlformats.org/drawingml/2006/main">
               <a:ext uri="{FF2B5EF4-FFF2-40B4-BE49-F238E27FC236}">
-                <a16:creationId xmlns:a16="http://schemas.microsoft.com/office/drawing/2014/main" id="{2781FE95-D5D1-47F1-A9FC-2F4C73C4E279}"/>
+                <a16:creationId xmlns:a16="http://schemas.microsoft.com/office/drawing/2014/main" id="{6167D6C5-C5A8-4F0F-893E-EFB67EBE75D2}"/>
               </a:ext>
             </a:extLst>
           </p:cNvPr>
@@ -20849,7 +20942,7 @@
           <p:cNvPr id="23" name="state">
             <a:extLst xmlns:a="http://schemas.openxmlformats.org/drawingml/2006/main">
               <a:ext uri="{FF2B5EF4-FFF2-40B4-BE49-F238E27FC236}">
-                <a16:creationId xmlns:a16="http://schemas.microsoft.com/office/drawing/2014/main" id="{D257BB02-EFD4-48B3-B7DC-CC2C2B916BF4}"/>
+                <a16:creationId xmlns:a16="http://schemas.microsoft.com/office/drawing/2014/main" id="{670E9E51-50CF-42C9-B2CF-810DBFFE0373}"/>
               </a:ext>
             </a:extLst>
           </p:cNvPr>
@@ -20942,7 +21035,7 @@
           <p:cNvPr id="24" name="human">
             <a:extLst xmlns:a="http://schemas.openxmlformats.org/drawingml/2006/main">
               <a:ext uri="{FF2B5EF4-FFF2-40B4-BE49-F238E27FC236}">
-                <a16:creationId xmlns:a16="http://schemas.microsoft.com/office/drawing/2014/main" id="{866BB33C-C8BB-4D26-B23B-1F79561C8878}"/>
+                <a16:creationId xmlns:a16="http://schemas.microsoft.com/office/drawing/2014/main" id="{A717AF3F-BCD6-4672-9959-C01B4153DE8C}"/>
               </a:ext>
             </a:extLst>
           </p:cNvPr>
@@ -21035,7 +21128,7 @@
           <p:cNvPr id="25" name="human-link">
             <a:extLst xmlns:a="http://schemas.openxmlformats.org/drawingml/2006/main">
               <a:ext uri="{FF2B5EF4-FFF2-40B4-BE49-F238E27FC236}">
-                <a16:creationId xmlns:a16="http://schemas.microsoft.com/office/drawing/2014/main" id="{BBF59EB0-2A1C-4539-B56F-87F05F0A312B}"/>
+                <a16:creationId xmlns:a16="http://schemas.microsoft.com/office/drawing/2014/main" id="{C43150BB-3C78-442A-BEDA-BA443BAA8076}"/>
               </a:ext>
             </a:extLst>
           </p:cNvPr>
@@ -21066,7 +21159,7 @@
           <p:cNvPr id="26" name="loop-note">
             <a:extLst xmlns:a="http://schemas.openxmlformats.org/drawingml/2006/main">
               <a:ext uri="{FF2B5EF4-FFF2-40B4-BE49-F238E27FC236}">
-                <a16:creationId xmlns:a16="http://schemas.microsoft.com/office/drawing/2014/main" id="{76B8B2DB-79C8-49F3-B446-C3088BFB1035}"/>
+                <a16:creationId xmlns:a16="http://schemas.microsoft.com/office/drawing/2014/main" id="{1FC5F7E6-34C4-4210-B26A-7668214596CF}"/>
               </a:ext>
             </a:extLst>
           </p:cNvPr>
@@ -21124,7 +21217,7 @@
     </p:spTree>
     <p:extLst>
       <p:ext uri="{BB962C8B-B14F-4D97-AF65-F5344CB8AC3E}">
-        <p14:creationId xmlns:p14="http://schemas.microsoft.com/office/powerpoint/2010/main" val="14333221"/>
+        <p14:creationId xmlns:p14="http://schemas.microsoft.com/office/powerpoint/2010/main" val="939050489"/>
       </p:ext>
     </p:extLst>
   </p:cSld>
@@ -21155,7 +21248,7 @@
           <p:cNvPr id="1" name="eyebrow">
             <a:extLst xmlns:a="http://schemas.openxmlformats.org/drawingml/2006/main">
               <a:ext uri="{FF2B5EF4-FFF2-40B4-BE49-F238E27FC236}">
-                <a16:creationId xmlns:a16="http://schemas.microsoft.com/office/drawing/2014/main" id="{AB516E34-8D22-4412-BFD0-BF671A5F24F9}"/>
+                <a16:creationId xmlns:a16="http://schemas.microsoft.com/office/drawing/2014/main" id="{D85527DB-F819-443F-98A8-EB49661BEF65}"/>
               </a:ext>
             </a:extLst>
           </p:cNvPr>
@@ -21215,7 +21308,7 @@
           <p:cNvPr id="2" name="title">
             <a:extLst xmlns:a="http://schemas.openxmlformats.org/drawingml/2006/main">
               <a:ext uri="{FF2B5EF4-FFF2-40B4-BE49-F238E27FC236}">
-                <a16:creationId xmlns:a16="http://schemas.microsoft.com/office/drawing/2014/main" id="{C973FC55-C1F9-47A1-8247-2A856855ED66}"/>
+                <a16:creationId xmlns:a16="http://schemas.microsoft.com/office/drawing/2014/main" id="{49DBAE55-E7EE-4B34-A69A-059446375F4A}"/>
               </a:ext>
             </a:extLst>
           </p:cNvPr>
@@ -21275,7 +21368,7 @@
           <p:cNvPr id="3" name="footer">
             <a:extLst xmlns:a="http://schemas.openxmlformats.org/drawingml/2006/main">
               <a:ext uri="{FF2B5EF4-FFF2-40B4-BE49-F238E27FC236}">
-                <a16:creationId xmlns:a16="http://schemas.microsoft.com/office/drawing/2014/main" id="{17075C79-F164-40A4-A835-039ADFDCF341}"/>
+                <a16:creationId xmlns:a16="http://schemas.microsoft.com/office/drawing/2014/main" id="{B1ADC2F9-D4DE-4698-8F38-4FC163F8C1D2}"/>
               </a:ext>
             </a:extLst>
           </p:cNvPr>
@@ -21335,7 +21428,7 @@
           <p:cNvPr id="4" name="table-bg">
             <a:extLst xmlns:a="http://schemas.openxmlformats.org/drawingml/2006/main">
               <a:ext uri="{FF2B5EF4-FFF2-40B4-BE49-F238E27FC236}">
-                <a16:creationId xmlns:a16="http://schemas.microsoft.com/office/drawing/2014/main" id="{8D0C9900-5601-47AB-A8D0-96C8BDC7ECC3}"/>
+                <a16:creationId xmlns:a16="http://schemas.microsoft.com/office/drawing/2014/main" id="{8CE0AD70-0BDE-4A34-965A-7525928DF15A}"/>
               </a:ext>
             </a:extLst>
           </p:cNvPr>
@@ -21370,7 +21463,7 @@
           <p:cNvPr id="5" name="h-0">
             <a:extLst xmlns:a="http://schemas.openxmlformats.org/drawingml/2006/main">
               <a:ext uri="{FF2B5EF4-FFF2-40B4-BE49-F238E27FC236}">
-                <a16:creationId xmlns:a16="http://schemas.microsoft.com/office/drawing/2014/main" id="{7C5A40EA-E629-4644-AB13-029DEE0EEF91}"/>
+                <a16:creationId xmlns:a16="http://schemas.microsoft.com/office/drawing/2014/main" id="{447D0BFC-D020-468D-A44E-8EC4470BABEE}"/>
               </a:ext>
             </a:extLst>
           </p:cNvPr>
@@ -21430,7 +21523,7 @@
           <p:cNvPr id="6" name="h-1">
             <a:extLst xmlns:a="http://schemas.openxmlformats.org/drawingml/2006/main">
               <a:ext uri="{FF2B5EF4-FFF2-40B4-BE49-F238E27FC236}">
-                <a16:creationId xmlns:a16="http://schemas.microsoft.com/office/drawing/2014/main" id="{25DCBB29-17C0-491D-8338-F46F6D3E0DD7}"/>
+                <a16:creationId xmlns:a16="http://schemas.microsoft.com/office/drawing/2014/main" id="{78954732-4245-430E-B57B-58303A9D50DA}"/>
               </a:ext>
             </a:extLst>
           </p:cNvPr>
@@ -21490,7 +21583,7 @@
           <p:cNvPr id="7" name="h-2">
             <a:extLst xmlns:a="http://schemas.openxmlformats.org/drawingml/2006/main">
               <a:ext uri="{FF2B5EF4-FFF2-40B4-BE49-F238E27FC236}">
-                <a16:creationId xmlns:a16="http://schemas.microsoft.com/office/drawing/2014/main" id="{197431D9-EDF1-4D07-B534-DEA62598EF67}"/>
+                <a16:creationId xmlns:a16="http://schemas.microsoft.com/office/drawing/2014/main" id="{1F8EAB54-8BCD-45AC-BBE7-D1B79D3E7AB4}"/>
               </a:ext>
             </a:extLst>
           </p:cNvPr>
@@ -21550,7 +21643,7 @@
           <p:cNvPr id="8" name="step-0">
             <a:extLst xmlns:a="http://schemas.openxmlformats.org/drawingml/2006/main">
               <a:ext uri="{FF2B5EF4-FFF2-40B4-BE49-F238E27FC236}">
-                <a16:creationId xmlns:a16="http://schemas.microsoft.com/office/drawing/2014/main" id="{7EDEA2B6-CDD0-42F8-836F-21A48396597D}"/>
+                <a16:creationId xmlns:a16="http://schemas.microsoft.com/office/drawing/2014/main" id="{B5B177B0-E1F2-4E4E-9612-4E295DC85015}"/>
               </a:ext>
             </a:extLst>
           </p:cNvPr>
@@ -21610,7 +21703,7 @@
           <p:cNvPr id="9" name="artifact-0">
             <a:extLst xmlns:a="http://schemas.openxmlformats.org/drawingml/2006/main">
               <a:ext uri="{FF2B5EF4-FFF2-40B4-BE49-F238E27FC236}">
-                <a16:creationId xmlns:a16="http://schemas.microsoft.com/office/drawing/2014/main" id="{8BB32931-60DD-433B-AEC4-C3422D136A4D}"/>
+                <a16:creationId xmlns:a16="http://schemas.microsoft.com/office/drawing/2014/main" id="{4A1616F5-A3CD-476C-8B3A-E65DCD3E05ED}"/>
               </a:ext>
             </a:extLst>
           </p:cNvPr>
@@ -21670,7 +21763,7 @@
           <p:cNvPr id="10" name="why-0">
             <a:extLst xmlns:a="http://schemas.openxmlformats.org/drawingml/2006/main">
               <a:ext uri="{FF2B5EF4-FFF2-40B4-BE49-F238E27FC236}">
-                <a16:creationId xmlns:a16="http://schemas.microsoft.com/office/drawing/2014/main" id="{AFE08EB7-EAD8-4631-BEE8-6887318FDDD1}"/>
+                <a16:creationId xmlns:a16="http://schemas.microsoft.com/office/drawing/2014/main" id="{05E79E11-88CB-4C96-B531-1BA7069D3833}"/>
               </a:ext>
             </a:extLst>
           </p:cNvPr>
@@ -21730,7 +21823,7 @@
           <p:cNvPr id="11" name="row-0">
             <a:extLst xmlns:a="http://schemas.openxmlformats.org/drawingml/2006/main">
               <a:ext uri="{FF2B5EF4-FFF2-40B4-BE49-F238E27FC236}">
-                <a16:creationId xmlns:a16="http://schemas.microsoft.com/office/drawing/2014/main" id="{10046DFB-4A93-4EDC-AA7D-E334D4FDE62A}"/>
+                <a16:creationId xmlns:a16="http://schemas.microsoft.com/office/drawing/2014/main" id="{25E48FC3-5BC5-465F-BB22-F37D9C711AEE}"/>
               </a:ext>
             </a:extLst>
           </p:cNvPr>
@@ -21761,7 +21854,7 @@
           <p:cNvPr id="12" name="step-1">
             <a:extLst xmlns:a="http://schemas.openxmlformats.org/drawingml/2006/main">
               <a:ext uri="{FF2B5EF4-FFF2-40B4-BE49-F238E27FC236}">
-                <a16:creationId xmlns:a16="http://schemas.microsoft.com/office/drawing/2014/main" id="{C4D7388C-E045-4E12-B492-7893934C7CF3}"/>
+                <a16:creationId xmlns:a16="http://schemas.microsoft.com/office/drawing/2014/main" id="{94233872-F412-4D93-90B9-4D8D0A09EEAA}"/>
               </a:ext>
             </a:extLst>
           </p:cNvPr>
@@ -21821,7 +21914,7 @@
           <p:cNvPr id="13" name="artifact-1">
             <a:extLst xmlns:a="http://schemas.openxmlformats.org/drawingml/2006/main">
               <a:ext uri="{FF2B5EF4-FFF2-40B4-BE49-F238E27FC236}">
-                <a16:creationId xmlns:a16="http://schemas.microsoft.com/office/drawing/2014/main" id="{948EA286-C355-427E-A4D0-D094E86F23AC}"/>
+                <a16:creationId xmlns:a16="http://schemas.microsoft.com/office/drawing/2014/main" id="{9196EFAE-EF4C-4177-9F4C-C5747B456857}"/>
               </a:ext>
             </a:extLst>
           </p:cNvPr>
@@ -21881,7 +21974,7 @@
           <p:cNvPr id="14" name="why-1">
             <a:extLst xmlns:a="http://schemas.openxmlformats.org/drawingml/2006/main">
               <a:ext uri="{FF2B5EF4-FFF2-40B4-BE49-F238E27FC236}">
-                <a16:creationId xmlns:a16="http://schemas.microsoft.com/office/drawing/2014/main" id="{26758E52-458B-4406-AB49-57D72C5E2857}"/>
+                <a16:creationId xmlns:a16="http://schemas.microsoft.com/office/drawing/2014/main" id="{CF3A469B-1E70-4EE8-91EE-89B8CF9E7503}"/>
               </a:ext>
             </a:extLst>
           </p:cNvPr>
@@ -21941,7 +22034,7 @@
           <p:cNvPr id="15" name="row-1">
             <a:extLst xmlns:a="http://schemas.openxmlformats.org/drawingml/2006/main">
               <a:ext uri="{FF2B5EF4-FFF2-40B4-BE49-F238E27FC236}">
-                <a16:creationId xmlns:a16="http://schemas.microsoft.com/office/drawing/2014/main" id="{657A799F-E259-4563-A7E7-43F985C526B8}"/>
+                <a16:creationId xmlns:a16="http://schemas.microsoft.com/office/drawing/2014/main" id="{2AAC461D-03CF-4603-9885-1EF7E3727205}"/>
               </a:ext>
             </a:extLst>
           </p:cNvPr>
@@ -21972,7 +22065,7 @@
           <p:cNvPr id="16" name="step-2">
             <a:extLst xmlns:a="http://schemas.openxmlformats.org/drawingml/2006/main">
               <a:ext uri="{FF2B5EF4-FFF2-40B4-BE49-F238E27FC236}">
-                <a16:creationId xmlns:a16="http://schemas.microsoft.com/office/drawing/2014/main" id="{7D1859C0-AFA5-4319-9DBA-4E61611778CA}"/>
+                <a16:creationId xmlns:a16="http://schemas.microsoft.com/office/drawing/2014/main" id="{5084A578-18F2-4897-B122-6ED4EDB2D51C}"/>
               </a:ext>
             </a:extLst>
           </p:cNvPr>
@@ -22032,7 +22125,7 @@
           <p:cNvPr id="17" name="artifact-2">
             <a:extLst xmlns:a="http://schemas.openxmlformats.org/drawingml/2006/main">
               <a:ext uri="{FF2B5EF4-FFF2-40B4-BE49-F238E27FC236}">
-                <a16:creationId xmlns:a16="http://schemas.microsoft.com/office/drawing/2014/main" id="{71C8A579-B55D-4AD1-A01C-5371A9880159}"/>
+                <a16:creationId xmlns:a16="http://schemas.microsoft.com/office/drawing/2014/main" id="{39F1F849-DE4B-4046-AB98-285DCF1FA93B}"/>
               </a:ext>
             </a:extLst>
           </p:cNvPr>
@@ -22092,7 +22185,7 @@
           <p:cNvPr id="18" name="why-2">
             <a:extLst xmlns:a="http://schemas.openxmlformats.org/drawingml/2006/main">
               <a:ext uri="{FF2B5EF4-FFF2-40B4-BE49-F238E27FC236}">
-                <a16:creationId xmlns:a16="http://schemas.microsoft.com/office/drawing/2014/main" id="{BADF91DB-67FF-4044-842A-C3B089646FCB}"/>
+                <a16:creationId xmlns:a16="http://schemas.microsoft.com/office/drawing/2014/main" id="{14B72D76-1566-4ABA-BAAB-35DA7EBB6944}"/>
               </a:ext>
             </a:extLst>
           </p:cNvPr>
@@ -22152,7 +22245,7 @@
           <p:cNvPr id="19" name="row-2">
             <a:extLst xmlns:a="http://schemas.openxmlformats.org/drawingml/2006/main">
               <a:ext uri="{FF2B5EF4-FFF2-40B4-BE49-F238E27FC236}">
-                <a16:creationId xmlns:a16="http://schemas.microsoft.com/office/drawing/2014/main" id="{EC139FCD-0033-4533-9460-97EDDC78D8D3}"/>
+                <a16:creationId xmlns:a16="http://schemas.microsoft.com/office/drawing/2014/main" id="{C7809C99-0D12-4CD5-AD94-E6D1F7B952E1}"/>
               </a:ext>
             </a:extLst>
           </p:cNvPr>
@@ -22183,7 +22276,7 @@
           <p:cNvPr id="20" name="step-3">
             <a:extLst xmlns:a="http://schemas.openxmlformats.org/drawingml/2006/main">
               <a:ext uri="{FF2B5EF4-FFF2-40B4-BE49-F238E27FC236}">
-                <a16:creationId xmlns:a16="http://schemas.microsoft.com/office/drawing/2014/main" id="{2DABCEF2-EEE8-4461-BE86-3188F8EF8666}"/>
+                <a16:creationId xmlns:a16="http://schemas.microsoft.com/office/drawing/2014/main" id="{86D7D7A4-00E7-4F96-8CCA-6CE322524E3F}"/>
               </a:ext>
             </a:extLst>
           </p:cNvPr>
@@ -22243,7 +22336,7 @@
           <p:cNvPr id="21" name="artifact-3">
             <a:extLst xmlns:a="http://schemas.openxmlformats.org/drawingml/2006/main">
               <a:ext uri="{FF2B5EF4-FFF2-40B4-BE49-F238E27FC236}">
-                <a16:creationId xmlns:a16="http://schemas.microsoft.com/office/drawing/2014/main" id="{288413A9-EF90-4AD8-9570-3F8FE4C64878}"/>
+                <a16:creationId xmlns:a16="http://schemas.microsoft.com/office/drawing/2014/main" id="{B597E53E-995B-47D4-9694-152660586E43}"/>
               </a:ext>
             </a:extLst>
           </p:cNvPr>
@@ -22303,7 +22396,7 @@
           <p:cNvPr id="22" name="why-3">
             <a:extLst xmlns:a="http://schemas.openxmlformats.org/drawingml/2006/main">
               <a:ext uri="{FF2B5EF4-FFF2-40B4-BE49-F238E27FC236}">
-                <a16:creationId xmlns:a16="http://schemas.microsoft.com/office/drawing/2014/main" id="{DE00E0B0-F50A-451E-BE42-6450CF987D3A}"/>
+                <a16:creationId xmlns:a16="http://schemas.microsoft.com/office/drawing/2014/main" id="{E6E128D1-D0C6-4948-8F95-930CEBF2EFD3}"/>
               </a:ext>
             </a:extLst>
           </p:cNvPr>
@@ -22363,7 +22456,7 @@
           <p:cNvPr id="23" name="row-3">
             <a:extLst xmlns:a="http://schemas.openxmlformats.org/drawingml/2006/main">
               <a:ext uri="{FF2B5EF4-FFF2-40B4-BE49-F238E27FC236}">
-                <a16:creationId xmlns:a16="http://schemas.microsoft.com/office/drawing/2014/main" id="{D9834D42-9874-4BF3-A0BA-A6F6CC9B39FA}"/>
+                <a16:creationId xmlns:a16="http://schemas.microsoft.com/office/drawing/2014/main" id="{7730F553-671B-4928-8BD6-832F461D7CFB}"/>
               </a:ext>
             </a:extLst>
           </p:cNvPr>
@@ -22394,7 +22487,7 @@
           <p:cNvPr id="24" name="step-4">
             <a:extLst xmlns:a="http://schemas.openxmlformats.org/drawingml/2006/main">
               <a:ext uri="{FF2B5EF4-FFF2-40B4-BE49-F238E27FC236}">
-                <a16:creationId xmlns:a16="http://schemas.microsoft.com/office/drawing/2014/main" id="{5A1836B8-4E48-4284-8BF4-6469C96629B3}"/>
+                <a16:creationId xmlns:a16="http://schemas.microsoft.com/office/drawing/2014/main" id="{ED63CD5B-28AA-4FD8-85A3-C0148656D63D}"/>
               </a:ext>
             </a:extLst>
           </p:cNvPr>
@@ -22454,7 +22547,7 @@
           <p:cNvPr id="25" name="artifact-4">
             <a:extLst xmlns:a="http://schemas.openxmlformats.org/drawingml/2006/main">
               <a:ext uri="{FF2B5EF4-FFF2-40B4-BE49-F238E27FC236}">
-                <a16:creationId xmlns:a16="http://schemas.microsoft.com/office/drawing/2014/main" id="{0A394824-C02B-4561-932E-0EFB27251A57}"/>
+                <a16:creationId xmlns:a16="http://schemas.microsoft.com/office/drawing/2014/main" id="{51DF6567-774A-4E57-BA9B-5B586B802F7F}"/>
               </a:ext>
             </a:extLst>
           </p:cNvPr>
@@ -22514,7 +22607,7 @@
           <p:cNvPr id="26" name="why-4">
             <a:extLst xmlns:a="http://schemas.openxmlformats.org/drawingml/2006/main">
               <a:ext uri="{FF2B5EF4-FFF2-40B4-BE49-F238E27FC236}">
-                <a16:creationId xmlns:a16="http://schemas.microsoft.com/office/drawing/2014/main" id="{2BEA1100-11CE-4493-8B73-17A9A57A3C5B}"/>
+                <a16:creationId xmlns:a16="http://schemas.microsoft.com/office/drawing/2014/main" id="{409A3CEB-0442-4124-A45D-AEA987AB073B}"/>
               </a:ext>
             </a:extLst>
           </p:cNvPr>
@@ -22574,7 +22667,7 @@
           <p:cNvPr id="27" name="row-4">
             <a:extLst xmlns:a="http://schemas.openxmlformats.org/drawingml/2006/main">
               <a:ext uri="{FF2B5EF4-FFF2-40B4-BE49-F238E27FC236}">
-                <a16:creationId xmlns:a16="http://schemas.microsoft.com/office/drawing/2014/main" id="{676498C5-2196-464B-B533-DE2BB1324342}"/>
+                <a16:creationId xmlns:a16="http://schemas.microsoft.com/office/drawing/2014/main" id="{71B9A8BD-A347-43CC-A8DD-9FD69D7F2113}"/>
               </a:ext>
             </a:extLst>
           </p:cNvPr>
@@ -22605,7 +22698,7 @@
           <p:cNvPr id="28" name="bottom">
             <a:extLst xmlns:a="http://schemas.openxmlformats.org/drawingml/2006/main">
               <a:ext uri="{FF2B5EF4-FFF2-40B4-BE49-F238E27FC236}">
-                <a16:creationId xmlns:a16="http://schemas.microsoft.com/office/drawing/2014/main" id="{446CF13C-6A86-43E1-91CD-DEB2384B3F80}"/>
+                <a16:creationId xmlns:a16="http://schemas.microsoft.com/office/drawing/2014/main" id="{8125B469-A82C-44BA-894F-2E0C043C266B}"/>
               </a:ext>
             </a:extLst>
           </p:cNvPr>
@@ -22663,7 +22756,7 @@
     </p:spTree>
     <p:extLst>
       <p:ext uri="{BB962C8B-B14F-4D97-AF65-F5344CB8AC3E}">
-        <p14:creationId xmlns:p14="http://schemas.microsoft.com/office/powerpoint/2010/main" val="1827080438"/>
+        <p14:creationId xmlns:p14="http://schemas.microsoft.com/office/powerpoint/2010/main" val="995860625"/>
       </p:ext>
     </p:extLst>
   </p:cSld>

</xml_diff>

<commit_message>
Fix lesson 02 closing slide connectors
</commit_message>
<xml_diff>
--- a/slides/lesson-02-ai-agents-vibe-coding-desktop-utilities.pptx
+++ b/slides/lesson-02-ai-agents-vibe-coding-desktop-utilities.pptx
@@ -2,34 +2,34 @@
 <file path=ppt/presentation.xml><?xml version="1.0" encoding="utf-8"?>
 <p:presentation xmlns:p="http://schemas.openxmlformats.org/presentationml/2006/main">
   <p:sldMasterIdLst>
-    <p:sldMasterId xmlns:r="http://schemas.openxmlformats.org/officeDocument/2006/relationships" id="2147483648" r:id="Rc40625c1391e42e7"/>
+    <p:sldMasterId xmlns:r="http://schemas.openxmlformats.org/officeDocument/2006/relationships" id="2147483648" r:id="Rd1feef99b8b3495b"/>
   </p:sldMasterIdLst>
   <p:notesMasterIdLst>
-    <p:notesMasterId xmlns:r="http://schemas.openxmlformats.org/officeDocument/2006/relationships" r:id="R96e603a7627c40ef"/>
+    <p:notesMasterId xmlns:r="http://schemas.openxmlformats.org/officeDocument/2006/relationships" r:id="R6ea0fac1500c45cb"/>
   </p:notesMasterIdLst>
   <p:sldIdLst>
-    <p:sldId xmlns:r="http://schemas.openxmlformats.org/officeDocument/2006/relationships" id="256" r:id="R6fe94ca6608046d9"/>
-    <p:sldId xmlns:r="http://schemas.openxmlformats.org/officeDocument/2006/relationships" id="257" r:id="Ra8dea8b2cc264b15"/>
-    <p:sldId xmlns:r="http://schemas.openxmlformats.org/officeDocument/2006/relationships" id="258" r:id="R66305664b7d341d8"/>
-    <p:sldId xmlns:r="http://schemas.openxmlformats.org/officeDocument/2006/relationships" id="259" r:id="R62e20b0d095141ca"/>
-    <p:sldId xmlns:r="http://schemas.openxmlformats.org/officeDocument/2006/relationships" id="260" r:id="Rde36b2c6729144e3"/>
-    <p:sldId xmlns:r="http://schemas.openxmlformats.org/officeDocument/2006/relationships" id="261" r:id="Rc0ecde53986746b9"/>
-    <p:sldId xmlns:r="http://schemas.openxmlformats.org/officeDocument/2006/relationships" id="262" r:id="R9444eb00476149c0"/>
-    <p:sldId xmlns:r="http://schemas.openxmlformats.org/officeDocument/2006/relationships" id="263" r:id="R535cfee5af6a47ae"/>
-    <p:sldId xmlns:r="http://schemas.openxmlformats.org/officeDocument/2006/relationships" id="264" r:id="R495ad4c8b4344998"/>
-    <p:sldId xmlns:r="http://schemas.openxmlformats.org/officeDocument/2006/relationships" id="265" r:id="Rdb90f5bffbca4ebf"/>
-    <p:sldId xmlns:r="http://schemas.openxmlformats.org/officeDocument/2006/relationships" id="266" r:id="R4493aca7796a453c"/>
-    <p:sldId xmlns:r="http://schemas.openxmlformats.org/officeDocument/2006/relationships" id="267" r:id="Rbc4d683aaef14dd9"/>
-    <p:sldId xmlns:r="http://schemas.openxmlformats.org/officeDocument/2006/relationships" id="268" r:id="R75cb5ab3dc8649aa"/>
-    <p:sldId xmlns:r="http://schemas.openxmlformats.org/officeDocument/2006/relationships" id="269" r:id="R5e1b655965cd4afa"/>
-    <p:sldId xmlns:r="http://schemas.openxmlformats.org/officeDocument/2006/relationships" id="270" r:id="R87e8daa973034c83"/>
-    <p:sldId xmlns:r="http://schemas.openxmlformats.org/officeDocument/2006/relationships" id="271" r:id="R9d7d01e32b4e4837"/>
-    <p:sldId xmlns:r="http://schemas.openxmlformats.org/officeDocument/2006/relationships" id="272" r:id="R0ac4adc914a64dc6"/>
-    <p:sldId xmlns:r="http://schemas.openxmlformats.org/officeDocument/2006/relationships" id="273" r:id="R86e235f0e8c84d92"/>
-    <p:sldId xmlns:r="http://schemas.openxmlformats.org/officeDocument/2006/relationships" id="274" r:id="Rb5f549b1fc0945b4"/>
-    <p:sldId xmlns:r="http://schemas.openxmlformats.org/officeDocument/2006/relationships" id="275" r:id="R01a0eb4ea93a44d2"/>
-    <p:sldId xmlns:r="http://schemas.openxmlformats.org/officeDocument/2006/relationships" id="276" r:id="R729d09ef7da84ae7"/>
-    <p:sldId xmlns:r="http://schemas.openxmlformats.org/officeDocument/2006/relationships" id="277" r:id="R880e8f4025764691"/>
+    <p:sldId xmlns:r="http://schemas.openxmlformats.org/officeDocument/2006/relationships" id="256" r:id="Rcf5a36c7146b4bef"/>
+    <p:sldId xmlns:r="http://schemas.openxmlformats.org/officeDocument/2006/relationships" id="257" r:id="R8df1c6e2e9834372"/>
+    <p:sldId xmlns:r="http://schemas.openxmlformats.org/officeDocument/2006/relationships" id="258" r:id="R70369e39f58f4608"/>
+    <p:sldId xmlns:r="http://schemas.openxmlformats.org/officeDocument/2006/relationships" id="259" r:id="R0a1e9b36d3754a76"/>
+    <p:sldId xmlns:r="http://schemas.openxmlformats.org/officeDocument/2006/relationships" id="260" r:id="R27dd8e4f3c3541f4"/>
+    <p:sldId xmlns:r="http://schemas.openxmlformats.org/officeDocument/2006/relationships" id="261" r:id="R7a426cf366b648c6"/>
+    <p:sldId xmlns:r="http://schemas.openxmlformats.org/officeDocument/2006/relationships" id="262" r:id="Re6946d27b0bf49a0"/>
+    <p:sldId xmlns:r="http://schemas.openxmlformats.org/officeDocument/2006/relationships" id="263" r:id="R42f078fda1cb4772"/>
+    <p:sldId xmlns:r="http://schemas.openxmlformats.org/officeDocument/2006/relationships" id="264" r:id="Rd2660a17b8544882"/>
+    <p:sldId xmlns:r="http://schemas.openxmlformats.org/officeDocument/2006/relationships" id="265" r:id="R7af09d9bda2f4fac"/>
+    <p:sldId xmlns:r="http://schemas.openxmlformats.org/officeDocument/2006/relationships" id="266" r:id="R5fdcffc82ca64d36"/>
+    <p:sldId xmlns:r="http://schemas.openxmlformats.org/officeDocument/2006/relationships" id="267" r:id="R7c6b89b6205647ac"/>
+    <p:sldId xmlns:r="http://schemas.openxmlformats.org/officeDocument/2006/relationships" id="268" r:id="R402a32bf7fc647bc"/>
+    <p:sldId xmlns:r="http://schemas.openxmlformats.org/officeDocument/2006/relationships" id="269" r:id="R30ec2552250b4d14"/>
+    <p:sldId xmlns:r="http://schemas.openxmlformats.org/officeDocument/2006/relationships" id="270" r:id="Rb59c017ed3b84830"/>
+    <p:sldId xmlns:r="http://schemas.openxmlformats.org/officeDocument/2006/relationships" id="271" r:id="Rca5482a2abf541b8"/>
+    <p:sldId xmlns:r="http://schemas.openxmlformats.org/officeDocument/2006/relationships" id="272" r:id="R6dfae8bba3ef49ee"/>
+    <p:sldId xmlns:r="http://schemas.openxmlformats.org/officeDocument/2006/relationships" id="273" r:id="R3542f3a365fc44f0"/>
+    <p:sldId xmlns:r="http://schemas.openxmlformats.org/officeDocument/2006/relationships" id="274" r:id="Rd4a5d3b85afc43c5"/>
+    <p:sldId xmlns:r="http://schemas.openxmlformats.org/officeDocument/2006/relationships" id="275" r:id="R1321dc4d19964c9d"/>
+    <p:sldId xmlns:r="http://schemas.openxmlformats.org/officeDocument/2006/relationships" id="276" r:id="Raeeb122a51de4b67"/>
+    <p:sldId xmlns:r="http://schemas.openxmlformats.org/officeDocument/2006/relationships" id="277" r:id="Rbf60811c1a7a4ae4"/>
   </p:sldIdLst>
   <p:sldSz cx="12192000" cy="6858000"/>
   <p:notesSz cx="6858000" cy="9144000"/>
@@ -2096,7 +2096,7 @@
   </p:cSld>
   <p:clrMap bg1="lt1" tx1="dk1" bg2="lt2" tx2="dk2" accent1="accent1" accent2="accent2" accent3="accent3" accent4="accent4" accent5="accent5" accent6="accent6" hlink="hlink" folHlink="folHlink"/>
   <p:sldLayoutIdLst>
-    <p:sldLayoutId xmlns:r="http://schemas.openxmlformats.org/officeDocument/2006/relationships" id="2147483649" r:id="Rc10ee2b0f8ba402d"/>
+    <p:sldLayoutId xmlns:r="http://schemas.openxmlformats.org/officeDocument/2006/relationships" id="2147483649" r:id="R42783488126f44e5"/>
   </p:sldLayoutIdLst>
   <p:txStyles>
     <p:titleStyle>
@@ -2647,7 +2647,7 @@
           <p:cNvPr id="1" name="eyebrow">
             <a:extLst xmlns:a="http://schemas.openxmlformats.org/drawingml/2006/main">
               <a:ext uri="{FF2B5EF4-FFF2-40B4-BE49-F238E27FC236}">
-                <a16:creationId xmlns:a16="http://schemas.microsoft.com/office/drawing/2014/main" id="{E6CD0B27-9A97-4406-9412-56C23CBC38D8}"/>
+                <a16:creationId xmlns:a16="http://schemas.microsoft.com/office/drawing/2014/main" id="{AF0A94B0-72C6-4C90-9A1E-23EA2E35A288}"/>
               </a:ext>
             </a:extLst>
           </p:cNvPr>
@@ -2707,7 +2707,7 @@
           <p:cNvPr id="2" name="lesson-title">
             <a:extLst xmlns:a="http://schemas.openxmlformats.org/drawingml/2006/main">
               <a:ext uri="{FF2B5EF4-FFF2-40B4-BE49-F238E27FC236}">
-                <a16:creationId xmlns:a16="http://schemas.microsoft.com/office/drawing/2014/main" id="{5FF59800-3E94-464F-8430-6AC750C6C093}"/>
+                <a16:creationId xmlns:a16="http://schemas.microsoft.com/office/drawing/2014/main" id="{59A3137D-2E1C-4981-98B3-81E57682F82B}"/>
               </a:ext>
             </a:extLst>
           </p:cNvPr>
@@ -2767,7 +2767,7 @@
           <p:cNvPr id="3" name="subtitle">
             <a:extLst xmlns:a="http://schemas.openxmlformats.org/drawingml/2006/main">
               <a:ext uri="{FF2B5EF4-FFF2-40B4-BE49-F238E27FC236}">
-                <a16:creationId xmlns:a16="http://schemas.microsoft.com/office/drawing/2014/main" id="{D7EE0F89-A192-4B85-BA10-AB2900880C26}"/>
+                <a16:creationId xmlns:a16="http://schemas.microsoft.com/office/drawing/2014/main" id="{657DD617-E3BA-43E2-B102-A7A9B1DDDC4A}"/>
               </a:ext>
             </a:extLst>
           </p:cNvPr>
@@ -2827,7 +2827,7 @@
           <p:cNvPr id="4" name="questions">
             <a:extLst xmlns:a="http://schemas.openxmlformats.org/drawingml/2006/main">
               <a:ext uri="{FF2B5EF4-FFF2-40B4-BE49-F238E27FC236}">
-                <a16:creationId xmlns:a16="http://schemas.microsoft.com/office/drawing/2014/main" id="{CC153C49-0315-4D2D-8427-6EC269DBA10D}"/>
+                <a16:creationId xmlns:a16="http://schemas.microsoft.com/office/drawing/2014/main" id="{97D0F77A-DFF9-471D-A73D-CA0C8DF0015E}"/>
               </a:ext>
             </a:extLst>
           </p:cNvPr>
@@ -2950,7 +2950,7 @@
           <p:cNvPr id="5" name="flow-line-1">
             <a:extLst xmlns:a="http://schemas.openxmlformats.org/drawingml/2006/main">
               <a:ext uri="{FF2B5EF4-FFF2-40B4-BE49-F238E27FC236}">
-                <a16:creationId xmlns:a16="http://schemas.microsoft.com/office/drawing/2014/main" id="{BC56240F-F2CC-42CD-8041-788EE8FC0281}"/>
+                <a16:creationId xmlns:a16="http://schemas.microsoft.com/office/drawing/2014/main" id="{99EBC20C-A9E2-4BD5-A022-8C357F18EF2E}"/>
               </a:ext>
             </a:extLst>
           </p:cNvPr>
@@ -2981,7 +2981,7 @@
           <p:cNvPr id="6" name="flow-line-2">
             <a:extLst xmlns:a="http://schemas.openxmlformats.org/drawingml/2006/main">
               <a:ext uri="{FF2B5EF4-FFF2-40B4-BE49-F238E27FC236}">
-                <a16:creationId xmlns:a16="http://schemas.microsoft.com/office/drawing/2014/main" id="{503C6C34-C508-4F51-B0F2-F16765A60C9A}"/>
+                <a16:creationId xmlns:a16="http://schemas.microsoft.com/office/drawing/2014/main" id="{AB1FE1DB-5B03-4678-B5D6-1A5D8088BA9E}"/>
               </a:ext>
             </a:extLst>
           </p:cNvPr>
@@ -3012,7 +3012,7 @@
           <p:cNvPr id="7" name="flow-line-3">
             <a:extLst xmlns:a="http://schemas.openxmlformats.org/drawingml/2006/main">
               <a:ext uri="{FF2B5EF4-FFF2-40B4-BE49-F238E27FC236}">
-                <a16:creationId xmlns:a16="http://schemas.microsoft.com/office/drawing/2014/main" id="{04471D85-53EE-4FF4-AA14-438272FA7BC2}"/>
+                <a16:creationId xmlns:a16="http://schemas.microsoft.com/office/drawing/2014/main" id="{5FE3896D-A749-47AD-B330-B2C9E6C4FC29}"/>
               </a:ext>
             </a:extLst>
           </p:cNvPr>
@@ -3043,7 +3043,7 @@
           <p:cNvPr id="8" name="ask">
             <a:extLst xmlns:a="http://schemas.openxmlformats.org/drawingml/2006/main">
               <a:ext uri="{FF2B5EF4-FFF2-40B4-BE49-F238E27FC236}">
-                <a16:creationId xmlns:a16="http://schemas.microsoft.com/office/drawing/2014/main" id="{5095C1D5-58CE-4EE4-9A7E-0926F15800A2}"/>
+                <a16:creationId xmlns:a16="http://schemas.microsoft.com/office/drawing/2014/main" id="{888D7A40-E646-4ADA-8DF7-A919F060C159}"/>
               </a:ext>
             </a:extLst>
           </p:cNvPr>
@@ -3109,7 +3109,7 @@
           <p:cNvPr id="9" name="plan">
             <a:extLst xmlns:a="http://schemas.openxmlformats.org/drawingml/2006/main">
               <a:ext uri="{FF2B5EF4-FFF2-40B4-BE49-F238E27FC236}">
-                <a16:creationId xmlns:a16="http://schemas.microsoft.com/office/drawing/2014/main" id="{8C74B0B1-DFD3-42F8-80AA-A5C8E2A0D14E}"/>
+                <a16:creationId xmlns:a16="http://schemas.microsoft.com/office/drawing/2014/main" id="{1E24A8A7-963C-48B1-A17D-9E9042C6769B}"/>
               </a:ext>
             </a:extLst>
           </p:cNvPr>
@@ -3175,7 +3175,7 @@
           <p:cNvPr id="10" name="tools">
             <a:extLst xmlns:a="http://schemas.openxmlformats.org/drawingml/2006/main">
               <a:ext uri="{FF2B5EF4-FFF2-40B4-BE49-F238E27FC236}">
-                <a16:creationId xmlns:a16="http://schemas.microsoft.com/office/drawing/2014/main" id="{68656B1C-0792-4D26-B49F-ACB983EF5672}"/>
+                <a16:creationId xmlns:a16="http://schemas.microsoft.com/office/drawing/2014/main" id="{A0EECB1E-E33D-45CD-8FFD-634612356B81}"/>
               </a:ext>
             </a:extLst>
           </p:cNvPr>
@@ -3241,7 +3241,7 @@
           <p:cNvPr id="11" name="verify">
             <a:extLst xmlns:a="http://schemas.openxmlformats.org/drawingml/2006/main">
               <a:ext uri="{FF2B5EF4-FFF2-40B4-BE49-F238E27FC236}">
-                <a16:creationId xmlns:a16="http://schemas.microsoft.com/office/drawing/2014/main" id="{01EC88B9-E561-4E35-956B-ED80D500B7E5}"/>
+                <a16:creationId xmlns:a16="http://schemas.microsoft.com/office/drawing/2014/main" id="{237C0D67-9F90-4937-9FF3-E1FC241A5B7D}"/>
               </a:ext>
             </a:extLst>
           </p:cNvPr>
@@ -3307,7 +3307,7 @@
           <p:cNvPr id="12" name="deliver">
             <a:extLst xmlns:a="http://schemas.openxmlformats.org/drawingml/2006/main">
               <a:ext uri="{FF2B5EF4-FFF2-40B4-BE49-F238E27FC236}">
-                <a16:creationId xmlns:a16="http://schemas.microsoft.com/office/drawing/2014/main" id="{85D52CDD-1AFC-49E5-9BE8-289C6A06BC36}"/>
+                <a16:creationId xmlns:a16="http://schemas.microsoft.com/office/drawing/2014/main" id="{CB826884-C55D-469B-A54B-F82CA31E1A5A}"/>
               </a:ext>
             </a:extLst>
           </p:cNvPr>
@@ -3373,7 +3373,7 @@
           <p:cNvPr id="13" name="right-note">
             <a:extLst xmlns:a="http://schemas.openxmlformats.org/drawingml/2006/main">
               <a:ext uri="{FF2B5EF4-FFF2-40B4-BE49-F238E27FC236}">
-                <a16:creationId xmlns:a16="http://schemas.microsoft.com/office/drawing/2014/main" id="{BB615A11-764F-4BBC-94E1-2C0BD380BB52}"/>
+                <a16:creationId xmlns:a16="http://schemas.microsoft.com/office/drawing/2014/main" id="{D08A443B-0CE8-4286-95D8-F61B818D9488}"/>
               </a:ext>
             </a:extLst>
           </p:cNvPr>
@@ -3433,7 +3433,7 @@
           <p:cNvPr id="14" name="footer">
             <a:extLst xmlns:a="http://schemas.openxmlformats.org/drawingml/2006/main">
               <a:ext uri="{FF2B5EF4-FFF2-40B4-BE49-F238E27FC236}">
-                <a16:creationId xmlns:a16="http://schemas.microsoft.com/office/drawing/2014/main" id="{4E24B76B-E168-46F6-9D26-A9E84BDA3BCC}"/>
+                <a16:creationId xmlns:a16="http://schemas.microsoft.com/office/drawing/2014/main" id="{22626DAF-2D5B-405C-A2F5-0A9670C8551E}"/>
               </a:ext>
             </a:extLst>
           </p:cNvPr>
@@ -3491,7 +3491,7 @@
     </p:spTree>
     <p:extLst>
       <p:ext uri="{BB962C8B-B14F-4D97-AF65-F5344CB8AC3E}">
-        <p14:creationId xmlns:p14="http://schemas.microsoft.com/office/powerpoint/2010/main" val="1611100231"/>
+        <p14:creationId xmlns:p14="http://schemas.microsoft.com/office/powerpoint/2010/main" val="1243056442"/>
       </p:ext>
     </p:extLst>
   </p:cSld>
@@ -3522,7 +3522,7 @@
           <p:cNvPr id="1" name="eyebrow">
             <a:extLst xmlns:a="http://schemas.openxmlformats.org/drawingml/2006/main">
               <a:ext uri="{FF2B5EF4-FFF2-40B4-BE49-F238E27FC236}">
-                <a16:creationId xmlns:a16="http://schemas.microsoft.com/office/drawing/2014/main" id="{4C661E81-6301-4EB6-A2E0-2FEEF1E3ABB3}"/>
+                <a16:creationId xmlns:a16="http://schemas.microsoft.com/office/drawing/2014/main" id="{25587BFB-3299-4A00-99BC-9D6B6C44B723}"/>
               </a:ext>
             </a:extLst>
           </p:cNvPr>
@@ -3582,7 +3582,7 @@
           <p:cNvPr id="2" name="title">
             <a:extLst xmlns:a="http://schemas.openxmlformats.org/drawingml/2006/main">
               <a:ext uri="{FF2B5EF4-FFF2-40B4-BE49-F238E27FC236}">
-                <a16:creationId xmlns:a16="http://schemas.microsoft.com/office/drawing/2014/main" id="{A913F7E1-91A3-4895-B90A-93E14E3C99C0}"/>
+                <a16:creationId xmlns:a16="http://schemas.microsoft.com/office/drawing/2014/main" id="{BF12D21B-7133-4181-AE79-8A6154C7E399}"/>
               </a:ext>
             </a:extLst>
           </p:cNvPr>
@@ -3642,7 +3642,7 @@
           <p:cNvPr id="3" name="footer">
             <a:extLst xmlns:a="http://schemas.openxmlformats.org/drawingml/2006/main">
               <a:ext uri="{FF2B5EF4-FFF2-40B4-BE49-F238E27FC236}">
-                <a16:creationId xmlns:a16="http://schemas.microsoft.com/office/drawing/2014/main" id="{9BAFD34C-BAC2-4BDA-AF19-05586DDED301}"/>
+                <a16:creationId xmlns:a16="http://schemas.microsoft.com/office/drawing/2014/main" id="{471D8C2B-2979-4A6C-9CD3-C8123A3C0955}"/>
               </a:ext>
             </a:extLst>
           </p:cNvPr>
@@ -3702,7 +3702,7 @@
           <p:cNvPr id="4" name="goal-plan-a">
             <a:extLst xmlns:a="http://schemas.openxmlformats.org/drawingml/2006/main">
               <a:ext uri="{FF2B5EF4-FFF2-40B4-BE49-F238E27FC236}">
-                <a16:creationId xmlns:a16="http://schemas.microsoft.com/office/drawing/2014/main" id="{7D09B6BB-4F1F-4B99-83A6-55A8036FC00A}"/>
+                <a16:creationId xmlns:a16="http://schemas.microsoft.com/office/drawing/2014/main" id="{32B93761-DB88-4496-814C-B99CBF663314}"/>
               </a:ext>
             </a:extLst>
           </p:cNvPr>
@@ -3733,7 +3733,7 @@
           <p:cNvPr id="5" name="goal-plan-b">
             <a:extLst xmlns:a="http://schemas.openxmlformats.org/drawingml/2006/main">
               <a:ext uri="{FF2B5EF4-FFF2-40B4-BE49-F238E27FC236}">
-                <a16:creationId xmlns:a16="http://schemas.microsoft.com/office/drawing/2014/main" id="{994DDF05-DF3F-41CF-9F92-873656694D10}"/>
+                <a16:creationId xmlns:a16="http://schemas.microsoft.com/office/drawing/2014/main" id="{5741CCCB-941B-4F0B-B01E-87F00013A310}"/>
               </a:ext>
             </a:extLst>
           </p:cNvPr>
@@ -3764,7 +3764,7 @@
           <p:cNvPr id="6" name="goal-plan-c">
             <a:extLst xmlns:a="http://schemas.openxmlformats.org/drawingml/2006/main">
               <a:ext uri="{FF2B5EF4-FFF2-40B4-BE49-F238E27FC236}">
-                <a16:creationId xmlns:a16="http://schemas.microsoft.com/office/drawing/2014/main" id="{603B2568-783D-4E53-B4A8-B7773E620A52}"/>
+                <a16:creationId xmlns:a16="http://schemas.microsoft.com/office/drawing/2014/main" id="{6ABD26B6-9061-452D-8C6A-58943452A738}"/>
               </a:ext>
             </a:extLst>
           </p:cNvPr>
@@ -3795,7 +3795,7 @@
           <p:cNvPr id="7" name="plan-act">
             <a:extLst xmlns:a="http://schemas.openxmlformats.org/drawingml/2006/main">
               <a:ext uri="{FF2B5EF4-FFF2-40B4-BE49-F238E27FC236}">
-                <a16:creationId xmlns:a16="http://schemas.microsoft.com/office/drawing/2014/main" id="{BFD182B5-FF61-4827-B7A6-38A6185905C1}"/>
+                <a16:creationId xmlns:a16="http://schemas.microsoft.com/office/drawing/2014/main" id="{52D285C3-670B-4CC6-8E23-3E8439427BF3}"/>
               </a:ext>
             </a:extLst>
           </p:cNvPr>
@@ -3826,7 +3826,7 @@
           <p:cNvPr id="8" name="act-observe-a">
             <a:extLst xmlns:a="http://schemas.openxmlformats.org/drawingml/2006/main">
               <a:ext uri="{FF2B5EF4-FFF2-40B4-BE49-F238E27FC236}">
-                <a16:creationId xmlns:a16="http://schemas.microsoft.com/office/drawing/2014/main" id="{3633E8B6-3803-452D-8D02-73780D038D9B}"/>
+                <a16:creationId xmlns:a16="http://schemas.microsoft.com/office/drawing/2014/main" id="{91272849-AAB6-4C90-A22D-59245B58B0F5}"/>
               </a:ext>
             </a:extLst>
           </p:cNvPr>
@@ -3857,7 +3857,7 @@
           <p:cNvPr id="9" name="act-observe-b">
             <a:extLst xmlns:a="http://schemas.openxmlformats.org/drawingml/2006/main">
               <a:ext uri="{FF2B5EF4-FFF2-40B4-BE49-F238E27FC236}">
-                <a16:creationId xmlns:a16="http://schemas.microsoft.com/office/drawing/2014/main" id="{6FF46793-4795-47C7-AC45-9272644E0132}"/>
+                <a16:creationId xmlns:a16="http://schemas.microsoft.com/office/drawing/2014/main" id="{DDC6763C-D88E-4CD5-AABC-2C5469F06976}"/>
               </a:ext>
             </a:extLst>
           </p:cNvPr>
@@ -3888,7 +3888,7 @@
           <p:cNvPr id="10" name="act-observe-c">
             <a:extLst xmlns:a="http://schemas.openxmlformats.org/drawingml/2006/main">
               <a:ext uri="{FF2B5EF4-FFF2-40B4-BE49-F238E27FC236}">
-                <a16:creationId xmlns:a16="http://schemas.microsoft.com/office/drawing/2014/main" id="{38B5FCBD-4669-47B4-8D9B-BEA65D1E944F}"/>
+                <a16:creationId xmlns:a16="http://schemas.microsoft.com/office/drawing/2014/main" id="{E73FE626-6418-4B54-A11D-62A64CFB3DAB}"/>
               </a:ext>
             </a:extLst>
           </p:cNvPr>
@@ -3919,7 +3919,7 @@
           <p:cNvPr id="11" name="observe-verify-a">
             <a:extLst xmlns:a="http://schemas.openxmlformats.org/drawingml/2006/main">
               <a:ext uri="{FF2B5EF4-FFF2-40B4-BE49-F238E27FC236}">
-                <a16:creationId xmlns:a16="http://schemas.microsoft.com/office/drawing/2014/main" id="{DF16430D-5C3F-4973-A1B1-6E3F13A6F897}"/>
+                <a16:creationId xmlns:a16="http://schemas.microsoft.com/office/drawing/2014/main" id="{D46F0997-0103-4E67-A383-3E9D32C130EF}"/>
               </a:ext>
             </a:extLst>
           </p:cNvPr>
@@ -3950,7 +3950,7 @@
           <p:cNvPr id="12" name="observe-verify-b">
             <a:extLst xmlns:a="http://schemas.openxmlformats.org/drawingml/2006/main">
               <a:ext uri="{FF2B5EF4-FFF2-40B4-BE49-F238E27FC236}">
-                <a16:creationId xmlns:a16="http://schemas.microsoft.com/office/drawing/2014/main" id="{AA253EB8-094A-435B-96ED-2D3D1CE565D4}"/>
+                <a16:creationId xmlns:a16="http://schemas.microsoft.com/office/drawing/2014/main" id="{75FDC200-3B94-4407-82DA-0A7E63D924EE}"/>
               </a:ext>
             </a:extLst>
           </p:cNvPr>
@@ -3981,7 +3981,7 @@
           <p:cNvPr id="13" name="observe-verify-c">
             <a:extLst xmlns:a="http://schemas.openxmlformats.org/drawingml/2006/main">
               <a:ext uri="{FF2B5EF4-FFF2-40B4-BE49-F238E27FC236}">
-                <a16:creationId xmlns:a16="http://schemas.microsoft.com/office/drawing/2014/main" id="{78DE58D6-B8F1-4A41-82A2-C3EA3EFD89E4}"/>
+                <a16:creationId xmlns:a16="http://schemas.microsoft.com/office/drawing/2014/main" id="{3453B08A-FE4F-4C50-8094-737455AB8AA8}"/>
               </a:ext>
             </a:extLst>
           </p:cNvPr>
@@ -4012,7 +4012,7 @@
           <p:cNvPr id="14" name="verify-state">
             <a:extLst xmlns:a="http://schemas.openxmlformats.org/drawingml/2006/main">
               <a:ext uri="{FF2B5EF4-FFF2-40B4-BE49-F238E27FC236}">
-                <a16:creationId xmlns:a16="http://schemas.microsoft.com/office/drawing/2014/main" id="{515917F2-CED2-47F3-8C30-FBDBC9BE17C9}"/>
+                <a16:creationId xmlns:a16="http://schemas.microsoft.com/office/drawing/2014/main" id="{3FB13BAD-F425-4472-8F6A-24D7B128DBB7}"/>
               </a:ext>
             </a:extLst>
           </p:cNvPr>
@@ -4043,7 +4043,7 @@
           <p:cNvPr id="15" name="state-goal-a">
             <a:extLst xmlns:a="http://schemas.openxmlformats.org/drawingml/2006/main">
               <a:ext uri="{FF2B5EF4-FFF2-40B4-BE49-F238E27FC236}">
-                <a16:creationId xmlns:a16="http://schemas.microsoft.com/office/drawing/2014/main" id="{6BFCEA53-E784-4FF1-BC41-B5AF92406091}"/>
+                <a16:creationId xmlns:a16="http://schemas.microsoft.com/office/drawing/2014/main" id="{EDA17CE4-8494-4F54-BD93-0DA95590382C}"/>
               </a:ext>
             </a:extLst>
           </p:cNvPr>
@@ -4074,7 +4074,7 @@
           <p:cNvPr id="16" name="state-goal-b">
             <a:extLst xmlns:a="http://schemas.openxmlformats.org/drawingml/2006/main">
               <a:ext uri="{FF2B5EF4-FFF2-40B4-BE49-F238E27FC236}">
-                <a16:creationId xmlns:a16="http://schemas.microsoft.com/office/drawing/2014/main" id="{346C6364-47E0-495E-AD00-8FF428178FF3}"/>
+                <a16:creationId xmlns:a16="http://schemas.microsoft.com/office/drawing/2014/main" id="{4FAE4415-B4E4-421E-AD5D-4C2979F24F05}"/>
               </a:ext>
             </a:extLst>
           </p:cNvPr>
@@ -4105,7 +4105,7 @@
           <p:cNvPr id="17" name="state-goal-c">
             <a:extLst xmlns:a="http://schemas.openxmlformats.org/drawingml/2006/main">
               <a:ext uri="{FF2B5EF4-FFF2-40B4-BE49-F238E27FC236}">
-                <a16:creationId xmlns:a16="http://schemas.microsoft.com/office/drawing/2014/main" id="{AE3A0BD6-B05F-4446-8935-BEF227D4A683}"/>
+                <a16:creationId xmlns:a16="http://schemas.microsoft.com/office/drawing/2014/main" id="{39B5AF2F-FD00-4EA2-9CEB-635F53A86F57}"/>
               </a:ext>
             </a:extLst>
           </p:cNvPr>
@@ -4136,7 +4136,7 @@
           <p:cNvPr id="18" name="goal">
             <a:extLst xmlns:a="http://schemas.openxmlformats.org/drawingml/2006/main">
               <a:ext uri="{FF2B5EF4-FFF2-40B4-BE49-F238E27FC236}">
-                <a16:creationId xmlns:a16="http://schemas.microsoft.com/office/drawing/2014/main" id="{44339CE9-EA03-44C8-8DDF-46E5DB0918CC}"/>
+                <a16:creationId xmlns:a16="http://schemas.microsoft.com/office/drawing/2014/main" id="{2594C3C8-25B1-4A43-9AA4-0AEB91E06FF0}"/>
               </a:ext>
             </a:extLst>
           </p:cNvPr>
@@ -4202,7 +4202,7 @@
           <p:cNvPr id="19" name="plan">
             <a:extLst xmlns:a="http://schemas.openxmlformats.org/drawingml/2006/main">
               <a:ext uri="{FF2B5EF4-FFF2-40B4-BE49-F238E27FC236}">
-                <a16:creationId xmlns:a16="http://schemas.microsoft.com/office/drawing/2014/main" id="{9AF0AC55-A116-468C-983E-B358F6573C3D}"/>
+                <a16:creationId xmlns:a16="http://schemas.microsoft.com/office/drawing/2014/main" id="{90BF48AF-5579-477F-9125-41720242BD02}"/>
               </a:ext>
             </a:extLst>
           </p:cNvPr>
@@ -4268,7 +4268,7 @@
           <p:cNvPr id="20" name="act">
             <a:extLst xmlns:a="http://schemas.openxmlformats.org/drawingml/2006/main">
               <a:ext uri="{FF2B5EF4-FFF2-40B4-BE49-F238E27FC236}">
-                <a16:creationId xmlns:a16="http://schemas.microsoft.com/office/drawing/2014/main" id="{FDB1F38A-6C91-40E3-B27E-DC680C6480E2}"/>
+                <a16:creationId xmlns:a16="http://schemas.microsoft.com/office/drawing/2014/main" id="{0FCAC835-8386-4C2C-A753-35C465DDCFE2}"/>
               </a:ext>
             </a:extLst>
           </p:cNvPr>
@@ -4361,7 +4361,7 @@
           <p:cNvPr id="21" name="observe">
             <a:extLst xmlns:a="http://schemas.openxmlformats.org/drawingml/2006/main">
               <a:ext uri="{FF2B5EF4-FFF2-40B4-BE49-F238E27FC236}">
-                <a16:creationId xmlns:a16="http://schemas.microsoft.com/office/drawing/2014/main" id="{7FA0A4FA-EDEB-431B-8576-159F72969C0B}"/>
+                <a16:creationId xmlns:a16="http://schemas.microsoft.com/office/drawing/2014/main" id="{85DFD03D-8866-49C1-896F-68B3E0E8490B}"/>
               </a:ext>
             </a:extLst>
           </p:cNvPr>
@@ -4427,7 +4427,7 @@
           <p:cNvPr id="22" name="verify">
             <a:extLst xmlns:a="http://schemas.openxmlformats.org/drawingml/2006/main">
               <a:ext uri="{FF2B5EF4-FFF2-40B4-BE49-F238E27FC236}">
-                <a16:creationId xmlns:a16="http://schemas.microsoft.com/office/drawing/2014/main" id="{EA6344BB-0E22-4CBB-AC2B-5304D38D1668}"/>
+                <a16:creationId xmlns:a16="http://schemas.microsoft.com/office/drawing/2014/main" id="{A2EE1520-F9B6-4A75-B341-FFF4B8B87641}"/>
               </a:ext>
             </a:extLst>
           </p:cNvPr>
@@ -4493,7 +4493,7 @@
           <p:cNvPr id="23" name="state">
             <a:extLst xmlns:a="http://schemas.openxmlformats.org/drawingml/2006/main">
               <a:ext uri="{FF2B5EF4-FFF2-40B4-BE49-F238E27FC236}">
-                <a16:creationId xmlns:a16="http://schemas.microsoft.com/office/drawing/2014/main" id="{840F7825-21CA-4EE4-ACC9-A426313C12E9}"/>
+                <a16:creationId xmlns:a16="http://schemas.microsoft.com/office/drawing/2014/main" id="{25CFCC47-EE90-4F97-80D9-CB2BEF6F9DC8}"/>
               </a:ext>
             </a:extLst>
           </p:cNvPr>
@@ -4586,7 +4586,7 @@
           <p:cNvPr id="24" name="human">
             <a:extLst xmlns:a="http://schemas.openxmlformats.org/drawingml/2006/main">
               <a:ext uri="{FF2B5EF4-FFF2-40B4-BE49-F238E27FC236}">
-                <a16:creationId xmlns:a16="http://schemas.microsoft.com/office/drawing/2014/main" id="{9032DE68-B985-4A9A-84E9-2E9CCA446B87}"/>
+                <a16:creationId xmlns:a16="http://schemas.microsoft.com/office/drawing/2014/main" id="{422EB857-A02E-4FCE-88CF-0846427CE2A6}"/>
               </a:ext>
             </a:extLst>
           </p:cNvPr>
@@ -4679,7 +4679,7 @@
           <p:cNvPr id="25" name="human-link">
             <a:extLst xmlns:a="http://schemas.openxmlformats.org/drawingml/2006/main">
               <a:ext uri="{FF2B5EF4-FFF2-40B4-BE49-F238E27FC236}">
-                <a16:creationId xmlns:a16="http://schemas.microsoft.com/office/drawing/2014/main" id="{B8FA5183-41EA-4F7C-B2CD-B0AFBFB63311}"/>
+                <a16:creationId xmlns:a16="http://schemas.microsoft.com/office/drawing/2014/main" id="{B7F8ADF1-B486-4E20-B68C-2E3E8EC11CAA}"/>
               </a:ext>
             </a:extLst>
           </p:cNvPr>
@@ -4710,7 +4710,7 @@
           <p:cNvPr id="26" name="loop-note">
             <a:extLst xmlns:a="http://schemas.openxmlformats.org/drawingml/2006/main">
               <a:ext uri="{FF2B5EF4-FFF2-40B4-BE49-F238E27FC236}">
-                <a16:creationId xmlns:a16="http://schemas.microsoft.com/office/drawing/2014/main" id="{7B35E12B-42B1-4AB1-87B6-707871029DB5}"/>
+                <a16:creationId xmlns:a16="http://schemas.microsoft.com/office/drawing/2014/main" id="{264CFC15-6F1A-4BA9-9A06-C03DF5005C70}"/>
               </a:ext>
             </a:extLst>
           </p:cNvPr>
@@ -4768,7 +4768,7 @@
     </p:spTree>
     <p:extLst>
       <p:ext uri="{BB962C8B-B14F-4D97-AF65-F5344CB8AC3E}">
-        <p14:creationId xmlns:p14="http://schemas.microsoft.com/office/powerpoint/2010/main" val="1838531000"/>
+        <p14:creationId xmlns:p14="http://schemas.microsoft.com/office/powerpoint/2010/main" val="1876399700"/>
       </p:ext>
     </p:extLst>
   </p:cSld>
@@ -4799,7 +4799,7 @@
           <p:cNvPr id="1" name="eyebrow">
             <a:extLst xmlns:a="http://schemas.openxmlformats.org/drawingml/2006/main">
               <a:ext uri="{FF2B5EF4-FFF2-40B4-BE49-F238E27FC236}">
-                <a16:creationId xmlns:a16="http://schemas.microsoft.com/office/drawing/2014/main" id="{8B08D75B-7F28-48D9-A32D-B58CEF0BAD64}"/>
+                <a16:creationId xmlns:a16="http://schemas.microsoft.com/office/drawing/2014/main" id="{9BEC4150-0F4A-4F22-8004-055F681DDB4B}"/>
               </a:ext>
             </a:extLst>
           </p:cNvPr>
@@ -4859,7 +4859,7 @@
           <p:cNvPr id="2" name="title">
             <a:extLst xmlns:a="http://schemas.openxmlformats.org/drawingml/2006/main">
               <a:ext uri="{FF2B5EF4-FFF2-40B4-BE49-F238E27FC236}">
-                <a16:creationId xmlns:a16="http://schemas.microsoft.com/office/drawing/2014/main" id="{6829B1A8-3398-42F5-9612-33198706166D}"/>
+                <a16:creationId xmlns:a16="http://schemas.microsoft.com/office/drawing/2014/main" id="{C101F0F9-6AEE-4A62-9916-1D9175B9E5B8}"/>
               </a:ext>
             </a:extLst>
           </p:cNvPr>
@@ -4919,7 +4919,7 @@
           <p:cNvPr id="3" name="footer">
             <a:extLst xmlns:a="http://schemas.openxmlformats.org/drawingml/2006/main">
               <a:ext uri="{FF2B5EF4-FFF2-40B4-BE49-F238E27FC236}">
-                <a16:creationId xmlns:a16="http://schemas.microsoft.com/office/drawing/2014/main" id="{4D70C317-1819-47D7-B5B5-9D3C4A20FC10}"/>
+                <a16:creationId xmlns:a16="http://schemas.microsoft.com/office/drawing/2014/main" id="{E49BB0C3-FAB5-4E79-AFB9-64940D906BAB}"/>
               </a:ext>
             </a:extLst>
           </p:cNvPr>
@@ -4979,7 +4979,7 @@
           <p:cNvPr id="4" name="table-bg">
             <a:extLst xmlns:a="http://schemas.openxmlformats.org/drawingml/2006/main">
               <a:ext uri="{FF2B5EF4-FFF2-40B4-BE49-F238E27FC236}">
-                <a16:creationId xmlns:a16="http://schemas.microsoft.com/office/drawing/2014/main" id="{800D8D5D-1711-452E-9D80-69991DC80F57}"/>
+                <a16:creationId xmlns:a16="http://schemas.microsoft.com/office/drawing/2014/main" id="{1F5943E4-BFD8-4FC4-955B-5E8B8EBD3D03}"/>
               </a:ext>
             </a:extLst>
           </p:cNvPr>
@@ -5014,7 +5014,7 @@
           <p:cNvPr id="5" name="h-0">
             <a:extLst xmlns:a="http://schemas.openxmlformats.org/drawingml/2006/main">
               <a:ext uri="{FF2B5EF4-FFF2-40B4-BE49-F238E27FC236}">
-                <a16:creationId xmlns:a16="http://schemas.microsoft.com/office/drawing/2014/main" id="{ECABDAB6-865C-4C68-A406-9ED92A7C98B9}"/>
+                <a16:creationId xmlns:a16="http://schemas.microsoft.com/office/drawing/2014/main" id="{C262AABD-B604-4473-ADCB-76B52527CCB4}"/>
               </a:ext>
             </a:extLst>
           </p:cNvPr>
@@ -5074,7 +5074,7 @@
           <p:cNvPr id="6" name="h-1">
             <a:extLst xmlns:a="http://schemas.openxmlformats.org/drawingml/2006/main">
               <a:ext uri="{FF2B5EF4-FFF2-40B4-BE49-F238E27FC236}">
-                <a16:creationId xmlns:a16="http://schemas.microsoft.com/office/drawing/2014/main" id="{ED424D50-0CC9-4067-BD5B-5A18FCFC5B44}"/>
+                <a16:creationId xmlns:a16="http://schemas.microsoft.com/office/drawing/2014/main" id="{FB248800-6D79-4E0A-B713-D3165021FC5E}"/>
               </a:ext>
             </a:extLst>
           </p:cNvPr>
@@ -5134,7 +5134,7 @@
           <p:cNvPr id="7" name="h-2">
             <a:extLst xmlns:a="http://schemas.openxmlformats.org/drawingml/2006/main">
               <a:ext uri="{FF2B5EF4-FFF2-40B4-BE49-F238E27FC236}">
-                <a16:creationId xmlns:a16="http://schemas.microsoft.com/office/drawing/2014/main" id="{268BCC74-B1D9-497F-930C-89EEEC83B9B6}"/>
+                <a16:creationId xmlns:a16="http://schemas.microsoft.com/office/drawing/2014/main" id="{3CC5FE0B-AF38-403C-B426-471B41DE756A}"/>
               </a:ext>
             </a:extLst>
           </p:cNvPr>
@@ -5194,7 +5194,7 @@
           <p:cNvPr id="8" name="step-0">
             <a:extLst xmlns:a="http://schemas.openxmlformats.org/drawingml/2006/main">
               <a:ext uri="{FF2B5EF4-FFF2-40B4-BE49-F238E27FC236}">
-                <a16:creationId xmlns:a16="http://schemas.microsoft.com/office/drawing/2014/main" id="{60BC8B35-068E-4C4C-9E4F-D874751430AD}"/>
+                <a16:creationId xmlns:a16="http://schemas.microsoft.com/office/drawing/2014/main" id="{B4A37DD5-BA45-467F-AB8F-41A75FFFA003}"/>
               </a:ext>
             </a:extLst>
           </p:cNvPr>
@@ -5254,7 +5254,7 @@
           <p:cNvPr id="9" name="artifact-0">
             <a:extLst xmlns:a="http://schemas.openxmlformats.org/drawingml/2006/main">
               <a:ext uri="{FF2B5EF4-FFF2-40B4-BE49-F238E27FC236}">
-                <a16:creationId xmlns:a16="http://schemas.microsoft.com/office/drawing/2014/main" id="{4B1805A0-CBBF-4C66-85C6-5D8638619BE0}"/>
+                <a16:creationId xmlns:a16="http://schemas.microsoft.com/office/drawing/2014/main" id="{3B24C9DF-56F6-4EEA-AF75-B60DEFF6113F}"/>
               </a:ext>
             </a:extLst>
           </p:cNvPr>
@@ -5314,7 +5314,7 @@
           <p:cNvPr id="10" name="why-0">
             <a:extLst xmlns:a="http://schemas.openxmlformats.org/drawingml/2006/main">
               <a:ext uri="{FF2B5EF4-FFF2-40B4-BE49-F238E27FC236}">
-                <a16:creationId xmlns:a16="http://schemas.microsoft.com/office/drawing/2014/main" id="{6101A414-F7B2-4FB3-A173-9896C699A613}"/>
+                <a16:creationId xmlns:a16="http://schemas.microsoft.com/office/drawing/2014/main" id="{B88E9A0C-24E0-45E6-85A1-A9F9553F43BD}"/>
               </a:ext>
             </a:extLst>
           </p:cNvPr>
@@ -5374,7 +5374,7 @@
           <p:cNvPr id="11" name="row-0">
             <a:extLst xmlns:a="http://schemas.openxmlformats.org/drawingml/2006/main">
               <a:ext uri="{FF2B5EF4-FFF2-40B4-BE49-F238E27FC236}">
-                <a16:creationId xmlns:a16="http://schemas.microsoft.com/office/drawing/2014/main" id="{A562673E-BDFF-4B3B-BBE7-08E1DF2AEDA3}"/>
+                <a16:creationId xmlns:a16="http://schemas.microsoft.com/office/drawing/2014/main" id="{D9AF3F68-F188-4963-A321-70C31DB7FB3D}"/>
               </a:ext>
             </a:extLst>
           </p:cNvPr>
@@ -5405,7 +5405,7 @@
           <p:cNvPr id="12" name="step-1">
             <a:extLst xmlns:a="http://schemas.openxmlformats.org/drawingml/2006/main">
               <a:ext uri="{FF2B5EF4-FFF2-40B4-BE49-F238E27FC236}">
-                <a16:creationId xmlns:a16="http://schemas.microsoft.com/office/drawing/2014/main" id="{E8562A06-93A7-4B6F-99DF-6CC1CD121458}"/>
+                <a16:creationId xmlns:a16="http://schemas.microsoft.com/office/drawing/2014/main" id="{1363C678-97BC-47F8-B6CE-8BB739C31F2F}"/>
               </a:ext>
             </a:extLst>
           </p:cNvPr>
@@ -5465,7 +5465,7 @@
           <p:cNvPr id="13" name="artifact-1">
             <a:extLst xmlns:a="http://schemas.openxmlformats.org/drawingml/2006/main">
               <a:ext uri="{FF2B5EF4-FFF2-40B4-BE49-F238E27FC236}">
-                <a16:creationId xmlns:a16="http://schemas.microsoft.com/office/drawing/2014/main" id="{45938185-DC7A-4E8E-AFAE-D8D75663D0BF}"/>
+                <a16:creationId xmlns:a16="http://schemas.microsoft.com/office/drawing/2014/main" id="{A6EE26F1-2DA3-49FC-AA82-AE4593C4DDA1}"/>
               </a:ext>
             </a:extLst>
           </p:cNvPr>
@@ -5525,7 +5525,7 @@
           <p:cNvPr id="14" name="why-1">
             <a:extLst xmlns:a="http://schemas.openxmlformats.org/drawingml/2006/main">
               <a:ext uri="{FF2B5EF4-FFF2-40B4-BE49-F238E27FC236}">
-                <a16:creationId xmlns:a16="http://schemas.microsoft.com/office/drawing/2014/main" id="{BEC20AC6-04E9-4901-B94C-A7D85E8AEEDB}"/>
+                <a16:creationId xmlns:a16="http://schemas.microsoft.com/office/drawing/2014/main" id="{AE9E9FE9-F1CA-45B1-B84E-0B4F87D87E54}"/>
               </a:ext>
             </a:extLst>
           </p:cNvPr>
@@ -5585,7 +5585,7 @@
           <p:cNvPr id="15" name="row-1">
             <a:extLst xmlns:a="http://schemas.openxmlformats.org/drawingml/2006/main">
               <a:ext uri="{FF2B5EF4-FFF2-40B4-BE49-F238E27FC236}">
-                <a16:creationId xmlns:a16="http://schemas.microsoft.com/office/drawing/2014/main" id="{F1E408E3-1870-4ABF-A788-C91E9CF373E8}"/>
+                <a16:creationId xmlns:a16="http://schemas.microsoft.com/office/drawing/2014/main" id="{44DCF3C0-2696-4EB1-966C-3CB03872B323}"/>
               </a:ext>
             </a:extLst>
           </p:cNvPr>
@@ -5616,7 +5616,7 @@
           <p:cNvPr id="16" name="step-2">
             <a:extLst xmlns:a="http://schemas.openxmlformats.org/drawingml/2006/main">
               <a:ext uri="{FF2B5EF4-FFF2-40B4-BE49-F238E27FC236}">
-                <a16:creationId xmlns:a16="http://schemas.microsoft.com/office/drawing/2014/main" id="{344B8511-084C-451D-A56F-346F389CDB96}"/>
+                <a16:creationId xmlns:a16="http://schemas.microsoft.com/office/drawing/2014/main" id="{078CDA59-1ABA-41FE-B924-564D4642EB05}"/>
               </a:ext>
             </a:extLst>
           </p:cNvPr>
@@ -5676,7 +5676,7 @@
           <p:cNvPr id="17" name="artifact-2">
             <a:extLst xmlns:a="http://schemas.openxmlformats.org/drawingml/2006/main">
               <a:ext uri="{FF2B5EF4-FFF2-40B4-BE49-F238E27FC236}">
-                <a16:creationId xmlns:a16="http://schemas.microsoft.com/office/drawing/2014/main" id="{D2453B83-F4CD-415B-9EE1-BCF1761E9543}"/>
+                <a16:creationId xmlns:a16="http://schemas.microsoft.com/office/drawing/2014/main" id="{AA72BC12-7D1D-4418-AAA4-AFDB9986B32D}"/>
               </a:ext>
             </a:extLst>
           </p:cNvPr>
@@ -5736,7 +5736,7 @@
           <p:cNvPr id="18" name="why-2">
             <a:extLst xmlns:a="http://schemas.openxmlformats.org/drawingml/2006/main">
               <a:ext uri="{FF2B5EF4-FFF2-40B4-BE49-F238E27FC236}">
-                <a16:creationId xmlns:a16="http://schemas.microsoft.com/office/drawing/2014/main" id="{D873B001-F4FE-48A4-8214-82DE27EAEE83}"/>
+                <a16:creationId xmlns:a16="http://schemas.microsoft.com/office/drawing/2014/main" id="{CED9D654-CFE7-4828-8954-EF65E3897D37}"/>
               </a:ext>
             </a:extLst>
           </p:cNvPr>
@@ -5796,7 +5796,7 @@
           <p:cNvPr id="19" name="row-2">
             <a:extLst xmlns:a="http://schemas.openxmlformats.org/drawingml/2006/main">
               <a:ext uri="{FF2B5EF4-FFF2-40B4-BE49-F238E27FC236}">
-                <a16:creationId xmlns:a16="http://schemas.microsoft.com/office/drawing/2014/main" id="{FB733CC6-0BF2-42D5-AA8A-1258C4C68C98}"/>
+                <a16:creationId xmlns:a16="http://schemas.microsoft.com/office/drawing/2014/main" id="{60EAAA12-9B60-4126-B1DE-815BCD32AC30}"/>
               </a:ext>
             </a:extLst>
           </p:cNvPr>
@@ -5827,7 +5827,7 @@
           <p:cNvPr id="20" name="step-3">
             <a:extLst xmlns:a="http://schemas.openxmlformats.org/drawingml/2006/main">
               <a:ext uri="{FF2B5EF4-FFF2-40B4-BE49-F238E27FC236}">
-                <a16:creationId xmlns:a16="http://schemas.microsoft.com/office/drawing/2014/main" id="{32F7B436-B762-47A6-81A6-F60E57E19035}"/>
+                <a16:creationId xmlns:a16="http://schemas.microsoft.com/office/drawing/2014/main" id="{77C3B7E5-1A49-4501-B0E1-DFE196877598}"/>
               </a:ext>
             </a:extLst>
           </p:cNvPr>
@@ -5887,7 +5887,7 @@
           <p:cNvPr id="21" name="artifact-3">
             <a:extLst xmlns:a="http://schemas.openxmlformats.org/drawingml/2006/main">
               <a:ext uri="{FF2B5EF4-FFF2-40B4-BE49-F238E27FC236}">
-                <a16:creationId xmlns:a16="http://schemas.microsoft.com/office/drawing/2014/main" id="{708FDD86-E1F6-4FFC-A3C1-8A2A1A638B44}"/>
+                <a16:creationId xmlns:a16="http://schemas.microsoft.com/office/drawing/2014/main" id="{271A3F67-9D40-4331-9876-27C799025787}"/>
               </a:ext>
             </a:extLst>
           </p:cNvPr>
@@ -5947,7 +5947,7 @@
           <p:cNvPr id="22" name="why-3">
             <a:extLst xmlns:a="http://schemas.openxmlformats.org/drawingml/2006/main">
               <a:ext uri="{FF2B5EF4-FFF2-40B4-BE49-F238E27FC236}">
-                <a16:creationId xmlns:a16="http://schemas.microsoft.com/office/drawing/2014/main" id="{3D79EEC8-12D3-45E0-B3D6-928E0BE5E3E1}"/>
+                <a16:creationId xmlns:a16="http://schemas.microsoft.com/office/drawing/2014/main" id="{2A59034F-0DDE-47C8-BA1B-75A2B6938255}"/>
               </a:ext>
             </a:extLst>
           </p:cNvPr>
@@ -6007,7 +6007,7 @@
           <p:cNvPr id="23" name="row-3">
             <a:extLst xmlns:a="http://schemas.openxmlformats.org/drawingml/2006/main">
               <a:ext uri="{FF2B5EF4-FFF2-40B4-BE49-F238E27FC236}">
-                <a16:creationId xmlns:a16="http://schemas.microsoft.com/office/drawing/2014/main" id="{5CC3216A-FECC-4AD9-BA84-A4450A04CC15}"/>
+                <a16:creationId xmlns:a16="http://schemas.microsoft.com/office/drawing/2014/main" id="{E7E3E440-4B91-4C72-BDB2-A7AF8A7C5A45}"/>
               </a:ext>
             </a:extLst>
           </p:cNvPr>
@@ -6038,7 +6038,7 @@
           <p:cNvPr id="24" name="step-4">
             <a:extLst xmlns:a="http://schemas.openxmlformats.org/drawingml/2006/main">
               <a:ext uri="{FF2B5EF4-FFF2-40B4-BE49-F238E27FC236}">
-                <a16:creationId xmlns:a16="http://schemas.microsoft.com/office/drawing/2014/main" id="{8D3B138B-09E6-4E35-A542-653A1057424E}"/>
+                <a16:creationId xmlns:a16="http://schemas.microsoft.com/office/drawing/2014/main" id="{9E81711D-ADA7-49A2-9A15-74AC66FE93FC}"/>
               </a:ext>
             </a:extLst>
           </p:cNvPr>
@@ -6098,7 +6098,7 @@
           <p:cNvPr id="25" name="artifact-4">
             <a:extLst xmlns:a="http://schemas.openxmlformats.org/drawingml/2006/main">
               <a:ext uri="{FF2B5EF4-FFF2-40B4-BE49-F238E27FC236}">
-                <a16:creationId xmlns:a16="http://schemas.microsoft.com/office/drawing/2014/main" id="{8695CE44-5D69-44A8-9343-97F31DAC5822}"/>
+                <a16:creationId xmlns:a16="http://schemas.microsoft.com/office/drawing/2014/main" id="{94D62554-7E21-4559-BFA1-A53912EF236D}"/>
               </a:ext>
             </a:extLst>
           </p:cNvPr>
@@ -6158,7 +6158,7 @@
           <p:cNvPr id="26" name="why-4">
             <a:extLst xmlns:a="http://schemas.openxmlformats.org/drawingml/2006/main">
               <a:ext uri="{FF2B5EF4-FFF2-40B4-BE49-F238E27FC236}">
-                <a16:creationId xmlns:a16="http://schemas.microsoft.com/office/drawing/2014/main" id="{154D34C5-31BE-48F6-AC3D-2F95D73B4B55}"/>
+                <a16:creationId xmlns:a16="http://schemas.microsoft.com/office/drawing/2014/main" id="{F06A74D7-1F95-40C0-A753-C36BBBD15013}"/>
               </a:ext>
             </a:extLst>
           </p:cNvPr>
@@ -6218,7 +6218,7 @@
           <p:cNvPr id="27" name="row-4">
             <a:extLst xmlns:a="http://schemas.openxmlformats.org/drawingml/2006/main">
               <a:ext uri="{FF2B5EF4-FFF2-40B4-BE49-F238E27FC236}">
-                <a16:creationId xmlns:a16="http://schemas.microsoft.com/office/drawing/2014/main" id="{3E5517C5-6CF3-45B5-BBBA-17A415CCDB98}"/>
+                <a16:creationId xmlns:a16="http://schemas.microsoft.com/office/drawing/2014/main" id="{774A471E-78F0-466D-B73C-70C7A9C71C36}"/>
               </a:ext>
             </a:extLst>
           </p:cNvPr>
@@ -6249,7 +6249,7 @@
           <p:cNvPr id="28" name="bottom">
             <a:extLst xmlns:a="http://schemas.openxmlformats.org/drawingml/2006/main">
               <a:ext uri="{FF2B5EF4-FFF2-40B4-BE49-F238E27FC236}">
-                <a16:creationId xmlns:a16="http://schemas.microsoft.com/office/drawing/2014/main" id="{E98260D6-FB2B-46C0-A203-101FF38072FB}"/>
+                <a16:creationId xmlns:a16="http://schemas.microsoft.com/office/drawing/2014/main" id="{422D87D1-BC12-4DD7-9B82-4F564CE35D8E}"/>
               </a:ext>
             </a:extLst>
           </p:cNvPr>
@@ -6307,7 +6307,7 @@
     </p:spTree>
     <p:extLst>
       <p:ext uri="{BB962C8B-B14F-4D97-AF65-F5344CB8AC3E}">
-        <p14:creationId xmlns:p14="http://schemas.microsoft.com/office/powerpoint/2010/main" val="49188952"/>
+        <p14:creationId xmlns:p14="http://schemas.microsoft.com/office/powerpoint/2010/main" val="1864035903"/>
       </p:ext>
     </p:extLst>
   </p:cSld>
@@ -6338,7 +6338,7 @@
           <p:cNvPr id="1" name="eyebrow">
             <a:extLst xmlns:a="http://schemas.openxmlformats.org/drawingml/2006/main">
               <a:ext uri="{FF2B5EF4-FFF2-40B4-BE49-F238E27FC236}">
-                <a16:creationId xmlns:a16="http://schemas.microsoft.com/office/drawing/2014/main" id="{0D74CFA6-4351-4820-A22D-26672F7D2B07}"/>
+                <a16:creationId xmlns:a16="http://schemas.microsoft.com/office/drawing/2014/main" id="{05D0C531-5DD9-479A-A8B5-B05F18415CAF}"/>
               </a:ext>
             </a:extLst>
           </p:cNvPr>
@@ -6398,7 +6398,7 @@
           <p:cNvPr id="2" name="title">
             <a:extLst xmlns:a="http://schemas.openxmlformats.org/drawingml/2006/main">
               <a:ext uri="{FF2B5EF4-FFF2-40B4-BE49-F238E27FC236}">
-                <a16:creationId xmlns:a16="http://schemas.microsoft.com/office/drawing/2014/main" id="{35BD2346-FF3A-460C-A1CF-EDD9262C9F05}"/>
+                <a16:creationId xmlns:a16="http://schemas.microsoft.com/office/drawing/2014/main" id="{3A47EE6F-8544-4414-8006-E1A1BA249482}"/>
               </a:ext>
             </a:extLst>
           </p:cNvPr>
@@ -6458,7 +6458,7 @@
           <p:cNvPr id="3" name="footer">
             <a:extLst xmlns:a="http://schemas.openxmlformats.org/drawingml/2006/main">
               <a:ext uri="{FF2B5EF4-FFF2-40B4-BE49-F238E27FC236}">
-                <a16:creationId xmlns:a16="http://schemas.microsoft.com/office/drawing/2014/main" id="{87D086C2-C053-4C96-9A94-DEAE82C5E0F8}"/>
+                <a16:creationId xmlns:a16="http://schemas.microsoft.com/office/drawing/2014/main" id="{056AFE1D-EA3D-4245-B2A3-43CC61BB8F1E}"/>
               </a:ext>
             </a:extLst>
           </p:cNvPr>
@@ -6518,7 +6518,7 @@
           <p:cNvPr id="4" name="good">
             <a:extLst xmlns:a="http://schemas.openxmlformats.org/drawingml/2006/main">
               <a:ext uri="{FF2B5EF4-FFF2-40B4-BE49-F238E27FC236}">
-                <a16:creationId xmlns:a16="http://schemas.microsoft.com/office/drawing/2014/main" id="{A04599A0-5446-421C-A9D7-6CBFE85D6FC7}"/>
+                <a16:creationId xmlns:a16="http://schemas.microsoft.com/office/drawing/2014/main" id="{0F4305D4-D83A-4865-89E6-22B1960A268F}"/>
               </a:ext>
             </a:extLst>
           </p:cNvPr>
@@ -6553,7 +6553,7 @@
           <p:cNvPr id="5" name="bad">
             <a:extLst xmlns:a="http://schemas.openxmlformats.org/drawingml/2006/main">
               <a:ext uri="{FF2B5EF4-FFF2-40B4-BE49-F238E27FC236}">
-                <a16:creationId xmlns:a16="http://schemas.microsoft.com/office/drawing/2014/main" id="{70F821A3-F590-402B-ACB5-1F90EF6DAC44}"/>
+                <a16:creationId xmlns:a16="http://schemas.microsoft.com/office/drawing/2014/main" id="{FC41346B-FCB7-4526-B997-00BD41E4DC05}"/>
               </a:ext>
             </a:extLst>
           </p:cNvPr>
@@ -6588,7 +6588,7 @@
           <p:cNvPr id="6" name="good-title">
             <a:extLst xmlns:a="http://schemas.openxmlformats.org/drawingml/2006/main">
               <a:ext uri="{FF2B5EF4-FFF2-40B4-BE49-F238E27FC236}">
-                <a16:creationId xmlns:a16="http://schemas.microsoft.com/office/drawing/2014/main" id="{B0727E9E-185A-4A47-BB36-E90682BE027A}"/>
+                <a16:creationId xmlns:a16="http://schemas.microsoft.com/office/drawing/2014/main" id="{12C0EA81-2F3B-4178-9EAD-02FEA1AF9915}"/>
               </a:ext>
             </a:extLst>
           </p:cNvPr>
@@ -6648,7 +6648,7 @@
           <p:cNvPr id="7" name="bad-title">
             <a:extLst xmlns:a="http://schemas.openxmlformats.org/drawingml/2006/main">
               <a:ext uri="{FF2B5EF4-FFF2-40B4-BE49-F238E27FC236}">
-                <a16:creationId xmlns:a16="http://schemas.microsoft.com/office/drawing/2014/main" id="{C585E7B3-34FE-42C6-8D17-7D242CEF61FC}"/>
+                <a16:creationId xmlns:a16="http://schemas.microsoft.com/office/drawing/2014/main" id="{9262E691-6C01-427A-94AE-9F948C77113B}"/>
               </a:ext>
             </a:extLst>
           </p:cNvPr>
@@ -6708,7 +6708,7 @@
           <p:cNvPr id="8" name="good-list">
             <a:extLst xmlns:a="http://schemas.openxmlformats.org/drawingml/2006/main">
               <a:ext uri="{FF2B5EF4-FFF2-40B4-BE49-F238E27FC236}">
-                <a16:creationId xmlns:a16="http://schemas.microsoft.com/office/drawing/2014/main" id="{4E0F6FFB-5D44-42A7-8A4D-8D76496B70B8}"/>
+                <a16:creationId xmlns:a16="http://schemas.microsoft.com/office/drawing/2014/main" id="{F4D4B7ED-5B78-4119-81B2-B83D17A732BC}"/>
               </a:ext>
             </a:extLst>
           </p:cNvPr>
@@ -6891,7 +6891,7 @@
           <p:cNvPr id="9" name="bad-list">
             <a:extLst xmlns:a="http://schemas.openxmlformats.org/drawingml/2006/main">
               <a:ext uri="{FF2B5EF4-FFF2-40B4-BE49-F238E27FC236}">
-                <a16:creationId xmlns:a16="http://schemas.microsoft.com/office/drawing/2014/main" id="{66798E2E-7AC3-4724-9C93-3B14449CDC3E}"/>
+                <a16:creationId xmlns:a16="http://schemas.microsoft.com/office/drawing/2014/main" id="{776087A4-0FBF-41FD-8A4D-18D61915984B}"/>
               </a:ext>
             </a:extLst>
           </p:cNvPr>
@@ -7074,7 +7074,7 @@
           <p:cNvPr id="10" name="bottom">
             <a:extLst xmlns:a="http://schemas.openxmlformats.org/drawingml/2006/main">
               <a:ext uri="{FF2B5EF4-FFF2-40B4-BE49-F238E27FC236}">
-                <a16:creationId xmlns:a16="http://schemas.microsoft.com/office/drawing/2014/main" id="{FD22F1C2-538B-4110-8D60-2BF61AD2A042}"/>
+                <a16:creationId xmlns:a16="http://schemas.microsoft.com/office/drawing/2014/main" id="{40E1DEF5-2FD2-4E8F-8767-900200FA5A80}"/>
               </a:ext>
             </a:extLst>
           </p:cNvPr>
@@ -7132,7 +7132,7 @@
     </p:spTree>
     <p:extLst>
       <p:ext uri="{BB962C8B-B14F-4D97-AF65-F5344CB8AC3E}">
-        <p14:creationId xmlns:p14="http://schemas.microsoft.com/office/powerpoint/2010/main" val="401843952"/>
+        <p14:creationId xmlns:p14="http://schemas.microsoft.com/office/powerpoint/2010/main" val="300643618"/>
       </p:ext>
     </p:extLst>
   </p:cSld>
@@ -7163,7 +7163,7 @@
           <p:cNvPr id="1" name="eyebrow">
             <a:extLst xmlns:a="http://schemas.openxmlformats.org/drawingml/2006/main">
               <a:ext uri="{FF2B5EF4-FFF2-40B4-BE49-F238E27FC236}">
-                <a16:creationId xmlns:a16="http://schemas.microsoft.com/office/drawing/2014/main" id="{EE0636DF-F55A-41FA-8231-2E5000A22D8F}"/>
+                <a16:creationId xmlns:a16="http://schemas.microsoft.com/office/drawing/2014/main" id="{E8263E38-2F91-46BC-B3AF-0BD9691DEBDA}"/>
               </a:ext>
             </a:extLst>
           </p:cNvPr>
@@ -7223,7 +7223,7 @@
           <p:cNvPr id="2" name="title">
             <a:extLst xmlns:a="http://schemas.openxmlformats.org/drawingml/2006/main">
               <a:ext uri="{FF2B5EF4-FFF2-40B4-BE49-F238E27FC236}">
-                <a16:creationId xmlns:a16="http://schemas.microsoft.com/office/drawing/2014/main" id="{65B668D1-F460-44B9-979B-39EFB4B1F98B}"/>
+                <a16:creationId xmlns:a16="http://schemas.microsoft.com/office/drawing/2014/main" id="{842AD21C-4E27-480D-82A7-DFB96ACEBC5B}"/>
               </a:ext>
             </a:extLst>
           </p:cNvPr>
@@ -7283,7 +7283,7 @@
           <p:cNvPr id="3" name="footer">
             <a:extLst xmlns:a="http://schemas.openxmlformats.org/drawingml/2006/main">
               <a:ext uri="{FF2B5EF4-FFF2-40B4-BE49-F238E27FC236}">
-                <a16:creationId xmlns:a16="http://schemas.microsoft.com/office/drawing/2014/main" id="{34F74EBE-53C8-4E06-9D57-A2834D2F693D}"/>
+                <a16:creationId xmlns:a16="http://schemas.microsoft.com/office/drawing/2014/main" id="{C6A74FFF-6093-4DC5-8E42-60E0847F04E0}"/>
               </a:ext>
             </a:extLst>
           </p:cNvPr>
@@ -7343,7 +7343,7 @@
           <p:cNvPr id="4" name="risk-0">
             <a:extLst xmlns:a="http://schemas.openxmlformats.org/drawingml/2006/main">
               <a:ext uri="{FF2B5EF4-FFF2-40B4-BE49-F238E27FC236}">
-                <a16:creationId xmlns:a16="http://schemas.microsoft.com/office/drawing/2014/main" id="{16B58836-E22F-4238-B5E9-42634069C9F5}"/>
+                <a16:creationId xmlns:a16="http://schemas.microsoft.com/office/drawing/2014/main" id="{B27F96F5-B9AB-4D85-9049-119F28014732}"/>
               </a:ext>
             </a:extLst>
           </p:cNvPr>
@@ -7378,7 +7378,7 @@
           <p:cNvPr id="5" name="risk-title-0">
             <a:extLst xmlns:a="http://schemas.openxmlformats.org/drawingml/2006/main">
               <a:ext uri="{FF2B5EF4-FFF2-40B4-BE49-F238E27FC236}">
-                <a16:creationId xmlns:a16="http://schemas.microsoft.com/office/drawing/2014/main" id="{BB9EE6F5-DE6A-4BA5-BF09-B533AB9941E8}"/>
+                <a16:creationId xmlns:a16="http://schemas.microsoft.com/office/drawing/2014/main" id="{399F2186-E2BE-4F1F-A909-ED746EF0BBAC}"/>
               </a:ext>
             </a:extLst>
           </p:cNvPr>
@@ -7438,7 +7438,7 @@
           <p:cNvPr id="6" name="risk-copy-0">
             <a:extLst xmlns:a="http://schemas.openxmlformats.org/drawingml/2006/main">
               <a:ext uri="{FF2B5EF4-FFF2-40B4-BE49-F238E27FC236}">
-                <a16:creationId xmlns:a16="http://schemas.microsoft.com/office/drawing/2014/main" id="{80D2489D-D33C-4A31-B084-11C616783C8F}"/>
+                <a16:creationId xmlns:a16="http://schemas.microsoft.com/office/drawing/2014/main" id="{12BB49FA-9D22-42E9-822C-E0FD7C7CC7B0}"/>
               </a:ext>
             </a:extLst>
           </p:cNvPr>
@@ -7498,7 +7498,7 @@
           <p:cNvPr id="7" name="risk-1">
             <a:extLst xmlns:a="http://schemas.openxmlformats.org/drawingml/2006/main">
               <a:ext uri="{FF2B5EF4-FFF2-40B4-BE49-F238E27FC236}">
-                <a16:creationId xmlns:a16="http://schemas.microsoft.com/office/drawing/2014/main" id="{645CC6F9-317B-4D3E-BEDA-739CE856FDC5}"/>
+                <a16:creationId xmlns:a16="http://schemas.microsoft.com/office/drawing/2014/main" id="{F8819EF1-8BF7-439B-86CA-D13C2BF21D1B}"/>
               </a:ext>
             </a:extLst>
           </p:cNvPr>
@@ -7533,7 +7533,7 @@
           <p:cNvPr id="8" name="risk-title-1">
             <a:extLst xmlns:a="http://schemas.openxmlformats.org/drawingml/2006/main">
               <a:ext uri="{FF2B5EF4-FFF2-40B4-BE49-F238E27FC236}">
-                <a16:creationId xmlns:a16="http://schemas.microsoft.com/office/drawing/2014/main" id="{E387DB97-F2D7-4DB7-AA27-FF9E24781AB9}"/>
+                <a16:creationId xmlns:a16="http://schemas.microsoft.com/office/drawing/2014/main" id="{91259360-EA30-473A-B9A5-83B91BB2CB56}"/>
               </a:ext>
             </a:extLst>
           </p:cNvPr>
@@ -7593,7 +7593,7 @@
           <p:cNvPr id="9" name="risk-copy-1">
             <a:extLst xmlns:a="http://schemas.openxmlformats.org/drawingml/2006/main">
               <a:ext uri="{FF2B5EF4-FFF2-40B4-BE49-F238E27FC236}">
-                <a16:creationId xmlns:a16="http://schemas.microsoft.com/office/drawing/2014/main" id="{EEEC73AE-E21B-46DD-9EDE-15C228DD40AA}"/>
+                <a16:creationId xmlns:a16="http://schemas.microsoft.com/office/drawing/2014/main" id="{CED85FA0-F844-4D0C-B849-BD7FE11EF75E}"/>
               </a:ext>
             </a:extLst>
           </p:cNvPr>
@@ -7653,7 +7653,7 @@
           <p:cNvPr id="10" name="risk-2">
             <a:extLst xmlns:a="http://schemas.openxmlformats.org/drawingml/2006/main">
               <a:ext uri="{FF2B5EF4-FFF2-40B4-BE49-F238E27FC236}">
-                <a16:creationId xmlns:a16="http://schemas.microsoft.com/office/drawing/2014/main" id="{D4CA04F7-5060-4A07-8251-D32C0E45F70F}"/>
+                <a16:creationId xmlns:a16="http://schemas.microsoft.com/office/drawing/2014/main" id="{8E9F94D7-95E0-4E32-9819-0C88D6F3DF1E}"/>
               </a:ext>
             </a:extLst>
           </p:cNvPr>
@@ -7688,7 +7688,7 @@
           <p:cNvPr id="11" name="risk-title-2">
             <a:extLst xmlns:a="http://schemas.openxmlformats.org/drawingml/2006/main">
               <a:ext uri="{FF2B5EF4-FFF2-40B4-BE49-F238E27FC236}">
-                <a16:creationId xmlns:a16="http://schemas.microsoft.com/office/drawing/2014/main" id="{31FDD859-3B63-4EE8-9BF7-BAD0377550F7}"/>
+                <a16:creationId xmlns:a16="http://schemas.microsoft.com/office/drawing/2014/main" id="{C7772401-D3CB-4FD9-AE75-547CA634FC30}"/>
               </a:ext>
             </a:extLst>
           </p:cNvPr>
@@ -7748,7 +7748,7 @@
           <p:cNvPr id="12" name="risk-copy-2">
             <a:extLst xmlns:a="http://schemas.openxmlformats.org/drawingml/2006/main">
               <a:ext uri="{FF2B5EF4-FFF2-40B4-BE49-F238E27FC236}">
-                <a16:creationId xmlns:a16="http://schemas.microsoft.com/office/drawing/2014/main" id="{DE227E14-8B86-4B4D-ABF3-2965E623EEB5}"/>
+                <a16:creationId xmlns:a16="http://schemas.microsoft.com/office/drawing/2014/main" id="{7D0300F4-A6ED-4986-97F0-6EEB2834FB2A}"/>
               </a:ext>
             </a:extLst>
           </p:cNvPr>
@@ -7808,7 +7808,7 @@
           <p:cNvPr id="13" name="risk-3">
             <a:extLst xmlns:a="http://schemas.openxmlformats.org/drawingml/2006/main">
               <a:ext uri="{FF2B5EF4-FFF2-40B4-BE49-F238E27FC236}">
-                <a16:creationId xmlns:a16="http://schemas.microsoft.com/office/drawing/2014/main" id="{86355917-DBCB-459E-AB0A-BCF78E8BCAE8}"/>
+                <a16:creationId xmlns:a16="http://schemas.microsoft.com/office/drawing/2014/main" id="{04272F68-AEDB-4772-888C-DF0447B21451}"/>
               </a:ext>
             </a:extLst>
           </p:cNvPr>
@@ -7843,7 +7843,7 @@
           <p:cNvPr id="14" name="risk-title-3">
             <a:extLst xmlns:a="http://schemas.openxmlformats.org/drawingml/2006/main">
               <a:ext uri="{FF2B5EF4-FFF2-40B4-BE49-F238E27FC236}">
-                <a16:creationId xmlns:a16="http://schemas.microsoft.com/office/drawing/2014/main" id="{73C53DED-BDFA-4237-9E5F-28692AD8E308}"/>
+                <a16:creationId xmlns:a16="http://schemas.microsoft.com/office/drawing/2014/main" id="{04FC9D7B-4825-4CE5-B08E-5B6E6A8C7225}"/>
               </a:ext>
             </a:extLst>
           </p:cNvPr>
@@ -7903,7 +7903,7 @@
           <p:cNvPr id="15" name="risk-copy-3">
             <a:extLst xmlns:a="http://schemas.openxmlformats.org/drawingml/2006/main">
               <a:ext uri="{FF2B5EF4-FFF2-40B4-BE49-F238E27FC236}">
-                <a16:creationId xmlns:a16="http://schemas.microsoft.com/office/drawing/2014/main" id="{9645F269-4EF9-4AED-812E-43B8B71DF296}"/>
+                <a16:creationId xmlns:a16="http://schemas.microsoft.com/office/drawing/2014/main" id="{F1F89881-0CDD-4A49-B948-388B9FC9BBF5}"/>
               </a:ext>
             </a:extLst>
           </p:cNvPr>
@@ -7963,7 +7963,7 @@
           <p:cNvPr id="16" name="gate">
             <a:extLst xmlns:a="http://schemas.openxmlformats.org/drawingml/2006/main">
               <a:ext uri="{FF2B5EF4-FFF2-40B4-BE49-F238E27FC236}">
-                <a16:creationId xmlns:a16="http://schemas.microsoft.com/office/drawing/2014/main" id="{65B3A523-211E-445A-A24D-C4DF59BAE8F4}"/>
+                <a16:creationId xmlns:a16="http://schemas.microsoft.com/office/drawing/2014/main" id="{E06F7C95-32D7-4A87-9807-4DC894CC802D}"/>
               </a:ext>
             </a:extLst>
           </p:cNvPr>
@@ -8027,7 +8027,7 @@
     </p:spTree>
     <p:extLst>
       <p:ext uri="{BB962C8B-B14F-4D97-AF65-F5344CB8AC3E}">
-        <p14:creationId xmlns:p14="http://schemas.microsoft.com/office/powerpoint/2010/main" val="2116275925"/>
+        <p14:creationId xmlns:p14="http://schemas.microsoft.com/office/powerpoint/2010/main" val="872210073"/>
       </p:ext>
     </p:extLst>
   </p:cSld>
@@ -8058,7 +8058,7 @@
           <p:cNvPr id="1" name="eyebrow">
             <a:extLst xmlns:a="http://schemas.openxmlformats.org/drawingml/2006/main">
               <a:ext uri="{FF2B5EF4-FFF2-40B4-BE49-F238E27FC236}">
-                <a16:creationId xmlns:a16="http://schemas.microsoft.com/office/drawing/2014/main" id="{859287FD-A70A-4062-B120-25464D564297}"/>
+                <a16:creationId xmlns:a16="http://schemas.microsoft.com/office/drawing/2014/main" id="{F6C3E50F-9B31-412A-8957-922AF86E4A52}"/>
               </a:ext>
             </a:extLst>
           </p:cNvPr>
@@ -8118,7 +8118,7 @@
           <p:cNvPr id="2" name="title">
             <a:extLst xmlns:a="http://schemas.openxmlformats.org/drawingml/2006/main">
               <a:ext uri="{FF2B5EF4-FFF2-40B4-BE49-F238E27FC236}">
-                <a16:creationId xmlns:a16="http://schemas.microsoft.com/office/drawing/2014/main" id="{D56C1C80-8C6F-47CB-9107-5762006E2945}"/>
+                <a16:creationId xmlns:a16="http://schemas.microsoft.com/office/drawing/2014/main" id="{3BAF9F72-A69E-4179-8F83-767DBDC6F19F}"/>
               </a:ext>
             </a:extLst>
           </p:cNvPr>
@@ -8178,7 +8178,7 @@
           <p:cNvPr id="3" name="footer">
             <a:extLst xmlns:a="http://schemas.openxmlformats.org/drawingml/2006/main">
               <a:ext uri="{FF2B5EF4-FFF2-40B4-BE49-F238E27FC236}">
-                <a16:creationId xmlns:a16="http://schemas.microsoft.com/office/drawing/2014/main" id="{B238F548-5357-4774-95D1-22F6D139B64C}"/>
+                <a16:creationId xmlns:a16="http://schemas.microsoft.com/office/drawing/2014/main" id="{5C9843AD-D338-42BD-89DC-F6FA3A84C337}"/>
               </a:ext>
             </a:extLst>
           </p:cNvPr>
@@ -8238,7 +8238,7 @@
           <p:cNvPr id="4" name="stage-line">
             <a:extLst xmlns:a="http://schemas.openxmlformats.org/drawingml/2006/main">
               <a:ext uri="{FF2B5EF4-FFF2-40B4-BE49-F238E27FC236}">
-                <a16:creationId xmlns:a16="http://schemas.microsoft.com/office/drawing/2014/main" id="{6E06186E-9485-4C88-8205-80C8B7383092}"/>
+                <a16:creationId xmlns:a16="http://schemas.microsoft.com/office/drawing/2014/main" id="{4B34666D-086D-4CA5-8AC6-118A6CECE4F5}"/>
               </a:ext>
             </a:extLst>
           </p:cNvPr>
@@ -8269,7 +8269,7 @@
           <p:cNvPr id="5" name="stage-0">
             <a:extLst xmlns:a="http://schemas.openxmlformats.org/drawingml/2006/main">
               <a:ext uri="{FF2B5EF4-FFF2-40B4-BE49-F238E27FC236}">
-                <a16:creationId xmlns:a16="http://schemas.microsoft.com/office/drawing/2014/main" id="{41B8B634-1B98-49C5-BAA7-C850C0E4EFDE}"/>
+                <a16:creationId xmlns:a16="http://schemas.microsoft.com/office/drawing/2014/main" id="{0F2EC6F2-F9C8-4B14-9DEA-3C565EEA74D0}"/>
               </a:ext>
             </a:extLst>
           </p:cNvPr>
@@ -8335,7 +8335,7 @@
           <p:cNvPr id="6" name="stage-copy-0">
             <a:extLst xmlns:a="http://schemas.openxmlformats.org/drawingml/2006/main">
               <a:ext uri="{FF2B5EF4-FFF2-40B4-BE49-F238E27FC236}">
-                <a16:creationId xmlns:a16="http://schemas.microsoft.com/office/drawing/2014/main" id="{ECA6C3F8-1509-4ECD-84EB-AE0FB31CA735}"/>
+                <a16:creationId xmlns:a16="http://schemas.microsoft.com/office/drawing/2014/main" id="{8E44CB15-1CDB-4EF0-8742-EFDB210C6F01}"/>
               </a:ext>
             </a:extLst>
           </p:cNvPr>
@@ -8395,7 +8395,7 @@
           <p:cNvPr id="7" name="stage-1">
             <a:extLst xmlns:a="http://schemas.openxmlformats.org/drawingml/2006/main">
               <a:ext uri="{FF2B5EF4-FFF2-40B4-BE49-F238E27FC236}">
-                <a16:creationId xmlns:a16="http://schemas.microsoft.com/office/drawing/2014/main" id="{FE2E92CB-0733-4D14-8137-D41E5F296253}"/>
+                <a16:creationId xmlns:a16="http://schemas.microsoft.com/office/drawing/2014/main" id="{1E44E5AC-8B50-4568-9183-C62A4A5C3D90}"/>
               </a:ext>
             </a:extLst>
           </p:cNvPr>
@@ -8461,7 +8461,7 @@
           <p:cNvPr id="8" name="stage-copy-1">
             <a:extLst xmlns:a="http://schemas.openxmlformats.org/drawingml/2006/main">
               <a:ext uri="{FF2B5EF4-FFF2-40B4-BE49-F238E27FC236}">
-                <a16:creationId xmlns:a16="http://schemas.microsoft.com/office/drawing/2014/main" id="{4E596338-51CD-4DBC-9A51-6F103BBB4C03}"/>
+                <a16:creationId xmlns:a16="http://schemas.microsoft.com/office/drawing/2014/main" id="{476FE9FB-33F3-4244-8777-E4BA50D93463}"/>
               </a:ext>
             </a:extLst>
           </p:cNvPr>
@@ -8521,7 +8521,7 @@
           <p:cNvPr id="9" name="stage-2">
             <a:extLst xmlns:a="http://schemas.openxmlformats.org/drawingml/2006/main">
               <a:ext uri="{FF2B5EF4-FFF2-40B4-BE49-F238E27FC236}">
-                <a16:creationId xmlns:a16="http://schemas.microsoft.com/office/drawing/2014/main" id="{5F3C0C13-200D-47E6-858C-DF2E64AA9ADA}"/>
+                <a16:creationId xmlns:a16="http://schemas.microsoft.com/office/drawing/2014/main" id="{ED9775B1-6B95-49BD-8945-614B0BC0154B}"/>
               </a:ext>
             </a:extLst>
           </p:cNvPr>
@@ -8587,7 +8587,7 @@
           <p:cNvPr id="10" name="stage-copy-2">
             <a:extLst xmlns:a="http://schemas.openxmlformats.org/drawingml/2006/main">
               <a:ext uri="{FF2B5EF4-FFF2-40B4-BE49-F238E27FC236}">
-                <a16:creationId xmlns:a16="http://schemas.microsoft.com/office/drawing/2014/main" id="{02B1A5B7-FE99-45D1-9369-97FBF9B3FF5C}"/>
+                <a16:creationId xmlns:a16="http://schemas.microsoft.com/office/drawing/2014/main" id="{2B377C31-8D80-494B-80E0-3E12F3CE594D}"/>
               </a:ext>
             </a:extLst>
           </p:cNvPr>
@@ -8647,7 +8647,7 @@
           <p:cNvPr id="11" name="stage-3">
             <a:extLst xmlns:a="http://schemas.openxmlformats.org/drawingml/2006/main">
               <a:ext uri="{FF2B5EF4-FFF2-40B4-BE49-F238E27FC236}">
-                <a16:creationId xmlns:a16="http://schemas.microsoft.com/office/drawing/2014/main" id="{F538AFBD-94F1-42E1-937F-3F15DDCE12E6}"/>
+                <a16:creationId xmlns:a16="http://schemas.microsoft.com/office/drawing/2014/main" id="{E61F3D2F-7810-4A26-B24C-AB4E04F46777}"/>
               </a:ext>
             </a:extLst>
           </p:cNvPr>
@@ -8713,7 +8713,7 @@
           <p:cNvPr id="12" name="stage-copy-3">
             <a:extLst xmlns:a="http://schemas.openxmlformats.org/drawingml/2006/main">
               <a:ext uri="{FF2B5EF4-FFF2-40B4-BE49-F238E27FC236}">
-                <a16:creationId xmlns:a16="http://schemas.microsoft.com/office/drawing/2014/main" id="{4A1B219F-FECF-4B3A-957E-EC01A9E190B6}"/>
+                <a16:creationId xmlns:a16="http://schemas.microsoft.com/office/drawing/2014/main" id="{5EC5512C-AFCE-4CC2-A0DB-85779F955E15}"/>
               </a:ext>
             </a:extLst>
           </p:cNvPr>
@@ -8773,7 +8773,7 @@
           <p:cNvPr id="13" name="stage-4">
             <a:extLst xmlns:a="http://schemas.openxmlformats.org/drawingml/2006/main">
               <a:ext uri="{FF2B5EF4-FFF2-40B4-BE49-F238E27FC236}">
-                <a16:creationId xmlns:a16="http://schemas.microsoft.com/office/drawing/2014/main" id="{AB7B2CEE-5832-4EB9-B374-1830A2B92D4B}"/>
+                <a16:creationId xmlns:a16="http://schemas.microsoft.com/office/drawing/2014/main" id="{A7B48E9D-D8D1-4AC9-9BEC-4424AB70F858}"/>
               </a:ext>
             </a:extLst>
           </p:cNvPr>
@@ -8839,7 +8839,7 @@
           <p:cNvPr id="14" name="stage-copy-4">
             <a:extLst xmlns:a="http://schemas.openxmlformats.org/drawingml/2006/main">
               <a:ext uri="{FF2B5EF4-FFF2-40B4-BE49-F238E27FC236}">
-                <a16:creationId xmlns:a16="http://schemas.microsoft.com/office/drawing/2014/main" id="{256E09ED-F05E-4ACF-98A2-D14503B62F95}"/>
+                <a16:creationId xmlns:a16="http://schemas.microsoft.com/office/drawing/2014/main" id="{24381248-D5B7-4A03-8654-F2CFB271732B}"/>
               </a:ext>
             </a:extLst>
           </p:cNvPr>
@@ -8899,7 +8899,7 @@
           <p:cNvPr id="15" name="bottom">
             <a:extLst xmlns:a="http://schemas.openxmlformats.org/drawingml/2006/main">
               <a:ext uri="{FF2B5EF4-FFF2-40B4-BE49-F238E27FC236}">
-                <a16:creationId xmlns:a16="http://schemas.microsoft.com/office/drawing/2014/main" id="{812973F3-B304-48C0-A166-B9B715D214C1}"/>
+                <a16:creationId xmlns:a16="http://schemas.microsoft.com/office/drawing/2014/main" id="{84E1F91A-8E25-4521-8429-F1258890060E}"/>
               </a:ext>
             </a:extLst>
           </p:cNvPr>
@@ -8957,7 +8957,7 @@
     </p:spTree>
     <p:extLst>
       <p:ext uri="{BB962C8B-B14F-4D97-AF65-F5344CB8AC3E}">
-        <p14:creationId xmlns:p14="http://schemas.microsoft.com/office/powerpoint/2010/main" val="1499136864"/>
+        <p14:creationId xmlns:p14="http://schemas.microsoft.com/office/powerpoint/2010/main" val="496179582"/>
       </p:ext>
     </p:extLst>
   </p:cSld>
@@ -8988,7 +8988,7 @@
           <p:cNvPr id="1" name="eyebrow">
             <a:extLst xmlns:a="http://schemas.openxmlformats.org/drawingml/2006/main">
               <a:ext uri="{FF2B5EF4-FFF2-40B4-BE49-F238E27FC236}">
-                <a16:creationId xmlns:a16="http://schemas.microsoft.com/office/drawing/2014/main" id="{73FC8600-EE68-47A4-B9FA-2F66DF32E73B}"/>
+                <a16:creationId xmlns:a16="http://schemas.microsoft.com/office/drawing/2014/main" id="{58271306-7411-482D-BB70-C5412D82F3B8}"/>
               </a:ext>
             </a:extLst>
           </p:cNvPr>
@@ -9048,7 +9048,7 @@
           <p:cNvPr id="2" name="title">
             <a:extLst xmlns:a="http://schemas.openxmlformats.org/drawingml/2006/main">
               <a:ext uri="{FF2B5EF4-FFF2-40B4-BE49-F238E27FC236}">
-                <a16:creationId xmlns:a16="http://schemas.microsoft.com/office/drawing/2014/main" id="{54BF0F62-F15C-4CC1-9229-1099C6EFB9E1}"/>
+                <a16:creationId xmlns:a16="http://schemas.microsoft.com/office/drawing/2014/main" id="{8AB41C9C-2DBB-46E9-8BED-6BE7865A7DA1}"/>
               </a:ext>
             </a:extLst>
           </p:cNvPr>
@@ -9108,7 +9108,7 @@
           <p:cNvPr id="3" name="footer">
             <a:extLst xmlns:a="http://schemas.openxmlformats.org/drawingml/2006/main">
               <a:ext uri="{FF2B5EF4-FFF2-40B4-BE49-F238E27FC236}">
-                <a16:creationId xmlns:a16="http://schemas.microsoft.com/office/drawing/2014/main" id="{B34056F0-26D3-4C47-B6D7-A27113FF7E32}"/>
+                <a16:creationId xmlns:a16="http://schemas.microsoft.com/office/drawing/2014/main" id="{1E6EDE67-E120-432F-8686-A8DFFC187C7E}"/>
               </a:ext>
             </a:extLst>
           </p:cNvPr>
@@ -9168,7 +9168,7 @@
           <p:cNvPr id="4" name="line-0">
             <a:extLst xmlns:a="http://schemas.openxmlformats.org/drawingml/2006/main">
               <a:ext uri="{FF2B5EF4-FFF2-40B4-BE49-F238E27FC236}">
-                <a16:creationId xmlns:a16="http://schemas.microsoft.com/office/drawing/2014/main" id="{9220B2FD-15CD-4C4E-9AD6-890B24B0E5A6}"/>
+                <a16:creationId xmlns:a16="http://schemas.microsoft.com/office/drawing/2014/main" id="{14292C54-5927-454F-9E99-303CBD389FAF}"/>
               </a:ext>
             </a:extLst>
           </p:cNvPr>
@@ -9199,7 +9199,7 @@
           <p:cNvPr id="5" name="line-1">
             <a:extLst xmlns:a="http://schemas.openxmlformats.org/drawingml/2006/main">
               <a:ext uri="{FF2B5EF4-FFF2-40B4-BE49-F238E27FC236}">
-                <a16:creationId xmlns:a16="http://schemas.microsoft.com/office/drawing/2014/main" id="{1930A8D9-F21C-4F5A-BD8E-C1B69950C827}"/>
+                <a16:creationId xmlns:a16="http://schemas.microsoft.com/office/drawing/2014/main" id="{12897209-9BF1-416F-929F-D726F0F257FE}"/>
               </a:ext>
             </a:extLst>
           </p:cNvPr>
@@ -9230,7 +9230,7 @@
           <p:cNvPr id="6" name="line-2">
             <a:extLst xmlns:a="http://schemas.openxmlformats.org/drawingml/2006/main">
               <a:ext uri="{FF2B5EF4-FFF2-40B4-BE49-F238E27FC236}">
-                <a16:creationId xmlns:a16="http://schemas.microsoft.com/office/drawing/2014/main" id="{C9C5C302-C0A6-44C6-ADEC-3260F8747BBE}"/>
+                <a16:creationId xmlns:a16="http://schemas.microsoft.com/office/drawing/2014/main" id="{B077CF50-B65C-43C5-B878-B469C3869692}"/>
               </a:ext>
             </a:extLst>
           </p:cNvPr>
@@ -9261,7 +9261,7 @@
           <p:cNvPr id="7" name="line-3">
             <a:extLst xmlns:a="http://schemas.openxmlformats.org/drawingml/2006/main">
               <a:ext uri="{FF2B5EF4-FFF2-40B4-BE49-F238E27FC236}">
-                <a16:creationId xmlns:a16="http://schemas.microsoft.com/office/drawing/2014/main" id="{0E821820-C3EB-4137-BAC9-B89480719CAD}"/>
+                <a16:creationId xmlns:a16="http://schemas.microsoft.com/office/drawing/2014/main" id="{BF91986C-D0FB-4E3A-9BF0-DE80CD7DC0C7}"/>
               </a:ext>
             </a:extLst>
           </p:cNvPr>
@@ -9292,7 +9292,7 @@
           <p:cNvPr id="8" name="line-4">
             <a:extLst xmlns:a="http://schemas.openxmlformats.org/drawingml/2006/main">
               <a:ext uri="{FF2B5EF4-FFF2-40B4-BE49-F238E27FC236}">
-                <a16:creationId xmlns:a16="http://schemas.microsoft.com/office/drawing/2014/main" id="{CD1D415A-2E6A-4FD8-91B3-86088CD9A249}"/>
+                <a16:creationId xmlns:a16="http://schemas.microsoft.com/office/drawing/2014/main" id="{422790E5-7FED-482B-AAD1-5BB5DEEE9DA4}"/>
               </a:ext>
             </a:extLst>
           </p:cNvPr>
@@ -9323,7 +9323,7 @@
           <p:cNvPr id="9" name="num-0">
             <a:extLst xmlns:a="http://schemas.openxmlformats.org/drawingml/2006/main">
               <a:ext uri="{FF2B5EF4-FFF2-40B4-BE49-F238E27FC236}">
-                <a16:creationId xmlns:a16="http://schemas.microsoft.com/office/drawing/2014/main" id="{BB13FF00-F8AB-4BC0-930E-17F1E4A679B9}"/>
+                <a16:creationId xmlns:a16="http://schemas.microsoft.com/office/drawing/2014/main" id="{E21DAC67-4288-4AF5-B312-EF1F41C1145F}"/>
               </a:ext>
             </a:extLst>
           </p:cNvPr>
@@ -9389,7 +9389,7 @@
           <p:cNvPr id="10" name="step-0">
             <a:extLst xmlns:a="http://schemas.openxmlformats.org/drawingml/2006/main">
               <a:ext uri="{FF2B5EF4-FFF2-40B4-BE49-F238E27FC236}">
-                <a16:creationId xmlns:a16="http://schemas.microsoft.com/office/drawing/2014/main" id="{A53A90FA-CFEF-4CEC-9398-55802F6D86EA}"/>
+                <a16:creationId xmlns:a16="http://schemas.microsoft.com/office/drawing/2014/main" id="{8D1FB2E9-A931-4166-96F6-E83BD808E7CB}"/>
               </a:ext>
             </a:extLst>
           </p:cNvPr>
@@ -9482,7 +9482,7 @@
           <p:cNvPr id="11" name="num-1">
             <a:extLst xmlns:a="http://schemas.openxmlformats.org/drawingml/2006/main">
               <a:ext uri="{FF2B5EF4-FFF2-40B4-BE49-F238E27FC236}">
-                <a16:creationId xmlns:a16="http://schemas.microsoft.com/office/drawing/2014/main" id="{2C75CAB6-83FA-4D2E-AA0D-995F4331ADDE}"/>
+                <a16:creationId xmlns:a16="http://schemas.microsoft.com/office/drawing/2014/main" id="{BAA26045-C496-4CFD-A96D-528932CCE474}"/>
               </a:ext>
             </a:extLst>
           </p:cNvPr>
@@ -9548,7 +9548,7 @@
           <p:cNvPr id="12" name="step-1">
             <a:extLst xmlns:a="http://schemas.openxmlformats.org/drawingml/2006/main">
               <a:ext uri="{FF2B5EF4-FFF2-40B4-BE49-F238E27FC236}">
-                <a16:creationId xmlns:a16="http://schemas.microsoft.com/office/drawing/2014/main" id="{2B025AA4-C843-4F88-8670-4FE05B4553A6}"/>
+                <a16:creationId xmlns:a16="http://schemas.microsoft.com/office/drawing/2014/main" id="{C58D52C0-DDEF-43DB-90A2-92A398A8D3AB}"/>
               </a:ext>
             </a:extLst>
           </p:cNvPr>
@@ -9641,7 +9641,7 @@
           <p:cNvPr id="13" name="num-2">
             <a:extLst xmlns:a="http://schemas.openxmlformats.org/drawingml/2006/main">
               <a:ext uri="{FF2B5EF4-FFF2-40B4-BE49-F238E27FC236}">
-                <a16:creationId xmlns:a16="http://schemas.microsoft.com/office/drawing/2014/main" id="{15D0D37F-856C-4DFE-AA5B-D83A27FAA4AA}"/>
+                <a16:creationId xmlns:a16="http://schemas.microsoft.com/office/drawing/2014/main" id="{32559E82-2BE5-4434-95D7-53F2534A57CB}"/>
               </a:ext>
             </a:extLst>
           </p:cNvPr>
@@ -9707,7 +9707,7 @@
           <p:cNvPr id="14" name="step-2">
             <a:extLst xmlns:a="http://schemas.openxmlformats.org/drawingml/2006/main">
               <a:ext uri="{FF2B5EF4-FFF2-40B4-BE49-F238E27FC236}">
-                <a16:creationId xmlns:a16="http://schemas.microsoft.com/office/drawing/2014/main" id="{CB4B16B1-6EC1-45B4-8E9B-F56EFA43BA42}"/>
+                <a16:creationId xmlns:a16="http://schemas.microsoft.com/office/drawing/2014/main" id="{B68CCA46-21ED-4DBE-B365-CC11A0E9E33F}"/>
               </a:ext>
             </a:extLst>
           </p:cNvPr>
@@ -9800,7 +9800,7 @@
           <p:cNvPr id="15" name="num-3">
             <a:extLst xmlns:a="http://schemas.openxmlformats.org/drawingml/2006/main">
               <a:ext uri="{FF2B5EF4-FFF2-40B4-BE49-F238E27FC236}">
-                <a16:creationId xmlns:a16="http://schemas.microsoft.com/office/drawing/2014/main" id="{A4D2CBE8-F3E0-4E14-B3CC-96150FC8DA20}"/>
+                <a16:creationId xmlns:a16="http://schemas.microsoft.com/office/drawing/2014/main" id="{6F0C5C59-3828-4E25-8DDE-AFDAF9676C47}"/>
               </a:ext>
             </a:extLst>
           </p:cNvPr>
@@ -9866,7 +9866,7 @@
           <p:cNvPr id="16" name="step-3">
             <a:extLst xmlns:a="http://schemas.openxmlformats.org/drawingml/2006/main">
               <a:ext uri="{FF2B5EF4-FFF2-40B4-BE49-F238E27FC236}">
-                <a16:creationId xmlns:a16="http://schemas.microsoft.com/office/drawing/2014/main" id="{58CDA92B-3A0A-44E9-A002-0F396420D248}"/>
+                <a16:creationId xmlns:a16="http://schemas.microsoft.com/office/drawing/2014/main" id="{F115F7B2-49E5-44A8-9A84-84AAD18C0CB3}"/>
               </a:ext>
             </a:extLst>
           </p:cNvPr>
@@ -9959,7 +9959,7 @@
           <p:cNvPr id="17" name="num-4">
             <a:extLst xmlns:a="http://schemas.openxmlformats.org/drawingml/2006/main">
               <a:ext uri="{FF2B5EF4-FFF2-40B4-BE49-F238E27FC236}">
-                <a16:creationId xmlns:a16="http://schemas.microsoft.com/office/drawing/2014/main" id="{458A0532-8203-4562-9100-89B9B25787B0}"/>
+                <a16:creationId xmlns:a16="http://schemas.microsoft.com/office/drawing/2014/main" id="{084CA9CD-E87D-4E23-A5EC-EE174295CA7C}"/>
               </a:ext>
             </a:extLst>
           </p:cNvPr>
@@ -10025,7 +10025,7 @@
           <p:cNvPr id="18" name="step-4">
             <a:extLst xmlns:a="http://schemas.openxmlformats.org/drawingml/2006/main">
               <a:ext uri="{FF2B5EF4-FFF2-40B4-BE49-F238E27FC236}">
-                <a16:creationId xmlns:a16="http://schemas.microsoft.com/office/drawing/2014/main" id="{68EB709F-C9A9-402A-900B-9155AFE4FECD}"/>
+                <a16:creationId xmlns:a16="http://schemas.microsoft.com/office/drawing/2014/main" id="{926BD4A2-126A-4866-9DB2-1D2F3105E7A3}"/>
               </a:ext>
             </a:extLst>
           </p:cNvPr>
@@ -10118,7 +10118,7 @@
           <p:cNvPr id="19" name="num-5">
             <a:extLst xmlns:a="http://schemas.openxmlformats.org/drawingml/2006/main">
               <a:ext uri="{FF2B5EF4-FFF2-40B4-BE49-F238E27FC236}">
-                <a16:creationId xmlns:a16="http://schemas.microsoft.com/office/drawing/2014/main" id="{88398150-60FE-4F4A-8198-D54625E5F32F}"/>
+                <a16:creationId xmlns:a16="http://schemas.microsoft.com/office/drawing/2014/main" id="{F4917239-EEFA-4EEC-9E60-B5ED41247570}"/>
               </a:ext>
             </a:extLst>
           </p:cNvPr>
@@ -10184,7 +10184,7 @@
           <p:cNvPr id="20" name="step-5">
             <a:extLst xmlns:a="http://schemas.openxmlformats.org/drawingml/2006/main">
               <a:ext uri="{FF2B5EF4-FFF2-40B4-BE49-F238E27FC236}">
-                <a16:creationId xmlns:a16="http://schemas.microsoft.com/office/drawing/2014/main" id="{E4112D7C-E024-44E3-B734-2AC786C0D872}"/>
+                <a16:creationId xmlns:a16="http://schemas.microsoft.com/office/drawing/2014/main" id="{59D276F6-DD23-4637-8862-F2507A3AEAF7}"/>
               </a:ext>
             </a:extLst>
           </p:cNvPr>
@@ -10277,7 +10277,7 @@
           <p:cNvPr id="21" name="rule">
             <a:extLst xmlns:a="http://schemas.openxmlformats.org/drawingml/2006/main">
               <a:ext uri="{FF2B5EF4-FFF2-40B4-BE49-F238E27FC236}">
-                <a16:creationId xmlns:a16="http://schemas.microsoft.com/office/drawing/2014/main" id="{689AAF43-4A7C-456F-A84E-6E687F532452}"/>
+                <a16:creationId xmlns:a16="http://schemas.microsoft.com/office/drawing/2014/main" id="{CB85483A-9F75-4290-8FD1-432235D9AF45}"/>
               </a:ext>
             </a:extLst>
           </p:cNvPr>
@@ -10312,7 +10312,7 @@
           <p:cNvPr id="22" name="rule-text">
             <a:extLst xmlns:a="http://schemas.openxmlformats.org/drawingml/2006/main">
               <a:ext uri="{FF2B5EF4-FFF2-40B4-BE49-F238E27FC236}">
-                <a16:creationId xmlns:a16="http://schemas.microsoft.com/office/drawing/2014/main" id="{AFB61667-DD66-429A-BAE1-BE827F1B3B26}"/>
+                <a16:creationId xmlns:a16="http://schemas.microsoft.com/office/drawing/2014/main" id="{8492B3E8-866C-4A67-9FAC-8866B458F324}"/>
               </a:ext>
             </a:extLst>
           </p:cNvPr>
@@ -10370,7 +10370,7 @@
     </p:spTree>
     <p:extLst>
       <p:ext uri="{BB962C8B-B14F-4D97-AF65-F5344CB8AC3E}">
-        <p14:creationId xmlns:p14="http://schemas.microsoft.com/office/powerpoint/2010/main" val="390001760"/>
+        <p14:creationId xmlns:p14="http://schemas.microsoft.com/office/powerpoint/2010/main" val="1119649753"/>
       </p:ext>
     </p:extLst>
   </p:cSld>
@@ -10401,7 +10401,7 @@
           <p:cNvPr id="1" name="eyebrow">
             <a:extLst xmlns:a="http://schemas.openxmlformats.org/drawingml/2006/main">
               <a:ext uri="{FF2B5EF4-FFF2-40B4-BE49-F238E27FC236}">
-                <a16:creationId xmlns:a16="http://schemas.microsoft.com/office/drawing/2014/main" id="{B72FFB9F-D25B-4EA8-BE45-AF0B9E28B026}"/>
+                <a16:creationId xmlns:a16="http://schemas.microsoft.com/office/drawing/2014/main" id="{E4BF93A2-AE54-4C7D-879B-E9C08D75A670}"/>
               </a:ext>
             </a:extLst>
           </p:cNvPr>
@@ -10461,7 +10461,7 @@
           <p:cNvPr id="2" name="title">
             <a:extLst xmlns:a="http://schemas.openxmlformats.org/drawingml/2006/main">
               <a:ext uri="{FF2B5EF4-FFF2-40B4-BE49-F238E27FC236}">
-                <a16:creationId xmlns:a16="http://schemas.microsoft.com/office/drawing/2014/main" id="{7B0832AD-165C-4CAB-BD89-FC1C8D791BD8}"/>
+                <a16:creationId xmlns:a16="http://schemas.microsoft.com/office/drawing/2014/main" id="{98382C73-412D-4046-A90F-5E8812CB3844}"/>
               </a:ext>
             </a:extLst>
           </p:cNvPr>
@@ -10521,7 +10521,7 @@
           <p:cNvPr id="3" name="footer">
             <a:extLst xmlns:a="http://schemas.openxmlformats.org/drawingml/2006/main">
               <a:ext uri="{FF2B5EF4-FFF2-40B4-BE49-F238E27FC236}">
-                <a16:creationId xmlns:a16="http://schemas.microsoft.com/office/drawing/2014/main" id="{8DDEE044-68FA-4C18-922B-093AD6A332D5}"/>
+                <a16:creationId xmlns:a16="http://schemas.microsoft.com/office/drawing/2014/main" id="{28D5D4A5-52EB-4200-A90A-1F2AA09DB7A1}"/>
               </a:ext>
             </a:extLst>
           </p:cNvPr>
@@ -10581,7 +10581,7 @@
           <p:cNvPr id="4" name="matrix">
             <a:extLst xmlns:a="http://schemas.openxmlformats.org/drawingml/2006/main">
               <a:ext uri="{FF2B5EF4-FFF2-40B4-BE49-F238E27FC236}">
-                <a16:creationId xmlns:a16="http://schemas.microsoft.com/office/drawing/2014/main" id="{8D5A1082-214E-470C-A1B3-92A0F696E5DE}"/>
+                <a16:creationId xmlns:a16="http://schemas.microsoft.com/office/drawing/2014/main" id="{DE8819CE-BE9A-487F-BD2A-23E11D340C2E}"/>
               </a:ext>
             </a:extLst>
           </p:cNvPr>
@@ -10616,7 +10616,7 @@
           <p:cNvPr id="5" name="vline">
             <a:extLst xmlns:a="http://schemas.openxmlformats.org/drawingml/2006/main">
               <a:ext uri="{FF2B5EF4-FFF2-40B4-BE49-F238E27FC236}">
-                <a16:creationId xmlns:a16="http://schemas.microsoft.com/office/drawing/2014/main" id="{9D68AC19-0A69-48FC-85C2-779D54C37745}"/>
+                <a16:creationId xmlns:a16="http://schemas.microsoft.com/office/drawing/2014/main" id="{2D2CED92-03D7-418F-8634-453888DAB9B8}"/>
               </a:ext>
             </a:extLst>
           </p:cNvPr>
@@ -10647,7 +10647,7 @@
           <p:cNvPr id="6" name="hline">
             <a:extLst xmlns:a="http://schemas.openxmlformats.org/drawingml/2006/main">
               <a:ext uri="{FF2B5EF4-FFF2-40B4-BE49-F238E27FC236}">
-                <a16:creationId xmlns:a16="http://schemas.microsoft.com/office/drawing/2014/main" id="{AB9A9878-15F0-46C9-8774-32DE29F5BA1F}"/>
+                <a16:creationId xmlns:a16="http://schemas.microsoft.com/office/drawing/2014/main" id="{22A9E93B-CA5D-44CA-B194-4C7F87359849}"/>
               </a:ext>
             </a:extLst>
           </p:cNvPr>
@@ -10678,7 +10678,7 @@
           <p:cNvPr id="7" name="axis-x">
             <a:extLst xmlns:a="http://schemas.openxmlformats.org/drawingml/2006/main">
               <a:ext uri="{FF2B5EF4-FFF2-40B4-BE49-F238E27FC236}">
-                <a16:creationId xmlns:a16="http://schemas.microsoft.com/office/drawing/2014/main" id="{5F4783F2-F86C-4269-9538-34EDD13EE00C}"/>
+                <a16:creationId xmlns:a16="http://schemas.microsoft.com/office/drawing/2014/main" id="{FC932ECB-BC5B-4CE3-97CA-9834A4F62767}"/>
               </a:ext>
             </a:extLst>
           </p:cNvPr>
@@ -10738,7 +10738,7 @@
           <p:cNvPr id="8" name="axis-y">
             <a:extLst xmlns:a="http://schemas.openxmlformats.org/drawingml/2006/main">
               <a:ext uri="{FF2B5EF4-FFF2-40B4-BE49-F238E27FC236}">
-                <a16:creationId xmlns:a16="http://schemas.microsoft.com/office/drawing/2014/main" id="{87D8B31D-C041-43AC-9753-30B05C529366}"/>
+                <a16:creationId xmlns:a16="http://schemas.microsoft.com/office/drawing/2014/main" id="{263F27ED-D3DD-48BF-A478-6E03AF60A7E4}"/>
               </a:ext>
             </a:extLst>
           </p:cNvPr>
@@ -10798,7 +10798,7 @@
           <p:cNvPr id="9" name="q1">
             <a:extLst xmlns:a="http://schemas.openxmlformats.org/drawingml/2006/main">
               <a:ext uri="{FF2B5EF4-FFF2-40B4-BE49-F238E27FC236}">
-                <a16:creationId xmlns:a16="http://schemas.microsoft.com/office/drawing/2014/main" id="{E192A701-9A49-480F-BBA7-C51F29C99832}"/>
+                <a16:creationId xmlns:a16="http://schemas.microsoft.com/office/drawing/2014/main" id="{72261CEE-1532-4C3B-AB2B-FF446C684A59}"/>
               </a:ext>
             </a:extLst>
           </p:cNvPr>
@@ -10885,7 +10885,7 @@
           <p:cNvPr id="10" name="q2">
             <a:extLst xmlns:a="http://schemas.openxmlformats.org/drawingml/2006/main">
               <a:ext uri="{FF2B5EF4-FFF2-40B4-BE49-F238E27FC236}">
-                <a16:creationId xmlns:a16="http://schemas.microsoft.com/office/drawing/2014/main" id="{22D87111-599C-4EB1-ADC7-627B369D6389}"/>
+                <a16:creationId xmlns:a16="http://schemas.microsoft.com/office/drawing/2014/main" id="{1FF766FF-ED56-4A2D-99E6-F468E044E383}"/>
               </a:ext>
             </a:extLst>
           </p:cNvPr>
@@ -10972,7 +10972,7 @@
           <p:cNvPr id="11" name="q3">
             <a:extLst xmlns:a="http://schemas.openxmlformats.org/drawingml/2006/main">
               <a:ext uri="{FF2B5EF4-FFF2-40B4-BE49-F238E27FC236}">
-                <a16:creationId xmlns:a16="http://schemas.microsoft.com/office/drawing/2014/main" id="{47D6BC4E-6F8A-43DC-885F-81BF25CE91CC}"/>
+                <a16:creationId xmlns:a16="http://schemas.microsoft.com/office/drawing/2014/main" id="{07EEE72E-AACE-482B-B777-FA4076D541D9}"/>
               </a:ext>
             </a:extLst>
           </p:cNvPr>
@@ -11059,7 +11059,7 @@
           <p:cNvPr id="12" name="q4">
             <a:extLst xmlns:a="http://schemas.openxmlformats.org/drawingml/2006/main">
               <a:ext uri="{FF2B5EF4-FFF2-40B4-BE49-F238E27FC236}">
-                <a16:creationId xmlns:a16="http://schemas.microsoft.com/office/drawing/2014/main" id="{A4172C8F-1B69-4EE8-8431-232E69D6AC9E}"/>
+                <a16:creationId xmlns:a16="http://schemas.microsoft.com/office/drawing/2014/main" id="{BFDBC86A-6A4D-4F72-AADE-8D9C1FE07CE9}"/>
               </a:ext>
             </a:extLst>
           </p:cNvPr>
@@ -11173,7 +11173,7 @@
           <p:cNvPr id="13" name="matrix-note">
             <a:extLst xmlns:a="http://schemas.openxmlformats.org/drawingml/2006/main">
               <a:ext uri="{FF2B5EF4-FFF2-40B4-BE49-F238E27FC236}">
-                <a16:creationId xmlns:a16="http://schemas.microsoft.com/office/drawing/2014/main" id="{1E3C56C0-07A6-4B34-8380-50781AC2C5A6}"/>
+                <a16:creationId xmlns:a16="http://schemas.microsoft.com/office/drawing/2014/main" id="{095F1B9F-429E-458F-8CD0-B1FED9C1C74B}"/>
               </a:ext>
             </a:extLst>
           </p:cNvPr>
@@ -11231,7 +11231,7 @@
     </p:spTree>
     <p:extLst>
       <p:ext uri="{BB962C8B-B14F-4D97-AF65-F5344CB8AC3E}">
-        <p14:creationId xmlns:p14="http://schemas.microsoft.com/office/powerpoint/2010/main" val="1361723133"/>
+        <p14:creationId xmlns:p14="http://schemas.microsoft.com/office/powerpoint/2010/main" val="620447882"/>
       </p:ext>
     </p:extLst>
   </p:cSld>
@@ -11262,7 +11262,7 @@
           <p:cNvPr id="1" name="eyebrow">
             <a:extLst xmlns:a="http://schemas.openxmlformats.org/drawingml/2006/main">
               <a:ext uri="{FF2B5EF4-FFF2-40B4-BE49-F238E27FC236}">
-                <a16:creationId xmlns:a16="http://schemas.microsoft.com/office/drawing/2014/main" id="{D7419C70-0E01-46BE-9896-9FD76EF1DE98}"/>
+                <a16:creationId xmlns:a16="http://schemas.microsoft.com/office/drawing/2014/main" id="{92534ECA-DB63-4B67-B159-00FBF3B79C06}"/>
               </a:ext>
             </a:extLst>
           </p:cNvPr>
@@ -11322,7 +11322,7 @@
           <p:cNvPr id="2" name="title">
             <a:extLst xmlns:a="http://schemas.openxmlformats.org/drawingml/2006/main">
               <a:ext uri="{FF2B5EF4-FFF2-40B4-BE49-F238E27FC236}">
-                <a16:creationId xmlns:a16="http://schemas.microsoft.com/office/drawing/2014/main" id="{04974177-E9F8-4E3A-9EB3-5B2FC938DAB6}"/>
+                <a16:creationId xmlns:a16="http://schemas.microsoft.com/office/drawing/2014/main" id="{72D0082A-C9E0-458D-8824-72742EFB17E4}"/>
               </a:ext>
             </a:extLst>
           </p:cNvPr>
@@ -11382,7 +11382,7 @@
           <p:cNvPr id="3" name="footer">
             <a:extLst xmlns:a="http://schemas.openxmlformats.org/drawingml/2006/main">
               <a:ext uri="{FF2B5EF4-FFF2-40B4-BE49-F238E27FC236}">
-                <a16:creationId xmlns:a16="http://schemas.microsoft.com/office/drawing/2014/main" id="{9F377230-78E3-42BE-8A7E-9039F14DACA7}"/>
+                <a16:creationId xmlns:a16="http://schemas.microsoft.com/office/drawing/2014/main" id="{13AFC467-A959-402A-AEFF-F9A6D8B8CDFA}"/>
               </a:ext>
             </a:extLst>
           </p:cNvPr>
@@ -11442,7 +11442,7 @@
           <p:cNvPr id="4" name="tool-0">
             <a:extLst xmlns:a="http://schemas.openxmlformats.org/drawingml/2006/main">
               <a:ext uri="{FF2B5EF4-FFF2-40B4-BE49-F238E27FC236}">
-                <a16:creationId xmlns:a16="http://schemas.microsoft.com/office/drawing/2014/main" id="{577C1AB6-7ED4-410D-8433-6D380D14E237}"/>
+                <a16:creationId xmlns:a16="http://schemas.microsoft.com/office/drawing/2014/main" id="{E73E4FA4-8D34-4B09-B193-B7429F3B28B0}"/>
               </a:ext>
             </a:extLst>
           </p:cNvPr>
@@ -11508,7 +11508,7 @@
           <p:cNvPr id="5" name="use-0">
             <a:extLst xmlns:a="http://schemas.openxmlformats.org/drawingml/2006/main">
               <a:ext uri="{FF2B5EF4-FFF2-40B4-BE49-F238E27FC236}">
-                <a16:creationId xmlns:a16="http://schemas.microsoft.com/office/drawing/2014/main" id="{DF111896-D4B6-4C52-BA7C-604847121206}"/>
+                <a16:creationId xmlns:a16="http://schemas.microsoft.com/office/drawing/2014/main" id="{4B59A548-C20B-4DA8-8A49-E1FF11D9076F}"/>
               </a:ext>
             </a:extLst>
           </p:cNvPr>
@@ -11568,7 +11568,7 @@
           <p:cNvPr id="6" name="link-0">
             <a:extLst xmlns:a="http://schemas.openxmlformats.org/drawingml/2006/main">
               <a:ext uri="{FF2B5EF4-FFF2-40B4-BE49-F238E27FC236}">
-                <a16:creationId xmlns:a16="http://schemas.microsoft.com/office/drawing/2014/main" id="{0416A738-3644-464E-BE76-299332F27D82}"/>
+                <a16:creationId xmlns:a16="http://schemas.microsoft.com/office/drawing/2014/main" id="{C4BC16A4-36CB-45D8-9527-D182704F589C}"/>
               </a:ext>
             </a:extLst>
           </p:cNvPr>
@@ -11599,7 +11599,7 @@
           <p:cNvPr id="7" name="tool-1">
             <a:extLst xmlns:a="http://schemas.openxmlformats.org/drawingml/2006/main">
               <a:ext uri="{FF2B5EF4-FFF2-40B4-BE49-F238E27FC236}">
-                <a16:creationId xmlns:a16="http://schemas.microsoft.com/office/drawing/2014/main" id="{434CED7A-2FFC-4C5A-B30A-BD6A474DEF04}"/>
+                <a16:creationId xmlns:a16="http://schemas.microsoft.com/office/drawing/2014/main" id="{7C12F47A-14B4-40ED-80CC-BD7550D5DDD5}"/>
               </a:ext>
             </a:extLst>
           </p:cNvPr>
@@ -11665,7 +11665,7 @@
           <p:cNvPr id="8" name="use-1">
             <a:extLst xmlns:a="http://schemas.openxmlformats.org/drawingml/2006/main">
               <a:ext uri="{FF2B5EF4-FFF2-40B4-BE49-F238E27FC236}">
-                <a16:creationId xmlns:a16="http://schemas.microsoft.com/office/drawing/2014/main" id="{7A3E6F6C-3079-4B80-9DAA-96DE0A8E31F6}"/>
+                <a16:creationId xmlns:a16="http://schemas.microsoft.com/office/drawing/2014/main" id="{D2B5CB00-F190-4748-96C3-62811D18986F}"/>
               </a:ext>
             </a:extLst>
           </p:cNvPr>
@@ -11725,7 +11725,7 @@
           <p:cNvPr id="9" name="link-1">
             <a:extLst xmlns:a="http://schemas.openxmlformats.org/drawingml/2006/main">
               <a:ext uri="{FF2B5EF4-FFF2-40B4-BE49-F238E27FC236}">
-                <a16:creationId xmlns:a16="http://schemas.microsoft.com/office/drawing/2014/main" id="{C844A3BD-A70E-4E6A-AB98-F7D2A5E140FA}"/>
+                <a16:creationId xmlns:a16="http://schemas.microsoft.com/office/drawing/2014/main" id="{F45E2D73-9BC5-469B-A6F9-529E31EB7A8C}"/>
               </a:ext>
             </a:extLst>
           </p:cNvPr>
@@ -11756,7 +11756,7 @@
           <p:cNvPr id="10" name="tool-2">
             <a:extLst xmlns:a="http://schemas.openxmlformats.org/drawingml/2006/main">
               <a:ext uri="{FF2B5EF4-FFF2-40B4-BE49-F238E27FC236}">
-                <a16:creationId xmlns:a16="http://schemas.microsoft.com/office/drawing/2014/main" id="{1676A348-6869-4835-BA20-1D3336E603AD}"/>
+                <a16:creationId xmlns:a16="http://schemas.microsoft.com/office/drawing/2014/main" id="{EFAF53C2-21DA-405A-A74D-806D05977DA5}"/>
               </a:ext>
             </a:extLst>
           </p:cNvPr>
@@ -11822,7 +11822,7 @@
           <p:cNvPr id="11" name="use-2">
             <a:extLst xmlns:a="http://schemas.openxmlformats.org/drawingml/2006/main">
               <a:ext uri="{FF2B5EF4-FFF2-40B4-BE49-F238E27FC236}">
-                <a16:creationId xmlns:a16="http://schemas.microsoft.com/office/drawing/2014/main" id="{28D70438-1C28-4F38-85CB-3A896D07FEA7}"/>
+                <a16:creationId xmlns:a16="http://schemas.microsoft.com/office/drawing/2014/main" id="{265753F6-C545-4BFA-B320-624427ED0B30}"/>
               </a:ext>
             </a:extLst>
           </p:cNvPr>
@@ -11882,7 +11882,7 @@
           <p:cNvPr id="12" name="link-2">
             <a:extLst xmlns:a="http://schemas.openxmlformats.org/drawingml/2006/main">
               <a:ext uri="{FF2B5EF4-FFF2-40B4-BE49-F238E27FC236}">
-                <a16:creationId xmlns:a16="http://schemas.microsoft.com/office/drawing/2014/main" id="{565BAFDA-6B18-4303-B048-6741BA832A8B}"/>
+                <a16:creationId xmlns:a16="http://schemas.microsoft.com/office/drawing/2014/main" id="{30A348C4-24EF-4DD4-9357-C00AB3BB269C}"/>
               </a:ext>
             </a:extLst>
           </p:cNvPr>
@@ -11913,7 +11913,7 @@
           <p:cNvPr id="13" name="tool-3">
             <a:extLst xmlns:a="http://schemas.openxmlformats.org/drawingml/2006/main">
               <a:ext uri="{FF2B5EF4-FFF2-40B4-BE49-F238E27FC236}">
-                <a16:creationId xmlns:a16="http://schemas.microsoft.com/office/drawing/2014/main" id="{D0B43EC7-2A81-49A5-92A9-AF41CC063948}"/>
+                <a16:creationId xmlns:a16="http://schemas.microsoft.com/office/drawing/2014/main" id="{B4725E87-4705-402C-853F-A1509FA68B4D}"/>
               </a:ext>
             </a:extLst>
           </p:cNvPr>
@@ -11979,7 +11979,7 @@
           <p:cNvPr id="14" name="use-3">
             <a:extLst xmlns:a="http://schemas.openxmlformats.org/drawingml/2006/main">
               <a:ext uri="{FF2B5EF4-FFF2-40B4-BE49-F238E27FC236}">
-                <a16:creationId xmlns:a16="http://schemas.microsoft.com/office/drawing/2014/main" id="{9246FB28-80FE-4E80-85D5-3213B6371719}"/>
+                <a16:creationId xmlns:a16="http://schemas.microsoft.com/office/drawing/2014/main" id="{3311DF62-302D-47D9-8F11-68087E1A5EB7}"/>
               </a:ext>
             </a:extLst>
           </p:cNvPr>
@@ -12039,7 +12039,7 @@
           <p:cNvPr id="15" name="link-3">
             <a:extLst xmlns:a="http://schemas.openxmlformats.org/drawingml/2006/main">
               <a:ext uri="{FF2B5EF4-FFF2-40B4-BE49-F238E27FC236}">
-                <a16:creationId xmlns:a16="http://schemas.microsoft.com/office/drawing/2014/main" id="{B3CFD359-598C-4FA8-AB94-F9A35994CE76}"/>
+                <a16:creationId xmlns:a16="http://schemas.microsoft.com/office/drawing/2014/main" id="{E6F76051-6CD5-4EA1-856C-2F5C5F9082CF}"/>
               </a:ext>
             </a:extLst>
           </p:cNvPr>
@@ -12070,7 +12070,7 @@
           <p:cNvPr id="16" name="tool-4">
             <a:extLst xmlns:a="http://schemas.openxmlformats.org/drawingml/2006/main">
               <a:ext uri="{FF2B5EF4-FFF2-40B4-BE49-F238E27FC236}">
-                <a16:creationId xmlns:a16="http://schemas.microsoft.com/office/drawing/2014/main" id="{61101910-C7C2-4DF8-9590-9060D4453DDD}"/>
+                <a16:creationId xmlns:a16="http://schemas.microsoft.com/office/drawing/2014/main" id="{B52C0187-A230-43A1-8A88-F1C2B13A3622}"/>
               </a:ext>
             </a:extLst>
           </p:cNvPr>
@@ -12136,7 +12136,7 @@
           <p:cNvPr id="17" name="use-4">
             <a:extLst xmlns:a="http://schemas.openxmlformats.org/drawingml/2006/main">
               <a:ext uri="{FF2B5EF4-FFF2-40B4-BE49-F238E27FC236}">
-                <a16:creationId xmlns:a16="http://schemas.microsoft.com/office/drawing/2014/main" id="{5B656EC8-BA81-424E-B288-82EB03E53730}"/>
+                <a16:creationId xmlns:a16="http://schemas.microsoft.com/office/drawing/2014/main" id="{8E7E00AC-2384-451F-A9F5-A29C47ADB5BC}"/>
               </a:ext>
             </a:extLst>
           </p:cNvPr>
@@ -12196,7 +12196,7 @@
           <p:cNvPr id="18" name="link-4">
             <a:extLst xmlns:a="http://schemas.openxmlformats.org/drawingml/2006/main">
               <a:ext uri="{FF2B5EF4-FFF2-40B4-BE49-F238E27FC236}">
-                <a16:creationId xmlns:a16="http://schemas.microsoft.com/office/drawing/2014/main" id="{5FCFAA49-3CCB-4228-B0C8-F30A14E3114A}"/>
+                <a16:creationId xmlns:a16="http://schemas.microsoft.com/office/drawing/2014/main" id="{2164D435-8954-4372-8B8D-296EB8858BBF}"/>
               </a:ext>
             </a:extLst>
           </p:cNvPr>
@@ -12227,7 +12227,7 @@
           <p:cNvPr id="19" name="bottom">
             <a:extLst xmlns:a="http://schemas.openxmlformats.org/drawingml/2006/main">
               <a:ext uri="{FF2B5EF4-FFF2-40B4-BE49-F238E27FC236}">
-                <a16:creationId xmlns:a16="http://schemas.microsoft.com/office/drawing/2014/main" id="{E90B2C3C-86B7-44BC-BB5F-9ECBAF985FC2}"/>
+                <a16:creationId xmlns:a16="http://schemas.microsoft.com/office/drawing/2014/main" id="{B037D0F3-5A74-4AE5-BBC6-43A6CE866CA3}"/>
               </a:ext>
             </a:extLst>
           </p:cNvPr>
@@ -12285,7 +12285,7 @@
     </p:spTree>
     <p:extLst>
       <p:ext uri="{BB962C8B-B14F-4D97-AF65-F5344CB8AC3E}">
-        <p14:creationId xmlns:p14="http://schemas.microsoft.com/office/powerpoint/2010/main" val="1440693918"/>
+        <p14:creationId xmlns:p14="http://schemas.microsoft.com/office/powerpoint/2010/main" val="1646394166"/>
       </p:ext>
     </p:extLst>
   </p:cSld>
@@ -12316,7 +12316,7 @@
           <p:cNvPr id="1" name="eyebrow">
             <a:extLst xmlns:a="http://schemas.openxmlformats.org/drawingml/2006/main">
               <a:ext uri="{FF2B5EF4-FFF2-40B4-BE49-F238E27FC236}">
-                <a16:creationId xmlns:a16="http://schemas.microsoft.com/office/drawing/2014/main" id="{976EC8F1-D1AA-477B-BDAE-634D0D181D00}"/>
+                <a16:creationId xmlns:a16="http://schemas.microsoft.com/office/drawing/2014/main" id="{C2ADFD5D-D118-4E25-BAA4-3420C42DB758}"/>
               </a:ext>
             </a:extLst>
           </p:cNvPr>
@@ -12376,7 +12376,7 @@
           <p:cNvPr id="2" name="title">
             <a:extLst xmlns:a="http://schemas.openxmlformats.org/drawingml/2006/main">
               <a:ext uri="{FF2B5EF4-FFF2-40B4-BE49-F238E27FC236}">
-                <a16:creationId xmlns:a16="http://schemas.microsoft.com/office/drawing/2014/main" id="{3ADABC75-930A-4136-BBF0-1B51BC2CF60B}"/>
+                <a16:creationId xmlns:a16="http://schemas.microsoft.com/office/drawing/2014/main" id="{80CEB763-ACF3-45F9-AD41-56BE5319FC1D}"/>
               </a:ext>
             </a:extLst>
           </p:cNvPr>
@@ -12436,7 +12436,7 @@
           <p:cNvPr id="3" name="footer">
             <a:extLst xmlns:a="http://schemas.openxmlformats.org/drawingml/2006/main">
               <a:ext uri="{FF2B5EF4-FFF2-40B4-BE49-F238E27FC236}">
-                <a16:creationId xmlns:a16="http://schemas.microsoft.com/office/drawing/2014/main" id="{AD6644C2-B7DC-4126-A8EC-5AEB245346B6}"/>
+                <a16:creationId xmlns:a16="http://schemas.microsoft.com/office/drawing/2014/main" id="{F4912175-4026-4138-9C47-571C5505D33B}"/>
               </a:ext>
             </a:extLst>
           </p:cNvPr>
@@ -12496,7 +12496,7 @@
           <p:cNvPr id="4" name="flow">
             <a:extLst xmlns:a="http://schemas.openxmlformats.org/drawingml/2006/main">
               <a:ext uri="{FF2B5EF4-FFF2-40B4-BE49-F238E27FC236}">
-                <a16:creationId xmlns:a16="http://schemas.microsoft.com/office/drawing/2014/main" id="{A04BBBF4-3CE6-43F1-B1D2-64860E2E60EA}"/>
+                <a16:creationId xmlns:a16="http://schemas.microsoft.com/office/drawing/2014/main" id="{F58EB261-E3F1-41FB-801B-F1FC427D0595}"/>
               </a:ext>
             </a:extLst>
           </p:cNvPr>
@@ -12527,7 +12527,7 @@
           <p:cNvPr id="5" name="step-0">
             <a:extLst xmlns:a="http://schemas.openxmlformats.org/drawingml/2006/main">
               <a:ext uri="{FF2B5EF4-FFF2-40B4-BE49-F238E27FC236}">
-                <a16:creationId xmlns:a16="http://schemas.microsoft.com/office/drawing/2014/main" id="{686C3CEC-602B-4742-B87A-15992F3E84D9}"/>
+                <a16:creationId xmlns:a16="http://schemas.microsoft.com/office/drawing/2014/main" id="{F43C311A-2D47-40A0-9305-A68BA6A101A3}"/>
               </a:ext>
             </a:extLst>
           </p:cNvPr>
@@ -12593,7 +12593,7 @@
           <p:cNvPr id="6" name="copy-0">
             <a:extLst xmlns:a="http://schemas.openxmlformats.org/drawingml/2006/main">
               <a:ext uri="{FF2B5EF4-FFF2-40B4-BE49-F238E27FC236}">
-                <a16:creationId xmlns:a16="http://schemas.microsoft.com/office/drawing/2014/main" id="{FCB7AFC1-30D4-47AB-86AA-239AC30B9E24}"/>
+                <a16:creationId xmlns:a16="http://schemas.microsoft.com/office/drawing/2014/main" id="{6FE54B51-2D34-4703-8B1E-AD4A9AD51C5B}"/>
               </a:ext>
             </a:extLst>
           </p:cNvPr>
@@ -12653,7 +12653,7 @@
           <p:cNvPr id="7" name="step-1">
             <a:extLst xmlns:a="http://schemas.openxmlformats.org/drawingml/2006/main">
               <a:ext uri="{FF2B5EF4-FFF2-40B4-BE49-F238E27FC236}">
-                <a16:creationId xmlns:a16="http://schemas.microsoft.com/office/drawing/2014/main" id="{7A55DD2A-2B50-4D00-AE7C-3B8F0AD3203E}"/>
+                <a16:creationId xmlns:a16="http://schemas.microsoft.com/office/drawing/2014/main" id="{472328C7-4A8C-45DF-9218-5717A3B1C59B}"/>
               </a:ext>
             </a:extLst>
           </p:cNvPr>
@@ -12719,7 +12719,7 @@
           <p:cNvPr id="8" name="copy-1">
             <a:extLst xmlns:a="http://schemas.openxmlformats.org/drawingml/2006/main">
               <a:ext uri="{FF2B5EF4-FFF2-40B4-BE49-F238E27FC236}">
-                <a16:creationId xmlns:a16="http://schemas.microsoft.com/office/drawing/2014/main" id="{E80FA8EA-1F73-4406-9417-83D626692DAC}"/>
+                <a16:creationId xmlns:a16="http://schemas.microsoft.com/office/drawing/2014/main" id="{43A3A6D2-FEF9-4285-9A96-142C7AE87366}"/>
               </a:ext>
             </a:extLst>
           </p:cNvPr>
@@ -12779,7 +12779,7 @@
           <p:cNvPr id="9" name="step-2">
             <a:extLst xmlns:a="http://schemas.openxmlformats.org/drawingml/2006/main">
               <a:ext uri="{FF2B5EF4-FFF2-40B4-BE49-F238E27FC236}">
-                <a16:creationId xmlns:a16="http://schemas.microsoft.com/office/drawing/2014/main" id="{3DBD0A2F-7D9F-4248-B8A7-F6E57D765503}"/>
+                <a16:creationId xmlns:a16="http://schemas.microsoft.com/office/drawing/2014/main" id="{02126BA0-3904-440F-BD7A-2048B18BEF92}"/>
               </a:ext>
             </a:extLst>
           </p:cNvPr>
@@ -12845,7 +12845,7 @@
           <p:cNvPr id="10" name="copy-2">
             <a:extLst xmlns:a="http://schemas.openxmlformats.org/drawingml/2006/main">
               <a:ext uri="{FF2B5EF4-FFF2-40B4-BE49-F238E27FC236}">
-                <a16:creationId xmlns:a16="http://schemas.microsoft.com/office/drawing/2014/main" id="{05E5B2A0-0E64-4925-825A-F2920EEAD96A}"/>
+                <a16:creationId xmlns:a16="http://schemas.microsoft.com/office/drawing/2014/main" id="{B125E71C-BAE1-47A6-AA63-A0929092A32D}"/>
               </a:ext>
             </a:extLst>
           </p:cNvPr>
@@ -12905,7 +12905,7 @@
           <p:cNvPr id="11" name="step-3">
             <a:extLst xmlns:a="http://schemas.openxmlformats.org/drawingml/2006/main">
               <a:ext uri="{FF2B5EF4-FFF2-40B4-BE49-F238E27FC236}">
-                <a16:creationId xmlns:a16="http://schemas.microsoft.com/office/drawing/2014/main" id="{34DEC4ED-1261-4850-8F62-6CA843ACEB4C}"/>
+                <a16:creationId xmlns:a16="http://schemas.microsoft.com/office/drawing/2014/main" id="{63A0768A-D828-4936-800B-170A6FD0BE7B}"/>
               </a:ext>
             </a:extLst>
           </p:cNvPr>
@@ -12971,7 +12971,7 @@
           <p:cNvPr id="12" name="copy-3">
             <a:extLst xmlns:a="http://schemas.openxmlformats.org/drawingml/2006/main">
               <a:ext uri="{FF2B5EF4-FFF2-40B4-BE49-F238E27FC236}">
-                <a16:creationId xmlns:a16="http://schemas.microsoft.com/office/drawing/2014/main" id="{04C5139A-8713-499B-9659-EE94FE6ED6BB}"/>
+                <a16:creationId xmlns:a16="http://schemas.microsoft.com/office/drawing/2014/main" id="{FE45E834-BF22-4B7A-9630-43F531D7EE7E}"/>
               </a:ext>
             </a:extLst>
           </p:cNvPr>
@@ -13031,7 +13031,7 @@
           <p:cNvPr id="13" name="example">
             <a:extLst xmlns:a="http://schemas.openxmlformats.org/drawingml/2006/main">
               <a:ext uri="{FF2B5EF4-FFF2-40B4-BE49-F238E27FC236}">
-                <a16:creationId xmlns:a16="http://schemas.microsoft.com/office/drawing/2014/main" id="{D875D434-9B47-44E1-A0E2-C9DBDF4A27B8}"/>
+                <a16:creationId xmlns:a16="http://schemas.microsoft.com/office/drawing/2014/main" id="{F0980553-629C-49D3-BC7E-1E6E3F9A7D3B}"/>
               </a:ext>
             </a:extLst>
           </p:cNvPr>
@@ -13066,7 +13066,7 @@
           <p:cNvPr id="14" name="example-text">
             <a:extLst xmlns:a="http://schemas.openxmlformats.org/drawingml/2006/main">
               <a:ext uri="{FF2B5EF4-FFF2-40B4-BE49-F238E27FC236}">
-                <a16:creationId xmlns:a16="http://schemas.microsoft.com/office/drawing/2014/main" id="{D65FC118-91A7-4EEC-83A4-7BC78C12F927}"/>
+                <a16:creationId xmlns:a16="http://schemas.microsoft.com/office/drawing/2014/main" id="{CC61D0AB-2052-4F2D-9328-733E5FCE923C}"/>
               </a:ext>
             </a:extLst>
           </p:cNvPr>
@@ -13124,7 +13124,7 @@
     </p:spTree>
     <p:extLst>
       <p:ext uri="{BB962C8B-B14F-4D97-AF65-F5344CB8AC3E}">
-        <p14:creationId xmlns:p14="http://schemas.microsoft.com/office/powerpoint/2010/main" val="924340071"/>
+        <p14:creationId xmlns:p14="http://schemas.microsoft.com/office/powerpoint/2010/main" val="1935922026"/>
       </p:ext>
     </p:extLst>
   </p:cSld>
@@ -13155,7 +13155,7 @@
           <p:cNvPr id="1" name="eyebrow">
             <a:extLst xmlns:a="http://schemas.openxmlformats.org/drawingml/2006/main">
               <a:ext uri="{FF2B5EF4-FFF2-40B4-BE49-F238E27FC236}">
-                <a16:creationId xmlns:a16="http://schemas.microsoft.com/office/drawing/2014/main" id="{32DD6B48-2118-4BA6-9371-A6E0A019833C}"/>
+                <a16:creationId xmlns:a16="http://schemas.microsoft.com/office/drawing/2014/main" id="{EF7286A0-B8C7-423E-A2BB-84F4E0913802}"/>
               </a:ext>
             </a:extLst>
           </p:cNvPr>
@@ -13215,7 +13215,7 @@
           <p:cNvPr id="2" name="title">
             <a:extLst xmlns:a="http://schemas.openxmlformats.org/drawingml/2006/main">
               <a:ext uri="{FF2B5EF4-FFF2-40B4-BE49-F238E27FC236}">
-                <a16:creationId xmlns:a16="http://schemas.microsoft.com/office/drawing/2014/main" id="{4B545446-2733-4B21-9258-46132BE1C350}"/>
+                <a16:creationId xmlns:a16="http://schemas.microsoft.com/office/drawing/2014/main" id="{2DA8ECB0-D98E-4CC1-B6BD-37565E395E2D}"/>
               </a:ext>
             </a:extLst>
           </p:cNvPr>
@@ -13275,7 +13275,7 @@
           <p:cNvPr id="3" name="footer">
             <a:extLst xmlns:a="http://schemas.openxmlformats.org/drawingml/2006/main">
               <a:ext uri="{FF2B5EF4-FFF2-40B4-BE49-F238E27FC236}">
-                <a16:creationId xmlns:a16="http://schemas.microsoft.com/office/drawing/2014/main" id="{BEF26B0C-269D-4E53-A94B-472D4C46A1F8}"/>
+                <a16:creationId xmlns:a16="http://schemas.microsoft.com/office/drawing/2014/main" id="{579FFEDC-C58C-48C9-8080-DD8B81C62527}"/>
               </a:ext>
             </a:extLst>
           </p:cNvPr>
@@ -13335,7 +13335,7 @@
           <p:cNvPr id="4" name="f-0">
             <a:extLst xmlns:a="http://schemas.openxmlformats.org/drawingml/2006/main">
               <a:ext uri="{FF2B5EF4-FFF2-40B4-BE49-F238E27FC236}">
-                <a16:creationId xmlns:a16="http://schemas.microsoft.com/office/drawing/2014/main" id="{ADE21BD8-1970-4AB0-A569-8C48C39585E5}"/>
+                <a16:creationId xmlns:a16="http://schemas.microsoft.com/office/drawing/2014/main" id="{9C8DB834-8A38-434F-9528-C7EC46877C2B}"/>
               </a:ext>
             </a:extLst>
           </p:cNvPr>
@@ -13370,7 +13370,7 @@
           <p:cNvPr id="5" name="f-title-0">
             <a:extLst xmlns:a="http://schemas.openxmlformats.org/drawingml/2006/main">
               <a:ext uri="{FF2B5EF4-FFF2-40B4-BE49-F238E27FC236}">
-                <a16:creationId xmlns:a16="http://schemas.microsoft.com/office/drawing/2014/main" id="{1C75E611-15CC-4E9D-B0C9-97B230AF5310}"/>
+                <a16:creationId xmlns:a16="http://schemas.microsoft.com/office/drawing/2014/main" id="{3FE23D3D-B94B-49F0-BF9E-9C10391AD0D9}"/>
               </a:ext>
             </a:extLst>
           </p:cNvPr>
@@ -13430,7 +13430,7 @@
           <p:cNvPr id="6" name="f-copy-0">
             <a:extLst xmlns:a="http://schemas.openxmlformats.org/drawingml/2006/main">
               <a:ext uri="{FF2B5EF4-FFF2-40B4-BE49-F238E27FC236}">
-                <a16:creationId xmlns:a16="http://schemas.microsoft.com/office/drawing/2014/main" id="{CA7C3226-27F7-405E-B19A-061361BB75AF}"/>
+                <a16:creationId xmlns:a16="http://schemas.microsoft.com/office/drawing/2014/main" id="{07566EEC-BEA0-4528-9D8F-AF892CFE38FD}"/>
               </a:ext>
             </a:extLst>
           </p:cNvPr>
@@ -13490,7 +13490,7 @@
           <p:cNvPr id="7" name="f-1">
             <a:extLst xmlns:a="http://schemas.openxmlformats.org/drawingml/2006/main">
               <a:ext uri="{FF2B5EF4-FFF2-40B4-BE49-F238E27FC236}">
-                <a16:creationId xmlns:a16="http://schemas.microsoft.com/office/drawing/2014/main" id="{9DB2556A-27D8-4C8C-9C6F-812E39A4A751}"/>
+                <a16:creationId xmlns:a16="http://schemas.microsoft.com/office/drawing/2014/main" id="{44B71E95-1291-4FE1-BA4C-A4C4D1D5252C}"/>
               </a:ext>
             </a:extLst>
           </p:cNvPr>
@@ -13525,7 +13525,7 @@
           <p:cNvPr id="8" name="f-title-1">
             <a:extLst xmlns:a="http://schemas.openxmlformats.org/drawingml/2006/main">
               <a:ext uri="{FF2B5EF4-FFF2-40B4-BE49-F238E27FC236}">
-                <a16:creationId xmlns:a16="http://schemas.microsoft.com/office/drawing/2014/main" id="{1B07AD31-1D2C-486F-9FBA-8EB5B39DDE94}"/>
+                <a16:creationId xmlns:a16="http://schemas.microsoft.com/office/drawing/2014/main" id="{FAA3EBE0-FB99-4EAD-9AEB-DD069D403E5F}"/>
               </a:ext>
             </a:extLst>
           </p:cNvPr>
@@ -13585,7 +13585,7 @@
           <p:cNvPr id="9" name="f-copy-1">
             <a:extLst xmlns:a="http://schemas.openxmlformats.org/drawingml/2006/main">
               <a:ext uri="{FF2B5EF4-FFF2-40B4-BE49-F238E27FC236}">
-                <a16:creationId xmlns:a16="http://schemas.microsoft.com/office/drawing/2014/main" id="{D4E61192-86B2-4557-988B-5076E669A029}"/>
+                <a16:creationId xmlns:a16="http://schemas.microsoft.com/office/drawing/2014/main" id="{CBFF9BCA-5266-4E33-A641-9C4BD0DD0941}"/>
               </a:ext>
             </a:extLst>
           </p:cNvPr>
@@ -13645,7 +13645,7 @@
           <p:cNvPr id="10" name="f-2">
             <a:extLst xmlns:a="http://schemas.openxmlformats.org/drawingml/2006/main">
               <a:ext uri="{FF2B5EF4-FFF2-40B4-BE49-F238E27FC236}">
-                <a16:creationId xmlns:a16="http://schemas.microsoft.com/office/drawing/2014/main" id="{766E2286-1836-49D0-BF34-B946F53D4769}"/>
+                <a16:creationId xmlns:a16="http://schemas.microsoft.com/office/drawing/2014/main" id="{29EA9789-F685-445F-8AA8-324B5424168B}"/>
               </a:ext>
             </a:extLst>
           </p:cNvPr>
@@ -13680,7 +13680,7 @@
           <p:cNvPr id="11" name="f-title-2">
             <a:extLst xmlns:a="http://schemas.openxmlformats.org/drawingml/2006/main">
               <a:ext uri="{FF2B5EF4-FFF2-40B4-BE49-F238E27FC236}">
-                <a16:creationId xmlns:a16="http://schemas.microsoft.com/office/drawing/2014/main" id="{D8DB025A-500B-40A6-90C3-3D32D2242831}"/>
+                <a16:creationId xmlns:a16="http://schemas.microsoft.com/office/drawing/2014/main" id="{414CC83B-0484-4466-9DDA-9A089EB8415C}"/>
               </a:ext>
             </a:extLst>
           </p:cNvPr>
@@ -13740,7 +13740,7 @@
           <p:cNvPr id="12" name="f-copy-2">
             <a:extLst xmlns:a="http://schemas.openxmlformats.org/drawingml/2006/main">
               <a:ext uri="{FF2B5EF4-FFF2-40B4-BE49-F238E27FC236}">
-                <a16:creationId xmlns:a16="http://schemas.microsoft.com/office/drawing/2014/main" id="{A70E5EAB-0D95-4845-B7E3-16B63FBAA4A6}"/>
+                <a16:creationId xmlns:a16="http://schemas.microsoft.com/office/drawing/2014/main" id="{71357705-D505-48C0-BD3B-B41802A67044}"/>
               </a:ext>
             </a:extLst>
           </p:cNvPr>
@@ -13800,7 +13800,7 @@
           <p:cNvPr id="13" name="f-3">
             <a:extLst xmlns:a="http://schemas.openxmlformats.org/drawingml/2006/main">
               <a:ext uri="{FF2B5EF4-FFF2-40B4-BE49-F238E27FC236}">
-                <a16:creationId xmlns:a16="http://schemas.microsoft.com/office/drawing/2014/main" id="{8661BD71-7ABE-401B-969F-713D5713AA2E}"/>
+                <a16:creationId xmlns:a16="http://schemas.microsoft.com/office/drawing/2014/main" id="{A8B2D862-4BE3-46D9-A647-6C17E4F4BCD6}"/>
               </a:ext>
             </a:extLst>
           </p:cNvPr>
@@ -13835,7 +13835,7 @@
           <p:cNvPr id="14" name="f-title-3">
             <a:extLst xmlns:a="http://schemas.openxmlformats.org/drawingml/2006/main">
               <a:ext uri="{FF2B5EF4-FFF2-40B4-BE49-F238E27FC236}">
-                <a16:creationId xmlns:a16="http://schemas.microsoft.com/office/drawing/2014/main" id="{5D51D5E9-B327-4251-AE42-B0663F73B751}"/>
+                <a16:creationId xmlns:a16="http://schemas.microsoft.com/office/drawing/2014/main" id="{8ED10DB5-3EBE-4351-915A-2751CA1AF629}"/>
               </a:ext>
             </a:extLst>
           </p:cNvPr>
@@ -13895,7 +13895,7 @@
           <p:cNvPr id="15" name="f-copy-3">
             <a:extLst xmlns:a="http://schemas.openxmlformats.org/drawingml/2006/main">
               <a:ext uri="{FF2B5EF4-FFF2-40B4-BE49-F238E27FC236}">
-                <a16:creationId xmlns:a16="http://schemas.microsoft.com/office/drawing/2014/main" id="{D7EF56BE-E2D5-4728-AF14-1224B28F776A}"/>
+                <a16:creationId xmlns:a16="http://schemas.microsoft.com/office/drawing/2014/main" id="{36F181FB-6F78-410B-B9F8-9983AE6BDB1A}"/>
               </a:ext>
             </a:extLst>
           </p:cNvPr>
@@ -13955,7 +13955,7 @@
           <p:cNvPr id="16" name="f-4">
             <a:extLst xmlns:a="http://schemas.openxmlformats.org/drawingml/2006/main">
               <a:ext uri="{FF2B5EF4-FFF2-40B4-BE49-F238E27FC236}">
-                <a16:creationId xmlns:a16="http://schemas.microsoft.com/office/drawing/2014/main" id="{235C6704-0CCE-4F3C-8A6B-A19F3E4E1985}"/>
+                <a16:creationId xmlns:a16="http://schemas.microsoft.com/office/drawing/2014/main" id="{34B7AEE4-A0D7-4C1D-BA14-9B87958E99EB}"/>
               </a:ext>
             </a:extLst>
           </p:cNvPr>
@@ -13990,7 +13990,7 @@
           <p:cNvPr id="17" name="f-title-4">
             <a:extLst xmlns:a="http://schemas.openxmlformats.org/drawingml/2006/main">
               <a:ext uri="{FF2B5EF4-FFF2-40B4-BE49-F238E27FC236}">
-                <a16:creationId xmlns:a16="http://schemas.microsoft.com/office/drawing/2014/main" id="{67D0491B-FB3E-447B-A876-1D2C7ADFDA04}"/>
+                <a16:creationId xmlns:a16="http://schemas.microsoft.com/office/drawing/2014/main" id="{2A5F1372-2295-4015-8322-C8076D6E61D6}"/>
               </a:ext>
             </a:extLst>
           </p:cNvPr>
@@ -14050,7 +14050,7 @@
           <p:cNvPr id="18" name="f-copy-4">
             <a:extLst xmlns:a="http://schemas.openxmlformats.org/drawingml/2006/main">
               <a:ext uri="{FF2B5EF4-FFF2-40B4-BE49-F238E27FC236}">
-                <a16:creationId xmlns:a16="http://schemas.microsoft.com/office/drawing/2014/main" id="{51F836F2-ACFD-48C5-B981-D54A2BF960D5}"/>
+                <a16:creationId xmlns:a16="http://schemas.microsoft.com/office/drawing/2014/main" id="{F19F4569-9884-44F0-93EC-62E758E33C9D}"/>
               </a:ext>
             </a:extLst>
           </p:cNvPr>
@@ -14110,7 +14110,7 @@
           <p:cNvPr id="19" name="f-5">
             <a:extLst xmlns:a="http://schemas.openxmlformats.org/drawingml/2006/main">
               <a:ext uri="{FF2B5EF4-FFF2-40B4-BE49-F238E27FC236}">
-                <a16:creationId xmlns:a16="http://schemas.microsoft.com/office/drawing/2014/main" id="{CD6B1245-708C-43A8-B002-F9A25FA8EAF7}"/>
+                <a16:creationId xmlns:a16="http://schemas.microsoft.com/office/drawing/2014/main" id="{C2304221-B0A7-4E26-9772-DC00DF4CFDD9}"/>
               </a:ext>
             </a:extLst>
           </p:cNvPr>
@@ -14145,7 +14145,7 @@
           <p:cNvPr id="20" name="f-title-5">
             <a:extLst xmlns:a="http://schemas.openxmlformats.org/drawingml/2006/main">
               <a:ext uri="{FF2B5EF4-FFF2-40B4-BE49-F238E27FC236}">
-                <a16:creationId xmlns:a16="http://schemas.microsoft.com/office/drawing/2014/main" id="{268E1C3C-9AD4-47B4-B938-A19257066909}"/>
+                <a16:creationId xmlns:a16="http://schemas.microsoft.com/office/drawing/2014/main" id="{D986B133-03B0-4CFA-BAC0-E1C384B220FA}"/>
               </a:ext>
             </a:extLst>
           </p:cNvPr>
@@ -14205,7 +14205,7 @@
           <p:cNvPr id="21" name="f-copy-5">
             <a:extLst xmlns:a="http://schemas.openxmlformats.org/drawingml/2006/main">
               <a:ext uri="{FF2B5EF4-FFF2-40B4-BE49-F238E27FC236}">
-                <a16:creationId xmlns:a16="http://schemas.microsoft.com/office/drawing/2014/main" id="{8F2C3F94-86CC-43A8-B17B-0F9CD1A264EB}"/>
+                <a16:creationId xmlns:a16="http://schemas.microsoft.com/office/drawing/2014/main" id="{7650BC08-AE53-419B-B287-2D953CB3A0CA}"/>
               </a:ext>
             </a:extLst>
           </p:cNvPr>
@@ -14265,7 +14265,7 @@
           <p:cNvPr id="22" name="bottom">
             <a:extLst xmlns:a="http://schemas.openxmlformats.org/drawingml/2006/main">
               <a:ext uri="{FF2B5EF4-FFF2-40B4-BE49-F238E27FC236}">
-                <a16:creationId xmlns:a16="http://schemas.microsoft.com/office/drawing/2014/main" id="{551D365D-9851-4E43-8891-75C28B0A2E5C}"/>
+                <a16:creationId xmlns:a16="http://schemas.microsoft.com/office/drawing/2014/main" id="{D399E0EE-810F-4158-A350-1DDC4A715A34}"/>
               </a:ext>
             </a:extLst>
           </p:cNvPr>
@@ -14323,7 +14323,7 @@
     </p:spTree>
     <p:extLst>
       <p:ext uri="{BB962C8B-B14F-4D97-AF65-F5344CB8AC3E}">
-        <p14:creationId xmlns:p14="http://schemas.microsoft.com/office/powerpoint/2010/main" val="857302691"/>
+        <p14:creationId xmlns:p14="http://schemas.microsoft.com/office/powerpoint/2010/main" val="285528064"/>
       </p:ext>
     </p:extLst>
   </p:cSld>
@@ -14354,7 +14354,7 @@
           <p:cNvPr id="1" name="eyebrow">
             <a:extLst xmlns:a="http://schemas.openxmlformats.org/drawingml/2006/main">
               <a:ext uri="{FF2B5EF4-FFF2-40B4-BE49-F238E27FC236}">
-                <a16:creationId xmlns:a16="http://schemas.microsoft.com/office/drawing/2014/main" id="{EBF671D1-774B-46DF-B7CB-4FE6326804D3}"/>
+                <a16:creationId xmlns:a16="http://schemas.microsoft.com/office/drawing/2014/main" id="{46ABF9E3-5414-42CB-86BC-37259925B030}"/>
               </a:ext>
             </a:extLst>
           </p:cNvPr>
@@ -14414,7 +14414,7 @@
           <p:cNvPr id="2" name="title">
             <a:extLst xmlns:a="http://schemas.openxmlformats.org/drawingml/2006/main">
               <a:ext uri="{FF2B5EF4-FFF2-40B4-BE49-F238E27FC236}">
-                <a16:creationId xmlns:a16="http://schemas.microsoft.com/office/drawing/2014/main" id="{654DB567-8E31-45C9-A817-416B010D5ECE}"/>
+                <a16:creationId xmlns:a16="http://schemas.microsoft.com/office/drawing/2014/main" id="{A4BE0F87-87BA-4C94-8FC9-A2F8B0A6E0AE}"/>
               </a:ext>
             </a:extLst>
           </p:cNvPr>
@@ -14474,7 +14474,7 @@
           <p:cNvPr id="3" name="footer">
             <a:extLst xmlns:a="http://schemas.openxmlformats.org/drawingml/2006/main">
               <a:ext uri="{FF2B5EF4-FFF2-40B4-BE49-F238E27FC236}">
-                <a16:creationId xmlns:a16="http://schemas.microsoft.com/office/drawing/2014/main" id="{2322F741-3D90-4270-9AFF-08417571D9AD}"/>
+                <a16:creationId xmlns:a16="http://schemas.microsoft.com/office/drawing/2014/main" id="{092494F4-02C0-4478-B363-627FF8E79F1E}"/>
               </a:ext>
             </a:extLst>
           </p:cNvPr>
@@ -14534,7 +14534,7 @@
           <p:cNvPr id="4" name="lead">
             <a:extLst xmlns:a="http://schemas.openxmlformats.org/drawingml/2006/main">
               <a:ext uri="{FF2B5EF4-FFF2-40B4-BE49-F238E27FC236}">
-                <a16:creationId xmlns:a16="http://schemas.microsoft.com/office/drawing/2014/main" id="{9AE3BBC0-747A-4EAE-8DDF-5A7B2C97FC88}"/>
+                <a16:creationId xmlns:a16="http://schemas.microsoft.com/office/drawing/2014/main" id="{954AB041-FC33-44CD-9960-DA966CD6F972}"/>
               </a:ext>
             </a:extLst>
           </p:cNvPr>
@@ -14594,7 +14594,7 @@
           <p:cNvPr id="5" name="surface-0">
             <a:extLst xmlns:a="http://schemas.openxmlformats.org/drawingml/2006/main">
               <a:ext uri="{FF2B5EF4-FFF2-40B4-BE49-F238E27FC236}">
-                <a16:creationId xmlns:a16="http://schemas.microsoft.com/office/drawing/2014/main" id="{DB37A088-349D-482F-BD10-0D8CE1CC56FD}"/>
+                <a16:creationId xmlns:a16="http://schemas.microsoft.com/office/drawing/2014/main" id="{845E0E25-0E8D-4DA9-A9EA-34B2152B9B1D}"/>
               </a:ext>
             </a:extLst>
           </p:cNvPr>
@@ -14629,7 +14629,7 @@
           <p:cNvPr id="6" name="head-0">
             <a:extLst xmlns:a="http://schemas.openxmlformats.org/drawingml/2006/main">
               <a:ext uri="{FF2B5EF4-FFF2-40B4-BE49-F238E27FC236}">
-                <a16:creationId xmlns:a16="http://schemas.microsoft.com/office/drawing/2014/main" id="{621BE3EA-13B5-432F-9B22-C620D197369D}"/>
+                <a16:creationId xmlns:a16="http://schemas.microsoft.com/office/drawing/2014/main" id="{40FD8E83-28B7-4A34-BE1F-4ED863429F87}"/>
               </a:ext>
             </a:extLst>
           </p:cNvPr>
@@ -14689,7 +14689,7 @@
           <p:cNvPr id="7" name="list-0">
             <a:extLst xmlns:a="http://schemas.openxmlformats.org/drawingml/2006/main">
               <a:ext uri="{FF2B5EF4-FFF2-40B4-BE49-F238E27FC236}">
-                <a16:creationId xmlns:a16="http://schemas.microsoft.com/office/drawing/2014/main" id="{AE9C36E3-4FFE-4435-B640-7D38F5080D3A}"/>
+                <a16:creationId xmlns:a16="http://schemas.microsoft.com/office/drawing/2014/main" id="{EDFDE559-BC3C-4398-8FB9-6A44004F3F56}"/>
               </a:ext>
             </a:extLst>
           </p:cNvPr>
@@ -14812,7 +14812,7 @@
           <p:cNvPr id="8" name="surface-1">
             <a:extLst xmlns:a="http://schemas.openxmlformats.org/drawingml/2006/main">
               <a:ext uri="{FF2B5EF4-FFF2-40B4-BE49-F238E27FC236}">
-                <a16:creationId xmlns:a16="http://schemas.microsoft.com/office/drawing/2014/main" id="{C2B75A1C-4D1E-4922-898D-1FD57AA73B6E}"/>
+                <a16:creationId xmlns:a16="http://schemas.microsoft.com/office/drawing/2014/main" id="{E0F99712-465C-42E9-924C-2CD88495F8AA}"/>
               </a:ext>
             </a:extLst>
           </p:cNvPr>
@@ -14847,7 +14847,7 @@
           <p:cNvPr id="9" name="head-1">
             <a:extLst xmlns:a="http://schemas.openxmlformats.org/drawingml/2006/main">
               <a:ext uri="{FF2B5EF4-FFF2-40B4-BE49-F238E27FC236}">
-                <a16:creationId xmlns:a16="http://schemas.microsoft.com/office/drawing/2014/main" id="{E47EF149-9BBF-49B3-9407-BC977BEA237A}"/>
+                <a16:creationId xmlns:a16="http://schemas.microsoft.com/office/drawing/2014/main" id="{3CDEDBB9-4491-4F77-9B56-9C3338978ED7}"/>
               </a:ext>
             </a:extLst>
           </p:cNvPr>
@@ -14907,7 +14907,7 @@
           <p:cNvPr id="10" name="list-1">
             <a:extLst xmlns:a="http://schemas.openxmlformats.org/drawingml/2006/main">
               <a:ext uri="{FF2B5EF4-FFF2-40B4-BE49-F238E27FC236}">
-                <a16:creationId xmlns:a16="http://schemas.microsoft.com/office/drawing/2014/main" id="{4ADCC3C9-A204-4255-9C69-15574505FE8F}"/>
+                <a16:creationId xmlns:a16="http://schemas.microsoft.com/office/drawing/2014/main" id="{B683BBF1-EFDE-4090-B4A0-EEE1D2EB9BD3}"/>
               </a:ext>
             </a:extLst>
           </p:cNvPr>
@@ -15030,7 +15030,7 @@
           <p:cNvPr id="11" name="bottom">
             <a:extLst xmlns:a="http://schemas.openxmlformats.org/drawingml/2006/main">
               <a:ext uri="{FF2B5EF4-FFF2-40B4-BE49-F238E27FC236}">
-                <a16:creationId xmlns:a16="http://schemas.microsoft.com/office/drawing/2014/main" id="{F7BA9028-01C5-419B-90AE-E13DCED384AC}"/>
+                <a16:creationId xmlns:a16="http://schemas.microsoft.com/office/drawing/2014/main" id="{603CC3BD-4C37-43B3-9C52-8764ED12B1E0}"/>
               </a:ext>
             </a:extLst>
           </p:cNvPr>
@@ -15088,7 +15088,7 @@
     </p:spTree>
     <p:extLst>
       <p:ext uri="{BB962C8B-B14F-4D97-AF65-F5344CB8AC3E}">
-        <p14:creationId xmlns:p14="http://schemas.microsoft.com/office/powerpoint/2010/main" val="1497082395"/>
+        <p14:creationId xmlns:p14="http://schemas.microsoft.com/office/powerpoint/2010/main" val="1702121380"/>
       </p:ext>
     </p:extLst>
   </p:cSld>
@@ -15119,7 +15119,7 @@
           <p:cNvPr id="1" name="eyebrow">
             <a:extLst xmlns:a="http://schemas.openxmlformats.org/drawingml/2006/main">
               <a:ext uri="{FF2B5EF4-FFF2-40B4-BE49-F238E27FC236}">
-                <a16:creationId xmlns:a16="http://schemas.microsoft.com/office/drawing/2014/main" id="{6173B600-DA2E-4484-8565-F1436CA9ABC8}"/>
+                <a16:creationId xmlns:a16="http://schemas.microsoft.com/office/drawing/2014/main" id="{C1639735-2EA3-449B-9305-3B103F3A544F}"/>
               </a:ext>
             </a:extLst>
           </p:cNvPr>
@@ -15179,7 +15179,7 @@
           <p:cNvPr id="2" name="title">
             <a:extLst xmlns:a="http://schemas.openxmlformats.org/drawingml/2006/main">
               <a:ext uri="{FF2B5EF4-FFF2-40B4-BE49-F238E27FC236}">
-                <a16:creationId xmlns:a16="http://schemas.microsoft.com/office/drawing/2014/main" id="{762078FF-527F-43E0-8800-1DF13B89BF93}"/>
+                <a16:creationId xmlns:a16="http://schemas.microsoft.com/office/drawing/2014/main" id="{8851E5BF-6E14-4E49-8915-9A38CFD94926}"/>
               </a:ext>
             </a:extLst>
           </p:cNvPr>
@@ -15239,7 +15239,7 @@
           <p:cNvPr id="3" name="footer">
             <a:extLst xmlns:a="http://schemas.openxmlformats.org/drawingml/2006/main">
               <a:ext uri="{FF2B5EF4-FFF2-40B4-BE49-F238E27FC236}">
-                <a16:creationId xmlns:a16="http://schemas.microsoft.com/office/drawing/2014/main" id="{C718B51D-BFAE-4B8C-BD77-1FC0355BE2CF}"/>
+                <a16:creationId xmlns:a16="http://schemas.microsoft.com/office/drawing/2014/main" id="{EB842180-5126-46E1-B221-1469D7BBF9AA}"/>
               </a:ext>
             </a:extLst>
           </p:cNvPr>
@@ -15299,7 +15299,7 @@
           <p:cNvPr id="4" name="case-0">
             <a:extLst xmlns:a="http://schemas.openxmlformats.org/drawingml/2006/main">
               <a:ext uri="{FF2B5EF4-FFF2-40B4-BE49-F238E27FC236}">
-                <a16:creationId xmlns:a16="http://schemas.microsoft.com/office/drawing/2014/main" id="{75A773E8-A85C-4076-8C2C-69F1B1C8E727}"/>
+                <a16:creationId xmlns:a16="http://schemas.microsoft.com/office/drawing/2014/main" id="{EC8A3507-10C7-42E9-89BD-CEFDC35BC853}"/>
               </a:ext>
             </a:extLst>
           </p:cNvPr>
@@ -15334,7 +15334,7 @@
           <p:cNvPr id="5" name="case-label-0">
             <a:extLst xmlns:a="http://schemas.openxmlformats.org/drawingml/2006/main">
               <a:ext uri="{FF2B5EF4-FFF2-40B4-BE49-F238E27FC236}">
-                <a16:creationId xmlns:a16="http://schemas.microsoft.com/office/drawing/2014/main" id="{CFA40171-1E18-4889-9886-E42C155F28C1}"/>
+                <a16:creationId xmlns:a16="http://schemas.microsoft.com/office/drawing/2014/main" id="{45A2A686-B6AE-4157-98C4-D927E67F89F7}"/>
               </a:ext>
             </a:extLst>
           </p:cNvPr>
@@ -15400,7 +15400,7 @@
           <p:cNvPr id="6" name="case-copy-0">
             <a:extLst xmlns:a="http://schemas.openxmlformats.org/drawingml/2006/main">
               <a:ext uri="{FF2B5EF4-FFF2-40B4-BE49-F238E27FC236}">
-                <a16:creationId xmlns:a16="http://schemas.microsoft.com/office/drawing/2014/main" id="{F1C8E18C-C4E4-4FCB-A647-A073F68B6147}"/>
+                <a16:creationId xmlns:a16="http://schemas.microsoft.com/office/drawing/2014/main" id="{9FC85C08-B5E1-4E19-A233-129C77840A47}"/>
               </a:ext>
             </a:extLst>
           </p:cNvPr>
@@ -15487,7 +15487,7 @@
           <p:cNvPr id="7" name="case-1">
             <a:extLst xmlns:a="http://schemas.openxmlformats.org/drawingml/2006/main">
               <a:ext uri="{FF2B5EF4-FFF2-40B4-BE49-F238E27FC236}">
-                <a16:creationId xmlns:a16="http://schemas.microsoft.com/office/drawing/2014/main" id="{58FA1023-00D2-483D-A2AA-2B33CC652DFF}"/>
+                <a16:creationId xmlns:a16="http://schemas.microsoft.com/office/drawing/2014/main" id="{5386F3E5-8435-4419-B057-22C7707B53C0}"/>
               </a:ext>
             </a:extLst>
           </p:cNvPr>
@@ -15522,7 +15522,7 @@
           <p:cNvPr id="8" name="case-label-1">
             <a:extLst xmlns:a="http://schemas.openxmlformats.org/drawingml/2006/main">
               <a:ext uri="{FF2B5EF4-FFF2-40B4-BE49-F238E27FC236}">
-                <a16:creationId xmlns:a16="http://schemas.microsoft.com/office/drawing/2014/main" id="{E84B81F6-955F-4B98-94CF-9828C54D434C}"/>
+                <a16:creationId xmlns:a16="http://schemas.microsoft.com/office/drawing/2014/main" id="{0837F2F9-A597-460F-B471-EFAD06D0F696}"/>
               </a:ext>
             </a:extLst>
           </p:cNvPr>
@@ -15588,7 +15588,7 @@
           <p:cNvPr id="9" name="case-copy-1">
             <a:extLst xmlns:a="http://schemas.openxmlformats.org/drawingml/2006/main">
               <a:ext uri="{FF2B5EF4-FFF2-40B4-BE49-F238E27FC236}">
-                <a16:creationId xmlns:a16="http://schemas.microsoft.com/office/drawing/2014/main" id="{E8B1CEE2-91A5-4E3B-AD32-2266123B7666}"/>
+                <a16:creationId xmlns:a16="http://schemas.microsoft.com/office/drawing/2014/main" id="{2CA3A03D-5E21-4BA6-AA53-3469A0409E14}"/>
               </a:ext>
             </a:extLst>
           </p:cNvPr>
@@ -15675,7 +15675,7 @@
           <p:cNvPr id="10" name="case-2">
             <a:extLst xmlns:a="http://schemas.openxmlformats.org/drawingml/2006/main">
               <a:ext uri="{FF2B5EF4-FFF2-40B4-BE49-F238E27FC236}">
-                <a16:creationId xmlns:a16="http://schemas.microsoft.com/office/drawing/2014/main" id="{D90346C2-C021-4C29-90CC-E9480DFD9954}"/>
+                <a16:creationId xmlns:a16="http://schemas.microsoft.com/office/drawing/2014/main" id="{36FB8F46-7DD0-49BD-A2F9-D9B87A2FBE86}"/>
               </a:ext>
             </a:extLst>
           </p:cNvPr>
@@ -15710,7 +15710,7 @@
           <p:cNvPr id="11" name="case-label-2">
             <a:extLst xmlns:a="http://schemas.openxmlformats.org/drawingml/2006/main">
               <a:ext uri="{FF2B5EF4-FFF2-40B4-BE49-F238E27FC236}">
-                <a16:creationId xmlns:a16="http://schemas.microsoft.com/office/drawing/2014/main" id="{D1B50E5A-D48F-4779-8198-51A9DBBD27AB}"/>
+                <a16:creationId xmlns:a16="http://schemas.microsoft.com/office/drawing/2014/main" id="{03C3F6D3-9EF1-470D-B672-B7F5688734B1}"/>
               </a:ext>
             </a:extLst>
           </p:cNvPr>
@@ -15776,7 +15776,7 @@
           <p:cNvPr id="12" name="case-copy-2">
             <a:extLst xmlns:a="http://schemas.openxmlformats.org/drawingml/2006/main">
               <a:ext uri="{FF2B5EF4-FFF2-40B4-BE49-F238E27FC236}">
-                <a16:creationId xmlns:a16="http://schemas.microsoft.com/office/drawing/2014/main" id="{297233F1-AB92-4249-AE46-E78D68EB7AE0}"/>
+                <a16:creationId xmlns:a16="http://schemas.microsoft.com/office/drawing/2014/main" id="{8CFC8CF6-9D5E-4492-9A82-0E67156F51DC}"/>
               </a:ext>
             </a:extLst>
           </p:cNvPr>
@@ -15863,7 +15863,7 @@
           <p:cNvPr id="13" name="prompt">
             <a:extLst xmlns:a="http://schemas.openxmlformats.org/drawingml/2006/main">
               <a:ext uri="{FF2B5EF4-FFF2-40B4-BE49-F238E27FC236}">
-                <a16:creationId xmlns:a16="http://schemas.microsoft.com/office/drawing/2014/main" id="{01C111C5-8A5B-4C7B-A257-6EBA01DC705A}"/>
+                <a16:creationId xmlns:a16="http://schemas.microsoft.com/office/drawing/2014/main" id="{3CA63573-DC45-4906-A269-759AB8B921C2}"/>
               </a:ext>
             </a:extLst>
           </p:cNvPr>
@@ -15921,7 +15921,7 @@
     </p:spTree>
     <p:extLst>
       <p:ext uri="{BB962C8B-B14F-4D97-AF65-F5344CB8AC3E}">
-        <p14:creationId xmlns:p14="http://schemas.microsoft.com/office/powerpoint/2010/main" val="580075084"/>
+        <p14:creationId xmlns:p14="http://schemas.microsoft.com/office/powerpoint/2010/main" val="1770417174"/>
       </p:ext>
     </p:extLst>
   </p:cSld>
@@ -15952,7 +15952,7 @@
           <p:cNvPr id="1" name="eyebrow">
             <a:extLst xmlns:a="http://schemas.openxmlformats.org/drawingml/2006/main">
               <a:ext uri="{FF2B5EF4-FFF2-40B4-BE49-F238E27FC236}">
-                <a16:creationId xmlns:a16="http://schemas.microsoft.com/office/drawing/2014/main" id="{A5E4F352-2AC4-4817-A3E2-6AA875C28BAD}"/>
+                <a16:creationId xmlns:a16="http://schemas.microsoft.com/office/drawing/2014/main" id="{C91E0CB6-7B59-4BFE-9F4B-420B8B2B4998}"/>
               </a:ext>
             </a:extLst>
           </p:cNvPr>
@@ -16012,7 +16012,7 @@
           <p:cNvPr id="2" name="title">
             <a:extLst xmlns:a="http://schemas.openxmlformats.org/drawingml/2006/main">
               <a:ext uri="{FF2B5EF4-FFF2-40B4-BE49-F238E27FC236}">
-                <a16:creationId xmlns:a16="http://schemas.microsoft.com/office/drawing/2014/main" id="{ECC845C7-D4F0-48E0-821C-13E8F2F27D0A}"/>
+                <a16:creationId xmlns:a16="http://schemas.microsoft.com/office/drawing/2014/main" id="{8DD41BDE-C9EC-4E93-A1F0-D1BE5E012486}"/>
               </a:ext>
             </a:extLst>
           </p:cNvPr>
@@ -16072,7 +16072,7 @@
           <p:cNvPr id="3" name="footer">
             <a:extLst xmlns:a="http://schemas.openxmlformats.org/drawingml/2006/main">
               <a:ext uri="{FF2B5EF4-FFF2-40B4-BE49-F238E27FC236}">
-                <a16:creationId xmlns:a16="http://schemas.microsoft.com/office/drawing/2014/main" id="{0BD5E766-95A4-458F-934B-65A67D0BFE5C}"/>
+                <a16:creationId xmlns:a16="http://schemas.microsoft.com/office/drawing/2014/main" id="{B8AA200D-C347-487E-99E5-0B80DE8E095A}"/>
               </a:ext>
             </a:extLst>
           </p:cNvPr>
@@ -16132,7 +16132,7 @@
           <p:cNvPr id="4" name="worksheet-0">
             <a:extLst xmlns:a="http://schemas.openxmlformats.org/drawingml/2006/main">
               <a:ext uri="{FF2B5EF4-FFF2-40B4-BE49-F238E27FC236}">
-                <a16:creationId xmlns:a16="http://schemas.microsoft.com/office/drawing/2014/main" id="{87B6F141-BBAD-4C1E-8E50-7372B5D86FE9}"/>
+                <a16:creationId xmlns:a16="http://schemas.microsoft.com/office/drawing/2014/main" id="{69ED0B3B-179B-4307-ADCB-9ADFF09A0F30}"/>
               </a:ext>
             </a:extLst>
           </p:cNvPr>
@@ -16167,7 +16167,7 @@
           <p:cNvPr id="5" name="worksheet-head-0">
             <a:extLst xmlns:a="http://schemas.openxmlformats.org/drawingml/2006/main">
               <a:ext uri="{FF2B5EF4-FFF2-40B4-BE49-F238E27FC236}">
-                <a16:creationId xmlns:a16="http://schemas.microsoft.com/office/drawing/2014/main" id="{93601225-F539-4D2A-8A99-767F6D83B398}"/>
+                <a16:creationId xmlns:a16="http://schemas.microsoft.com/office/drawing/2014/main" id="{91757BAE-7B72-4531-ADEB-2AF69265A447}"/>
               </a:ext>
             </a:extLst>
           </p:cNvPr>
@@ -16227,7 +16227,7 @@
           <p:cNvPr id="6" name="worksheet-sub-0">
             <a:extLst xmlns:a="http://schemas.openxmlformats.org/drawingml/2006/main">
               <a:ext uri="{FF2B5EF4-FFF2-40B4-BE49-F238E27FC236}">
-                <a16:creationId xmlns:a16="http://schemas.microsoft.com/office/drawing/2014/main" id="{5DBCD59E-4E20-45F6-BE63-3EECBEA5A382}"/>
+                <a16:creationId xmlns:a16="http://schemas.microsoft.com/office/drawing/2014/main" id="{52C42E91-8B67-4DB2-A039-77B97ED9F60B}"/>
               </a:ext>
             </a:extLst>
           </p:cNvPr>
@@ -16287,7 +16287,7 @@
           <p:cNvPr id="7" name="worksheet-1">
             <a:extLst xmlns:a="http://schemas.openxmlformats.org/drawingml/2006/main">
               <a:ext uri="{FF2B5EF4-FFF2-40B4-BE49-F238E27FC236}">
-                <a16:creationId xmlns:a16="http://schemas.microsoft.com/office/drawing/2014/main" id="{C412A772-F615-4700-9273-A18C8255BF9B}"/>
+                <a16:creationId xmlns:a16="http://schemas.microsoft.com/office/drawing/2014/main" id="{4CBC10FC-5152-4B43-822C-F819B3E85502}"/>
               </a:ext>
             </a:extLst>
           </p:cNvPr>
@@ -16322,7 +16322,7 @@
           <p:cNvPr id="8" name="worksheet-head-1">
             <a:extLst xmlns:a="http://schemas.openxmlformats.org/drawingml/2006/main">
               <a:ext uri="{FF2B5EF4-FFF2-40B4-BE49-F238E27FC236}">
-                <a16:creationId xmlns:a16="http://schemas.microsoft.com/office/drawing/2014/main" id="{FE5E7083-84E0-4254-9740-CC8743717103}"/>
+                <a16:creationId xmlns:a16="http://schemas.microsoft.com/office/drawing/2014/main" id="{BA07B37F-C714-4F86-8614-99BF9341561E}"/>
               </a:ext>
             </a:extLst>
           </p:cNvPr>
@@ -16382,7 +16382,7 @@
           <p:cNvPr id="9" name="worksheet-sub-1">
             <a:extLst xmlns:a="http://schemas.openxmlformats.org/drawingml/2006/main">
               <a:ext uri="{FF2B5EF4-FFF2-40B4-BE49-F238E27FC236}">
-                <a16:creationId xmlns:a16="http://schemas.microsoft.com/office/drawing/2014/main" id="{E8C95BB3-D463-4454-AC21-F7227E39F60F}"/>
+                <a16:creationId xmlns:a16="http://schemas.microsoft.com/office/drawing/2014/main" id="{5FCB96A5-4333-48B1-AAF8-4018A86A5093}"/>
               </a:ext>
             </a:extLst>
           </p:cNvPr>
@@ -16442,7 +16442,7 @@
           <p:cNvPr id="10" name="worksheet-2">
             <a:extLst xmlns:a="http://schemas.openxmlformats.org/drawingml/2006/main">
               <a:ext uri="{FF2B5EF4-FFF2-40B4-BE49-F238E27FC236}">
-                <a16:creationId xmlns:a16="http://schemas.microsoft.com/office/drawing/2014/main" id="{30D8927F-FB0F-4D1F-A1CD-50EC4BBC179C}"/>
+                <a16:creationId xmlns:a16="http://schemas.microsoft.com/office/drawing/2014/main" id="{5AA88F55-98C2-4965-B824-64DCECC03E33}"/>
               </a:ext>
             </a:extLst>
           </p:cNvPr>
@@ -16477,7 +16477,7 @@
           <p:cNvPr id="11" name="worksheet-head-2">
             <a:extLst xmlns:a="http://schemas.openxmlformats.org/drawingml/2006/main">
               <a:ext uri="{FF2B5EF4-FFF2-40B4-BE49-F238E27FC236}">
-                <a16:creationId xmlns:a16="http://schemas.microsoft.com/office/drawing/2014/main" id="{ED15C62C-6FC0-425C-9841-2971958BEEF0}"/>
+                <a16:creationId xmlns:a16="http://schemas.microsoft.com/office/drawing/2014/main" id="{21375754-48FD-4B9B-9DE9-6B576EB01949}"/>
               </a:ext>
             </a:extLst>
           </p:cNvPr>
@@ -16537,7 +16537,7 @@
           <p:cNvPr id="12" name="worksheet-sub-2">
             <a:extLst xmlns:a="http://schemas.openxmlformats.org/drawingml/2006/main">
               <a:ext uri="{FF2B5EF4-FFF2-40B4-BE49-F238E27FC236}">
-                <a16:creationId xmlns:a16="http://schemas.microsoft.com/office/drawing/2014/main" id="{00F42308-4488-4163-8F94-6816F8F6560A}"/>
+                <a16:creationId xmlns:a16="http://schemas.microsoft.com/office/drawing/2014/main" id="{173D7DAA-46B5-434E-8694-4FC20E59AA2F}"/>
               </a:ext>
             </a:extLst>
           </p:cNvPr>
@@ -16597,7 +16597,7 @@
           <p:cNvPr id="13" name="worksheet-3">
             <a:extLst xmlns:a="http://schemas.openxmlformats.org/drawingml/2006/main">
               <a:ext uri="{FF2B5EF4-FFF2-40B4-BE49-F238E27FC236}">
-                <a16:creationId xmlns:a16="http://schemas.microsoft.com/office/drawing/2014/main" id="{2BF54C0C-44EF-40FC-9B11-74A215974471}"/>
+                <a16:creationId xmlns:a16="http://schemas.microsoft.com/office/drawing/2014/main" id="{6C041224-60D6-486E-AEF0-C7F4FF9C3E5F}"/>
               </a:ext>
             </a:extLst>
           </p:cNvPr>
@@ -16632,7 +16632,7 @@
           <p:cNvPr id="14" name="worksheet-head-3">
             <a:extLst xmlns:a="http://schemas.openxmlformats.org/drawingml/2006/main">
               <a:ext uri="{FF2B5EF4-FFF2-40B4-BE49-F238E27FC236}">
-                <a16:creationId xmlns:a16="http://schemas.microsoft.com/office/drawing/2014/main" id="{D57F703C-C2DE-4553-B9E5-319C1BF0A37A}"/>
+                <a16:creationId xmlns:a16="http://schemas.microsoft.com/office/drawing/2014/main" id="{5C164AF5-15A1-4CE7-90CC-CF0647960824}"/>
               </a:ext>
             </a:extLst>
           </p:cNvPr>
@@ -16692,7 +16692,7 @@
           <p:cNvPr id="15" name="worksheet-sub-3">
             <a:extLst xmlns:a="http://schemas.openxmlformats.org/drawingml/2006/main">
               <a:ext uri="{FF2B5EF4-FFF2-40B4-BE49-F238E27FC236}">
-                <a16:creationId xmlns:a16="http://schemas.microsoft.com/office/drawing/2014/main" id="{B92D3F2C-A654-4181-AAAD-44E2EEBB2B35}"/>
+                <a16:creationId xmlns:a16="http://schemas.microsoft.com/office/drawing/2014/main" id="{F3DBD514-0A5E-4448-A80B-A28D839879F7}"/>
               </a:ext>
             </a:extLst>
           </p:cNvPr>
@@ -16752,7 +16752,7 @@
           <p:cNvPr id="16" name="worksheet-4">
             <a:extLst xmlns:a="http://schemas.openxmlformats.org/drawingml/2006/main">
               <a:ext uri="{FF2B5EF4-FFF2-40B4-BE49-F238E27FC236}">
-                <a16:creationId xmlns:a16="http://schemas.microsoft.com/office/drawing/2014/main" id="{541CAADA-3A1F-48A1-A406-4BC95B7D18BD}"/>
+                <a16:creationId xmlns:a16="http://schemas.microsoft.com/office/drawing/2014/main" id="{35EAE3FA-C2E2-4678-9795-7DD5F087EF1B}"/>
               </a:ext>
             </a:extLst>
           </p:cNvPr>
@@ -16787,7 +16787,7 @@
           <p:cNvPr id="17" name="worksheet-head-4">
             <a:extLst xmlns:a="http://schemas.openxmlformats.org/drawingml/2006/main">
               <a:ext uri="{FF2B5EF4-FFF2-40B4-BE49-F238E27FC236}">
-                <a16:creationId xmlns:a16="http://schemas.microsoft.com/office/drawing/2014/main" id="{0A6E8E5C-5F4B-4E3E-A7D2-ECB4AB12C403}"/>
+                <a16:creationId xmlns:a16="http://schemas.microsoft.com/office/drawing/2014/main" id="{10C1D150-1F0A-4230-8ACC-F8630CEA1F75}"/>
               </a:ext>
             </a:extLst>
           </p:cNvPr>
@@ -16847,7 +16847,7 @@
           <p:cNvPr id="18" name="worksheet-sub-4">
             <a:extLst xmlns:a="http://schemas.openxmlformats.org/drawingml/2006/main">
               <a:ext uri="{FF2B5EF4-FFF2-40B4-BE49-F238E27FC236}">
-                <a16:creationId xmlns:a16="http://schemas.microsoft.com/office/drawing/2014/main" id="{6BFD50EA-6344-4C0B-8E99-D6DAB0ED3EF2}"/>
+                <a16:creationId xmlns:a16="http://schemas.microsoft.com/office/drawing/2014/main" id="{B3C5B18B-E602-491D-8952-35FDD0768C5A}"/>
               </a:ext>
             </a:extLst>
           </p:cNvPr>
@@ -16907,7 +16907,7 @@
           <p:cNvPr id="19" name="deliverable">
             <a:extLst xmlns:a="http://schemas.openxmlformats.org/drawingml/2006/main">
               <a:ext uri="{FF2B5EF4-FFF2-40B4-BE49-F238E27FC236}">
-                <a16:creationId xmlns:a16="http://schemas.microsoft.com/office/drawing/2014/main" id="{34F73C49-9A3C-4556-9A9E-293D189B7CD3}"/>
+                <a16:creationId xmlns:a16="http://schemas.microsoft.com/office/drawing/2014/main" id="{FCD11296-974E-486E-A753-C91F8EA97C33}"/>
               </a:ext>
             </a:extLst>
           </p:cNvPr>
@@ -16942,7 +16942,7 @@
           <p:cNvPr id="20" name="deliverable-text">
             <a:extLst xmlns:a="http://schemas.openxmlformats.org/drawingml/2006/main">
               <a:ext uri="{FF2B5EF4-FFF2-40B4-BE49-F238E27FC236}">
-                <a16:creationId xmlns:a16="http://schemas.microsoft.com/office/drawing/2014/main" id="{333F60F2-979A-4101-9D30-9DC00A30299F}"/>
+                <a16:creationId xmlns:a16="http://schemas.microsoft.com/office/drawing/2014/main" id="{604B8D82-6C70-4EA4-8CC3-78758C5E9C2C}"/>
               </a:ext>
             </a:extLst>
           </p:cNvPr>
@@ -17000,7 +17000,7 @@
     </p:spTree>
     <p:extLst>
       <p:ext uri="{BB962C8B-B14F-4D97-AF65-F5344CB8AC3E}">
-        <p14:creationId xmlns:p14="http://schemas.microsoft.com/office/powerpoint/2010/main" val="1577528478"/>
+        <p14:creationId xmlns:p14="http://schemas.microsoft.com/office/powerpoint/2010/main" val="1199288447"/>
       </p:ext>
     </p:extLst>
   </p:cSld>
@@ -17031,7 +17031,7 @@
           <p:cNvPr id="1" name="transition-title">
             <a:extLst xmlns:a="http://schemas.openxmlformats.org/drawingml/2006/main">
               <a:ext uri="{FF2B5EF4-FFF2-40B4-BE49-F238E27FC236}">
-                <a16:creationId xmlns:a16="http://schemas.microsoft.com/office/drawing/2014/main" id="{1F5CD473-3339-4548-922D-3B9C1760FA9A}"/>
+                <a16:creationId xmlns:a16="http://schemas.microsoft.com/office/drawing/2014/main" id="{B92EAAB8-E918-4205-B01E-9A9DB66BB4BC}"/>
               </a:ext>
             </a:extLst>
           </p:cNvPr>
@@ -17091,7 +17091,7 @@
           <p:cNvPr id="2" name="transition-subtitle">
             <a:extLst xmlns:a="http://schemas.openxmlformats.org/drawingml/2006/main">
               <a:ext uri="{FF2B5EF4-FFF2-40B4-BE49-F238E27FC236}">
-                <a16:creationId xmlns:a16="http://schemas.microsoft.com/office/drawing/2014/main" id="{BCF7E286-94D4-4839-98D5-34CCEF0AC293}"/>
+                <a16:creationId xmlns:a16="http://schemas.microsoft.com/office/drawing/2014/main" id="{ECDAC846-14B9-4307-AD37-67D0E216389F}"/>
               </a:ext>
             </a:extLst>
           </p:cNvPr>
@@ -17148,10 +17148,103 @@
       </p:sp>
       <p:sp>
         <p:nvSpPr>
-          <p:cNvPr id="3" name="model">
-            <a:extLst xmlns:a="http://schemas.openxmlformats.org/drawingml/2006/main">
-              <a:ext uri="{FF2B5EF4-FFF2-40B4-BE49-F238E27FC236}">
-                <a16:creationId xmlns:a16="http://schemas.microsoft.com/office/drawing/2014/main" id="{A0F0BFFA-B9FD-4762-BA1F-372ADBBADB20}"/>
+          <p:cNvPr id="3" name="model-to-bus">
+            <a:extLst xmlns:a="http://schemas.openxmlformats.org/drawingml/2006/main">
+              <a:ext uri="{FF2B5EF4-FFF2-40B4-BE49-F238E27FC236}">
+                <a16:creationId xmlns:a16="http://schemas.microsoft.com/office/drawing/2014/main" id="{9ED2FF9B-A66C-4927-BB7F-191D2D5DB959}"/>
+              </a:ext>
+            </a:extLst>
+          </p:cNvPr>
+          <p:cNvSpPr>
+            <a:spLocks xmlns:a="http://schemas.openxmlformats.org/drawingml/2006/main" noGrp="1"/>
+          </p:cNvSpPr>
+          <p:nvPr/>
+        </p:nvSpPr>
+        <p:spPr>
+          <a:xfrm xmlns:a="http://schemas.openxmlformats.org/drawingml/2006/main">
+            <a:off x="7924800" y="2952750"/>
+            <a:ext cx="0" cy="1828800"/>
+          </a:xfrm>
+          <a:prstGeom xmlns:a="http://schemas.openxmlformats.org/drawingml/2006/main" prst="line">
+            <a:avLst/>
+          </a:prstGeom>
+          <a:noFill xmlns:a="http://schemas.openxmlformats.org/drawingml/2006/main"/>
+          <a:ln xmlns:a="http://schemas.openxmlformats.org/drawingml/2006/main" w="11430">
+            <a:solidFill>
+              <a:srgbClr val="52616D"/>
+            </a:solidFill>
+            <a:prstDash val="solid"/>
+          </a:ln>
+        </p:spPr>
+      </p:sp>
+      <p:sp>
+        <p:nvSpPr>
+          <p:cNvPr id="4" name="context-to-bus">
+            <a:extLst xmlns:a="http://schemas.openxmlformats.org/drawingml/2006/main">
+              <a:ext uri="{FF2B5EF4-FFF2-40B4-BE49-F238E27FC236}">
+                <a16:creationId xmlns:a16="http://schemas.microsoft.com/office/drawing/2014/main" id="{6C56BE1A-FFDD-4CA7-AD42-19E9ED1DB257}"/>
+              </a:ext>
+            </a:extLst>
+          </p:cNvPr>
+          <p:cNvSpPr>
+            <a:spLocks xmlns:a="http://schemas.openxmlformats.org/drawingml/2006/main" noGrp="1"/>
+          </p:cNvSpPr>
+          <p:nvPr/>
+        </p:nvSpPr>
+        <p:spPr>
+          <a:xfrm xmlns:a="http://schemas.openxmlformats.org/drawingml/2006/main">
+            <a:off x="6724650" y="3876675"/>
+            <a:ext cx="1200150" cy="0"/>
+          </a:xfrm>
+          <a:prstGeom xmlns:a="http://schemas.openxmlformats.org/drawingml/2006/main" prst="line">
+            <a:avLst/>
+          </a:prstGeom>
+          <a:noFill xmlns:a="http://schemas.openxmlformats.org/drawingml/2006/main"/>
+          <a:ln xmlns:a="http://schemas.openxmlformats.org/drawingml/2006/main" w="11430">
+            <a:solidFill>
+              <a:srgbClr val="52616D"/>
+            </a:solidFill>
+            <a:prstDash val="solid"/>
+          </a:ln>
+        </p:spPr>
+      </p:sp>
+      <p:sp>
+        <p:nvSpPr>
+          <p:cNvPr id="5" name="bus-to-tools">
+            <a:extLst xmlns:a="http://schemas.openxmlformats.org/drawingml/2006/main">
+              <a:ext uri="{FF2B5EF4-FFF2-40B4-BE49-F238E27FC236}">
+                <a16:creationId xmlns:a16="http://schemas.microsoft.com/office/drawing/2014/main" id="{A50DCAA3-0F50-476E-9B52-CE2BFD7C03E2}"/>
+              </a:ext>
+            </a:extLst>
+          </p:cNvPr>
+          <p:cNvSpPr>
+            <a:spLocks xmlns:a="http://schemas.openxmlformats.org/drawingml/2006/main" noGrp="1"/>
+          </p:cNvSpPr>
+          <p:nvPr/>
+        </p:nvSpPr>
+        <p:spPr>
+          <a:xfrm xmlns:a="http://schemas.openxmlformats.org/drawingml/2006/main">
+            <a:off x="7924800" y="3876675"/>
+            <a:ext cx="1123950" cy="0"/>
+          </a:xfrm>
+          <a:prstGeom xmlns:a="http://schemas.openxmlformats.org/drawingml/2006/main" prst="line">
+            <a:avLst/>
+          </a:prstGeom>
+          <a:noFill xmlns:a="http://schemas.openxmlformats.org/drawingml/2006/main"/>
+          <a:ln xmlns:a="http://schemas.openxmlformats.org/drawingml/2006/main" w="11430">
+            <a:solidFill>
+              <a:srgbClr val="52616D"/>
+            </a:solidFill>
+            <a:prstDash val="solid"/>
+          </a:ln>
+        </p:spPr>
+      </p:sp>
+      <p:sp>
+        <p:nvSpPr>
+          <p:cNvPr id="6" name="model">
+            <a:extLst xmlns:a="http://schemas.openxmlformats.org/drawingml/2006/main">
+              <a:ext uri="{FF2B5EF4-FFF2-40B4-BE49-F238E27FC236}">
+                <a16:creationId xmlns:a16="http://schemas.microsoft.com/office/drawing/2014/main" id="{E9EA60EC-04A6-4F71-9578-71A928BBFAE2}"/>
               </a:ext>
             </a:extLst>
           </p:cNvPr>
@@ -17214,10 +17307,10 @@
       </p:sp>
       <p:sp>
         <p:nvSpPr>
-          <p:cNvPr id="4" name="context">
-            <a:extLst xmlns:a="http://schemas.openxmlformats.org/drawingml/2006/main">
-              <a:ext uri="{FF2B5EF4-FFF2-40B4-BE49-F238E27FC236}">
-                <a16:creationId xmlns:a16="http://schemas.microsoft.com/office/drawing/2014/main" id="{8ADD9A7B-3E55-4514-9E31-4DAFA5C133B5}"/>
+          <p:cNvPr id="7" name="context">
+            <a:extLst xmlns:a="http://schemas.openxmlformats.org/drawingml/2006/main">
+              <a:ext uri="{FF2B5EF4-FFF2-40B4-BE49-F238E27FC236}">
+                <a16:creationId xmlns:a16="http://schemas.microsoft.com/office/drawing/2014/main" id="{D0F82329-5489-411C-BDDF-90BA7C0688E2}"/>
               </a:ext>
             </a:extLst>
           </p:cNvPr>
@@ -17280,10 +17373,10 @@
       </p:sp>
       <p:sp>
         <p:nvSpPr>
-          <p:cNvPr id="5" name="tools">
-            <a:extLst xmlns:a="http://schemas.openxmlformats.org/drawingml/2006/main">
-              <a:ext uri="{FF2B5EF4-FFF2-40B4-BE49-F238E27FC236}">
-                <a16:creationId xmlns:a16="http://schemas.microsoft.com/office/drawing/2014/main" id="{1D504CD9-CE94-4A61-889D-C2F30CFAF3BA}"/>
+          <p:cNvPr id="8" name="tools">
+            <a:extLst xmlns:a="http://schemas.openxmlformats.org/drawingml/2006/main">
+              <a:ext uri="{FF2B5EF4-FFF2-40B4-BE49-F238E27FC236}">
+                <a16:creationId xmlns:a16="http://schemas.microsoft.com/office/drawing/2014/main" id="{4F8E5F5F-53D2-40CF-B2BA-D4FD648680CE}"/>
               </a:ext>
             </a:extLst>
           </p:cNvPr>
@@ -17346,21 +17439,21 @@
       </p:sp>
       <p:sp>
         <p:nvSpPr>
-          <p:cNvPr id="6" name="verify">
-            <a:extLst xmlns:a="http://schemas.openxmlformats.org/drawingml/2006/main">
-              <a:ext uri="{FF2B5EF4-FFF2-40B4-BE49-F238E27FC236}">
-                <a16:creationId xmlns:a16="http://schemas.microsoft.com/office/drawing/2014/main" id="{AA1E6C72-5AD7-4066-9333-A30BBF9EC84D}"/>
-              </a:ext>
-            </a:extLst>
-          </p:cNvPr>
-          <p:cNvSpPr>
-            <a:spLocks xmlns:a="http://schemas.openxmlformats.org/drawingml/2006/main" noGrp="1"/>
-          </p:cNvSpPr>
-          <p:nvPr/>
-        </p:nvSpPr>
-        <p:spPr>
-          <a:xfrm xmlns:a="http://schemas.openxmlformats.org/drawingml/2006/main">
-            <a:off x="7239000" y="4781550"/>
+          <p:cNvPr id="9" name="verify">
+            <a:extLst xmlns:a="http://schemas.openxmlformats.org/drawingml/2006/main">
+              <a:ext uri="{FF2B5EF4-FFF2-40B4-BE49-F238E27FC236}">
+                <a16:creationId xmlns:a16="http://schemas.microsoft.com/office/drawing/2014/main" id="{4FDEB1F7-BC53-43B1-856F-62DC83DF2650}"/>
+              </a:ext>
+            </a:extLst>
+          </p:cNvPr>
+          <p:cNvSpPr>
+            <a:spLocks xmlns:a="http://schemas.openxmlformats.org/drawingml/2006/main" noGrp="1"/>
+          </p:cNvSpPr>
+          <p:nvPr/>
+        </p:nvSpPr>
+        <p:spPr>
+          <a:xfrm xmlns:a="http://schemas.openxmlformats.org/drawingml/2006/main">
+            <a:off x="7296150" y="4781550"/>
             <a:ext cx="1257300" cy="476250"/>
           </a:xfrm>
           <a:prstGeom xmlns:a="http://schemas.openxmlformats.org/drawingml/2006/main" prst="roundRect">
@@ -17412,103 +17505,10 @@
       </p:sp>
       <p:sp>
         <p:nvSpPr>
-          <p:cNvPr id="7" name="l1">
-            <a:extLst xmlns:a="http://schemas.openxmlformats.org/drawingml/2006/main">
-              <a:ext uri="{FF2B5EF4-FFF2-40B4-BE49-F238E27FC236}">
-                <a16:creationId xmlns:a16="http://schemas.microsoft.com/office/drawing/2014/main" id="{2DC27495-7668-4C02-8BCF-0B741BE48A90}"/>
-              </a:ext>
-            </a:extLst>
-          </p:cNvPr>
-          <p:cNvSpPr>
-            <a:spLocks xmlns:a="http://schemas.openxmlformats.org/drawingml/2006/main" noGrp="1"/>
-          </p:cNvSpPr>
-          <p:nvPr/>
-        </p:nvSpPr>
-        <p:spPr>
-          <a:xfrm xmlns:a="http://schemas.openxmlformats.org/drawingml/2006/main">
-            <a:off x="6724650" y="2647950"/>
-            <a:ext cx="400050" cy="1219200"/>
-          </a:xfrm>
-          <a:prstGeom xmlns:a="http://schemas.openxmlformats.org/drawingml/2006/main" prst="line">
-            <a:avLst/>
-          </a:prstGeom>
-          <a:noFill xmlns:a="http://schemas.openxmlformats.org/drawingml/2006/main"/>
-          <a:ln xmlns:a="http://schemas.openxmlformats.org/drawingml/2006/main" w="11430">
-            <a:solidFill>
-              <a:srgbClr val="52616D"/>
-            </a:solidFill>
-            <a:prstDash val="solid"/>
-          </a:ln>
-        </p:spPr>
-      </p:sp>
-      <p:sp>
-        <p:nvSpPr>
-          <p:cNvPr id="8" name="l2">
-            <a:extLst xmlns:a="http://schemas.openxmlformats.org/drawingml/2006/main">
-              <a:ext uri="{FF2B5EF4-FFF2-40B4-BE49-F238E27FC236}">
-                <a16:creationId xmlns:a16="http://schemas.microsoft.com/office/drawing/2014/main" id="{CA756C9A-A79D-4B4C-B9FF-0184C04CBB3F}"/>
-              </a:ext>
-            </a:extLst>
-          </p:cNvPr>
-          <p:cNvSpPr>
-            <a:spLocks xmlns:a="http://schemas.openxmlformats.org/drawingml/2006/main" noGrp="1"/>
-          </p:cNvSpPr>
-          <p:nvPr/>
-        </p:nvSpPr>
-        <p:spPr>
-          <a:xfrm xmlns:a="http://schemas.openxmlformats.org/drawingml/2006/main">
-            <a:off x="8724900" y="2647950"/>
-            <a:ext cx="323850" cy="1219200"/>
-          </a:xfrm>
-          <a:prstGeom xmlns:a="http://schemas.openxmlformats.org/drawingml/2006/main" prst="line">
-            <a:avLst/>
-          </a:prstGeom>
-          <a:noFill xmlns:a="http://schemas.openxmlformats.org/drawingml/2006/main"/>
-          <a:ln xmlns:a="http://schemas.openxmlformats.org/drawingml/2006/main" w="11430">
-            <a:solidFill>
-              <a:srgbClr val="52616D"/>
-            </a:solidFill>
-            <a:prstDash val="solid"/>
-          </a:ln>
-        </p:spPr>
-      </p:sp>
-      <p:sp>
-        <p:nvSpPr>
-          <p:cNvPr id="9" name="l3">
-            <a:extLst xmlns:a="http://schemas.openxmlformats.org/drawingml/2006/main">
-              <a:ext uri="{FF2B5EF4-FFF2-40B4-BE49-F238E27FC236}">
-                <a16:creationId xmlns:a16="http://schemas.microsoft.com/office/drawing/2014/main" id="{50A8FCDB-0F45-44A6-B4AF-C4A3AC9F5928}"/>
-              </a:ext>
-            </a:extLst>
-          </p:cNvPr>
-          <p:cNvSpPr>
-            <a:spLocks xmlns:a="http://schemas.openxmlformats.org/drawingml/2006/main" noGrp="1"/>
-          </p:cNvSpPr>
-          <p:nvPr/>
-        </p:nvSpPr>
-        <p:spPr>
-          <a:xfrm xmlns:a="http://schemas.openxmlformats.org/drawingml/2006/main">
-            <a:off x="7867650" y="2952750"/>
-            <a:ext cx="57150" cy="1828800"/>
-          </a:xfrm>
-          <a:prstGeom xmlns:a="http://schemas.openxmlformats.org/drawingml/2006/main" prst="line">
-            <a:avLst/>
-          </a:prstGeom>
-          <a:noFill xmlns:a="http://schemas.openxmlformats.org/drawingml/2006/main"/>
-          <a:ln xmlns:a="http://schemas.openxmlformats.org/drawingml/2006/main" w="11430">
-            <a:solidFill>
-              <a:srgbClr val="52616D"/>
-            </a:solidFill>
-            <a:prstDash val="solid"/>
-          </a:ln>
-        </p:spPr>
-      </p:sp>
-      <p:sp>
-        <p:nvSpPr>
           <p:cNvPr id="10" name="wrap">
             <a:extLst xmlns:a="http://schemas.openxmlformats.org/drawingml/2006/main">
               <a:ext uri="{FF2B5EF4-FFF2-40B4-BE49-F238E27FC236}">
-                <a16:creationId xmlns:a16="http://schemas.microsoft.com/office/drawing/2014/main" id="{1495ED66-4FF1-4069-AF23-ECACCE124227}"/>
+                <a16:creationId xmlns:a16="http://schemas.microsoft.com/office/drawing/2014/main" id="{0B0634B0-0BFC-4A88-8B03-558E4011CE7E}"/>
               </a:ext>
             </a:extLst>
           </p:cNvPr>
@@ -17568,7 +17568,7 @@
           <p:cNvPr id="11" name="footer-dark">
             <a:extLst xmlns:a="http://schemas.openxmlformats.org/drawingml/2006/main">
               <a:ext uri="{FF2B5EF4-FFF2-40B4-BE49-F238E27FC236}">
-                <a16:creationId xmlns:a16="http://schemas.microsoft.com/office/drawing/2014/main" id="{C814F413-1980-4F26-8698-FA137F01CD9C}"/>
+                <a16:creationId xmlns:a16="http://schemas.microsoft.com/office/drawing/2014/main" id="{97753DEB-984B-41CB-8F6C-E71C1222DDAA}"/>
               </a:ext>
             </a:extLst>
           </p:cNvPr>
@@ -17626,7 +17626,7 @@
     </p:spTree>
     <p:extLst>
       <p:ext uri="{BB962C8B-B14F-4D97-AF65-F5344CB8AC3E}">
-        <p14:creationId xmlns:p14="http://schemas.microsoft.com/office/powerpoint/2010/main" val="454386638"/>
+        <p14:creationId xmlns:p14="http://schemas.microsoft.com/office/powerpoint/2010/main" val="2009985713"/>
       </p:ext>
     </p:extLst>
   </p:cSld>
@@ -17657,7 +17657,7 @@
           <p:cNvPr id="1" name="eyebrow">
             <a:extLst xmlns:a="http://schemas.openxmlformats.org/drawingml/2006/main">
               <a:ext uri="{FF2B5EF4-FFF2-40B4-BE49-F238E27FC236}">
-                <a16:creationId xmlns:a16="http://schemas.microsoft.com/office/drawing/2014/main" id="{15ED87D1-A141-415A-9695-DB427D391D80}"/>
+                <a16:creationId xmlns:a16="http://schemas.microsoft.com/office/drawing/2014/main" id="{280990F9-B04B-4208-9945-115E1F73DC32}"/>
               </a:ext>
             </a:extLst>
           </p:cNvPr>
@@ -17717,7 +17717,7 @@
           <p:cNvPr id="2" name="title">
             <a:extLst xmlns:a="http://schemas.openxmlformats.org/drawingml/2006/main">
               <a:ext uri="{FF2B5EF4-FFF2-40B4-BE49-F238E27FC236}">
-                <a16:creationId xmlns:a16="http://schemas.microsoft.com/office/drawing/2014/main" id="{9B002E9A-3C99-428B-85F6-3DBCE92D6A63}"/>
+                <a16:creationId xmlns:a16="http://schemas.microsoft.com/office/drawing/2014/main" id="{97227013-5A42-4782-8E6C-B407CE1116AF}"/>
               </a:ext>
             </a:extLst>
           </p:cNvPr>
@@ -17777,7 +17777,7 @@
           <p:cNvPr id="3" name="footer">
             <a:extLst xmlns:a="http://schemas.openxmlformats.org/drawingml/2006/main">
               <a:ext uri="{FF2B5EF4-FFF2-40B4-BE49-F238E27FC236}">
-                <a16:creationId xmlns:a16="http://schemas.microsoft.com/office/drawing/2014/main" id="{18592830-0911-4E02-A1B0-0D4A82405DCC}"/>
+                <a16:creationId xmlns:a16="http://schemas.microsoft.com/office/drawing/2014/main" id="{CBE971BB-C544-4325-9C5E-787A89EA21BB}"/>
               </a:ext>
             </a:extLst>
           </p:cNvPr>
@@ -17837,7 +17837,7 @@
           <p:cNvPr id="4" name="stack-0">
             <a:extLst xmlns:a="http://schemas.openxmlformats.org/drawingml/2006/main">
               <a:ext uri="{FF2B5EF4-FFF2-40B4-BE49-F238E27FC236}">
-                <a16:creationId xmlns:a16="http://schemas.microsoft.com/office/drawing/2014/main" id="{065E494F-DE96-4B28-AB0F-F46B925C6D09}"/>
+                <a16:creationId xmlns:a16="http://schemas.microsoft.com/office/drawing/2014/main" id="{1CDA1569-4BC3-4D3D-916F-A3F8750987DA}"/>
               </a:ext>
             </a:extLst>
           </p:cNvPr>
@@ -17872,7 +17872,7 @@
           <p:cNvPr id="5" name="stack-name-0">
             <a:extLst xmlns:a="http://schemas.openxmlformats.org/drawingml/2006/main">
               <a:ext uri="{FF2B5EF4-FFF2-40B4-BE49-F238E27FC236}">
-                <a16:creationId xmlns:a16="http://schemas.microsoft.com/office/drawing/2014/main" id="{D693E5F6-B302-4846-AE9E-0AF431CF4503}"/>
+                <a16:creationId xmlns:a16="http://schemas.microsoft.com/office/drawing/2014/main" id="{59E4F5F6-94D9-4381-983A-C8739B13CA48}"/>
               </a:ext>
             </a:extLst>
           </p:cNvPr>
@@ -17932,7 +17932,7 @@
           <p:cNvPr id="6" name="stack-copy-0">
             <a:extLst xmlns:a="http://schemas.openxmlformats.org/drawingml/2006/main">
               <a:ext uri="{FF2B5EF4-FFF2-40B4-BE49-F238E27FC236}">
-                <a16:creationId xmlns:a16="http://schemas.microsoft.com/office/drawing/2014/main" id="{1A0FCE96-1EA6-45D8-82BA-4C6E396D6708}"/>
+                <a16:creationId xmlns:a16="http://schemas.microsoft.com/office/drawing/2014/main" id="{2BA50940-74A1-4FA9-BC68-BA13E32FD931}"/>
               </a:ext>
             </a:extLst>
           </p:cNvPr>
@@ -17992,7 +17992,7 @@
           <p:cNvPr id="7" name="stack-line-0">
             <a:extLst xmlns:a="http://schemas.openxmlformats.org/drawingml/2006/main">
               <a:ext uri="{FF2B5EF4-FFF2-40B4-BE49-F238E27FC236}">
-                <a16:creationId xmlns:a16="http://schemas.microsoft.com/office/drawing/2014/main" id="{1D09CA15-E8E2-42ED-AC66-5F0DA895C4FF}"/>
+                <a16:creationId xmlns:a16="http://schemas.microsoft.com/office/drawing/2014/main" id="{4D8B5051-5FC4-4833-94A8-E46F35F6155A}"/>
               </a:ext>
             </a:extLst>
           </p:cNvPr>
@@ -18023,7 +18023,7 @@
           <p:cNvPr id="8" name="stack-1">
             <a:extLst xmlns:a="http://schemas.openxmlformats.org/drawingml/2006/main">
               <a:ext uri="{FF2B5EF4-FFF2-40B4-BE49-F238E27FC236}">
-                <a16:creationId xmlns:a16="http://schemas.microsoft.com/office/drawing/2014/main" id="{D9100362-2886-4EFB-BF55-27FB8A4F611C}"/>
+                <a16:creationId xmlns:a16="http://schemas.microsoft.com/office/drawing/2014/main" id="{54AC0C61-1A61-47A8-B4A5-5F214B1B9BF3}"/>
               </a:ext>
             </a:extLst>
           </p:cNvPr>
@@ -18058,7 +18058,7 @@
           <p:cNvPr id="9" name="stack-name-1">
             <a:extLst xmlns:a="http://schemas.openxmlformats.org/drawingml/2006/main">
               <a:ext uri="{FF2B5EF4-FFF2-40B4-BE49-F238E27FC236}">
-                <a16:creationId xmlns:a16="http://schemas.microsoft.com/office/drawing/2014/main" id="{E80F3C68-D2BF-4468-BBCA-20BA0A233993}"/>
+                <a16:creationId xmlns:a16="http://schemas.microsoft.com/office/drawing/2014/main" id="{681DC29D-BAAF-4DCD-BB82-66AC8F44FE79}"/>
               </a:ext>
             </a:extLst>
           </p:cNvPr>
@@ -18118,7 +18118,7 @@
           <p:cNvPr id="10" name="stack-copy-1">
             <a:extLst xmlns:a="http://schemas.openxmlformats.org/drawingml/2006/main">
               <a:ext uri="{FF2B5EF4-FFF2-40B4-BE49-F238E27FC236}">
-                <a16:creationId xmlns:a16="http://schemas.microsoft.com/office/drawing/2014/main" id="{CF922706-6222-4F71-9F24-DA8C1D118BAF}"/>
+                <a16:creationId xmlns:a16="http://schemas.microsoft.com/office/drawing/2014/main" id="{742B8E6E-79CA-4ECA-A426-5E150D606BC5}"/>
               </a:ext>
             </a:extLst>
           </p:cNvPr>
@@ -18178,7 +18178,7 @@
           <p:cNvPr id="11" name="stack-line-1">
             <a:extLst xmlns:a="http://schemas.openxmlformats.org/drawingml/2006/main">
               <a:ext uri="{FF2B5EF4-FFF2-40B4-BE49-F238E27FC236}">
-                <a16:creationId xmlns:a16="http://schemas.microsoft.com/office/drawing/2014/main" id="{207EA7AD-BFA0-4440-9FFE-5BA828BF5036}"/>
+                <a16:creationId xmlns:a16="http://schemas.microsoft.com/office/drawing/2014/main" id="{AE5CB788-1F5E-4308-B9F5-836D97524E56}"/>
               </a:ext>
             </a:extLst>
           </p:cNvPr>
@@ -18209,7 +18209,7 @@
           <p:cNvPr id="12" name="stack-2">
             <a:extLst xmlns:a="http://schemas.openxmlformats.org/drawingml/2006/main">
               <a:ext uri="{FF2B5EF4-FFF2-40B4-BE49-F238E27FC236}">
-                <a16:creationId xmlns:a16="http://schemas.microsoft.com/office/drawing/2014/main" id="{D3713E7B-75F8-497D-A5F0-8DE5782CD26E}"/>
+                <a16:creationId xmlns:a16="http://schemas.microsoft.com/office/drawing/2014/main" id="{F7125309-416A-4BD1-B8BF-58B95F6B7EB5}"/>
               </a:ext>
             </a:extLst>
           </p:cNvPr>
@@ -18244,7 +18244,7 @@
           <p:cNvPr id="13" name="stack-name-2">
             <a:extLst xmlns:a="http://schemas.openxmlformats.org/drawingml/2006/main">
               <a:ext uri="{FF2B5EF4-FFF2-40B4-BE49-F238E27FC236}">
-                <a16:creationId xmlns:a16="http://schemas.microsoft.com/office/drawing/2014/main" id="{E2510D33-BA78-4E84-881A-07D376BAC894}"/>
+                <a16:creationId xmlns:a16="http://schemas.microsoft.com/office/drawing/2014/main" id="{4FFFA8BB-D1FB-4277-A465-4F9D3DEC537B}"/>
               </a:ext>
             </a:extLst>
           </p:cNvPr>
@@ -18304,7 +18304,7 @@
           <p:cNvPr id="14" name="stack-copy-2">
             <a:extLst xmlns:a="http://schemas.openxmlformats.org/drawingml/2006/main">
               <a:ext uri="{FF2B5EF4-FFF2-40B4-BE49-F238E27FC236}">
-                <a16:creationId xmlns:a16="http://schemas.microsoft.com/office/drawing/2014/main" id="{657650BC-D9DF-4B5D-979F-E958207374CC}"/>
+                <a16:creationId xmlns:a16="http://schemas.microsoft.com/office/drawing/2014/main" id="{CBA2BAFB-DFBE-4689-B91B-03E57FC43132}"/>
               </a:ext>
             </a:extLst>
           </p:cNvPr>
@@ -18364,7 +18364,7 @@
           <p:cNvPr id="15" name="stack-line-2">
             <a:extLst xmlns:a="http://schemas.openxmlformats.org/drawingml/2006/main">
               <a:ext uri="{FF2B5EF4-FFF2-40B4-BE49-F238E27FC236}">
-                <a16:creationId xmlns:a16="http://schemas.microsoft.com/office/drawing/2014/main" id="{399AC744-4BBD-4700-B991-8FF117319EF6}"/>
+                <a16:creationId xmlns:a16="http://schemas.microsoft.com/office/drawing/2014/main" id="{927E2255-E86F-4B9D-9A30-D194A05CC69A}"/>
               </a:ext>
             </a:extLst>
           </p:cNvPr>
@@ -18395,7 +18395,7 @@
           <p:cNvPr id="16" name="stack-3">
             <a:extLst xmlns:a="http://schemas.openxmlformats.org/drawingml/2006/main">
               <a:ext uri="{FF2B5EF4-FFF2-40B4-BE49-F238E27FC236}">
-                <a16:creationId xmlns:a16="http://schemas.microsoft.com/office/drawing/2014/main" id="{FDEA6E0D-FD30-42DC-8B6C-FFBAD10F39EA}"/>
+                <a16:creationId xmlns:a16="http://schemas.microsoft.com/office/drawing/2014/main" id="{45D463E6-5A09-46E5-B447-0778CA787127}"/>
               </a:ext>
             </a:extLst>
           </p:cNvPr>
@@ -18430,7 +18430,7 @@
           <p:cNvPr id="17" name="stack-name-3">
             <a:extLst xmlns:a="http://schemas.openxmlformats.org/drawingml/2006/main">
               <a:ext uri="{FF2B5EF4-FFF2-40B4-BE49-F238E27FC236}">
-                <a16:creationId xmlns:a16="http://schemas.microsoft.com/office/drawing/2014/main" id="{61C161E4-70E7-4575-B7C0-BAFF324112CF}"/>
+                <a16:creationId xmlns:a16="http://schemas.microsoft.com/office/drawing/2014/main" id="{18E074E2-82A6-4A96-A250-A16C3C1B1209}"/>
               </a:ext>
             </a:extLst>
           </p:cNvPr>
@@ -18490,7 +18490,7 @@
           <p:cNvPr id="18" name="stack-copy-3">
             <a:extLst xmlns:a="http://schemas.openxmlformats.org/drawingml/2006/main">
               <a:ext uri="{FF2B5EF4-FFF2-40B4-BE49-F238E27FC236}">
-                <a16:creationId xmlns:a16="http://schemas.microsoft.com/office/drawing/2014/main" id="{B492158F-7C34-46C4-B943-3AD5C95FCD28}"/>
+                <a16:creationId xmlns:a16="http://schemas.microsoft.com/office/drawing/2014/main" id="{60C1FBC6-C4A6-452E-A68A-EDC2345B5708}"/>
               </a:ext>
             </a:extLst>
           </p:cNvPr>
@@ -18550,7 +18550,7 @@
           <p:cNvPr id="19" name="stack-line-3">
             <a:extLst xmlns:a="http://schemas.openxmlformats.org/drawingml/2006/main">
               <a:ext uri="{FF2B5EF4-FFF2-40B4-BE49-F238E27FC236}">
-                <a16:creationId xmlns:a16="http://schemas.microsoft.com/office/drawing/2014/main" id="{7A2004BB-B0B1-4EAF-9CB5-3CFC0613162B}"/>
+                <a16:creationId xmlns:a16="http://schemas.microsoft.com/office/drawing/2014/main" id="{5A42CA5B-7F7E-4DAD-8BBA-49597ABB47F7}"/>
               </a:ext>
             </a:extLst>
           </p:cNvPr>
@@ -18581,7 +18581,7 @@
           <p:cNvPr id="20" name="stack-4">
             <a:extLst xmlns:a="http://schemas.openxmlformats.org/drawingml/2006/main">
               <a:ext uri="{FF2B5EF4-FFF2-40B4-BE49-F238E27FC236}">
-                <a16:creationId xmlns:a16="http://schemas.microsoft.com/office/drawing/2014/main" id="{76E415E4-688E-4264-85A8-63948EA72FC2}"/>
+                <a16:creationId xmlns:a16="http://schemas.microsoft.com/office/drawing/2014/main" id="{DDD76E9E-113D-4CCC-A211-598E4034CA0F}"/>
               </a:ext>
             </a:extLst>
           </p:cNvPr>
@@ -18616,7 +18616,7 @@
           <p:cNvPr id="21" name="stack-name-4">
             <a:extLst xmlns:a="http://schemas.openxmlformats.org/drawingml/2006/main">
               <a:ext uri="{FF2B5EF4-FFF2-40B4-BE49-F238E27FC236}">
-                <a16:creationId xmlns:a16="http://schemas.microsoft.com/office/drawing/2014/main" id="{1D5DA4C4-176B-48FF-95EC-BD4908A18E81}"/>
+                <a16:creationId xmlns:a16="http://schemas.microsoft.com/office/drawing/2014/main" id="{333C445F-F37A-4DCF-9DD0-09AC738F0EED}"/>
               </a:ext>
             </a:extLst>
           </p:cNvPr>
@@ -18676,7 +18676,7 @@
           <p:cNvPr id="22" name="stack-copy-4">
             <a:extLst xmlns:a="http://schemas.openxmlformats.org/drawingml/2006/main">
               <a:ext uri="{FF2B5EF4-FFF2-40B4-BE49-F238E27FC236}">
-                <a16:creationId xmlns:a16="http://schemas.microsoft.com/office/drawing/2014/main" id="{76B20B41-0D53-440F-B50C-A0E3D3D9E9F8}"/>
+                <a16:creationId xmlns:a16="http://schemas.microsoft.com/office/drawing/2014/main" id="{67D77048-7B41-4D78-8CFD-DADFCDAC69D3}"/>
               </a:ext>
             </a:extLst>
           </p:cNvPr>
@@ -18736,7 +18736,7 @@
           <p:cNvPr id="23" name="stack-line-4">
             <a:extLst xmlns:a="http://schemas.openxmlformats.org/drawingml/2006/main">
               <a:ext uri="{FF2B5EF4-FFF2-40B4-BE49-F238E27FC236}">
-                <a16:creationId xmlns:a16="http://schemas.microsoft.com/office/drawing/2014/main" id="{3F477248-8376-4D30-A277-27E62C8A67DB}"/>
+                <a16:creationId xmlns:a16="http://schemas.microsoft.com/office/drawing/2014/main" id="{88088C0F-BFA2-4175-B01D-39D3CE2016F3}"/>
               </a:ext>
             </a:extLst>
           </p:cNvPr>
@@ -18767,7 +18767,7 @@
           <p:cNvPr id="24" name="goal-box">
             <a:extLst xmlns:a="http://schemas.openxmlformats.org/drawingml/2006/main">
               <a:ext uri="{FF2B5EF4-FFF2-40B4-BE49-F238E27FC236}">
-                <a16:creationId xmlns:a16="http://schemas.microsoft.com/office/drawing/2014/main" id="{D09EBFC4-5F5D-43D2-A281-3E0338EBE53C}"/>
+                <a16:creationId xmlns:a16="http://schemas.microsoft.com/office/drawing/2014/main" id="{2AA6F81E-606C-47D4-8C92-29C9A195B533}"/>
               </a:ext>
             </a:extLst>
           </p:cNvPr>
@@ -18802,7 +18802,7 @@
           <p:cNvPr id="25" name="goal-text">
             <a:extLst xmlns:a="http://schemas.openxmlformats.org/drawingml/2006/main">
               <a:ext uri="{FF2B5EF4-FFF2-40B4-BE49-F238E27FC236}">
-                <a16:creationId xmlns:a16="http://schemas.microsoft.com/office/drawing/2014/main" id="{1565A689-647E-4C45-871E-F64052222482}"/>
+                <a16:creationId xmlns:a16="http://schemas.microsoft.com/office/drawing/2014/main" id="{C7BCB0BC-698F-4300-8CB5-94FD4E6BE699}"/>
               </a:ext>
             </a:extLst>
           </p:cNvPr>
@@ -18860,7 +18860,7 @@
     </p:spTree>
     <p:extLst>
       <p:ext uri="{BB962C8B-B14F-4D97-AF65-F5344CB8AC3E}">
-        <p14:creationId xmlns:p14="http://schemas.microsoft.com/office/powerpoint/2010/main" val="436003649"/>
+        <p14:creationId xmlns:p14="http://schemas.microsoft.com/office/powerpoint/2010/main" val="1866729087"/>
       </p:ext>
     </p:extLst>
   </p:cSld>
@@ -18891,7 +18891,7 @@
           <p:cNvPr id="1" name="eyebrow">
             <a:extLst xmlns:a="http://schemas.openxmlformats.org/drawingml/2006/main">
               <a:ext uri="{FF2B5EF4-FFF2-40B4-BE49-F238E27FC236}">
-                <a16:creationId xmlns:a16="http://schemas.microsoft.com/office/drawing/2014/main" id="{D7B83A7F-7309-4028-A5D0-6BB4D834EC6B}"/>
+                <a16:creationId xmlns:a16="http://schemas.microsoft.com/office/drawing/2014/main" id="{94EDE1A8-907E-4DC7-AD9C-C7B4D99EE15E}"/>
               </a:ext>
             </a:extLst>
           </p:cNvPr>
@@ -18951,7 +18951,7 @@
           <p:cNvPr id="2" name="title">
             <a:extLst xmlns:a="http://schemas.openxmlformats.org/drawingml/2006/main">
               <a:ext uri="{FF2B5EF4-FFF2-40B4-BE49-F238E27FC236}">
-                <a16:creationId xmlns:a16="http://schemas.microsoft.com/office/drawing/2014/main" id="{950575BB-C4BA-4CE5-A965-9B2F87B6F6DF}"/>
+                <a16:creationId xmlns:a16="http://schemas.microsoft.com/office/drawing/2014/main" id="{E3403460-984F-46C2-A883-10DC9E5DE88C}"/>
               </a:ext>
             </a:extLst>
           </p:cNvPr>
@@ -19011,7 +19011,7 @@
           <p:cNvPr id="3" name="footer">
             <a:extLst xmlns:a="http://schemas.openxmlformats.org/drawingml/2006/main">
               <a:ext uri="{FF2B5EF4-FFF2-40B4-BE49-F238E27FC236}">
-                <a16:creationId xmlns:a16="http://schemas.microsoft.com/office/drawing/2014/main" id="{80FAFD23-F066-4558-B026-7167DD4DB18E}"/>
+                <a16:creationId xmlns:a16="http://schemas.microsoft.com/office/drawing/2014/main" id="{AF3D21BB-E6FE-4733-9E24-EB9B812B5F18}"/>
               </a:ext>
             </a:extLst>
           </p:cNvPr>
@@ -19071,7 +19071,7 @@
           <p:cNvPr id="4" name="lead">
             <a:extLst xmlns:a="http://schemas.openxmlformats.org/drawingml/2006/main">
               <a:ext uri="{FF2B5EF4-FFF2-40B4-BE49-F238E27FC236}">
-                <a16:creationId xmlns:a16="http://schemas.microsoft.com/office/drawing/2014/main" id="{75BB19F1-27FE-4069-AFAC-DDA6EEEBBE01}"/>
+                <a16:creationId xmlns:a16="http://schemas.microsoft.com/office/drawing/2014/main" id="{C3438BBD-C0DB-47C8-B81D-6F5B2AAD4F5E}"/>
               </a:ext>
             </a:extLst>
           </p:cNvPr>
@@ -19131,7 +19131,7 @@
           <p:cNvPr id="5" name="tool-card-0">
             <a:extLst xmlns:a="http://schemas.openxmlformats.org/drawingml/2006/main">
               <a:ext uri="{FF2B5EF4-FFF2-40B4-BE49-F238E27FC236}">
-                <a16:creationId xmlns:a16="http://schemas.microsoft.com/office/drawing/2014/main" id="{FADA5994-A63F-43EC-940D-D4C8B1801522}"/>
+                <a16:creationId xmlns:a16="http://schemas.microsoft.com/office/drawing/2014/main" id="{C413A9F3-7882-4716-9395-68FF96A9FD9C}"/>
               </a:ext>
             </a:extLst>
           </p:cNvPr>
@@ -19166,7 +19166,7 @@
           <p:cNvPr id="6" name="tool-name-0">
             <a:extLst xmlns:a="http://schemas.openxmlformats.org/drawingml/2006/main">
               <a:ext uri="{FF2B5EF4-FFF2-40B4-BE49-F238E27FC236}">
-                <a16:creationId xmlns:a16="http://schemas.microsoft.com/office/drawing/2014/main" id="{41FA8FA0-E5D8-470A-B77A-7BF9443FBE4A}"/>
+                <a16:creationId xmlns:a16="http://schemas.microsoft.com/office/drawing/2014/main" id="{A3FD445D-4547-473F-AB6C-CCA910E57E46}"/>
               </a:ext>
             </a:extLst>
           </p:cNvPr>
@@ -19226,7 +19226,7 @@
           <p:cNvPr id="7" name="tool-role-0">
             <a:extLst xmlns:a="http://schemas.openxmlformats.org/drawingml/2006/main">
               <a:ext uri="{FF2B5EF4-FFF2-40B4-BE49-F238E27FC236}">
-                <a16:creationId xmlns:a16="http://schemas.microsoft.com/office/drawing/2014/main" id="{539DE089-2E12-4269-9C62-37CA6DF69429}"/>
+                <a16:creationId xmlns:a16="http://schemas.microsoft.com/office/drawing/2014/main" id="{75C596E0-B766-4D54-B548-858A4DABAC06}"/>
               </a:ext>
             </a:extLst>
           </p:cNvPr>
@@ -19286,7 +19286,7 @@
           <p:cNvPr id="8" name="tool-uses-0">
             <a:extLst xmlns:a="http://schemas.openxmlformats.org/drawingml/2006/main">
               <a:ext uri="{FF2B5EF4-FFF2-40B4-BE49-F238E27FC236}">
-                <a16:creationId xmlns:a16="http://schemas.microsoft.com/office/drawing/2014/main" id="{E2F30EF8-89D4-4278-B55D-76EF3FB35139}"/>
+                <a16:creationId xmlns:a16="http://schemas.microsoft.com/office/drawing/2014/main" id="{0A2A5414-AFBF-456A-AB56-41EFA6A9DC78}"/>
               </a:ext>
             </a:extLst>
           </p:cNvPr>
@@ -19379,7 +19379,7 @@
           <p:cNvPr id="9" name="tool-caution-0">
             <a:extLst xmlns:a="http://schemas.openxmlformats.org/drawingml/2006/main">
               <a:ext uri="{FF2B5EF4-FFF2-40B4-BE49-F238E27FC236}">
-                <a16:creationId xmlns:a16="http://schemas.microsoft.com/office/drawing/2014/main" id="{1ACD9A83-3154-4D85-BBEF-BA9ED658A6FE}"/>
+                <a16:creationId xmlns:a16="http://schemas.microsoft.com/office/drawing/2014/main" id="{277FB96F-FC17-4BA7-A225-96DD89878D95}"/>
               </a:ext>
             </a:extLst>
           </p:cNvPr>
@@ -19439,7 +19439,7 @@
           <p:cNvPr id="10" name="tool-card-1">
             <a:extLst xmlns:a="http://schemas.openxmlformats.org/drawingml/2006/main">
               <a:ext uri="{FF2B5EF4-FFF2-40B4-BE49-F238E27FC236}">
-                <a16:creationId xmlns:a16="http://schemas.microsoft.com/office/drawing/2014/main" id="{15432C14-5C4C-4BE6-8069-0CB707896E06}"/>
+                <a16:creationId xmlns:a16="http://schemas.microsoft.com/office/drawing/2014/main" id="{C811DE16-3B95-4766-94FA-CFA047638678}"/>
               </a:ext>
             </a:extLst>
           </p:cNvPr>
@@ -19474,7 +19474,7 @@
           <p:cNvPr id="11" name="tool-name-1">
             <a:extLst xmlns:a="http://schemas.openxmlformats.org/drawingml/2006/main">
               <a:ext uri="{FF2B5EF4-FFF2-40B4-BE49-F238E27FC236}">
-                <a16:creationId xmlns:a16="http://schemas.microsoft.com/office/drawing/2014/main" id="{4E641F32-58F8-49E5-9952-A4B080EA366B}"/>
+                <a16:creationId xmlns:a16="http://schemas.microsoft.com/office/drawing/2014/main" id="{E06B8184-86E4-454E-AEED-2D0D2BD62A34}"/>
               </a:ext>
             </a:extLst>
           </p:cNvPr>
@@ -19534,7 +19534,7 @@
           <p:cNvPr id="12" name="tool-role-1">
             <a:extLst xmlns:a="http://schemas.openxmlformats.org/drawingml/2006/main">
               <a:ext uri="{FF2B5EF4-FFF2-40B4-BE49-F238E27FC236}">
-                <a16:creationId xmlns:a16="http://schemas.microsoft.com/office/drawing/2014/main" id="{3158D4C4-EB6A-453D-8B7D-208927848845}"/>
+                <a16:creationId xmlns:a16="http://schemas.microsoft.com/office/drawing/2014/main" id="{D6EC42A3-C86B-406D-9462-57721EA45432}"/>
               </a:ext>
             </a:extLst>
           </p:cNvPr>
@@ -19594,7 +19594,7 @@
           <p:cNvPr id="13" name="tool-uses-1">
             <a:extLst xmlns:a="http://schemas.openxmlformats.org/drawingml/2006/main">
               <a:ext uri="{FF2B5EF4-FFF2-40B4-BE49-F238E27FC236}">
-                <a16:creationId xmlns:a16="http://schemas.microsoft.com/office/drawing/2014/main" id="{AEE503C8-7823-4169-AB6E-B4E168A5BCDE}"/>
+                <a16:creationId xmlns:a16="http://schemas.microsoft.com/office/drawing/2014/main" id="{62118CE1-2F88-4918-A5B2-5A2484B5827E}"/>
               </a:ext>
             </a:extLst>
           </p:cNvPr>
@@ -19687,7 +19687,7 @@
           <p:cNvPr id="14" name="tool-caution-1">
             <a:extLst xmlns:a="http://schemas.openxmlformats.org/drawingml/2006/main">
               <a:ext uri="{FF2B5EF4-FFF2-40B4-BE49-F238E27FC236}">
-                <a16:creationId xmlns:a16="http://schemas.microsoft.com/office/drawing/2014/main" id="{EB18D0EF-A701-4797-87E2-016B1D257EFD}"/>
+                <a16:creationId xmlns:a16="http://schemas.microsoft.com/office/drawing/2014/main" id="{CAA29FEA-F0BB-4049-8A00-721779D0B36C}"/>
               </a:ext>
             </a:extLst>
           </p:cNvPr>
@@ -19747,7 +19747,7 @@
           <p:cNvPr id="15" name="tool-card-2">
             <a:extLst xmlns:a="http://schemas.openxmlformats.org/drawingml/2006/main">
               <a:ext uri="{FF2B5EF4-FFF2-40B4-BE49-F238E27FC236}">
-                <a16:creationId xmlns:a16="http://schemas.microsoft.com/office/drawing/2014/main" id="{7B04BAC4-08E3-485C-B23F-427C36B7BB6D}"/>
+                <a16:creationId xmlns:a16="http://schemas.microsoft.com/office/drawing/2014/main" id="{5E972E86-D8C5-4E10-8AE5-AC465B378038}"/>
               </a:ext>
             </a:extLst>
           </p:cNvPr>
@@ -19782,7 +19782,7 @@
           <p:cNvPr id="16" name="tool-name-2">
             <a:extLst xmlns:a="http://schemas.openxmlformats.org/drawingml/2006/main">
               <a:ext uri="{FF2B5EF4-FFF2-40B4-BE49-F238E27FC236}">
-                <a16:creationId xmlns:a16="http://schemas.microsoft.com/office/drawing/2014/main" id="{318A4CEE-DDA2-4066-AD5F-EAE456E7D54F}"/>
+                <a16:creationId xmlns:a16="http://schemas.microsoft.com/office/drawing/2014/main" id="{68F629D5-84D4-4EFE-9BD2-835555827F5C}"/>
               </a:ext>
             </a:extLst>
           </p:cNvPr>
@@ -19842,7 +19842,7 @@
           <p:cNvPr id="17" name="tool-role-2">
             <a:extLst xmlns:a="http://schemas.openxmlformats.org/drawingml/2006/main">
               <a:ext uri="{FF2B5EF4-FFF2-40B4-BE49-F238E27FC236}">
-                <a16:creationId xmlns:a16="http://schemas.microsoft.com/office/drawing/2014/main" id="{7C73DF1A-6605-4985-A002-A7635891AB8A}"/>
+                <a16:creationId xmlns:a16="http://schemas.microsoft.com/office/drawing/2014/main" id="{D71EAC59-5D85-4C3D-986C-C5422F7A429D}"/>
               </a:ext>
             </a:extLst>
           </p:cNvPr>
@@ -19902,7 +19902,7 @@
           <p:cNvPr id="18" name="tool-uses-2">
             <a:extLst xmlns:a="http://schemas.openxmlformats.org/drawingml/2006/main">
               <a:ext uri="{FF2B5EF4-FFF2-40B4-BE49-F238E27FC236}">
-                <a16:creationId xmlns:a16="http://schemas.microsoft.com/office/drawing/2014/main" id="{2EEA150D-D3FD-4E1D-8CEF-C41F1FB44FAC}"/>
+                <a16:creationId xmlns:a16="http://schemas.microsoft.com/office/drawing/2014/main" id="{D5F07BB9-3158-4145-9EB9-6BE6D38C0C79}"/>
               </a:ext>
             </a:extLst>
           </p:cNvPr>
@@ -19995,7 +19995,7 @@
           <p:cNvPr id="19" name="tool-caution-2">
             <a:extLst xmlns:a="http://schemas.openxmlformats.org/drawingml/2006/main">
               <a:ext uri="{FF2B5EF4-FFF2-40B4-BE49-F238E27FC236}">
-                <a16:creationId xmlns:a16="http://schemas.microsoft.com/office/drawing/2014/main" id="{EA6EDEFA-FC48-4539-BA2A-F3BC76307302}"/>
+                <a16:creationId xmlns:a16="http://schemas.microsoft.com/office/drawing/2014/main" id="{0C8979EB-0082-4406-9DF7-39834AFDCA17}"/>
               </a:ext>
             </a:extLst>
           </p:cNvPr>
@@ -20055,7 +20055,7 @@
           <p:cNvPr id="20" name="tool-card-3">
             <a:extLst xmlns:a="http://schemas.openxmlformats.org/drawingml/2006/main">
               <a:ext uri="{FF2B5EF4-FFF2-40B4-BE49-F238E27FC236}">
-                <a16:creationId xmlns:a16="http://schemas.microsoft.com/office/drawing/2014/main" id="{ABC8FCEE-2337-4586-A59F-C602C8632183}"/>
+                <a16:creationId xmlns:a16="http://schemas.microsoft.com/office/drawing/2014/main" id="{F19CDB44-DB14-4C02-9EC7-6EF36962E2AC}"/>
               </a:ext>
             </a:extLst>
           </p:cNvPr>
@@ -20090,7 +20090,7 @@
           <p:cNvPr id="21" name="tool-name-3">
             <a:extLst xmlns:a="http://schemas.openxmlformats.org/drawingml/2006/main">
               <a:ext uri="{FF2B5EF4-FFF2-40B4-BE49-F238E27FC236}">
-                <a16:creationId xmlns:a16="http://schemas.microsoft.com/office/drawing/2014/main" id="{A755B873-33DA-4969-8FEF-443E07A9D9AB}"/>
+                <a16:creationId xmlns:a16="http://schemas.microsoft.com/office/drawing/2014/main" id="{C8BD8782-5DDF-464A-8BCE-9D20988FBE57}"/>
               </a:ext>
             </a:extLst>
           </p:cNvPr>
@@ -20150,7 +20150,7 @@
           <p:cNvPr id="22" name="tool-role-3">
             <a:extLst xmlns:a="http://schemas.openxmlformats.org/drawingml/2006/main">
               <a:ext uri="{FF2B5EF4-FFF2-40B4-BE49-F238E27FC236}">
-                <a16:creationId xmlns:a16="http://schemas.microsoft.com/office/drawing/2014/main" id="{F60B67CF-9ED7-41DC-9871-2B921C3AB086}"/>
+                <a16:creationId xmlns:a16="http://schemas.microsoft.com/office/drawing/2014/main" id="{50A8356B-9535-49B4-AC91-CB6DD7B6953F}"/>
               </a:ext>
             </a:extLst>
           </p:cNvPr>
@@ -20210,7 +20210,7 @@
           <p:cNvPr id="23" name="tool-uses-3">
             <a:extLst xmlns:a="http://schemas.openxmlformats.org/drawingml/2006/main">
               <a:ext uri="{FF2B5EF4-FFF2-40B4-BE49-F238E27FC236}">
-                <a16:creationId xmlns:a16="http://schemas.microsoft.com/office/drawing/2014/main" id="{0C735687-504A-4BC1-B2CF-AE409052D9F5}"/>
+                <a16:creationId xmlns:a16="http://schemas.microsoft.com/office/drawing/2014/main" id="{7C3727C5-542C-4FF1-9EC7-E7B39FACF355}"/>
               </a:ext>
             </a:extLst>
           </p:cNvPr>
@@ -20303,7 +20303,7 @@
           <p:cNvPr id="24" name="tool-caution-3">
             <a:extLst xmlns:a="http://schemas.openxmlformats.org/drawingml/2006/main">
               <a:ext uri="{FF2B5EF4-FFF2-40B4-BE49-F238E27FC236}">
-                <a16:creationId xmlns:a16="http://schemas.microsoft.com/office/drawing/2014/main" id="{848DEBAC-2453-40B7-B0F8-3498CCBA3A2C}"/>
+                <a16:creationId xmlns:a16="http://schemas.microsoft.com/office/drawing/2014/main" id="{79FFE6BE-EF3B-451D-B69D-4BCF2F3F9030}"/>
               </a:ext>
             </a:extLst>
           </p:cNvPr>
@@ -20363,7 +20363,7 @@
           <p:cNvPr id="25" name="tool-card-4">
             <a:extLst xmlns:a="http://schemas.openxmlformats.org/drawingml/2006/main">
               <a:ext uri="{FF2B5EF4-FFF2-40B4-BE49-F238E27FC236}">
-                <a16:creationId xmlns:a16="http://schemas.microsoft.com/office/drawing/2014/main" id="{797DECE2-46B2-4F98-B51D-3198BA38E5EA}"/>
+                <a16:creationId xmlns:a16="http://schemas.microsoft.com/office/drawing/2014/main" id="{45D769F6-7F8A-47F6-988D-03066453D71C}"/>
               </a:ext>
             </a:extLst>
           </p:cNvPr>
@@ -20398,7 +20398,7 @@
           <p:cNvPr id="26" name="tool-name-4">
             <a:extLst xmlns:a="http://schemas.openxmlformats.org/drawingml/2006/main">
               <a:ext uri="{FF2B5EF4-FFF2-40B4-BE49-F238E27FC236}">
-                <a16:creationId xmlns:a16="http://schemas.microsoft.com/office/drawing/2014/main" id="{F1ABA207-ED51-4238-82A2-4C1FB4AEC8C0}"/>
+                <a16:creationId xmlns:a16="http://schemas.microsoft.com/office/drawing/2014/main" id="{3365BAAF-A06A-4EA3-A4E8-98458B9258BA}"/>
               </a:ext>
             </a:extLst>
           </p:cNvPr>
@@ -20458,7 +20458,7 @@
           <p:cNvPr id="27" name="tool-role-4">
             <a:extLst xmlns:a="http://schemas.openxmlformats.org/drawingml/2006/main">
               <a:ext uri="{FF2B5EF4-FFF2-40B4-BE49-F238E27FC236}">
-                <a16:creationId xmlns:a16="http://schemas.microsoft.com/office/drawing/2014/main" id="{03F69425-451D-46F7-9C00-EAD3DEBF1B05}"/>
+                <a16:creationId xmlns:a16="http://schemas.microsoft.com/office/drawing/2014/main" id="{80BF113D-D270-46C5-BCC2-4B5E5E865522}"/>
               </a:ext>
             </a:extLst>
           </p:cNvPr>
@@ -20518,7 +20518,7 @@
           <p:cNvPr id="28" name="tool-uses-4">
             <a:extLst xmlns:a="http://schemas.openxmlformats.org/drawingml/2006/main">
               <a:ext uri="{FF2B5EF4-FFF2-40B4-BE49-F238E27FC236}">
-                <a16:creationId xmlns:a16="http://schemas.microsoft.com/office/drawing/2014/main" id="{0442D350-A18C-4F91-A423-C5888EAC7EDE}"/>
+                <a16:creationId xmlns:a16="http://schemas.microsoft.com/office/drawing/2014/main" id="{288C1EF7-F90E-4DC8-8EFD-F2C15FAF1831}"/>
               </a:ext>
             </a:extLst>
           </p:cNvPr>
@@ -20611,7 +20611,7 @@
           <p:cNvPr id="29" name="tool-caution-4">
             <a:extLst xmlns:a="http://schemas.openxmlformats.org/drawingml/2006/main">
               <a:ext uri="{FF2B5EF4-FFF2-40B4-BE49-F238E27FC236}">
-                <a16:creationId xmlns:a16="http://schemas.microsoft.com/office/drawing/2014/main" id="{2E6B82BD-B22F-4826-A4CC-5585D0F69521}"/>
+                <a16:creationId xmlns:a16="http://schemas.microsoft.com/office/drawing/2014/main" id="{33EB83E4-0340-4863-8AEE-1E857FAD94A3}"/>
               </a:ext>
             </a:extLst>
           </p:cNvPr>
@@ -20671,7 +20671,7 @@
           <p:cNvPr id="30" name="tool-card-5">
             <a:extLst xmlns:a="http://schemas.openxmlformats.org/drawingml/2006/main">
               <a:ext uri="{FF2B5EF4-FFF2-40B4-BE49-F238E27FC236}">
-                <a16:creationId xmlns:a16="http://schemas.microsoft.com/office/drawing/2014/main" id="{81EEDEC1-984D-4A95-9AA6-B2B36E5B9015}"/>
+                <a16:creationId xmlns:a16="http://schemas.microsoft.com/office/drawing/2014/main" id="{111BD5F4-C1A2-4A67-A252-AE5E897EFD78}"/>
               </a:ext>
             </a:extLst>
           </p:cNvPr>
@@ -20706,7 +20706,7 @@
           <p:cNvPr id="31" name="tool-name-5">
             <a:extLst xmlns:a="http://schemas.openxmlformats.org/drawingml/2006/main">
               <a:ext uri="{FF2B5EF4-FFF2-40B4-BE49-F238E27FC236}">
-                <a16:creationId xmlns:a16="http://schemas.microsoft.com/office/drawing/2014/main" id="{B82DD7A7-D8CD-4778-9B2C-66026D8FFCB5}"/>
+                <a16:creationId xmlns:a16="http://schemas.microsoft.com/office/drawing/2014/main" id="{246A9FA6-F35C-4E04-8D57-4C22EA4E9D9E}"/>
               </a:ext>
             </a:extLst>
           </p:cNvPr>
@@ -20766,7 +20766,7 @@
           <p:cNvPr id="32" name="tool-role-5">
             <a:extLst xmlns:a="http://schemas.openxmlformats.org/drawingml/2006/main">
               <a:ext uri="{FF2B5EF4-FFF2-40B4-BE49-F238E27FC236}">
-                <a16:creationId xmlns:a16="http://schemas.microsoft.com/office/drawing/2014/main" id="{EAD22EC1-D622-4121-8F38-7BEDDEF18513}"/>
+                <a16:creationId xmlns:a16="http://schemas.microsoft.com/office/drawing/2014/main" id="{366804FC-D534-47F7-A9A4-922670B80EDE}"/>
               </a:ext>
             </a:extLst>
           </p:cNvPr>
@@ -20826,7 +20826,7 @@
           <p:cNvPr id="33" name="tool-uses-5">
             <a:extLst xmlns:a="http://schemas.openxmlformats.org/drawingml/2006/main">
               <a:ext uri="{FF2B5EF4-FFF2-40B4-BE49-F238E27FC236}">
-                <a16:creationId xmlns:a16="http://schemas.microsoft.com/office/drawing/2014/main" id="{1A681CD7-C036-458E-BFEF-A533C1CB27EB}"/>
+                <a16:creationId xmlns:a16="http://schemas.microsoft.com/office/drawing/2014/main" id="{2638C845-79AD-42A0-8D27-29BC593F0CD2}"/>
               </a:ext>
             </a:extLst>
           </p:cNvPr>
@@ -20919,7 +20919,7 @@
           <p:cNvPr id="34" name="tool-caution-5">
             <a:extLst xmlns:a="http://schemas.openxmlformats.org/drawingml/2006/main">
               <a:ext uri="{FF2B5EF4-FFF2-40B4-BE49-F238E27FC236}">
-                <a16:creationId xmlns:a16="http://schemas.microsoft.com/office/drawing/2014/main" id="{43649135-4D17-4DF4-82F1-2FCF4D3E66F0}"/>
+                <a16:creationId xmlns:a16="http://schemas.microsoft.com/office/drawing/2014/main" id="{516D6AC0-E270-4F3D-A24B-8E1623F118A5}"/>
               </a:ext>
             </a:extLst>
           </p:cNvPr>
@@ -20979,7 +20979,7 @@
           <p:cNvPr id="35" name="bottom">
             <a:extLst xmlns:a="http://schemas.openxmlformats.org/drawingml/2006/main">
               <a:ext uri="{FF2B5EF4-FFF2-40B4-BE49-F238E27FC236}">
-                <a16:creationId xmlns:a16="http://schemas.microsoft.com/office/drawing/2014/main" id="{0DCD5A8D-E4A1-4A0A-9364-3DBE19987BFC}"/>
+                <a16:creationId xmlns:a16="http://schemas.microsoft.com/office/drawing/2014/main" id="{9069F865-4E81-4407-A76F-8E8CF5F68223}"/>
               </a:ext>
             </a:extLst>
           </p:cNvPr>
@@ -21037,7 +21037,7 @@
     </p:spTree>
     <p:extLst>
       <p:ext uri="{BB962C8B-B14F-4D97-AF65-F5344CB8AC3E}">
-        <p14:creationId xmlns:p14="http://schemas.microsoft.com/office/powerpoint/2010/main" val="377860012"/>
+        <p14:creationId xmlns:p14="http://schemas.microsoft.com/office/powerpoint/2010/main" val="814698357"/>
       </p:ext>
     </p:extLst>
   </p:cSld>
@@ -21068,7 +21068,7 @@
           <p:cNvPr id="1" name="eyebrow">
             <a:extLst xmlns:a="http://schemas.openxmlformats.org/drawingml/2006/main">
               <a:ext uri="{FF2B5EF4-FFF2-40B4-BE49-F238E27FC236}">
-                <a16:creationId xmlns:a16="http://schemas.microsoft.com/office/drawing/2014/main" id="{60CA8FA9-CB25-4C2B-93C7-DEA359E0A2A9}"/>
+                <a16:creationId xmlns:a16="http://schemas.microsoft.com/office/drawing/2014/main" id="{D2D843F8-D9D8-41ED-B470-029C6ADB2608}"/>
               </a:ext>
             </a:extLst>
           </p:cNvPr>
@@ -21128,7 +21128,7 @@
           <p:cNvPr id="2" name="title">
             <a:extLst xmlns:a="http://schemas.openxmlformats.org/drawingml/2006/main">
               <a:ext uri="{FF2B5EF4-FFF2-40B4-BE49-F238E27FC236}">
-                <a16:creationId xmlns:a16="http://schemas.microsoft.com/office/drawing/2014/main" id="{6EEB4100-04EC-4834-8534-F8CFD1A59A1D}"/>
+                <a16:creationId xmlns:a16="http://schemas.microsoft.com/office/drawing/2014/main" id="{194E604A-7129-4108-AE19-CF4CFBFC747C}"/>
               </a:ext>
             </a:extLst>
           </p:cNvPr>
@@ -21188,7 +21188,7 @@
           <p:cNvPr id="3" name="footer">
             <a:extLst xmlns:a="http://schemas.openxmlformats.org/drawingml/2006/main">
               <a:ext uri="{FF2B5EF4-FFF2-40B4-BE49-F238E27FC236}">
-                <a16:creationId xmlns:a16="http://schemas.microsoft.com/office/drawing/2014/main" id="{6DC370E2-A2C3-4B91-B9AF-265428507A96}"/>
+                <a16:creationId xmlns:a16="http://schemas.microsoft.com/office/drawing/2014/main" id="{7CBCBF62-E1D9-4052-AFF5-6F394D0A602A}"/>
               </a:ext>
             </a:extLst>
           </p:cNvPr>
@@ -21248,7 +21248,7 @@
           <p:cNvPr id="4" name="lead">
             <a:extLst xmlns:a="http://schemas.openxmlformats.org/drawingml/2006/main">
               <a:ext uri="{FF2B5EF4-FFF2-40B4-BE49-F238E27FC236}">
-                <a16:creationId xmlns:a16="http://schemas.microsoft.com/office/drawing/2014/main" id="{CFBEFC8B-ED7F-4AC2-B54C-FBDD26B15C36}"/>
+                <a16:creationId xmlns:a16="http://schemas.microsoft.com/office/drawing/2014/main" id="{FC18C8AB-70CC-4292-91B5-6435A50105FF}"/>
               </a:ext>
             </a:extLst>
           </p:cNvPr>
@@ -21308,7 +21308,7 @@
           <p:cNvPr id="5" name="head-0">
             <a:extLst xmlns:a="http://schemas.openxmlformats.org/drawingml/2006/main">
               <a:ext uri="{FF2B5EF4-FFF2-40B4-BE49-F238E27FC236}">
-                <a16:creationId xmlns:a16="http://schemas.microsoft.com/office/drawing/2014/main" id="{8E47BC42-082F-4EC1-89B4-70EA1732BA38}"/>
+                <a16:creationId xmlns:a16="http://schemas.microsoft.com/office/drawing/2014/main" id="{88A39CE6-F31A-416E-BDCF-B2A189E99A82}"/>
               </a:ext>
             </a:extLst>
           </p:cNvPr>
@@ -21368,7 +21368,7 @@
           <p:cNvPr id="6" name="head-1">
             <a:extLst xmlns:a="http://schemas.openxmlformats.org/drawingml/2006/main">
               <a:ext uri="{FF2B5EF4-FFF2-40B4-BE49-F238E27FC236}">
-                <a16:creationId xmlns:a16="http://schemas.microsoft.com/office/drawing/2014/main" id="{3C97F943-4D86-4646-9538-F8FDA973D596}"/>
+                <a16:creationId xmlns:a16="http://schemas.microsoft.com/office/drawing/2014/main" id="{E02432D7-37CF-45E2-B7FE-C06B99C1BE2E}"/>
               </a:ext>
             </a:extLst>
           </p:cNvPr>
@@ -21428,7 +21428,7 @@
           <p:cNvPr id="7" name="head-2">
             <a:extLst xmlns:a="http://schemas.openxmlformats.org/drawingml/2006/main">
               <a:ext uri="{FF2B5EF4-FFF2-40B4-BE49-F238E27FC236}">
-                <a16:creationId xmlns:a16="http://schemas.microsoft.com/office/drawing/2014/main" id="{69028FE8-3867-4CA3-8E10-DC3AE96CD96C}"/>
+                <a16:creationId xmlns:a16="http://schemas.microsoft.com/office/drawing/2014/main" id="{9F9A57CA-F5AD-414D-80FA-5F439EF01A32}"/>
               </a:ext>
             </a:extLst>
           </p:cNvPr>
@@ -21488,7 +21488,7 @@
           <p:cNvPr id="8" name="row-bg-0">
             <a:extLst xmlns:a="http://schemas.openxmlformats.org/drawingml/2006/main">
               <a:ext uri="{FF2B5EF4-FFF2-40B4-BE49-F238E27FC236}">
-                <a16:creationId xmlns:a16="http://schemas.microsoft.com/office/drawing/2014/main" id="{B4D59466-975A-4CE8-9D1E-7A488D4A7585}"/>
+                <a16:creationId xmlns:a16="http://schemas.microsoft.com/office/drawing/2014/main" id="{CA933904-8E3E-4636-9A71-6DB177F78CAD}"/>
               </a:ext>
             </a:extLst>
           </p:cNvPr>
@@ -21523,7 +21523,7 @@
           <p:cNvPr id="9" name="tool-0">
             <a:extLst xmlns:a="http://schemas.openxmlformats.org/drawingml/2006/main">
               <a:ext uri="{FF2B5EF4-FFF2-40B4-BE49-F238E27FC236}">
-                <a16:creationId xmlns:a16="http://schemas.microsoft.com/office/drawing/2014/main" id="{C5B31640-767B-4FD3-B285-2F332E1A071B}"/>
+                <a16:creationId xmlns:a16="http://schemas.microsoft.com/office/drawing/2014/main" id="{52CA118B-2BB9-4D7E-A1EE-8D61C3D24CC7}"/>
               </a:ext>
             </a:extLst>
           </p:cNvPr>
@@ -21583,7 +21583,7 @@
           <p:cNvPr id="10" name="artifact-0">
             <a:extLst xmlns:a="http://schemas.openxmlformats.org/drawingml/2006/main">
               <a:ext uri="{FF2B5EF4-FFF2-40B4-BE49-F238E27FC236}">
-                <a16:creationId xmlns:a16="http://schemas.microsoft.com/office/drawing/2014/main" id="{E55BF74E-C029-4771-B68B-ADD57E1F0C33}"/>
+                <a16:creationId xmlns:a16="http://schemas.microsoft.com/office/drawing/2014/main" id="{7FC9048D-8CB9-4BC6-B830-831A826D3053}"/>
               </a:ext>
             </a:extLst>
           </p:cNvPr>
@@ -21643,7 +21643,7 @@
           <p:cNvPr id="11" name="check-0">
             <a:extLst xmlns:a="http://schemas.openxmlformats.org/drawingml/2006/main">
               <a:ext uri="{FF2B5EF4-FFF2-40B4-BE49-F238E27FC236}">
-                <a16:creationId xmlns:a16="http://schemas.microsoft.com/office/drawing/2014/main" id="{FF97F833-3993-4ED8-892E-727FEE4EF6BF}"/>
+                <a16:creationId xmlns:a16="http://schemas.microsoft.com/office/drawing/2014/main" id="{EAF5CCBA-2251-42CB-9EDA-8355FA294A8E}"/>
               </a:ext>
             </a:extLst>
           </p:cNvPr>
@@ -21703,7 +21703,7 @@
           <p:cNvPr id="12" name="row-bg-1">
             <a:extLst xmlns:a="http://schemas.openxmlformats.org/drawingml/2006/main">
               <a:ext uri="{FF2B5EF4-FFF2-40B4-BE49-F238E27FC236}">
-                <a16:creationId xmlns:a16="http://schemas.microsoft.com/office/drawing/2014/main" id="{4170D26B-D707-4389-8917-3261FDC21735}"/>
+                <a16:creationId xmlns:a16="http://schemas.microsoft.com/office/drawing/2014/main" id="{96A1E980-DEB1-4BC7-ACCA-6B0E774BB071}"/>
               </a:ext>
             </a:extLst>
           </p:cNvPr>
@@ -21738,7 +21738,7 @@
           <p:cNvPr id="13" name="tool-1">
             <a:extLst xmlns:a="http://schemas.openxmlformats.org/drawingml/2006/main">
               <a:ext uri="{FF2B5EF4-FFF2-40B4-BE49-F238E27FC236}">
-                <a16:creationId xmlns:a16="http://schemas.microsoft.com/office/drawing/2014/main" id="{E1A02202-EE00-4361-9580-ACE96136BCDA}"/>
+                <a16:creationId xmlns:a16="http://schemas.microsoft.com/office/drawing/2014/main" id="{729CFA48-4B41-43EE-BCBC-20BB7D7030CC}"/>
               </a:ext>
             </a:extLst>
           </p:cNvPr>
@@ -21798,7 +21798,7 @@
           <p:cNvPr id="14" name="artifact-1">
             <a:extLst xmlns:a="http://schemas.openxmlformats.org/drawingml/2006/main">
               <a:ext uri="{FF2B5EF4-FFF2-40B4-BE49-F238E27FC236}">
-                <a16:creationId xmlns:a16="http://schemas.microsoft.com/office/drawing/2014/main" id="{34D8DC59-2D35-47DE-B85A-B54A022BFCD2}"/>
+                <a16:creationId xmlns:a16="http://schemas.microsoft.com/office/drawing/2014/main" id="{671E59E6-8FE8-46DA-A295-1DA68E25D6A1}"/>
               </a:ext>
             </a:extLst>
           </p:cNvPr>
@@ -21858,7 +21858,7 @@
           <p:cNvPr id="15" name="check-1">
             <a:extLst xmlns:a="http://schemas.openxmlformats.org/drawingml/2006/main">
               <a:ext uri="{FF2B5EF4-FFF2-40B4-BE49-F238E27FC236}">
-                <a16:creationId xmlns:a16="http://schemas.microsoft.com/office/drawing/2014/main" id="{0EF85BCC-5585-47A6-A44E-164DC7F3B630}"/>
+                <a16:creationId xmlns:a16="http://schemas.microsoft.com/office/drawing/2014/main" id="{D8E752FF-B4AF-434E-B08B-868A23C5F4BA}"/>
               </a:ext>
             </a:extLst>
           </p:cNvPr>
@@ -21918,7 +21918,7 @@
           <p:cNvPr id="16" name="row-bg-2">
             <a:extLst xmlns:a="http://schemas.openxmlformats.org/drawingml/2006/main">
               <a:ext uri="{FF2B5EF4-FFF2-40B4-BE49-F238E27FC236}">
-                <a16:creationId xmlns:a16="http://schemas.microsoft.com/office/drawing/2014/main" id="{C60DFCDB-A143-42FF-BD8C-59DD63490892}"/>
+                <a16:creationId xmlns:a16="http://schemas.microsoft.com/office/drawing/2014/main" id="{BC1C7324-34E5-4448-84AB-FCF79E768839}"/>
               </a:ext>
             </a:extLst>
           </p:cNvPr>
@@ -21953,7 +21953,7 @@
           <p:cNvPr id="17" name="tool-2">
             <a:extLst xmlns:a="http://schemas.openxmlformats.org/drawingml/2006/main">
               <a:ext uri="{FF2B5EF4-FFF2-40B4-BE49-F238E27FC236}">
-                <a16:creationId xmlns:a16="http://schemas.microsoft.com/office/drawing/2014/main" id="{F793F9F9-056E-41F2-B331-ADC4C5D025EA}"/>
+                <a16:creationId xmlns:a16="http://schemas.microsoft.com/office/drawing/2014/main" id="{44F2D0A3-4354-4D42-BEF6-CAE67EF8BE07}"/>
               </a:ext>
             </a:extLst>
           </p:cNvPr>
@@ -22013,7 +22013,7 @@
           <p:cNvPr id="18" name="artifact-2">
             <a:extLst xmlns:a="http://schemas.openxmlformats.org/drawingml/2006/main">
               <a:ext uri="{FF2B5EF4-FFF2-40B4-BE49-F238E27FC236}">
-                <a16:creationId xmlns:a16="http://schemas.microsoft.com/office/drawing/2014/main" id="{E1C68DFB-F372-42FD-B9B0-6885BF752046}"/>
+                <a16:creationId xmlns:a16="http://schemas.microsoft.com/office/drawing/2014/main" id="{A05B0F05-3BF5-4064-8510-845736ECE6FF}"/>
               </a:ext>
             </a:extLst>
           </p:cNvPr>
@@ -22073,7 +22073,7 @@
           <p:cNvPr id="19" name="check-2">
             <a:extLst xmlns:a="http://schemas.openxmlformats.org/drawingml/2006/main">
               <a:ext uri="{FF2B5EF4-FFF2-40B4-BE49-F238E27FC236}">
-                <a16:creationId xmlns:a16="http://schemas.microsoft.com/office/drawing/2014/main" id="{B9C0C237-2898-47D7-8928-40C24C00ED00}"/>
+                <a16:creationId xmlns:a16="http://schemas.microsoft.com/office/drawing/2014/main" id="{636DD510-12E9-4591-8E7B-D04895E5253D}"/>
               </a:ext>
             </a:extLst>
           </p:cNvPr>
@@ -22133,7 +22133,7 @@
           <p:cNvPr id="20" name="row-bg-3">
             <a:extLst xmlns:a="http://schemas.openxmlformats.org/drawingml/2006/main">
               <a:ext uri="{FF2B5EF4-FFF2-40B4-BE49-F238E27FC236}">
-                <a16:creationId xmlns:a16="http://schemas.microsoft.com/office/drawing/2014/main" id="{D9DE385E-9D28-4738-A0A3-94E859556E77}"/>
+                <a16:creationId xmlns:a16="http://schemas.microsoft.com/office/drawing/2014/main" id="{F029ACE9-54F5-42EB-837D-3DBF1B9B324B}"/>
               </a:ext>
             </a:extLst>
           </p:cNvPr>
@@ -22168,7 +22168,7 @@
           <p:cNvPr id="21" name="tool-3">
             <a:extLst xmlns:a="http://schemas.openxmlformats.org/drawingml/2006/main">
               <a:ext uri="{FF2B5EF4-FFF2-40B4-BE49-F238E27FC236}">
-                <a16:creationId xmlns:a16="http://schemas.microsoft.com/office/drawing/2014/main" id="{24DAE259-F07D-4E64-96B4-31E88C4A5259}"/>
+                <a16:creationId xmlns:a16="http://schemas.microsoft.com/office/drawing/2014/main" id="{7C7F46A1-AAE5-49ED-801C-C56094ECF326}"/>
               </a:ext>
             </a:extLst>
           </p:cNvPr>
@@ -22228,7 +22228,7 @@
           <p:cNvPr id="22" name="artifact-3">
             <a:extLst xmlns:a="http://schemas.openxmlformats.org/drawingml/2006/main">
               <a:ext uri="{FF2B5EF4-FFF2-40B4-BE49-F238E27FC236}">
-                <a16:creationId xmlns:a16="http://schemas.microsoft.com/office/drawing/2014/main" id="{B123E7A1-9F3F-44AD-974E-622FE5CAA364}"/>
+                <a16:creationId xmlns:a16="http://schemas.microsoft.com/office/drawing/2014/main" id="{C56BA974-229C-4A1A-82A8-3B7E09982958}"/>
               </a:ext>
             </a:extLst>
           </p:cNvPr>
@@ -22288,7 +22288,7 @@
           <p:cNvPr id="23" name="check-3">
             <a:extLst xmlns:a="http://schemas.openxmlformats.org/drawingml/2006/main">
               <a:ext uri="{FF2B5EF4-FFF2-40B4-BE49-F238E27FC236}">
-                <a16:creationId xmlns:a16="http://schemas.microsoft.com/office/drawing/2014/main" id="{73F0F072-676E-45C7-9DBF-814A553EC507}"/>
+                <a16:creationId xmlns:a16="http://schemas.microsoft.com/office/drawing/2014/main" id="{F4F3BD27-285F-4E30-A0FB-4A27914E7566}"/>
               </a:ext>
             </a:extLst>
           </p:cNvPr>
@@ -22348,7 +22348,7 @@
           <p:cNvPr id="24" name="row-bg-4">
             <a:extLst xmlns:a="http://schemas.openxmlformats.org/drawingml/2006/main">
               <a:ext uri="{FF2B5EF4-FFF2-40B4-BE49-F238E27FC236}">
-                <a16:creationId xmlns:a16="http://schemas.microsoft.com/office/drawing/2014/main" id="{0418E79D-03E9-4C57-B711-9B917859C378}"/>
+                <a16:creationId xmlns:a16="http://schemas.microsoft.com/office/drawing/2014/main" id="{CF698689-02DB-47E8-A6C7-ABC512E60A90}"/>
               </a:ext>
             </a:extLst>
           </p:cNvPr>
@@ -22383,7 +22383,7 @@
           <p:cNvPr id="25" name="tool-4">
             <a:extLst xmlns:a="http://schemas.openxmlformats.org/drawingml/2006/main">
               <a:ext uri="{FF2B5EF4-FFF2-40B4-BE49-F238E27FC236}">
-                <a16:creationId xmlns:a16="http://schemas.microsoft.com/office/drawing/2014/main" id="{EC34B77F-E364-43EC-A2F8-0CA1F8F191AB}"/>
+                <a16:creationId xmlns:a16="http://schemas.microsoft.com/office/drawing/2014/main" id="{6328E48E-9B4B-4405-B5DB-FF85EF71455A}"/>
               </a:ext>
             </a:extLst>
           </p:cNvPr>
@@ -22443,7 +22443,7 @@
           <p:cNvPr id="26" name="artifact-4">
             <a:extLst xmlns:a="http://schemas.openxmlformats.org/drawingml/2006/main">
               <a:ext uri="{FF2B5EF4-FFF2-40B4-BE49-F238E27FC236}">
-                <a16:creationId xmlns:a16="http://schemas.microsoft.com/office/drawing/2014/main" id="{29FAE40B-817E-401E-A242-57F7CF5B03D7}"/>
+                <a16:creationId xmlns:a16="http://schemas.microsoft.com/office/drawing/2014/main" id="{198C2B98-B270-4466-A823-A74BADE8E3E8}"/>
               </a:ext>
             </a:extLst>
           </p:cNvPr>
@@ -22503,7 +22503,7 @@
           <p:cNvPr id="27" name="check-4">
             <a:extLst xmlns:a="http://schemas.openxmlformats.org/drawingml/2006/main">
               <a:ext uri="{FF2B5EF4-FFF2-40B4-BE49-F238E27FC236}">
-                <a16:creationId xmlns:a16="http://schemas.microsoft.com/office/drawing/2014/main" id="{4DC4EB08-DBE7-44CF-9091-BBB28E52B8BD}"/>
+                <a16:creationId xmlns:a16="http://schemas.microsoft.com/office/drawing/2014/main" id="{878AF443-3B81-4AB6-848E-2976FE1336D3}"/>
               </a:ext>
             </a:extLst>
           </p:cNvPr>
@@ -22563,7 +22563,7 @@
           <p:cNvPr id="28" name="row-bg-5">
             <a:extLst xmlns:a="http://schemas.openxmlformats.org/drawingml/2006/main">
               <a:ext uri="{FF2B5EF4-FFF2-40B4-BE49-F238E27FC236}">
-                <a16:creationId xmlns:a16="http://schemas.microsoft.com/office/drawing/2014/main" id="{EE08E2AB-F725-44CD-BDFA-3727B7082BFA}"/>
+                <a16:creationId xmlns:a16="http://schemas.microsoft.com/office/drawing/2014/main" id="{3A5824FB-E883-4880-8507-84DE2F62C2BE}"/>
               </a:ext>
             </a:extLst>
           </p:cNvPr>
@@ -22598,7 +22598,7 @@
           <p:cNvPr id="29" name="tool-5">
             <a:extLst xmlns:a="http://schemas.openxmlformats.org/drawingml/2006/main">
               <a:ext uri="{FF2B5EF4-FFF2-40B4-BE49-F238E27FC236}">
-                <a16:creationId xmlns:a16="http://schemas.microsoft.com/office/drawing/2014/main" id="{2791D11D-F96A-43F9-9F9A-DE2E14A4C5CE}"/>
+                <a16:creationId xmlns:a16="http://schemas.microsoft.com/office/drawing/2014/main" id="{848C38E7-BED3-4AE7-A96A-85D069BBA7FA}"/>
               </a:ext>
             </a:extLst>
           </p:cNvPr>
@@ -22658,7 +22658,7 @@
           <p:cNvPr id="30" name="artifact-5">
             <a:extLst xmlns:a="http://schemas.openxmlformats.org/drawingml/2006/main">
               <a:ext uri="{FF2B5EF4-FFF2-40B4-BE49-F238E27FC236}">
-                <a16:creationId xmlns:a16="http://schemas.microsoft.com/office/drawing/2014/main" id="{AE94C657-10F9-4905-BCF9-B1B7A8589BAC}"/>
+                <a16:creationId xmlns:a16="http://schemas.microsoft.com/office/drawing/2014/main" id="{1BFD6B66-F6F8-4021-A334-C06D62CF2209}"/>
               </a:ext>
             </a:extLst>
           </p:cNvPr>
@@ -22718,7 +22718,7 @@
           <p:cNvPr id="31" name="check-5">
             <a:extLst xmlns:a="http://schemas.openxmlformats.org/drawingml/2006/main">
               <a:ext uri="{FF2B5EF4-FFF2-40B4-BE49-F238E27FC236}">
-                <a16:creationId xmlns:a16="http://schemas.microsoft.com/office/drawing/2014/main" id="{EBE012FC-4166-4888-A168-BD01C3A2A876}"/>
+                <a16:creationId xmlns:a16="http://schemas.microsoft.com/office/drawing/2014/main" id="{573A9FA6-E030-405D-94DC-24E73CED07A2}"/>
               </a:ext>
             </a:extLst>
           </p:cNvPr>
@@ -22778,7 +22778,7 @@
           <p:cNvPr id="32" name="bottom">
             <a:extLst xmlns:a="http://schemas.openxmlformats.org/drawingml/2006/main">
               <a:ext uri="{FF2B5EF4-FFF2-40B4-BE49-F238E27FC236}">
-                <a16:creationId xmlns:a16="http://schemas.microsoft.com/office/drawing/2014/main" id="{A215CCB0-4741-4C32-8A9E-9BE14D1D43A1}"/>
+                <a16:creationId xmlns:a16="http://schemas.microsoft.com/office/drawing/2014/main" id="{D0A5AA0B-F81C-428A-84A2-2EED41195469}"/>
               </a:ext>
             </a:extLst>
           </p:cNvPr>
@@ -22836,7 +22836,7 @@
     </p:spTree>
     <p:extLst>
       <p:ext uri="{BB962C8B-B14F-4D97-AF65-F5344CB8AC3E}">
-        <p14:creationId xmlns:p14="http://schemas.microsoft.com/office/powerpoint/2010/main" val="1527875752"/>
+        <p14:creationId xmlns:p14="http://schemas.microsoft.com/office/powerpoint/2010/main" val="1082489918"/>
       </p:ext>
     </p:extLst>
   </p:cSld>
@@ -22867,7 +22867,7 @@
           <p:cNvPr id="1" name="eyebrow">
             <a:extLst xmlns:a="http://schemas.openxmlformats.org/drawingml/2006/main">
               <a:ext uri="{FF2B5EF4-FFF2-40B4-BE49-F238E27FC236}">
-                <a16:creationId xmlns:a16="http://schemas.microsoft.com/office/drawing/2014/main" id="{FD3DDCA5-2C37-4309-AAC8-A0DE9C41BAC3}"/>
+                <a16:creationId xmlns:a16="http://schemas.microsoft.com/office/drawing/2014/main" id="{9E5935E6-0DD6-436B-8CEE-BA6BB9F363EB}"/>
               </a:ext>
             </a:extLst>
           </p:cNvPr>
@@ -22927,7 +22927,7 @@
           <p:cNvPr id="2" name="title">
             <a:extLst xmlns:a="http://schemas.openxmlformats.org/drawingml/2006/main">
               <a:ext uri="{FF2B5EF4-FFF2-40B4-BE49-F238E27FC236}">
-                <a16:creationId xmlns:a16="http://schemas.microsoft.com/office/drawing/2014/main" id="{EB1FA2C6-62D4-4F1B-A74A-C4BF22B278D7}"/>
+                <a16:creationId xmlns:a16="http://schemas.microsoft.com/office/drawing/2014/main" id="{36EB4F1E-7C61-4839-B596-7B043F1FE0D2}"/>
               </a:ext>
             </a:extLst>
           </p:cNvPr>
@@ -22987,7 +22987,7 @@
           <p:cNvPr id="3" name="footer">
             <a:extLst xmlns:a="http://schemas.openxmlformats.org/drawingml/2006/main">
               <a:ext uri="{FF2B5EF4-FFF2-40B4-BE49-F238E27FC236}">
-                <a16:creationId xmlns:a16="http://schemas.microsoft.com/office/drawing/2014/main" id="{84B97971-36E2-4178-B6ED-1B474E8881AB}"/>
+                <a16:creationId xmlns:a16="http://schemas.microsoft.com/office/drawing/2014/main" id="{13A8558E-85D8-4DF9-8B99-31C774BB885F}"/>
               </a:ext>
             </a:extLst>
           </p:cNvPr>
@@ -23047,7 +23047,7 @@
           <p:cNvPr id="4" name="scenario">
             <a:extLst xmlns:a="http://schemas.openxmlformats.org/drawingml/2006/main">
               <a:ext uri="{FF2B5EF4-FFF2-40B4-BE49-F238E27FC236}">
-                <a16:creationId xmlns:a16="http://schemas.microsoft.com/office/drawing/2014/main" id="{0F3FEC19-7ED5-4F4A-B517-BD00CAC2EE8E}"/>
+                <a16:creationId xmlns:a16="http://schemas.microsoft.com/office/drawing/2014/main" id="{BA02A166-3D37-44A5-8120-6D7A9149B307}"/>
               </a:ext>
             </a:extLst>
           </p:cNvPr>
@@ -23107,7 +23107,7 @@
           <p:cNvPr id="5" name="row-head-0">
             <a:extLst xmlns:a="http://schemas.openxmlformats.org/drawingml/2006/main">
               <a:ext uri="{FF2B5EF4-FFF2-40B4-BE49-F238E27FC236}">
-                <a16:creationId xmlns:a16="http://schemas.microsoft.com/office/drawing/2014/main" id="{FD06B061-47E4-422F-B27D-1CB9E56B7E3F}"/>
+                <a16:creationId xmlns:a16="http://schemas.microsoft.com/office/drawing/2014/main" id="{4ECC03DD-6904-4CFE-9D9D-83E6322C1804}"/>
               </a:ext>
             </a:extLst>
           </p:cNvPr>
@@ -23173,7 +23173,7 @@
           <p:cNvPr id="6" name="row-copy-0">
             <a:extLst xmlns:a="http://schemas.openxmlformats.org/drawingml/2006/main">
               <a:ext uri="{FF2B5EF4-FFF2-40B4-BE49-F238E27FC236}">
-                <a16:creationId xmlns:a16="http://schemas.microsoft.com/office/drawing/2014/main" id="{D6258E25-5F41-41AA-AC59-02D2EC552B8A}"/>
+                <a16:creationId xmlns:a16="http://schemas.microsoft.com/office/drawing/2014/main" id="{F12B9984-F0E4-4705-BB5E-D2EA57AD4305}"/>
               </a:ext>
             </a:extLst>
           </p:cNvPr>
@@ -23233,7 +23233,7 @@
           <p:cNvPr id="7" name="row-line-0">
             <a:extLst xmlns:a="http://schemas.openxmlformats.org/drawingml/2006/main">
               <a:ext uri="{FF2B5EF4-FFF2-40B4-BE49-F238E27FC236}">
-                <a16:creationId xmlns:a16="http://schemas.microsoft.com/office/drawing/2014/main" id="{AA8BFD7A-6A3F-458A-AB23-2AE74FF835F7}"/>
+                <a16:creationId xmlns:a16="http://schemas.microsoft.com/office/drawing/2014/main" id="{CABFA756-877D-4E4D-BE8D-857CBA6D3EF8}"/>
               </a:ext>
             </a:extLst>
           </p:cNvPr>
@@ -23264,7 +23264,7 @@
           <p:cNvPr id="8" name="row-head-1">
             <a:extLst xmlns:a="http://schemas.openxmlformats.org/drawingml/2006/main">
               <a:ext uri="{FF2B5EF4-FFF2-40B4-BE49-F238E27FC236}">
-                <a16:creationId xmlns:a16="http://schemas.microsoft.com/office/drawing/2014/main" id="{7179FB04-6CDF-49E9-9C38-CEB9E5D98C9C}"/>
+                <a16:creationId xmlns:a16="http://schemas.microsoft.com/office/drawing/2014/main" id="{782025F9-69A8-4D16-BEFC-798B99D2BDB6}"/>
               </a:ext>
             </a:extLst>
           </p:cNvPr>
@@ -23330,7 +23330,7 @@
           <p:cNvPr id="9" name="row-copy-1">
             <a:extLst xmlns:a="http://schemas.openxmlformats.org/drawingml/2006/main">
               <a:ext uri="{FF2B5EF4-FFF2-40B4-BE49-F238E27FC236}">
-                <a16:creationId xmlns:a16="http://schemas.microsoft.com/office/drawing/2014/main" id="{1566241C-69F9-4D85-B494-3019200B41B5}"/>
+                <a16:creationId xmlns:a16="http://schemas.microsoft.com/office/drawing/2014/main" id="{9A5D5F4A-610E-4CE1-AAED-EF0F0BA6785D}"/>
               </a:ext>
             </a:extLst>
           </p:cNvPr>
@@ -23390,7 +23390,7 @@
           <p:cNvPr id="10" name="row-line-1">
             <a:extLst xmlns:a="http://schemas.openxmlformats.org/drawingml/2006/main">
               <a:ext uri="{FF2B5EF4-FFF2-40B4-BE49-F238E27FC236}">
-                <a16:creationId xmlns:a16="http://schemas.microsoft.com/office/drawing/2014/main" id="{2D8E6CAB-B0DB-4683-A013-C936BDB82B30}"/>
+                <a16:creationId xmlns:a16="http://schemas.microsoft.com/office/drawing/2014/main" id="{C1F19AFD-7BD5-4D87-87A1-99E16E618033}"/>
               </a:ext>
             </a:extLst>
           </p:cNvPr>
@@ -23421,7 +23421,7 @@
           <p:cNvPr id="11" name="row-head-2">
             <a:extLst xmlns:a="http://schemas.openxmlformats.org/drawingml/2006/main">
               <a:ext uri="{FF2B5EF4-FFF2-40B4-BE49-F238E27FC236}">
-                <a16:creationId xmlns:a16="http://schemas.microsoft.com/office/drawing/2014/main" id="{7AA21989-1DE5-4069-96CC-86549A1161A1}"/>
+                <a16:creationId xmlns:a16="http://schemas.microsoft.com/office/drawing/2014/main" id="{B21B4E23-F3F5-4CEB-AE50-857C9B4CDAE6}"/>
               </a:ext>
             </a:extLst>
           </p:cNvPr>
@@ -23487,7 +23487,7 @@
           <p:cNvPr id="12" name="row-copy-2">
             <a:extLst xmlns:a="http://schemas.openxmlformats.org/drawingml/2006/main">
               <a:ext uri="{FF2B5EF4-FFF2-40B4-BE49-F238E27FC236}">
-                <a16:creationId xmlns:a16="http://schemas.microsoft.com/office/drawing/2014/main" id="{9DA31CAA-B8E3-4DB5-92C8-1D0CD4EAE3BF}"/>
+                <a16:creationId xmlns:a16="http://schemas.microsoft.com/office/drawing/2014/main" id="{79F29317-ED5A-49D7-8F45-221A32708C04}"/>
               </a:ext>
             </a:extLst>
           </p:cNvPr>
@@ -23547,7 +23547,7 @@
           <p:cNvPr id="13" name="row-line-2">
             <a:extLst xmlns:a="http://schemas.openxmlformats.org/drawingml/2006/main">
               <a:ext uri="{FF2B5EF4-FFF2-40B4-BE49-F238E27FC236}">
-                <a16:creationId xmlns:a16="http://schemas.microsoft.com/office/drawing/2014/main" id="{E405554D-DC39-47D5-B424-03AD3BCEDA3A}"/>
+                <a16:creationId xmlns:a16="http://schemas.microsoft.com/office/drawing/2014/main" id="{47109A37-8000-4F3F-B234-CA963938DD70}"/>
               </a:ext>
             </a:extLst>
           </p:cNvPr>
@@ -23578,7 +23578,7 @@
           <p:cNvPr id="14" name="row-head-3">
             <a:extLst xmlns:a="http://schemas.openxmlformats.org/drawingml/2006/main">
               <a:ext uri="{FF2B5EF4-FFF2-40B4-BE49-F238E27FC236}">
-                <a16:creationId xmlns:a16="http://schemas.microsoft.com/office/drawing/2014/main" id="{EE95DA56-F84F-4DCD-8AF4-3E456A125C2C}"/>
+                <a16:creationId xmlns:a16="http://schemas.microsoft.com/office/drawing/2014/main" id="{0244DE4F-3DFE-4739-B1B4-C655092B074F}"/>
               </a:ext>
             </a:extLst>
           </p:cNvPr>
@@ -23644,7 +23644,7 @@
           <p:cNvPr id="15" name="row-copy-3">
             <a:extLst xmlns:a="http://schemas.openxmlformats.org/drawingml/2006/main">
               <a:ext uri="{FF2B5EF4-FFF2-40B4-BE49-F238E27FC236}">
-                <a16:creationId xmlns:a16="http://schemas.microsoft.com/office/drawing/2014/main" id="{7D27A02A-549A-4FC0-82DC-9E991BD17CC3}"/>
+                <a16:creationId xmlns:a16="http://schemas.microsoft.com/office/drawing/2014/main" id="{90333EFA-E44D-40E1-9620-4FB647D08A87}"/>
               </a:ext>
             </a:extLst>
           </p:cNvPr>
@@ -23704,7 +23704,7 @@
           <p:cNvPr id="16" name="row-line-3">
             <a:extLst xmlns:a="http://schemas.openxmlformats.org/drawingml/2006/main">
               <a:ext uri="{FF2B5EF4-FFF2-40B4-BE49-F238E27FC236}">
-                <a16:creationId xmlns:a16="http://schemas.microsoft.com/office/drawing/2014/main" id="{D97307DF-A1F2-4AFB-8F9C-D5F13D75DB20}"/>
+                <a16:creationId xmlns:a16="http://schemas.microsoft.com/office/drawing/2014/main" id="{3282FEE5-3144-4C04-91DB-30E67EBAD2CE}"/>
               </a:ext>
             </a:extLst>
           </p:cNvPr>
@@ -23735,7 +23735,7 @@
           <p:cNvPr id="17" name="note">
             <a:extLst xmlns:a="http://schemas.openxmlformats.org/drawingml/2006/main">
               <a:ext uri="{FF2B5EF4-FFF2-40B4-BE49-F238E27FC236}">
-                <a16:creationId xmlns:a16="http://schemas.microsoft.com/office/drawing/2014/main" id="{EA3FFF79-BED6-432A-BCB8-254AD766836C}"/>
+                <a16:creationId xmlns:a16="http://schemas.microsoft.com/office/drawing/2014/main" id="{9C35D755-59B9-42C6-B527-CAAF886118C0}"/>
               </a:ext>
             </a:extLst>
           </p:cNvPr>
@@ -23793,7 +23793,7 @@
     </p:spTree>
     <p:extLst>
       <p:ext uri="{BB962C8B-B14F-4D97-AF65-F5344CB8AC3E}">
-        <p14:creationId xmlns:p14="http://schemas.microsoft.com/office/powerpoint/2010/main" val="223445889"/>
+        <p14:creationId xmlns:p14="http://schemas.microsoft.com/office/powerpoint/2010/main" val="2085202455"/>
       </p:ext>
     </p:extLst>
   </p:cSld>
@@ -23824,7 +23824,7 @@
           <p:cNvPr id="1" name="eyebrow">
             <a:extLst xmlns:a="http://schemas.openxmlformats.org/drawingml/2006/main">
               <a:ext uri="{FF2B5EF4-FFF2-40B4-BE49-F238E27FC236}">
-                <a16:creationId xmlns:a16="http://schemas.microsoft.com/office/drawing/2014/main" id="{A16A95BE-C3AB-46D0-BDF3-46E803D1057A}"/>
+                <a16:creationId xmlns:a16="http://schemas.microsoft.com/office/drawing/2014/main" id="{F159352D-EB47-4608-8ABA-CE2CB95BE76D}"/>
               </a:ext>
             </a:extLst>
           </p:cNvPr>
@@ -23884,7 +23884,7 @@
           <p:cNvPr id="2" name="title">
             <a:extLst xmlns:a="http://schemas.openxmlformats.org/drawingml/2006/main">
               <a:ext uri="{FF2B5EF4-FFF2-40B4-BE49-F238E27FC236}">
-                <a16:creationId xmlns:a16="http://schemas.microsoft.com/office/drawing/2014/main" id="{008126EF-8434-407E-A41E-A43D88C6AA5A}"/>
+                <a16:creationId xmlns:a16="http://schemas.microsoft.com/office/drawing/2014/main" id="{AEF74BE9-BC51-46DF-9ABE-9BE4E059A861}"/>
               </a:ext>
             </a:extLst>
           </p:cNvPr>
@@ -23944,7 +23944,7 @@
           <p:cNvPr id="3" name="footer">
             <a:extLst xmlns:a="http://schemas.openxmlformats.org/drawingml/2006/main">
               <a:ext uri="{FF2B5EF4-FFF2-40B4-BE49-F238E27FC236}">
-                <a16:creationId xmlns:a16="http://schemas.microsoft.com/office/drawing/2014/main" id="{B0760CAC-D116-453F-A199-642988081B30}"/>
+                <a16:creationId xmlns:a16="http://schemas.microsoft.com/office/drawing/2014/main" id="{19B1BB94-6FAF-4C66-B7A4-581EC2A4A17D}"/>
               </a:ext>
             </a:extLst>
           </p:cNvPr>
@@ -24004,7 +24004,7 @@
           <p:cNvPr id="4" name="ladder-line">
             <a:extLst xmlns:a="http://schemas.openxmlformats.org/drawingml/2006/main">
               <a:ext uri="{FF2B5EF4-FFF2-40B4-BE49-F238E27FC236}">
-                <a16:creationId xmlns:a16="http://schemas.microsoft.com/office/drawing/2014/main" id="{A1BB41F6-257A-4C28-BBEB-D5DA40F23007}"/>
+                <a16:creationId xmlns:a16="http://schemas.microsoft.com/office/drawing/2014/main" id="{9B23E144-AF62-452E-97E6-163FA5AE4FE3}"/>
               </a:ext>
             </a:extLst>
           </p:cNvPr>
@@ -24035,7 +24035,7 @@
           <p:cNvPr id="5" name="level-0">
             <a:extLst xmlns:a="http://schemas.openxmlformats.org/drawingml/2006/main">
               <a:ext uri="{FF2B5EF4-FFF2-40B4-BE49-F238E27FC236}">
-                <a16:creationId xmlns:a16="http://schemas.microsoft.com/office/drawing/2014/main" id="{E233FD32-2C12-4340-961F-0202EA019A2C}"/>
+                <a16:creationId xmlns:a16="http://schemas.microsoft.com/office/drawing/2014/main" id="{D4BDF897-CB54-4942-8020-6365D4028340}"/>
               </a:ext>
             </a:extLst>
           </p:cNvPr>
@@ -24101,7 +24101,7 @@
           <p:cNvPr id="6" name="level-copy-0">
             <a:extLst xmlns:a="http://schemas.openxmlformats.org/drawingml/2006/main">
               <a:ext uri="{FF2B5EF4-FFF2-40B4-BE49-F238E27FC236}">
-                <a16:creationId xmlns:a16="http://schemas.microsoft.com/office/drawing/2014/main" id="{6E8577BD-4239-458F-801E-577B267431AE}"/>
+                <a16:creationId xmlns:a16="http://schemas.microsoft.com/office/drawing/2014/main" id="{DC9A88A4-D78A-44C0-99D8-C0AB2D9E3E85}"/>
               </a:ext>
             </a:extLst>
           </p:cNvPr>
@@ -24161,7 +24161,7 @@
           <p:cNvPr id="7" name="level-1">
             <a:extLst xmlns:a="http://schemas.openxmlformats.org/drawingml/2006/main">
               <a:ext uri="{FF2B5EF4-FFF2-40B4-BE49-F238E27FC236}">
-                <a16:creationId xmlns:a16="http://schemas.microsoft.com/office/drawing/2014/main" id="{B2748A8A-D315-4E51-8769-4B1052BD774A}"/>
+                <a16:creationId xmlns:a16="http://schemas.microsoft.com/office/drawing/2014/main" id="{51C7B895-084D-4C7E-BD13-C02C6753EA24}"/>
               </a:ext>
             </a:extLst>
           </p:cNvPr>
@@ -24227,7 +24227,7 @@
           <p:cNvPr id="8" name="level-copy-1">
             <a:extLst xmlns:a="http://schemas.openxmlformats.org/drawingml/2006/main">
               <a:ext uri="{FF2B5EF4-FFF2-40B4-BE49-F238E27FC236}">
-                <a16:creationId xmlns:a16="http://schemas.microsoft.com/office/drawing/2014/main" id="{757C8713-8B28-4B89-93EB-90642EAF9272}"/>
+                <a16:creationId xmlns:a16="http://schemas.microsoft.com/office/drawing/2014/main" id="{659E0BD6-45BD-455F-B821-E0429945DA2C}"/>
               </a:ext>
             </a:extLst>
           </p:cNvPr>
@@ -24287,7 +24287,7 @@
           <p:cNvPr id="9" name="level-2">
             <a:extLst xmlns:a="http://schemas.openxmlformats.org/drawingml/2006/main">
               <a:ext uri="{FF2B5EF4-FFF2-40B4-BE49-F238E27FC236}">
-                <a16:creationId xmlns:a16="http://schemas.microsoft.com/office/drawing/2014/main" id="{0BEC18A8-2839-4C00-802E-57528C50D724}"/>
+                <a16:creationId xmlns:a16="http://schemas.microsoft.com/office/drawing/2014/main" id="{45C4F0B7-EC2B-4F1E-A9BB-1176FD858486}"/>
               </a:ext>
             </a:extLst>
           </p:cNvPr>
@@ -24353,7 +24353,7 @@
           <p:cNvPr id="10" name="level-copy-2">
             <a:extLst xmlns:a="http://schemas.openxmlformats.org/drawingml/2006/main">
               <a:ext uri="{FF2B5EF4-FFF2-40B4-BE49-F238E27FC236}">
-                <a16:creationId xmlns:a16="http://schemas.microsoft.com/office/drawing/2014/main" id="{2611A62B-9369-40EA-A1F8-5B1FF4A5EC8E}"/>
+                <a16:creationId xmlns:a16="http://schemas.microsoft.com/office/drawing/2014/main" id="{6930F802-E9F8-4719-A639-072A7471B1BC}"/>
               </a:ext>
             </a:extLst>
           </p:cNvPr>
@@ -24413,7 +24413,7 @@
           <p:cNvPr id="11" name="level-3">
             <a:extLst xmlns:a="http://schemas.openxmlformats.org/drawingml/2006/main">
               <a:ext uri="{FF2B5EF4-FFF2-40B4-BE49-F238E27FC236}">
-                <a16:creationId xmlns:a16="http://schemas.microsoft.com/office/drawing/2014/main" id="{393F6B8A-C5B6-420F-9771-B39019329040}"/>
+                <a16:creationId xmlns:a16="http://schemas.microsoft.com/office/drawing/2014/main" id="{42241B79-7768-4AC1-A83F-66D3902221B0}"/>
               </a:ext>
             </a:extLst>
           </p:cNvPr>
@@ -24479,7 +24479,7 @@
           <p:cNvPr id="12" name="level-copy-3">
             <a:extLst xmlns:a="http://schemas.openxmlformats.org/drawingml/2006/main">
               <a:ext uri="{FF2B5EF4-FFF2-40B4-BE49-F238E27FC236}">
-                <a16:creationId xmlns:a16="http://schemas.microsoft.com/office/drawing/2014/main" id="{03EE2C1F-FD66-4F20-8CD9-62B180DB74BD}"/>
+                <a16:creationId xmlns:a16="http://schemas.microsoft.com/office/drawing/2014/main" id="{2729E5C6-BED8-47B1-95F1-A35C93868CFC}"/>
               </a:ext>
             </a:extLst>
           </p:cNvPr>
@@ -24539,7 +24539,7 @@
           <p:cNvPr id="13" name="level-4">
             <a:extLst xmlns:a="http://schemas.openxmlformats.org/drawingml/2006/main">
               <a:ext uri="{FF2B5EF4-FFF2-40B4-BE49-F238E27FC236}">
-                <a16:creationId xmlns:a16="http://schemas.microsoft.com/office/drawing/2014/main" id="{4A762AFA-9146-4AEE-BD13-6791583052DC}"/>
+                <a16:creationId xmlns:a16="http://schemas.microsoft.com/office/drawing/2014/main" id="{F371C88D-A7F2-4F99-A0EE-08E629748DBF}"/>
               </a:ext>
             </a:extLst>
           </p:cNvPr>
@@ -24605,7 +24605,7 @@
           <p:cNvPr id="14" name="level-copy-4">
             <a:extLst xmlns:a="http://schemas.openxmlformats.org/drawingml/2006/main">
               <a:ext uri="{FF2B5EF4-FFF2-40B4-BE49-F238E27FC236}">
-                <a16:creationId xmlns:a16="http://schemas.microsoft.com/office/drawing/2014/main" id="{E29C4447-E4DB-4682-82BE-E2145F9D9E3D}"/>
+                <a16:creationId xmlns:a16="http://schemas.microsoft.com/office/drawing/2014/main" id="{4F9A23E8-0DE5-444E-B7B4-F063BF458D25}"/>
               </a:ext>
             </a:extLst>
           </p:cNvPr>
@@ -24665,7 +24665,7 @@
           <p:cNvPr id="15" name="takeaway">
             <a:extLst xmlns:a="http://schemas.openxmlformats.org/drawingml/2006/main">
               <a:ext uri="{FF2B5EF4-FFF2-40B4-BE49-F238E27FC236}">
-                <a16:creationId xmlns:a16="http://schemas.microsoft.com/office/drawing/2014/main" id="{B0C69672-63B8-45B9-A6EF-EB92E721D2EC}"/>
+                <a16:creationId xmlns:a16="http://schemas.microsoft.com/office/drawing/2014/main" id="{B7510493-33F0-4621-AE53-5B30AAC06C2F}"/>
               </a:ext>
             </a:extLst>
           </p:cNvPr>
@@ -24723,7 +24723,7 @@
     </p:spTree>
     <p:extLst>
       <p:ext uri="{BB962C8B-B14F-4D97-AF65-F5344CB8AC3E}">
-        <p14:creationId xmlns:p14="http://schemas.microsoft.com/office/powerpoint/2010/main" val="2054075223"/>
+        <p14:creationId xmlns:p14="http://schemas.microsoft.com/office/powerpoint/2010/main" val="1835676066"/>
       </p:ext>
     </p:extLst>
   </p:cSld>
@@ -24754,7 +24754,7 @@
           <p:cNvPr id="1" name="eyebrow">
             <a:extLst xmlns:a="http://schemas.openxmlformats.org/drawingml/2006/main">
               <a:ext uri="{FF2B5EF4-FFF2-40B4-BE49-F238E27FC236}">
-                <a16:creationId xmlns:a16="http://schemas.microsoft.com/office/drawing/2014/main" id="{9D65802A-F21B-4714-AE7A-B397933504EF}"/>
+                <a16:creationId xmlns:a16="http://schemas.microsoft.com/office/drawing/2014/main" id="{4F2D36FE-686D-416C-A269-C801592823D3}"/>
               </a:ext>
             </a:extLst>
           </p:cNvPr>
@@ -24814,7 +24814,7 @@
           <p:cNvPr id="2" name="title">
             <a:extLst xmlns:a="http://schemas.openxmlformats.org/drawingml/2006/main">
               <a:ext uri="{FF2B5EF4-FFF2-40B4-BE49-F238E27FC236}">
-                <a16:creationId xmlns:a16="http://schemas.microsoft.com/office/drawing/2014/main" id="{887BA3CF-7400-44B5-AA1A-D060F62140AD}"/>
+                <a16:creationId xmlns:a16="http://schemas.microsoft.com/office/drawing/2014/main" id="{7650235D-1C7F-4C0E-9864-52E4A07FCFBD}"/>
               </a:ext>
             </a:extLst>
           </p:cNvPr>
@@ -24874,7 +24874,7 @@
           <p:cNvPr id="3" name="footer">
             <a:extLst xmlns:a="http://schemas.openxmlformats.org/drawingml/2006/main">
               <a:ext uri="{FF2B5EF4-FFF2-40B4-BE49-F238E27FC236}">
-                <a16:creationId xmlns:a16="http://schemas.microsoft.com/office/drawing/2014/main" id="{DB0788A1-FDD2-4A21-9AC2-BD393EB19094}"/>
+                <a16:creationId xmlns:a16="http://schemas.microsoft.com/office/drawing/2014/main" id="{63BE9799-34B9-4A1B-9D10-E17C90EECD2E}"/>
               </a:ext>
             </a:extLst>
           </p:cNvPr>
@@ -24934,7 +24934,7 @@
           <p:cNvPr id="4" name="left">
             <a:extLst xmlns:a="http://schemas.openxmlformats.org/drawingml/2006/main">
               <a:ext uri="{FF2B5EF4-FFF2-40B4-BE49-F238E27FC236}">
-                <a16:creationId xmlns:a16="http://schemas.microsoft.com/office/drawing/2014/main" id="{19387D77-EE8B-4725-B76C-9BEA9A814959}"/>
+                <a16:creationId xmlns:a16="http://schemas.microsoft.com/office/drawing/2014/main" id="{CE8201C2-D245-4C0A-A618-375374ED32A0}"/>
               </a:ext>
             </a:extLst>
           </p:cNvPr>
@@ -24969,7 +24969,7 @@
           <p:cNvPr id="5" name="right">
             <a:extLst xmlns:a="http://schemas.openxmlformats.org/drawingml/2006/main">
               <a:ext uri="{FF2B5EF4-FFF2-40B4-BE49-F238E27FC236}">
-                <a16:creationId xmlns:a16="http://schemas.microsoft.com/office/drawing/2014/main" id="{C1910196-C423-4EEC-964A-CA9234F11BFD}"/>
+                <a16:creationId xmlns:a16="http://schemas.microsoft.com/office/drawing/2014/main" id="{B50DF348-8698-40FB-917E-B13551B6B17B}"/>
               </a:ext>
             </a:extLst>
           </p:cNvPr>
@@ -25004,7 +25004,7 @@
           <p:cNvPr id="6" name="left-title">
             <a:extLst xmlns:a="http://schemas.openxmlformats.org/drawingml/2006/main">
               <a:ext uri="{FF2B5EF4-FFF2-40B4-BE49-F238E27FC236}">
-                <a16:creationId xmlns:a16="http://schemas.microsoft.com/office/drawing/2014/main" id="{FA510C0D-5B36-43A6-9FFB-7146CC47AF6A}"/>
+                <a16:creationId xmlns:a16="http://schemas.microsoft.com/office/drawing/2014/main" id="{73EB1A77-EB42-4294-9007-8D399F21DED5}"/>
               </a:ext>
             </a:extLst>
           </p:cNvPr>
@@ -25064,7 +25064,7 @@
           <p:cNvPr id="7" name="right-title">
             <a:extLst xmlns:a="http://schemas.openxmlformats.org/drawingml/2006/main">
               <a:ext uri="{FF2B5EF4-FFF2-40B4-BE49-F238E27FC236}">
-                <a16:creationId xmlns:a16="http://schemas.microsoft.com/office/drawing/2014/main" id="{339319DB-1696-4D08-BB8F-C44BF5B093C7}"/>
+                <a16:creationId xmlns:a16="http://schemas.microsoft.com/office/drawing/2014/main" id="{EC7434CE-E4A3-4150-AC2A-1D25910EE576}"/>
               </a:ext>
             </a:extLst>
           </p:cNvPr>
@@ -25124,7 +25124,7 @@
           <p:cNvPr id="8" name="prompt">
             <a:extLst xmlns:a="http://schemas.openxmlformats.org/drawingml/2006/main">
               <a:ext uri="{FF2B5EF4-FFF2-40B4-BE49-F238E27FC236}">
-                <a16:creationId xmlns:a16="http://schemas.microsoft.com/office/drawing/2014/main" id="{65EF1538-C75D-4D2C-BC67-8A3428AD9B31}"/>
+                <a16:creationId xmlns:a16="http://schemas.microsoft.com/office/drawing/2014/main" id="{FC7B07E4-6026-4D3A-B578-25E2E5EA7157}"/>
               </a:ext>
             </a:extLst>
           </p:cNvPr>
@@ -25190,7 +25190,7 @@
           <p:cNvPr id="9" name="response">
             <a:extLst xmlns:a="http://schemas.openxmlformats.org/drawingml/2006/main">
               <a:ext uri="{FF2B5EF4-FFF2-40B4-BE49-F238E27FC236}">
-                <a16:creationId xmlns:a16="http://schemas.microsoft.com/office/drawing/2014/main" id="{6AC41AFB-D87D-4480-9F50-B774691990F0}"/>
+                <a16:creationId xmlns:a16="http://schemas.microsoft.com/office/drawing/2014/main" id="{FE5F2DD7-36FC-49FB-B570-1C2DC173D2CB}"/>
               </a:ext>
             </a:extLst>
           </p:cNvPr>
@@ -25256,7 +25256,7 @@
           <p:cNvPr id="10" name="chat-line">
             <a:extLst xmlns:a="http://schemas.openxmlformats.org/drawingml/2006/main">
               <a:ext uri="{FF2B5EF4-FFF2-40B4-BE49-F238E27FC236}">
-                <a16:creationId xmlns:a16="http://schemas.microsoft.com/office/drawing/2014/main" id="{2CC97917-2556-4888-8B28-6D4C0F4F04CD}"/>
+                <a16:creationId xmlns:a16="http://schemas.microsoft.com/office/drawing/2014/main" id="{684F2EB3-A91F-4CE9-85CC-03EFFB0466CF}"/>
               </a:ext>
             </a:extLst>
           </p:cNvPr>
@@ -25287,7 +25287,7 @@
           <p:cNvPr id="11" name="left-copy">
             <a:extLst xmlns:a="http://schemas.openxmlformats.org/drawingml/2006/main">
               <a:ext uri="{FF2B5EF4-FFF2-40B4-BE49-F238E27FC236}">
-                <a16:creationId xmlns:a16="http://schemas.microsoft.com/office/drawing/2014/main" id="{A7265039-8BA6-484F-9806-E927ED2FFBDC}"/>
+                <a16:creationId xmlns:a16="http://schemas.microsoft.com/office/drawing/2014/main" id="{99A0B057-58DA-47BA-800A-6BB8E332EE3C}"/>
               </a:ext>
             </a:extLst>
           </p:cNvPr>
@@ -25347,7 +25347,7 @@
           <p:cNvPr id="12" name="a1">
             <a:extLst xmlns:a="http://schemas.openxmlformats.org/drawingml/2006/main">
               <a:ext uri="{FF2B5EF4-FFF2-40B4-BE49-F238E27FC236}">
-                <a16:creationId xmlns:a16="http://schemas.microsoft.com/office/drawing/2014/main" id="{F25D194C-C054-4122-AC1A-AE17DF6DD8BB}"/>
+                <a16:creationId xmlns:a16="http://schemas.microsoft.com/office/drawing/2014/main" id="{7C00559E-4DA0-41F8-A80A-54A988E7D1EA}"/>
               </a:ext>
             </a:extLst>
           </p:cNvPr>
@@ -25378,7 +25378,7 @@
           <p:cNvPr id="13" name="a2">
             <a:extLst xmlns:a="http://schemas.openxmlformats.org/drawingml/2006/main">
               <a:ext uri="{FF2B5EF4-FFF2-40B4-BE49-F238E27FC236}">
-                <a16:creationId xmlns:a16="http://schemas.microsoft.com/office/drawing/2014/main" id="{D6156E9C-41A9-4A97-BE84-51E9CDE20C5E}"/>
+                <a16:creationId xmlns:a16="http://schemas.microsoft.com/office/drawing/2014/main" id="{3645790D-141C-4792-A1DD-E6C49EB05C28}"/>
               </a:ext>
             </a:extLst>
           </p:cNvPr>
@@ -25409,7 +25409,7 @@
           <p:cNvPr id="14" name="a3">
             <a:extLst xmlns:a="http://schemas.openxmlformats.org/drawingml/2006/main">
               <a:ext uri="{FF2B5EF4-FFF2-40B4-BE49-F238E27FC236}">
-                <a16:creationId xmlns:a16="http://schemas.microsoft.com/office/drawing/2014/main" id="{7091CBA2-05CB-41C3-B5D2-3BF2282FFA95}"/>
+                <a16:creationId xmlns:a16="http://schemas.microsoft.com/office/drawing/2014/main" id="{2051D095-400F-4824-B0E2-8094A074C82C}"/>
               </a:ext>
             </a:extLst>
           </p:cNvPr>
@@ -25440,7 +25440,7 @@
           <p:cNvPr id="15" name="a4">
             <a:extLst xmlns:a="http://schemas.openxmlformats.org/drawingml/2006/main">
               <a:ext uri="{FF2B5EF4-FFF2-40B4-BE49-F238E27FC236}">
-                <a16:creationId xmlns:a16="http://schemas.microsoft.com/office/drawing/2014/main" id="{D6E99C3D-E32D-4EAA-A669-93DD30C9F614}"/>
+                <a16:creationId xmlns:a16="http://schemas.microsoft.com/office/drawing/2014/main" id="{A7E16C64-DC61-4AB8-8E92-225097067FCE}"/>
               </a:ext>
             </a:extLst>
           </p:cNvPr>
@@ -25471,7 +25471,7 @@
           <p:cNvPr id="16" name="agent-Goal">
             <a:extLst xmlns:a="http://schemas.openxmlformats.org/drawingml/2006/main">
               <a:ext uri="{FF2B5EF4-FFF2-40B4-BE49-F238E27FC236}">
-                <a16:creationId xmlns:a16="http://schemas.microsoft.com/office/drawing/2014/main" id="{6688A1D4-2156-4960-8BF2-44F07265661D}"/>
+                <a16:creationId xmlns:a16="http://schemas.microsoft.com/office/drawing/2014/main" id="{EC79428A-6026-4671-9203-6A015373BD35}"/>
               </a:ext>
             </a:extLst>
           </p:cNvPr>
@@ -25537,7 +25537,7 @@
           <p:cNvPr id="17" name="agent-Tools">
             <a:extLst xmlns:a="http://schemas.openxmlformats.org/drawingml/2006/main">
               <a:ext uri="{FF2B5EF4-FFF2-40B4-BE49-F238E27FC236}">
-                <a16:creationId xmlns:a16="http://schemas.microsoft.com/office/drawing/2014/main" id="{BC7EE485-75AC-40FF-8DE0-908B357B0148}"/>
+                <a16:creationId xmlns:a16="http://schemas.microsoft.com/office/drawing/2014/main" id="{975EC48C-4A0A-4390-B141-20B1FF4CB3CD}"/>
               </a:ext>
             </a:extLst>
           </p:cNvPr>
@@ -25603,7 +25603,7 @@
           <p:cNvPr id="18" name="agent-Evidence">
             <a:extLst xmlns:a="http://schemas.openxmlformats.org/drawingml/2006/main">
               <a:ext uri="{FF2B5EF4-FFF2-40B4-BE49-F238E27FC236}">
-                <a16:creationId xmlns:a16="http://schemas.microsoft.com/office/drawing/2014/main" id="{2E3AE305-64A6-4DDD-8706-BD75AE8CF490}"/>
+                <a16:creationId xmlns:a16="http://schemas.microsoft.com/office/drawing/2014/main" id="{77109F86-FC10-40E0-B710-37CDA5B89383}"/>
               </a:ext>
             </a:extLst>
           </p:cNvPr>
@@ -25669,7 +25669,7 @@
           <p:cNvPr id="19" name="agent-Verify">
             <a:extLst xmlns:a="http://schemas.openxmlformats.org/drawingml/2006/main">
               <a:ext uri="{FF2B5EF4-FFF2-40B4-BE49-F238E27FC236}">
-                <a16:creationId xmlns:a16="http://schemas.microsoft.com/office/drawing/2014/main" id="{C3421923-410A-472C-B58E-EA6FABB47023}"/>
+                <a16:creationId xmlns:a16="http://schemas.microsoft.com/office/drawing/2014/main" id="{AAAB2859-3009-45C7-997F-3BB6EC876EB5}"/>
               </a:ext>
             </a:extLst>
           </p:cNvPr>
@@ -25735,7 +25735,7 @@
           <p:cNvPr id="20" name="agent-Artifact">
             <a:extLst xmlns:a="http://schemas.openxmlformats.org/drawingml/2006/main">
               <a:ext uri="{FF2B5EF4-FFF2-40B4-BE49-F238E27FC236}">
-                <a16:creationId xmlns:a16="http://schemas.microsoft.com/office/drawing/2014/main" id="{224D50D2-4265-4AF5-BBD5-6314C86BD6E0}"/>
+                <a16:creationId xmlns:a16="http://schemas.microsoft.com/office/drawing/2014/main" id="{A8583D90-6DA9-4F29-B025-D3D3E70F4896}"/>
               </a:ext>
             </a:extLst>
           </p:cNvPr>
@@ -25801,7 +25801,7 @@
           <p:cNvPr id="21" name="right-copy">
             <a:extLst xmlns:a="http://schemas.openxmlformats.org/drawingml/2006/main">
               <a:ext uri="{FF2B5EF4-FFF2-40B4-BE49-F238E27FC236}">
-                <a16:creationId xmlns:a16="http://schemas.microsoft.com/office/drawing/2014/main" id="{DBF7ECF9-7A6D-4C45-827A-09F713D9A9CF}"/>
+                <a16:creationId xmlns:a16="http://schemas.microsoft.com/office/drawing/2014/main" id="{487EDE05-2A42-4A37-8B58-3126F7C1B0DF}"/>
               </a:ext>
             </a:extLst>
           </p:cNvPr>
@@ -25859,7 +25859,7 @@
     </p:spTree>
     <p:extLst>
       <p:ext uri="{BB962C8B-B14F-4D97-AF65-F5344CB8AC3E}">
-        <p14:creationId xmlns:p14="http://schemas.microsoft.com/office/powerpoint/2010/main" val="1920383497"/>
+        <p14:creationId xmlns:p14="http://schemas.microsoft.com/office/powerpoint/2010/main" val="1707049448"/>
       </p:ext>
     </p:extLst>
   </p:cSld>
@@ -25890,7 +25890,7 @@
           <p:cNvPr id="1" name="eyebrow">
             <a:extLst xmlns:a="http://schemas.openxmlformats.org/drawingml/2006/main">
               <a:ext uri="{FF2B5EF4-FFF2-40B4-BE49-F238E27FC236}">
-                <a16:creationId xmlns:a16="http://schemas.microsoft.com/office/drawing/2014/main" id="{02245A4B-9FEF-4CE7-8D7D-7EA8C13E2563}"/>
+                <a16:creationId xmlns:a16="http://schemas.microsoft.com/office/drawing/2014/main" id="{82BCABA6-984D-4F84-9D47-9D0620A1584C}"/>
               </a:ext>
             </a:extLst>
           </p:cNvPr>
@@ -25950,7 +25950,7 @@
           <p:cNvPr id="2" name="title">
             <a:extLst xmlns:a="http://schemas.openxmlformats.org/drawingml/2006/main">
               <a:ext uri="{FF2B5EF4-FFF2-40B4-BE49-F238E27FC236}">
-                <a16:creationId xmlns:a16="http://schemas.microsoft.com/office/drawing/2014/main" id="{0523FD4F-9347-47ED-B0F5-910A664A7F8C}"/>
+                <a16:creationId xmlns:a16="http://schemas.microsoft.com/office/drawing/2014/main" id="{7A9FBAB6-10D3-44CF-BC92-3AC7C7A9981B}"/>
               </a:ext>
             </a:extLst>
           </p:cNvPr>
@@ -26010,7 +26010,7 @@
           <p:cNvPr id="3" name="footer">
             <a:extLst xmlns:a="http://schemas.openxmlformats.org/drawingml/2006/main">
               <a:ext uri="{FF2B5EF4-FFF2-40B4-BE49-F238E27FC236}">
-                <a16:creationId xmlns:a16="http://schemas.microsoft.com/office/drawing/2014/main" id="{4AD67911-0DA2-4EBF-AE86-F0C8D3498693}"/>
+                <a16:creationId xmlns:a16="http://schemas.microsoft.com/office/drawing/2014/main" id="{E03B5E03-90FF-4306-AB80-36B7F68F18DD}"/>
               </a:ext>
             </a:extLst>
           </p:cNvPr>
@@ -26070,7 +26070,7 @@
           <p:cNvPr id="4" name="workflow-boundary">
             <a:extLst xmlns:a="http://schemas.openxmlformats.org/drawingml/2006/main">
               <a:ext uri="{FF2B5EF4-FFF2-40B4-BE49-F238E27FC236}">
-                <a16:creationId xmlns:a16="http://schemas.microsoft.com/office/drawing/2014/main" id="{15A31E38-4448-4ADD-B825-AE3F23CF46F6}"/>
+                <a16:creationId xmlns:a16="http://schemas.microsoft.com/office/drawing/2014/main" id="{18243E80-0C23-4FBF-AAC1-B9E3E9B8D6FE}"/>
               </a:ext>
             </a:extLst>
           </p:cNvPr>
@@ -26103,7 +26103,7 @@
           <p:cNvPr id="5" name="boundary-label">
             <a:extLst xmlns:a="http://schemas.openxmlformats.org/drawingml/2006/main">
               <a:ext uri="{FF2B5EF4-FFF2-40B4-BE49-F238E27FC236}">
-                <a16:creationId xmlns:a16="http://schemas.microsoft.com/office/drawing/2014/main" id="{2F392FCF-B936-4DF6-81E3-6EF75123F121}"/>
+                <a16:creationId xmlns:a16="http://schemas.microsoft.com/office/drawing/2014/main" id="{8ED57D87-2DC8-46DE-866B-9F5C0C3DCE7D}"/>
               </a:ext>
             </a:extLst>
           </p:cNvPr>
@@ -26163,7 +26163,7 @@
           <p:cNvPr id="6" name="goal-to-model">
             <a:extLst xmlns:a="http://schemas.openxmlformats.org/drawingml/2006/main">
               <a:ext uri="{FF2B5EF4-FFF2-40B4-BE49-F238E27FC236}">
-                <a16:creationId xmlns:a16="http://schemas.microsoft.com/office/drawing/2014/main" id="{3C532912-B950-43E0-8E06-72979FA26462}"/>
+                <a16:creationId xmlns:a16="http://schemas.microsoft.com/office/drawing/2014/main" id="{52F39093-525C-472F-BEAC-9F3C708292F0}"/>
               </a:ext>
             </a:extLst>
           </p:cNvPr>
@@ -26194,7 +26194,7 @@
           <p:cNvPr id="7" name="context-to-model">
             <a:extLst xmlns:a="http://schemas.openxmlformats.org/drawingml/2006/main">
               <a:ext uri="{FF2B5EF4-FFF2-40B4-BE49-F238E27FC236}">
-                <a16:creationId xmlns:a16="http://schemas.microsoft.com/office/drawing/2014/main" id="{B915A82F-7ADA-45F3-BE0B-D5CDD3DFA6C5}"/>
+                <a16:creationId xmlns:a16="http://schemas.microsoft.com/office/drawing/2014/main" id="{C19936A9-560D-42D4-A5D2-573FAECC7E2D}"/>
               </a:ext>
             </a:extLst>
           </p:cNvPr>
@@ -26225,7 +26225,7 @@
           <p:cNvPr id="8" name="model-to-tools">
             <a:extLst xmlns:a="http://schemas.openxmlformats.org/drawingml/2006/main">
               <a:ext uri="{FF2B5EF4-FFF2-40B4-BE49-F238E27FC236}">
-                <a16:creationId xmlns:a16="http://schemas.microsoft.com/office/drawing/2014/main" id="{7B56D1AF-5994-4C45-A0C5-3F1F8D99FBDA}"/>
+                <a16:creationId xmlns:a16="http://schemas.microsoft.com/office/drawing/2014/main" id="{933CF9F5-C58C-43F3-84DD-43BB188579DE}"/>
               </a:ext>
             </a:extLst>
           </p:cNvPr>
@@ -26256,7 +26256,7 @@
           <p:cNvPr id="9" name="model-to-state">
             <a:extLst xmlns:a="http://schemas.openxmlformats.org/drawingml/2006/main">
               <a:ext uri="{FF2B5EF4-FFF2-40B4-BE49-F238E27FC236}">
-                <a16:creationId xmlns:a16="http://schemas.microsoft.com/office/drawing/2014/main" id="{0CD5C2C5-6832-4C31-A77C-545F6A6E8CE5}"/>
+                <a16:creationId xmlns:a16="http://schemas.microsoft.com/office/drawing/2014/main" id="{6130527D-C64B-460D-9BF0-9229965C1269}"/>
               </a:ext>
             </a:extLst>
           </p:cNvPr>
@@ -26287,7 +26287,7 @@
           <p:cNvPr id="10" name="state-to-verify">
             <a:extLst xmlns:a="http://schemas.openxmlformats.org/drawingml/2006/main">
               <a:ext uri="{FF2B5EF4-FFF2-40B4-BE49-F238E27FC236}">
-                <a16:creationId xmlns:a16="http://schemas.microsoft.com/office/drawing/2014/main" id="{78E8E5CF-DB51-45C0-BACF-F9855C412E0A}"/>
+                <a16:creationId xmlns:a16="http://schemas.microsoft.com/office/drawing/2014/main" id="{6D7BC9ED-B6BA-4EA8-B2DD-EF1E44AD8506}"/>
               </a:ext>
             </a:extLst>
           </p:cNvPr>
@@ -26318,7 +26318,7 @@
           <p:cNvPr id="11" name="node-Goal">
             <a:extLst xmlns:a="http://schemas.openxmlformats.org/drawingml/2006/main">
               <a:ext uri="{FF2B5EF4-FFF2-40B4-BE49-F238E27FC236}">
-                <a16:creationId xmlns:a16="http://schemas.microsoft.com/office/drawing/2014/main" id="{0326470B-05D2-4CDF-96CD-9607A99FE3B7}"/>
+                <a16:creationId xmlns:a16="http://schemas.microsoft.com/office/drawing/2014/main" id="{E30A09ED-6DFF-4760-8FD2-56497E189030}"/>
               </a:ext>
             </a:extLst>
           </p:cNvPr>
@@ -26411,7 +26411,7 @@
           <p:cNvPr id="12" name="node-Context">
             <a:extLst xmlns:a="http://schemas.openxmlformats.org/drawingml/2006/main">
               <a:ext uri="{FF2B5EF4-FFF2-40B4-BE49-F238E27FC236}">
-                <a16:creationId xmlns:a16="http://schemas.microsoft.com/office/drawing/2014/main" id="{6397AE3C-B7DC-49E4-9785-F6BEA1E40682}"/>
+                <a16:creationId xmlns:a16="http://schemas.microsoft.com/office/drawing/2014/main" id="{9BE41303-9F73-4094-B71E-D3CFE9E816DD}"/>
               </a:ext>
             </a:extLst>
           </p:cNvPr>
@@ -26504,7 +26504,7 @@
           <p:cNvPr id="13" name="model">
             <a:extLst xmlns:a="http://schemas.openxmlformats.org/drawingml/2006/main">
               <a:ext uri="{FF2B5EF4-FFF2-40B4-BE49-F238E27FC236}">
-                <a16:creationId xmlns:a16="http://schemas.microsoft.com/office/drawing/2014/main" id="{BCBDE6C2-4A50-457B-B032-63D345372BF3}"/>
+                <a16:creationId xmlns:a16="http://schemas.microsoft.com/office/drawing/2014/main" id="{1A843402-749B-4AC0-82B7-4C19D6A9A345}"/>
               </a:ext>
             </a:extLst>
           </p:cNvPr>
@@ -26597,7 +26597,7 @@
           <p:cNvPr id="14" name="node-Tools">
             <a:extLst xmlns:a="http://schemas.openxmlformats.org/drawingml/2006/main">
               <a:ext uri="{FF2B5EF4-FFF2-40B4-BE49-F238E27FC236}">
-                <a16:creationId xmlns:a16="http://schemas.microsoft.com/office/drawing/2014/main" id="{5F28104C-7B35-42D6-AAF2-CDD0427CABB5}"/>
+                <a16:creationId xmlns:a16="http://schemas.microsoft.com/office/drawing/2014/main" id="{DE735A17-22E3-4A9E-86D7-6D73FAA57851}"/>
               </a:ext>
             </a:extLst>
           </p:cNvPr>
@@ -26690,7 +26690,7 @@
           <p:cNvPr id="15" name="node-State">
             <a:extLst xmlns:a="http://schemas.openxmlformats.org/drawingml/2006/main">
               <a:ext uri="{FF2B5EF4-FFF2-40B4-BE49-F238E27FC236}">
-                <a16:creationId xmlns:a16="http://schemas.microsoft.com/office/drawing/2014/main" id="{DAD80A86-9AE6-475C-AB32-C23CD773E082}"/>
+                <a16:creationId xmlns:a16="http://schemas.microsoft.com/office/drawing/2014/main" id="{D364CF99-3A1B-4643-B072-C2C3DEBF07DC}"/>
               </a:ext>
             </a:extLst>
           </p:cNvPr>
@@ -26783,7 +26783,7 @@
           <p:cNvPr id="16" name="node-Verification">
             <a:extLst xmlns:a="http://schemas.openxmlformats.org/drawingml/2006/main">
               <a:ext uri="{FF2B5EF4-FFF2-40B4-BE49-F238E27FC236}">
-                <a16:creationId xmlns:a16="http://schemas.microsoft.com/office/drawing/2014/main" id="{CBCF1F3A-AF62-407B-8348-386352591854}"/>
+                <a16:creationId xmlns:a16="http://schemas.microsoft.com/office/drawing/2014/main" id="{3E3F1A5B-F425-4122-B2D8-1B4D300DAB7C}"/>
               </a:ext>
             </a:extLst>
           </p:cNvPr>
@@ -26874,7 +26874,7 @@
     </p:spTree>
     <p:extLst>
       <p:ext uri="{BB962C8B-B14F-4D97-AF65-F5344CB8AC3E}">
-        <p14:creationId xmlns:p14="http://schemas.microsoft.com/office/powerpoint/2010/main" val="1128179861"/>
+        <p14:creationId xmlns:p14="http://schemas.microsoft.com/office/powerpoint/2010/main" val="545505616"/>
       </p:ext>
     </p:extLst>
   </p:cSld>

</xml_diff>